<commit_message>
initial write up on equivalence relations
</commit_message>
<xml_diff>
--- a/images/icu.pptx
+++ b/images/icu.pptx
@@ -5,7 +5,7 @@
     <p:sldMasterId id="2147483648" r:id="rId1"/>
   </p:sldMasterIdLst>
   <p:notesMasterIdLst>
-    <p:notesMasterId r:id="rId8"/>
+    <p:notesMasterId r:id="rId9"/>
   </p:notesMasterIdLst>
   <p:sldIdLst>
     <p:sldId id="256" r:id="rId2"/>
@@ -14,6 +14,7 @@
     <p:sldId id="259" r:id="rId5"/>
     <p:sldId id="260" r:id="rId6"/>
     <p:sldId id="262" r:id="rId7"/>
+    <p:sldId id="263" r:id="rId8"/>
   </p:sldIdLst>
   <p:sldSz cx="12192000" cy="6858000"/>
   <p:notesSz cx="6858000" cy="9144000"/>
@@ -202,7 +203,7 @@
           <a:p>
             <a:fld id="{AD42B31F-4ABA-274F-9BB4-DA3A6583FDB8}" type="datetimeFigureOut">
               <a:rPr lang="en-US" smtClean="0"/>
-              <a:t>5/11/26</a:t>
+              <a:t>5/18/26</a:t>
             </a:fld>
             <a:endParaRPr lang="en-US"/>
           </a:p>
@@ -554,6 +555,114 @@
 </p:notes>
 </file>
 
+<file path=ppt/notesSlides/notesSlide2.xml><?xml version="1.0" encoding="utf-8"?>
+<p:notes xmlns:a="http://schemas.openxmlformats.org/drawingml/2006/main" xmlns:r="http://schemas.openxmlformats.org/officeDocument/2006/relationships" xmlns:p="http://schemas.openxmlformats.org/presentationml/2006/main">
+  <p:cSld>
+    <p:spTree>
+      <p:nvGrpSpPr>
+        <p:cNvPr id="1" name="">
+          <a:extLst>
+            <a:ext uri="{FF2B5EF4-FFF2-40B4-BE49-F238E27FC236}">
+              <a16:creationId xmlns:a16="http://schemas.microsoft.com/office/drawing/2014/main" id="{638BBEB6-1903-B4BF-7D57-D57AD1BE7E04}"/>
+            </a:ext>
+          </a:extLst>
+        </p:cNvPr>
+        <p:cNvGrpSpPr/>
+        <p:nvPr/>
+      </p:nvGrpSpPr>
+      <p:grpSpPr>
+        <a:xfrm>
+          <a:off x="0" y="0"/>
+          <a:ext cx="0" cy="0"/>
+          <a:chOff x="0" y="0"/>
+          <a:chExt cx="0" cy="0"/>
+        </a:xfrm>
+      </p:grpSpPr>
+      <p:sp>
+        <p:nvSpPr>
+          <p:cNvPr id="2" name="Slide Image Placeholder 1">
+            <a:extLst>
+              <a:ext uri="{FF2B5EF4-FFF2-40B4-BE49-F238E27FC236}">
+                <a16:creationId xmlns:a16="http://schemas.microsoft.com/office/drawing/2014/main" id="{B0FF4B89-E594-C0FC-FCED-F7DEFB01083A}"/>
+              </a:ext>
+            </a:extLst>
+          </p:cNvPr>
+          <p:cNvSpPr>
+            <a:spLocks noGrp="1" noRot="1" noChangeAspect="1"/>
+          </p:cNvSpPr>
+          <p:nvPr>
+            <p:ph type="sldImg"/>
+          </p:nvPr>
+        </p:nvSpPr>
+        <p:spPr/>
+      </p:sp>
+      <p:sp>
+        <p:nvSpPr>
+          <p:cNvPr id="3" name="Notes Placeholder 2">
+            <a:extLst>
+              <a:ext uri="{FF2B5EF4-FFF2-40B4-BE49-F238E27FC236}">
+                <a16:creationId xmlns:a16="http://schemas.microsoft.com/office/drawing/2014/main" id="{834BA25C-9143-3D7E-9E54-E5C421F145FC}"/>
+              </a:ext>
+            </a:extLst>
+          </p:cNvPr>
+          <p:cNvSpPr>
+            <a:spLocks noGrp="1"/>
+          </p:cNvSpPr>
+          <p:nvPr>
+            <p:ph type="body" idx="1"/>
+          </p:nvPr>
+        </p:nvSpPr>
+        <p:spPr/>
+        <p:txBody>
+          <a:bodyPr/>
+          <a:lstStyle/>
+          <a:p>
+            <a:endParaRPr lang="en-US" dirty="0"/>
+          </a:p>
+        </p:txBody>
+      </p:sp>
+      <p:sp>
+        <p:nvSpPr>
+          <p:cNvPr id="4" name="Slide Number Placeholder 3">
+            <a:extLst>
+              <a:ext uri="{FF2B5EF4-FFF2-40B4-BE49-F238E27FC236}">
+                <a16:creationId xmlns:a16="http://schemas.microsoft.com/office/drawing/2014/main" id="{DBF7D8E3-4891-3E7D-DA0C-F42A0ADBE160}"/>
+              </a:ext>
+            </a:extLst>
+          </p:cNvPr>
+          <p:cNvSpPr>
+            <a:spLocks noGrp="1"/>
+          </p:cNvSpPr>
+          <p:nvPr>
+            <p:ph type="sldNum" sz="quarter" idx="5"/>
+          </p:nvPr>
+        </p:nvSpPr>
+        <p:spPr/>
+        <p:txBody>
+          <a:bodyPr/>
+          <a:lstStyle/>
+          <a:p>
+            <a:fld id="{C0ECF21E-4684-E148-81FF-D3B1FD823314}" type="slidenum">
+              <a:rPr lang="en-US" smtClean="0"/>
+              <a:t>7</a:t>
+            </a:fld>
+            <a:endParaRPr lang="en-US"/>
+          </a:p>
+        </p:txBody>
+      </p:sp>
+    </p:spTree>
+    <p:extLst>
+      <p:ext uri="{BB962C8B-B14F-4D97-AF65-F5344CB8AC3E}">
+        <p14:creationId xmlns:p14="http://schemas.microsoft.com/office/powerpoint/2010/main" val="3659913339"/>
+      </p:ext>
+    </p:extLst>
+  </p:cSld>
+  <p:clrMapOvr>
+    <a:masterClrMapping/>
+  </p:clrMapOvr>
+</p:notes>
+</file>
+
 <file path=ppt/slideLayouts/slideLayout1.xml><?xml version="1.0" encoding="utf-8"?>
 <p:sldLayout xmlns:a="http://schemas.openxmlformats.org/drawingml/2006/main" xmlns:r="http://schemas.openxmlformats.org/officeDocument/2006/relationships" xmlns:p="http://schemas.openxmlformats.org/presentationml/2006/main" type="title" preserve="1">
   <p:cSld name="Title Slide">
@@ -703,7 +812,7 @@
           <a:p>
             <a:fld id="{0D21F05F-ACFB-0C4D-9827-53BE568178E4}" type="datetimeFigureOut">
               <a:rPr lang="en-US" smtClean="0"/>
-              <a:t>5/11/26</a:t>
+              <a:t>5/18/26</a:t>
             </a:fld>
             <a:endParaRPr lang="en-US"/>
           </a:p>
@@ -903,7 +1012,7 @@
           <a:p>
             <a:fld id="{0D21F05F-ACFB-0C4D-9827-53BE568178E4}" type="datetimeFigureOut">
               <a:rPr lang="en-US" smtClean="0"/>
-              <a:t>5/11/26</a:t>
+              <a:t>5/18/26</a:t>
             </a:fld>
             <a:endParaRPr lang="en-US"/>
           </a:p>
@@ -1113,7 +1222,7 @@
           <a:p>
             <a:fld id="{0D21F05F-ACFB-0C4D-9827-53BE568178E4}" type="datetimeFigureOut">
               <a:rPr lang="en-US" smtClean="0"/>
-              <a:t>5/11/26</a:t>
+              <a:t>5/18/26</a:t>
             </a:fld>
             <a:endParaRPr lang="en-US"/>
           </a:p>
@@ -1313,7 +1422,7 @@
           <a:p>
             <a:fld id="{0D21F05F-ACFB-0C4D-9827-53BE568178E4}" type="datetimeFigureOut">
               <a:rPr lang="en-US" smtClean="0"/>
-              <a:t>5/11/26</a:t>
+              <a:t>5/18/26</a:t>
             </a:fld>
             <a:endParaRPr lang="en-US"/>
           </a:p>
@@ -1589,7 +1698,7 @@
           <a:p>
             <a:fld id="{0D21F05F-ACFB-0C4D-9827-53BE568178E4}" type="datetimeFigureOut">
               <a:rPr lang="en-US" smtClean="0"/>
-              <a:t>5/11/26</a:t>
+              <a:t>5/18/26</a:t>
             </a:fld>
             <a:endParaRPr lang="en-US"/>
           </a:p>
@@ -1857,7 +1966,7 @@
           <a:p>
             <a:fld id="{0D21F05F-ACFB-0C4D-9827-53BE568178E4}" type="datetimeFigureOut">
               <a:rPr lang="en-US" smtClean="0"/>
-              <a:t>5/11/26</a:t>
+              <a:t>5/18/26</a:t>
             </a:fld>
             <a:endParaRPr lang="en-US"/>
           </a:p>
@@ -2272,7 +2381,7 @@
           <a:p>
             <a:fld id="{0D21F05F-ACFB-0C4D-9827-53BE568178E4}" type="datetimeFigureOut">
               <a:rPr lang="en-US" smtClean="0"/>
-              <a:t>5/11/26</a:t>
+              <a:t>5/18/26</a:t>
             </a:fld>
             <a:endParaRPr lang="en-US"/>
           </a:p>
@@ -2414,7 +2523,7 @@
           <a:p>
             <a:fld id="{0D21F05F-ACFB-0C4D-9827-53BE568178E4}" type="datetimeFigureOut">
               <a:rPr lang="en-US" smtClean="0"/>
-              <a:t>5/11/26</a:t>
+              <a:t>5/18/26</a:t>
             </a:fld>
             <a:endParaRPr lang="en-US"/>
           </a:p>
@@ -2527,7 +2636,7 @@
           <a:p>
             <a:fld id="{0D21F05F-ACFB-0C4D-9827-53BE568178E4}" type="datetimeFigureOut">
               <a:rPr lang="en-US" smtClean="0"/>
-              <a:t>5/11/26</a:t>
+              <a:t>5/18/26</a:t>
             </a:fld>
             <a:endParaRPr lang="en-US"/>
           </a:p>
@@ -2840,7 +2949,7 @@
           <a:p>
             <a:fld id="{0D21F05F-ACFB-0C4D-9827-53BE568178E4}" type="datetimeFigureOut">
               <a:rPr lang="en-US" smtClean="0"/>
-              <a:t>5/11/26</a:t>
+              <a:t>5/18/26</a:t>
             </a:fld>
             <a:endParaRPr lang="en-US"/>
           </a:p>
@@ -3129,7 +3238,7 @@
           <a:p>
             <a:fld id="{0D21F05F-ACFB-0C4D-9827-53BE568178E4}" type="datetimeFigureOut">
               <a:rPr lang="en-US" smtClean="0"/>
-              <a:t>5/11/26</a:t>
+              <a:t>5/18/26</a:t>
             </a:fld>
             <a:endParaRPr lang="en-US"/>
           </a:p>
@@ -3372,7 +3481,7 @@
           <a:p>
             <a:fld id="{0D21F05F-ACFB-0C4D-9827-53BE568178E4}" type="datetimeFigureOut">
               <a:rPr lang="en-US" smtClean="0"/>
-              <a:t>5/11/26</a:t>
+              <a:t>5/18/26</a:t>
             </a:fld>
             <a:endParaRPr lang="en-US"/>
           </a:p>
@@ -3791,10 +3900,10 @@
       </p:grpSpPr>
       <p:grpSp>
         <p:nvGrpSpPr>
-          <p:cNvPr id="16" name="Group 15">
-            <a:extLst>
-              <a:ext uri="{FF2B5EF4-FFF2-40B4-BE49-F238E27FC236}">
-                <a16:creationId xmlns:a16="http://schemas.microsoft.com/office/drawing/2014/main" id="{7FDD478E-B191-BEBF-B7F5-500E150B8800}"/>
+          <p:cNvPr id="8" name="Group 7">
+            <a:extLst>
+              <a:ext uri="{FF2B5EF4-FFF2-40B4-BE49-F238E27FC236}">
+                <a16:creationId xmlns:a16="http://schemas.microsoft.com/office/drawing/2014/main" id="{7819292F-E7D8-28A1-7327-66AE9B1ADB47}"/>
               </a:ext>
             </a:extLst>
           </p:cNvPr>
@@ -4310,7 +4419,7 @@
           </p:blipFill>
           <p:spPr>
             <a:xfrm>
-              <a:off x="709596" y="3929217"/>
+              <a:off x="709596" y="3974373"/>
               <a:ext cx="634696" cy="634696"/>
             </a:xfrm>
             <a:prstGeom prst="rect">
@@ -4345,7 +4454,7 @@
           </p:blipFill>
           <p:spPr>
             <a:xfrm>
-              <a:off x="1775428" y="3929217"/>
+              <a:off x="1775428" y="3974373"/>
               <a:ext cx="634696" cy="634696"/>
             </a:xfrm>
             <a:prstGeom prst="rect">
@@ -4380,7 +4489,7 @@
           </p:blipFill>
           <p:spPr>
             <a:xfrm>
-              <a:off x="709596" y="4768306"/>
+              <a:off x="709596" y="4813462"/>
               <a:ext cx="634696" cy="634696"/>
             </a:xfrm>
             <a:prstGeom prst="rect">
@@ -4415,7 +4524,7 @@
           </p:blipFill>
           <p:spPr>
             <a:xfrm>
-              <a:off x="1775428" y="4768306"/>
+              <a:off x="1775428" y="4813462"/>
               <a:ext cx="634696" cy="634696"/>
             </a:xfrm>
             <a:prstGeom prst="rect">
@@ -5115,7 +5224,7 @@
           </p:blipFill>
           <p:spPr>
             <a:xfrm>
-              <a:off x="9781876" y="4122861"/>
+              <a:off x="9781876" y="4190595"/>
               <a:ext cx="634696" cy="634696"/>
             </a:xfrm>
             <a:prstGeom prst="rect">
@@ -5150,7 +5259,7 @@
           </p:blipFill>
           <p:spPr>
             <a:xfrm>
-              <a:off x="10847708" y="4122861"/>
+              <a:off x="10847708" y="4190595"/>
               <a:ext cx="634696" cy="634696"/>
             </a:xfrm>
             <a:prstGeom prst="rect">
@@ -5185,7 +5294,7 @@
           </p:blipFill>
           <p:spPr>
             <a:xfrm>
-              <a:off x="9781876" y="4961950"/>
+              <a:off x="9781876" y="5029684"/>
               <a:ext cx="634696" cy="634696"/>
             </a:xfrm>
             <a:prstGeom prst="rect">
@@ -5220,7 +5329,7 @@
           </p:blipFill>
           <p:spPr>
             <a:xfrm>
-              <a:off x="10847708" y="4961950"/>
+              <a:off x="10847708" y="5029684"/>
               <a:ext cx="634696" cy="634696"/>
             </a:xfrm>
             <a:prstGeom prst="rect">
@@ -5774,6 +5883,94 @@
             </a:p>
           </p:txBody>
         </p:sp>
+        <p:cxnSp>
+          <p:nvCxnSpPr>
+            <p:cNvPr id="3" name="Straight Connector 2">
+              <a:extLst>
+                <a:ext uri="{FF2B5EF4-FFF2-40B4-BE49-F238E27FC236}">
+                  <a16:creationId xmlns:a16="http://schemas.microsoft.com/office/drawing/2014/main" id="{C62E2935-6100-EB7C-8087-4EE2E2063A44}"/>
+                </a:ext>
+              </a:extLst>
+            </p:cNvPr>
+            <p:cNvCxnSpPr>
+              <a:cxnSpLocks/>
+            </p:cNvCxnSpPr>
+            <p:nvPr/>
+          </p:nvCxnSpPr>
+          <p:spPr>
+            <a:xfrm>
+              <a:off x="225912" y="3803847"/>
+              <a:ext cx="1456132" cy="0"/>
+            </a:xfrm>
+            <a:prstGeom prst="line">
+              <a:avLst/>
+            </a:prstGeom>
+            <a:ln w="47625">
+              <a:solidFill>
+                <a:schemeClr val="tx1"/>
+              </a:solidFill>
+              <a:prstDash val="sysDot"/>
+            </a:ln>
+          </p:spPr>
+          <p:style>
+            <a:lnRef idx="2">
+              <a:schemeClr val="accent1"/>
+            </a:lnRef>
+            <a:fillRef idx="0">
+              <a:schemeClr val="accent1"/>
+            </a:fillRef>
+            <a:effectRef idx="1">
+              <a:schemeClr val="accent1"/>
+            </a:effectRef>
+            <a:fontRef idx="minor">
+              <a:schemeClr val="tx1"/>
+            </a:fontRef>
+          </p:style>
+        </p:cxnSp>
+        <p:cxnSp>
+          <p:nvCxnSpPr>
+            <p:cNvPr id="7" name="Straight Connector 6">
+              <a:extLst>
+                <a:ext uri="{FF2B5EF4-FFF2-40B4-BE49-F238E27FC236}">
+                  <a16:creationId xmlns:a16="http://schemas.microsoft.com/office/drawing/2014/main" id="{95577FF9-BB3E-68FD-ED66-EF09EB425FAB}"/>
+                </a:ext>
+              </a:extLst>
+            </p:cNvPr>
+            <p:cNvCxnSpPr>
+              <a:cxnSpLocks/>
+            </p:cNvCxnSpPr>
+            <p:nvPr/>
+          </p:nvCxnSpPr>
+          <p:spPr>
+            <a:xfrm>
+              <a:off x="9267714" y="4122861"/>
+              <a:ext cx="1456132" cy="0"/>
+            </a:xfrm>
+            <a:prstGeom prst="line">
+              <a:avLst/>
+            </a:prstGeom>
+            <a:ln w="47625">
+              <a:solidFill>
+                <a:schemeClr val="tx1"/>
+              </a:solidFill>
+              <a:prstDash val="sysDot"/>
+            </a:ln>
+          </p:spPr>
+          <p:style>
+            <a:lnRef idx="2">
+              <a:schemeClr val="accent1"/>
+            </a:lnRef>
+            <a:fillRef idx="0">
+              <a:schemeClr val="accent1"/>
+            </a:fillRef>
+            <a:effectRef idx="1">
+              <a:schemeClr val="accent1"/>
+            </a:effectRef>
+            <a:fontRef idx="minor">
+              <a:schemeClr val="tx1"/>
+            </a:fontRef>
+          </p:style>
+        </p:cxnSp>
       </p:grpSp>
     </p:spTree>
     <p:extLst>
@@ -11336,10 +11533,10 @@
       </p:grpSpPr>
       <p:grpSp>
         <p:nvGrpSpPr>
-          <p:cNvPr id="79" name="Group 78">
-            <a:extLst>
-              <a:ext uri="{FF2B5EF4-FFF2-40B4-BE49-F238E27FC236}">
-                <a16:creationId xmlns:a16="http://schemas.microsoft.com/office/drawing/2014/main" id="{79285C56-49F7-4A42-B644-B32941F2B6CC}"/>
+          <p:cNvPr id="5" name="Group 4">
+            <a:extLst>
+              <a:ext uri="{FF2B5EF4-FFF2-40B4-BE49-F238E27FC236}">
+                <a16:creationId xmlns:a16="http://schemas.microsoft.com/office/drawing/2014/main" id="{F6595D03-EB6E-3E3E-BD60-5E2D5286FCE4}"/>
               </a:ext>
             </a:extLst>
           </p:cNvPr>
@@ -12015,8 +12212,8 @@
           </p:nvSpPr>
           <p:spPr>
             <a:xfrm>
-              <a:off x="564471" y="4402744"/>
-              <a:ext cx="8726283" cy="1216301"/>
+              <a:off x="519315" y="4402744"/>
+              <a:ext cx="4413929" cy="1216301"/>
             </a:xfrm>
             <a:prstGeom prst="roundRect">
               <a:avLst>
@@ -12074,7 +12271,7 @@
           <p:spPr>
             <a:xfrm>
               <a:off x="558779" y="2753115"/>
-              <a:ext cx="8726283" cy="1216301"/>
+              <a:ext cx="7772421" cy="1216301"/>
             </a:xfrm>
             <a:prstGeom prst="roundRect">
               <a:avLst>
@@ -12825,6 +13022,64 @@
                 <a:rPr lang="en-US" dirty="0"/>
                 <a:t>B16</a:t>
               </a:r>
+            </a:p>
+          </p:txBody>
+        </p:sp>
+        <p:sp>
+          <p:nvSpPr>
+            <p:cNvPr id="4" name="Rounded Rectangle 3">
+              <a:extLst>
+                <a:ext uri="{FF2B5EF4-FFF2-40B4-BE49-F238E27FC236}">
+                  <a16:creationId xmlns:a16="http://schemas.microsoft.com/office/drawing/2014/main" id="{3761E35C-EBFD-3737-12A0-192593EF7A58}"/>
+                </a:ext>
+              </a:extLst>
+            </p:cNvPr>
+            <p:cNvSpPr/>
+            <p:nvPr/>
+          </p:nvSpPr>
+          <p:spPr>
+            <a:xfrm>
+              <a:off x="5015752" y="4361056"/>
+              <a:ext cx="4413929" cy="1216301"/>
+            </a:xfrm>
+            <a:prstGeom prst="roundRect">
+              <a:avLst>
+                <a:gd name="adj" fmla="val 36591"/>
+              </a:avLst>
+            </a:prstGeom>
+            <a:solidFill>
+              <a:srgbClr val="00B0F0">
+                <a:alpha val="25714"/>
+              </a:srgbClr>
+            </a:solidFill>
+            <a:ln w="34925">
+              <a:solidFill>
+                <a:srgbClr val="0070C0"/>
+              </a:solidFill>
+            </a:ln>
+          </p:spPr>
+          <p:style>
+            <a:lnRef idx="2">
+              <a:schemeClr val="accent1">
+                <a:shade val="15000"/>
+              </a:schemeClr>
+            </a:lnRef>
+            <a:fillRef idx="1">
+              <a:schemeClr val="accent1"/>
+            </a:fillRef>
+            <a:effectRef idx="0">
+              <a:schemeClr val="accent1"/>
+            </a:effectRef>
+            <a:fontRef idx="minor">
+              <a:schemeClr val="lt1"/>
+            </a:fontRef>
+          </p:style>
+          <p:txBody>
+            <a:bodyPr rtlCol="0" anchor="ctr"/>
+            <a:lstStyle/>
+            <a:p>
+              <a:pPr algn="ctr"/>
+              <a:endParaRPr lang="en-US"/>
             </a:p>
           </p:txBody>
         </p:sp>
@@ -12867,10 +13122,10 @@
       </p:grpSpPr>
       <p:grpSp>
         <p:nvGrpSpPr>
-          <p:cNvPr id="238" name="Group 237">
-            <a:extLst>
-              <a:ext uri="{FF2B5EF4-FFF2-40B4-BE49-F238E27FC236}">
-                <a16:creationId xmlns:a16="http://schemas.microsoft.com/office/drawing/2014/main" id="{B52557F3-EB90-2A9C-43C7-ABD8A4B9D17D}"/>
+          <p:cNvPr id="4" name="Group 3">
+            <a:extLst>
+              <a:ext uri="{FF2B5EF4-FFF2-40B4-BE49-F238E27FC236}">
+                <a16:creationId xmlns:a16="http://schemas.microsoft.com/office/drawing/2014/main" id="{1A4A71B0-9642-F627-57C5-ED44E2AD9A09}"/>
               </a:ext>
             </a:extLst>
           </p:cNvPr>
@@ -12954,8 +13209,8 @@
           </p:nvSpPr>
           <p:spPr>
             <a:xfrm>
-              <a:off x="634029" y="1367293"/>
-              <a:ext cx="8964403" cy="2097152"/>
+              <a:off x="667897" y="1373741"/>
+              <a:ext cx="7791352" cy="2097152"/>
             </a:xfrm>
             <a:prstGeom prst="roundRect">
               <a:avLst>
@@ -13012,8 +13267,8 @@
           </p:nvSpPr>
           <p:spPr>
             <a:xfrm>
-              <a:off x="634029" y="3635462"/>
-              <a:ext cx="8964403" cy="2097152"/>
+              <a:off x="667897" y="3635462"/>
+              <a:ext cx="4420820" cy="2097152"/>
             </a:xfrm>
             <a:prstGeom prst="roundRect">
               <a:avLst>
@@ -13223,7 +13478,7 @@
           </p:blipFill>
           <p:spPr>
             <a:xfrm>
-              <a:off x="5307934" y="3977496"/>
+              <a:off x="5375668" y="3977496"/>
               <a:ext cx="634696" cy="634696"/>
             </a:xfrm>
             <a:prstGeom prst="rect">
@@ -13258,7 +13513,7 @@
           </p:blipFill>
           <p:spPr>
             <a:xfrm>
-              <a:off x="6373766" y="3977496"/>
+              <a:off x="6441500" y="3977496"/>
               <a:ext cx="634696" cy="634696"/>
             </a:xfrm>
             <a:prstGeom prst="rect">
@@ -13293,7 +13548,7 @@
           </p:blipFill>
           <p:spPr>
             <a:xfrm>
-              <a:off x="7483099" y="3977496"/>
+              <a:off x="7550833" y="3977496"/>
               <a:ext cx="634696" cy="634696"/>
             </a:xfrm>
             <a:prstGeom prst="rect">
@@ -13328,7 +13583,7 @@
           </p:blipFill>
           <p:spPr>
             <a:xfrm>
-              <a:off x="8548931" y="3977496"/>
+              <a:off x="8616665" y="3977496"/>
               <a:ext cx="634696" cy="634696"/>
             </a:xfrm>
             <a:prstGeom prst="rect">
@@ -13490,7 +13745,7 @@
           </p:nvSpPr>
           <p:spPr>
             <a:xfrm>
-              <a:off x="5353803" y="3827569"/>
+              <a:off x="5421537" y="3827569"/>
               <a:ext cx="570990" cy="369332"/>
             </a:xfrm>
             <a:prstGeom prst="rect">
@@ -13525,7 +13780,7 @@
           </p:nvSpPr>
           <p:spPr>
             <a:xfrm>
-              <a:off x="6415608" y="3827569"/>
+              <a:off x="6483342" y="3827569"/>
               <a:ext cx="570990" cy="369332"/>
             </a:xfrm>
             <a:prstGeom prst="rect">
@@ -13560,7 +13815,7 @@
           </p:nvSpPr>
           <p:spPr>
             <a:xfrm>
-              <a:off x="7482268" y="3827569"/>
+              <a:off x="7550002" y="3827569"/>
               <a:ext cx="570990" cy="369332"/>
             </a:xfrm>
             <a:prstGeom prst="rect">
@@ -13595,7 +13850,7 @@
           </p:nvSpPr>
           <p:spPr>
             <a:xfrm>
-              <a:off x="8571828" y="3827569"/>
+              <a:off x="8639562" y="3827569"/>
               <a:ext cx="570990" cy="369332"/>
             </a:xfrm>
             <a:prstGeom prst="rect">
@@ -13777,7 +14032,7 @@
           </p:nvSpPr>
           <p:spPr>
             <a:xfrm rot="16200000">
-              <a:off x="6506447" y="4161658"/>
+              <a:off x="6574181" y="4161658"/>
               <a:ext cx="369333" cy="901063"/>
             </a:xfrm>
             <a:prstGeom prst="leftBracket">
@@ -13826,7 +14081,7 @@
           </p:nvSpPr>
           <p:spPr>
             <a:xfrm rot="16200000">
-              <a:off x="8725114" y="4161658"/>
+              <a:off x="8792848" y="4161658"/>
               <a:ext cx="369333" cy="901063"/>
             </a:xfrm>
             <a:prstGeom prst="leftBracket">
@@ -13961,7 +14216,7 @@
           </p:blipFill>
           <p:spPr>
             <a:xfrm>
-              <a:off x="6382675" y="4851763"/>
+              <a:off x="6450409" y="4851763"/>
               <a:ext cx="636856" cy="636856"/>
             </a:xfrm>
             <a:prstGeom prst="rect">
@@ -14033,7 +14288,7 @@
           </p:blipFill>
           <p:spPr>
             <a:xfrm>
-              <a:off x="8591352" y="4842814"/>
+              <a:off x="8659086" y="4842814"/>
               <a:ext cx="636856" cy="636856"/>
             </a:xfrm>
             <a:prstGeom prst="rect">
@@ -15212,11 +15467,1997 @@
             </a:prstGeom>
           </p:spPr>
         </p:pic>
+        <p:sp>
+          <p:nvSpPr>
+            <p:cNvPr id="2" name="Rounded Rectangle 1">
+              <a:extLst>
+                <a:ext uri="{FF2B5EF4-FFF2-40B4-BE49-F238E27FC236}">
+                  <a16:creationId xmlns:a16="http://schemas.microsoft.com/office/drawing/2014/main" id="{9F7A5CA0-D1B4-5B79-524D-9ED242F9E643}"/>
+                </a:ext>
+              </a:extLst>
+            </p:cNvPr>
+            <p:cNvSpPr/>
+            <p:nvPr/>
+          </p:nvSpPr>
+          <p:spPr>
+            <a:xfrm>
+              <a:off x="5255767" y="3614372"/>
+              <a:ext cx="4305899" cy="2097152"/>
+            </a:xfrm>
+            <a:prstGeom prst="roundRect">
+              <a:avLst>
+                <a:gd name="adj" fmla="val 21519"/>
+              </a:avLst>
+            </a:prstGeom>
+            <a:solidFill>
+              <a:srgbClr val="00B0F0">
+                <a:alpha val="25714"/>
+              </a:srgbClr>
+            </a:solidFill>
+            <a:ln w="34925">
+              <a:solidFill>
+                <a:srgbClr val="0070C0"/>
+              </a:solidFill>
+            </a:ln>
+          </p:spPr>
+          <p:style>
+            <a:lnRef idx="2">
+              <a:schemeClr val="accent1">
+                <a:shade val="15000"/>
+              </a:schemeClr>
+            </a:lnRef>
+            <a:fillRef idx="1">
+              <a:schemeClr val="accent1"/>
+            </a:fillRef>
+            <a:effectRef idx="0">
+              <a:schemeClr val="accent1"/>
+            </a:effectRef>
+            <a:fontRef idx="minor">
+              <a:schemeClr val="lt1"/>
+            </a:fontRef>
+          </p:style>
+          <p:txBody>
+            <a:bodyPr rtlCol="0" anchor="ctr"/>
+            <a:lstStyle/>
+            <a:p>
+              <a:pPr algn="ctr"/>
+              <a:endParaRPr lang="en-US"/>
+            </a:p>
+          </p:txBody>
+        </p:sp>
       </p:grpSp>
     </p:spTree>
     <p:extLst>
       <p:ext uri="{BB962C8B-B14F-4D97-AF65-F5344CB8AC3E}">
         <p14:creationId xmlns:p14="http://schemas.microsoft.com/office/powerpoint/2010/main" val="1764696701"/>
+      </p:ext>
+    </p:extLst>
+  </p:cSld>
+  <p:clrMapOvr>
+    <a:masterClrMapping/>
+  </p:clrMapOvr>
+</p:sld>
+</file>
+
+<file path=ppt/slides/slide7.xml><?xml version="1.0" encoding="utf-8"?>
+<p:sld xmlns:a="http://schemas.openxmlformats.org/drawingml/2006/main" xmlns:r="http://schemas.openxmlformats.org/officeDocument/2006/relationships" xmlns:p="http://schemas.openxmlformats.org/presentationml/2006/main">
+  <p:cSld>
+    <p:spTree>
+      <p:nvGrpSpPr>
+        <p:cNvPr id="1" name="">
+          <a:extLst>
+            <a:ext uri="{FF2B5EF4-FFF2-40B4-BE49-F238E27FC236}">
+              <a16:creationId xmlns:a16="http://schemas.microsoft.com/office/drawing/2014/main" id="{7C29DA9A-4AEF-F740-D1B1-0661DC705954}"/>
+            </a:ext>
+          </a:extLst>
+        </p:cNvPr>
+        <p:cNvGrpSpPr/>
+        <p:nvPr/>
+      </p:nvGrpSpPr>
+      <p:grpSpPr>
+        <a:xfrm>
+          <a:off x="0" y="0"/>
+          <a:ext cx="0" cy="0"/>
+          <a:chOff x="0" y="0"/>
+          <a:chExt cx="0" cy="0"/>
+        </a:xfrm>
+      </p:grpSpPr>
+      <p:grpSp>
+        <p:nvGrpSpPr>
+          <p:cNvPr id="151" name="Group 150">
+            <a:extLst>
+              <a:ext uri="{FF2B5EF4-FFF2-40B4-BE49-F238E27FC236}">
+                <a16:creationId xmlns:a16="http://schemas.microsoft.com/office/drawing/2014/main" id="{FEFE4444-288E-9F92-35A8-814AA1E39F34}"/>
+              </a:ext>
+            </a:extLst>
+          </p:cNvPr>
+          <p:cNvGrpSpPr/>
+          <p:nvPr/>
+        </p:nvGrpSpPr>
+        <p:grpSpPr>
+          <a:xfrm>
+            <a:off x="84476" y="371799"/>
+            <a:ext cx="16750422" cy="2107707"/>
+            <a:chOff x="84476" y="371799"/>
+            <a:chExt cx="16750422" cy="2107707"/>
+          </a:xfrm>
+        </p:grpSpPr>
+        <p:sp>
+          <p:nvSpPr>
+            <p:cNvPr id="113" name="Rounded Rectangle 112">
+              <a:extLst>
+                <a:ext uri="{FF2B5EF4-FFF2-40B4-BE49-F238E27FC236}">
+                  <a16:creationId xmlns:a16="http://schemas.microsoft.com/office/drawing/2014/main" id="{A1540FC9-4ADD-FA5C-B4EC-26C61119D191}"/>
+                </a:ext>
+              </a:extLst>
+            </p:cNvPr>
+            <p:cNvSpPr/>
+            <p:nvPr/>
+          </p:nvSpPr>
+          <p:spPr>
+            <a:xfrm>
+              <a:off x="84476" y="371799"/>
+              <a:ext cx="7791352" cy="2097152"/>
+            </a:xfrm>
+            <a:prstGeom prst="roundRect">
+              <a:avLst>
+                <a:gd name="adj" fmla="val 21519"/>
+              </a:avLst>
+            </a:prstGeom>
+            <a:solidFill>
+              <a:srgbClr val="00B0F0">
+                <a:alpha val="25714"/>
+              </a:srgbClr>
+            </a:solidFill>
+            <a:ln w="34925">
+              <a:solidFill>
+                <a:srgbClr val="0070C0"/>
+              </a:solidFill>
+            </a:ln>
+          </p:spPr>
+          <p:style>
+            <a:lnRef idx="2">
+              <a:schemeClr val="accent1">
+                <a:shade val="15000"/>
+              </a:schemeClr>
+            </a:lnRef>
+            <a:fillRef idx="1">
+              <a:schemeClr val="accent1"/>
+            </a:fillRef>
+            <a:effectRef idx="0">
+              <a:schemeClr val="accent1"/>
+            </a:effectRef>
+            <a:fontRef idx="minor">
+              <a:schemeClr val="lt1"/>
+            </a:fontRef>
+          </p:style>
+          <p:txBody>
+            <a:bodyPr rtlCol="0" anchor="ctr"/>
+            <a:lstStyle/>
+            <a:p>
+              <a:pPr algn="ctr"/>
+              <a:endParaRPr lang="en-US"/>
+            </a:p>
+          </p:txBody>
+        </p:sp>
+        <p:pic>
+          <p:nvPicPr>
+            <p:cNvPr id="87" name="Graphic 86" descr="Bed with solid fill">
+              <a:extLst>
+                <a:ext uri="{FF2B5EF4-FFF2-40B4-BE49-F238E27FC236}">
+                  <a16:creationId xmlns:a16="http://schemas.microsoft.com/office/drawing/2014/main" id="{9386ABEC-692D-DC16-8CE3-86DB51B9C38A}"/>
+                </a:ext>
+              </a:extLst>
+            </p:cNvPr>
+            <p:cNvPicPr>
+              <a:picLocks noChangeAspect="1"/>
+            </p:cNvPicPr>
+            <p:nvPr/>
+          </p:nvPicPr>
+          <p:blipFill>
+            <a:blip>
+              <a:extLst>
+                <a:ext uri="{96DAC541-7B7A-43D3-8B79-37D633B846F1}">
+                  <asvg:svgBlip xmlns:asvg="http://schemas.microsoft.com/office/drawing/2016/SVG/main" r:embed="rId3"/>
+                </a:ext>
+              </a:extLst>
+            </a:blip>
+            <a:srcRect/>
+            <a:stretch/>
+          </p:blipFill>
+          <p:spPr>
+            <a:xfrm>
+              <a:off x="364115" y="707385"/>
+              <a:ext cx="634696" cy="634696"/>
+            </a:xfrm>
+            <a:prstGeom prst="rect">
+              <a:avLst/>
+            </a:prstGeom>
+          </p:spPr>
+        </p:pic>
+        <p:pic>
+          <p:nvPicPr>
+            <p:cNvPr id="88" name="Graphic 87" descr="Sleep with solid fill">
+              <a:extLst>
+                <a:ext uri="{FF2B5EF4-FFF2-40B4-BE49-F238E27FC236}">
+                  <a16:creationId xmlns:a16="http://schemas.microsoft.com/office/drawing/2014/main" id="{ACA9114A-50E6-3F9C-30AA-3DBF656020E9}"/>
+                </a:ext>
+              </a:extLst>
+            </p:cNvPr>
+            <p:cNvPicPr>
+              <a:picLocks noChangeAspect="1"/>
+            </p:cNvPicPr>
+            <p:nvPr/>
+          </p:nvPicPr>
+          <p:blipFill>
+            <a:blip>
+              <a:extLst>
+                <a:ext uri="{96DAC541-7B7A-43D3-8B79-37D633B846F1}">
+                  <asvg:svgBlip xmlns:asvg="http://schemas.microsoft.com/office/drawing/2016/SVG/main" r:embed="rId4"/>
+                </a:ext>
+              </a:extLst>
+            </a:blip>
+            <a:srcRect/>
+            <a:stretch/>
+          </p:blipFill>
+          <p:spPr>
+            <a:xfrm>
+              <a:off x="1429947" y="707385"/>
+              <a:ext cx="634696" cy="634696"/>
+            </a:xfrm>
+            <a:prstGeom prst="rect">
+              <a:avLst/>
+            </a:prstGeom>
+          </p:spPr>
+        </p:pic>
+        <p:pic>
+          <p:nvPicPr>
+            <p:cNvPr id="89" name="Graphic 88" descr="Sleep with solid fill">
+              <a:extLst>
+                <a:ext uri="{FF2B5EF4-FFF2-40B4-BE49-F238E27FC236}">
+                  <a16:creationId xmlns:a16="http://schemas.microsoft.com/office/drawing/2014/main" id="{7DE5CD83-1C46-15D6-E3D4-8B78B0E9C2D4}"/>
+                </a:ext>
+              </a:extLst>
+            </p:cNvPr>
+            <p:cNvPicPr>
+              <a:picLocks noChangeAspect="1"/>
+            </p:cNvPicPr>
+            <p:nvPr/>
+          </p:nvPicPr>
+          <p:blipFill>
+            <a:blip>
+              <a:extLst>
+                <a:ext uri="{96DAC541-7B7A-43D3-8B79-37D633B846F1}">
+                  <asvg:svgBlip xmlns:asvg="http://schemas.microsoft.com/office/drawing/2016/SVG/main" r:embed="rId5"/>
+                </a:ext>
+              </a:extLst>
+            </a:blip>
+            <a:srcRect/>
+            <a:stretch/>
+          </p:blipFill>
+          <p:spPr>
+            <a:xfrm>
+              <a:off x="2539280" y="707385"/>
+              <a:ext cx="634696" cy="634696"/>
+            </a:xfrm>
+            <a:prstGeom prst="rect">
+              <a:avLst/>
+            </a:prstGeom>
+          </p:spPr>
+        </p:pic>
+        <p:pic>
+          <p:nvPicPr>
+            <p:cNvPr id="90" name="Graphic 89" descr="Sleep with solid fill">
+              <a:extLst>
+                <a:ext uri="{FF2B5EF4-FFF2-40B4-BE49-F238E27FC236}">
+                  <a16:creationId xmlns:a16="http://schemas.microsoft.com/office/drawing/2014/main" id="{3DBDBF98-3A79-BE94-10D9-3224403209C6}"/>
+                </a:ext>
+              </a:extLst>
+            </p:cNvPr>
+            <p:cNvPicPr>
+              <a:picLocks noChangeAspect="1"/>
+            </p:cNvPicPr>
+            <p:nvPr/>
+          </p:nvPicPr>
+          <p:blipFill>
+            <a:blip>
+              <a:extLst>
+                <a:ext uri="{96DAC541-7B7A-43D3-8B79-37D633B846F1}">
+                  <asvg:svgBlip xmlns:asvg="http://schemas.microsoft.com/office/drawing/2016/SVG/main" r:embed="rId5"/>
+                </a:ext>
+              </a:extLst>
+            </a:blip>
+            <a:srcRect/>
+            <a:stretch/>
+          </p:blipFill>
+          <p:spPr>
+            <a:xfrm>
+              <a:off x="3605112" y="707385"/>
+              <a:ext cx="634696" cy="634696"/>
+            </a:xfrm>
+            <a:prstGeom prst="rect">
+              <a:avLst/>
+            </a:prstGeom>
+          </p:spPr>
+        </p:pic>
+        <p:pic>
+          <p:nvPicPr>
+            <p:cNvPr id="91" name="Graphic 90" descr="Bed with solid fill">
+              <a:extLst>
+                <a:ext uri="{FF2B5EF4-FFF2-40B4-BE49-F238E27FC236}">
+                  <a16:creationId xmlns:a16="http://schemas.microsoft.com/office/drawing/2014/main" id="{6A3E6F40-46C5-104D-FC8F-7013A1D557AE}"/>
+                </a:ext>
+              </a:extLst>
+            </p:cNvPr>
+            <p:cNvPicPr>
+              <a:picLocks noChangeAspect="1"/>
+            </p:cNvPicPr>
+            <p:nvPr/>
+          </p:nvPicPr>
+          <p:blipFill>
+            <a:blip>
+              <a:extLst>
+                <a:ext uri="{96DAC541-7B7A-43D3-8B79-37D633B846F1}">
+                  <asvg:svgBlip xmlns:asvg="http://schemas.microsoft.com/office/drawing/2016/SVG/main" r:embed="rId3"/>
+                </a:ext>
+              </a:extLst>
+            </a:blip>
+            <a:srcRect/>
+            <a:stretch/>
+          </p:blipFill>
+          <p:spPr>
+            <a:xfrm>
+              <a:off x="4724513" y="707385"/>
+              <a:ext cx="634696" cy="634696"/>
+            </a:xfrm>
+            <a:prstGeom prst="rect">
+              <a:avLst/>
+            </a:prstGeom>
+          </p:spPr>
+        </p:pic>
+        <p:pic>
+          <p:nvPicPr>
+            <p:cNvPr id="92" name="Graphic 91" descr="Sleep with solid fill">
+              <a:extLst>
+                <a:ext uri="{FF2B5EF4-FFF2-40B4-BE49-F238E27FC236}">
+                  <a16:creationId xmlns:a16="http://schemas.microsoft.com/office/drawing/2014/main" id="{A2CBB878-C5EA-7016-C24D-469F11982FF3}"/>
+                </a:ext>
+              </a:extLst>
+            </p:cNvPr>
+            <p:cNvPicPr>
+              <a:picLocks noChangeAspect="1"/>
+            </p:cNvPicPr>
+            <p:nvPr/>
+          </p:nvPicPr>
+          <p:blipFill>
+            <a:blip>
+              <a:extLst>
+                <a:ext uri="{96DAC541-7B7A-43D3-8B79-37D633B846F1}">
+                  <asvg:svgBlip xmlns:asvg="http://schemas.microsoft.com/office/drawing/2016/SVG/main" r:embed="rId6"/>
+                </a:ext>
+              </a:extLst>
+            </a:blip>
+            <a:srcRect/>
+            <a:stretch/>
+          </p:blipFill>
+          <p:spPr>
+            <a:xfrm>
+              <a:off x="5790345" y="707385"/>
+              <a:ext cx="634696" cy="634696"/>
+            </a:xfrm>
+            <a:prstGeom prst="rect">
+              <a:avLst/>
+            </a:prstGeom>
+          </p:spPr>
+        </p:pic>
+        <p:pic>
+          <p:nvPicPr>
+            <p:cNvPr id="93" name="Graphic 92" descr="Sleep with solid fill">
+              <a:extLst>
+                <a:ext uri="{FF2B5EF4-FFF2-40B4-BE49-F238E27FC236}">
+                  <a16:creationId xmlns:a16="http://schemas.microsoft.com/office/drawing/2014/main" id="{64EEB7D8-0889-631D-27B0-BC3E38B61367}"/>
+                </a:ext>
+              </a:extLst>
+            </p:cNvPr>
+            <p:cNvPicPr>
+              <a:picLocks noChangeAspect="1"/>
+            </p:cNvPicPr>
+            <p:nvPr/>
+          </p:nvPicPr>
+          <p:blipFill>
+            <a:blip>
+              <a:extLst>
+                <a:ext uri="{96DAC541-7B7A-43D3-8B79-37D633B846F1}">
+                  <asvg:svgBlip xmlns:asvg="http://schemas.microsoft.com/office/drawing/2016/SVG/main" r:embed="rId7"/>
+                </a:ext>
+              </a:extLst>
+            </a:blip>
+            <a:srcRect/>
+            <a:stretch/>
+          </p:blipFill>
+          <p:spPr>
+            <a:xfrm>
+              <a:off x="6899678" y="707385"/>
+              <a:ext cx="634696" cy="634696"/>
+            </a:xfrm>
+            <a:prstGeom prst="rect">
+              <a:avLst/>
+            </a:prstGeom>
+          </p:spPr>
+        </p:pic>
+        <p:sp>
+          <p:nvSpPr>
+            <p:cNvPr id="95" name="TextBox 94">
+              <a:extLst>
+                <a:ext uri="{FF2B5EF4-FFF2-40B4-BE49-F238E27FC236}">
+                  <a16:creationId xmlns:a16="http://schemas.microsoft.com/office/drawing/2014/main" id="{C824215A-B707-C9E4-B869-D290CF992198}"/>
+                </a:ext>
+              </a:extLst>
+            </p:cNvPr>
+            <p:cNvSpPr txBox="1"/>
+            <p:nvPr/>
+          </p:nvSpPr>
+          <p:spPr>
+            <a:xfrm>
+              <a:off x="432563" y="552869"/>
+              <a:ext cx="570990" cy="369332"/>
+            </a:xfrm>
+            <a:prstGeom prst="rect">
+              <a:avLst/>
+            </a:prstGeom>
+            <a:noFill/>
+          </p:spPr>
+          <p:txBody>
+            <a:bodyPr wrap="none" rtlCol="0">
+              <a:spAutoFit/>
+            </a:bodyPr>
+            <a:lstStyle/>
+            <a:p>
+              <a:r>
+                <a:rPr lang="en-US" dirty="0"/>
+                <a:t>B08</a:t>
+              </a:r>
+            </a:p>
+          </p:txBody>
+        </p:sp>
+        <p:sp>
+          <p:nvSpPr>
+            <p:cNvPr id="96" name="TextBox 95">
+              <a:extLst>
+                <a:ext uri="{FF2B5EF4-FFF2-40B4-BE49-F238E27FC236}">
+                  <a16:creationId xmlns:a16="http://schemas.microsoft.com/office/drawing/2014/main" id="{BFC54B12-C692-C3CD-B236-6FC8526CD127}"/>
+                </a:ext>
+              </a:extLst>
+            </p:cNvPr>
+            <p:cNvSpPr txBox="1"/>
+            <p:nvPr/>
+          </p:nvSpPr>
+          <p:spPr>
+            <a:xfrm>
+              <a:off x="1494368" y="552869"/>
+              <a:ext cx="570990" cy="369332"/>
+            </a:xfrm>
+            <a:prstGeom prst="rect">
+              <a:avLst/>
+            </a:prstGeom>
+            <a:noFill/>
+          </p:spPr>
+          <p:txBody>
+            <a:bodyPr wrap="none" rtlCol="0">
+              <a:spAutoFit/>
+            </a:bodyPr>
+            <a:lstStyle/>
+            <a:p>
+              <a:r>
+                <a:rPr lang="en-US" dirty="0"/>
+                <a:t>B09</a:t>
+              </a:r>
+            </a:p>
+          </p:txBody>
+        </p:sp>
+        <p:sp>
+          <p:nvSpPr>
+            <p:cNvPr id="97" name="TextBox 96">
+              <a:extLst>
+                <a:ext uri="{FF2B5EF4-FFF2-40B4-BE49-F238E27FC236}">
+                  <a16:creationId xmlns:a16="http://schemas.microsoft.com/office/drawing/2014/main" id="{C210A5F0-2679-8FA5-1250-14A64408EBFF}"/>
+                </a:ext>
+              </a:extLst>
+            </p:cNvPr>
+            <p:cNvSpPr txBox="1"/>
+            <p:nvPr/>
+          </p:nvSpPr>
+          <p:spPr>
+            <a:xfrm>
+              <a:off x="2561028" y="552869"/>
+              <a:ext cx="570990" cy="369332"/>
+            </a:xfrm>
+            <a:prstGeom prst="rect">
+              <a:avLst/>
+            </a:prstGeom>
+            <a:noFill/>
+          </p:spPr>
+          <p:txBody>
+            <a:bodyPr wrap="none" rtlCol="0">
+              <a:spAutoFit/>
+            </a:bodyPr>
+            <a:lstStyle/>
+            <a:p>
+              <a:r>
+                <a:rPr lang="en-US" dirty="0"/>
+                <a:t>B10</a:t>
+              </a:r>
+            </a:p>
+          </p:txBody>
+        </p:sp>
+        <p:sp>
+          <p:nvSpPr>
+            <p:cNvPr id="98" name="TextBox 97">
+              <a:extLst>
+                <a:ext uri="{FF2B5EF4-FFF2-40B4-BE49-F238E27FC236}">
+                  <a16:creationId xmlns:a16="http://schemas.microsoft.com/office/drawing/2014/main" id="{6A98972F-F41D-8BD9-BBC9-C1C4A8A2A62E}"/>
+                </a:ext>
+              </a:extLst>
+            </p:cNvPr>
+            <p:cNvSpPr txBox="1"/>
+            <p:nvPr/>
+          </p:nvSpPr>
+          <p:spPr>
+            <a:xfrm>
+              <a:off x="3650588" y="552869"/>
+              <a:ext cx="570990" cy="369332"/>
+            </a:xfrm>
+            <a:prstGeom prst="rect">
+              <a:avLst/>
+            </a:prstGeom>
+            <a:noFill/>
+          </p:spPr>
+          <p:txBody>
+            <a:bodyPr wrap="none" rtlCol="0">
+              <a:spAutoFit/>
+            </a:bodyPr>
+            <a:lstStyle/>
+            <a:p>
+              <a:r>
+                <a:rPr lang="en-US" dirty="0"/>
+                <a:t>B11</a:t>
+              </a:r>
+            </a:p>
+          </p:txBody>
+        </p:sp>
+        <p:sp>
+          <p:nvSpPr>
+            <p:cNvPr id="99" name="TextBox 98">
+              <a:extLst>
+                <a:ext uri="{FF2B5EF4-FFF2-40B4-BE49-F238E27FC236}">
+                  <a16:creationId xmlns:a16="http://schemas.microsoft.com/office/drawing/2014/main" id="{F1E2729E-D7BA-7607-952E-0FF750B6D6AC}"/>
+                </a:ext>
+              </a:extLst>
+            </p:cNvPr>
+            <p:cNvSpPr txBox="1"/>
+            <p:nvPr/>
+          </p:nvSpPr>
+          <p:spPr>
+            <a:xfrm>
+              <a:off x="4770382" y="557458"/>
+              <a:ext cx="570990" cy="369332"/>
+            </a:xfrm>
+            <a:prstGeom prst="rect">
+              <a:avLst/>
+            </a:prstGeom>
+            <a:noFill/>
+          </p:spPr>
+          <p:txBody>
+            <a:bodyPr wrap="none" rtlCol="0">
+              <a:spAutoFit/>
+            </a:bodyPr>
+            <a:lstStyle/>
+            <a:p>
+              <a:r>
+                <a:rPr lang="en-US" dirty="0"/>
+                <a:t>B12</a:t>
+              </a:r>
+            </a:p>
+          </p:txBody>
+        </p:sp>
+        <p:sp>
+          <p:nvSpPr>
+            <p:cNvPr id="100" name="TextBox 99">
+              <a:extLst>
+                <a:ext uri="{FF2B5EF4-FFF2-40B4-BE49-F238E27FC236}">
+                  <a16:creationId xmlns:a16="http://schemas.microsoft.com/office/drawing/2014/main" id="{8A72836C-15DC-874D-45B2-5AAFC07F9060}"/>
+                </a:ext>
+              </a:extLst>
+            </p:cNvPr>
+            <p:cNvSpPr txBox="1"/>
+            <p:nvPr/>
+          </p:nvSpPr>
+          <p:spPr>
+            <a:xfrm>
+              <a:off x="5832187" y="557458"/>
+              <a:ext cx="570990" cy="369332"/>
+            </a:xfrm>
+            <a:prstGeom prst="rect">
+              <a:avLst/>
+            </a:prstGeom>
+            <a:noFill/>
+          </p:spPr>
+          <p:txBody>
+            <a:bodyPr wrap="none" rtlCol="0">
+              <a:spAutoFit/>
+            </a:bodyPr>
+            <a:lstStyle/>
+            <a:p>
+              <a:r>
+                <a:rPr lang="en-US" dirty="0"/>
+                <a:t>B13</a:t>
+              </a:r>
+            </a:p>
+          </p:txBody>
+        </p:sp>
+        <p:sp>
+          <p:nvSpPr>
+            <p:cNvPr id="101" name="TextBox 100">
+              <a:extLst>
+                <a:ext uri="{FF2B5EF4-FFF2-40B4-BE49-F238E27FC236}">
+                  <a16:creationId xmlns:a16="http://schemas.microsoft.com/office/drawing/2014/main" id="{0DB17C08-71EF-190D-507B-A75ACA877BB6}"/>
+                </a:ext>
+              </a:extLst>
+            </p:cNvPr>
+            <p:cNvSpPr txBox="1"/>
+            <p:nvPr/>
+          </p:nvSpPr>
+          <p:spPr>
+            <a:xfrm>
+              <a:off x="6898847" y="557458"/>
+              <a:ext cx="570990" cy="369332"/>
+            </a:xfrm>
+            <a:prstGeom prst="rect">
+              <a:avLst/>
+            </a:prstGeom>
+            <a:noFill/>
+          </p:spPr>
+          <p:txBody>
+            <a:bodyPr wrap="none" rtlCol="0">
+              <a:spAutoFit/>
+            </a:bodyPr>
+            <a:lstStyle/>
+            <a:p>
+              <a:r>
+                <a:rPr lang="en-US" dirty="0"/>
+                <a:t>B14</a:t>
+              </a:r>
+            </a:p>
+          </p:txBody>
+        </p:sp>
+        <p:sp>
+          <p:nvSpPr>
+            <p:cNvPr id="103" name="Left Bracket 102">
+              <a:extLst>
+                <a:ext uri="{FF2B5EF4-FFF2-40B4-BE49-F238E27FC236}">
+                  <a16:creationId xmlns:a16="http://schemas.microsoft.com/office/drawing/2014/main" id="{A170DE1D-421D-2C53-6861-877010554EFC}"/>
+                </a:ext>
+              </a:extLst>
+            </p:cNvPr>
+            <p:cNvSpPr/>
+            <p:nvPr/>
+          </p:nvSpPr>
+          <p:spPr>
+            <a:xfrm rot="16200000">
+              <a:off x="3199409" y="324153"/>
+              <a:ext cx="369333" cy="2035851"/>
+            </a:xfrm>
+            <a:prstGeom prst="leftBracket">
+              <a:avLst/>
+            </a:prstGeom>
+            <a:ln w="25400">
+              <a:solidFill>
+                <a:schemeClr val="tx1"/>
+              </a:solidFill>
+            </a:ln>
+          </p:spPr>
+          <p:style>
+            <a:lnRef idx="2">
+              <a:schemeClr val="accent1"/>
+            </a:lnRef>
+            <a:fillRef idx="0">
+              <a:schemeClr val="accent1"/>
+            </a:fillRef>
+            <a:effectRef idx="1">
+              <a:schemeClr val="accent1"/>
+            </a:effectRef>
+            <a:fontRef idx="minor">
+              <a:schemeClr val="tx1"/>
+            </a:fontRef>
+          </p:style>
+          <p:txBody>
+            <a:bodyPr rtlCol="0" anchor="ctr"/>
+            <a:lstStyle/>
+            <a:p>
+              <a:pPr algn="ctr"/>
+              <a:endParaRPr lang="en-US"/>
+            </a:p>
+          </p:txBody>
+        </p:sp>
+        <p:sp>
+          <p:nvSpPr>
+            <p:cNvPr id="104" name="Left Bracket 103">
+              <a:extLst>
+                <a:ext uri="{FF2B5EF4-FFF2-40B4-BE49-F238E27FC236}">
+                  <a16:creationId xmlns:a16="http://schemas.microsoft.com/office/drawing/2014/main" id="{05921564-1889-9429-8749-01ADFF536291}"/>
+                </a:ext>
+              </a:extLst>
+            </p:cNvPr>
+            <p:cNvSpPr/>
+            <p:nvPr/>
+          </p:nvSpPr>
+          <p:spPr>
+            <a:xfrm rot="16200000">
+              <a:off x="1566183" y="891547"/>
+              <a:ext cx="369333" cy="901063"/>
+            </a:xfrm>
+            <a:prstGeom prst="leftBracket">
+              <a:avLst/>
+            </a:prstGeom>
+            <a:ln w="25400">
+              <a:solidFill>
+                <a:schemeClr val="tx1"/>
+              </a:solidFill>
+            </a:ln>
+          </p:spPr>
+          <p:style>
+            <a:lnRef idx="2">
+              <a:schemeClr val="accent1"/>
+            </a:lnRef>
+            <a:fillRef idx="0">
+              <a:schemeClr val="accent1"/>
+            </a:fillRef>
+            <a:effectRef idx="1">
+              <a:schemeClr val="accent1"/>
+            </a:effectRef>
+            <a:fontRef idx="minor">
+              <a:schemeClr val="tx1"/>
+            </a:fontRef>
+          </p:style>
+          <p:txBody>
+            <a:bodyPr rtlCol="0" anchor="ctr"/>
+            <a:lstStyle/>
+            <a:p>
+              <a:pPr algn="ctr"/>
+              <a:endParaRPr lang="en-US"/>
+            </a:p>
+          </p:txBody>
+        </p:sp>
+        <p:pic>
+          <p:nvPicPr>
+            <p:cNvPr id="108" name="Graphic 107" descr="Doctor male with solid fill">
+              <a:extLst>
+                <a:ext uri="{FF2B5EF4-FFF2-40B4-BE49-F238E27FC236}">
+                  <a16:creationId xmlns:a16="http://schemas.microsoft.com/office/drawing/2014/main" id="{CB2C7BDE-2E65-7ED0-1ABF-8AC256E520FC}"/>
+                </a:ext>
+              </a:extLst>
+            </p:cNvPr>
+            <p:cNvPicPr>
+              <a:picLocks noChangeAspect="1"/>
+            </p:cNvPicPr>
+            <p:nvPr/>
+          </p:nvPicPr>
+          <p:blipFill>
+            <a:blip>
+              <a:extLst>
+                <a:ext uri="{96DAC541-7B7A-43D3-8B79-37D633B846F1}">
+                  <asvg:svgBlip xmlns:asvg="http://schemas.microsoft.com/office/drawing/2016/SVG/main" r:embed="rId8"/>
+                </a:ext>
+              </a:extLst>
+            </a:blip>
+            <a:stretch>
+              <a:fillRect/>
+            </a:stretch>
+          </p:blipFill>
+          <p:spPr>
+            <a:xfrm>
+              <a:off x="3065647" y="1577292"/>
+              <a:ext cx="636856" cy="636856"/>
+            </a:xfrm>
+            <a:prstGeom prst="rect">
+              <a:avLst/>
+            </a:prstGeom>
+          </p:spPr>
+        </p:pic>
+        <p:pic>
+          <p:nvPicPr>
+            <p:cNvPr id="109" name="Graphic 108" descr="Doctor female with solid fill">
+              <a:extLst>
+                <a:ext uri="{FF2B5EF4-FFF2-40B4-BE49-F238E27FC236}">
+                  <a16:creationId xmlns:a16="http://schemas.microsoft.com/office/drawing/2014/main" id="{DA556557-4A21-B133-BC24-B60D9DAA6B42}"/>
+                </a:ext>
+              </a:extLst>
+            </p:cNvPr>
+            <p:cNvPicPr>
+              <a:picLocks noChangeAspect="1"/>
+            </p:cNvPicPr>
+            <p:nvPr/>
+          </p:nvPicPr>
+          <p:blipFill>
+            <a:blip>
+              <a:extLst>
+                <a:ext uri="{96DAC541-7B7A-43D3-8B79-37D633B846F1}">
+                  <asvg:svgBlip xmlns:asvg="http://schemas.microsoft.com/office/drawing/2016/SVG/main" r:embed="rId9"/>
+                </a:ext>
+              </a:extLst>
+            </a:blip>
+            <a:stretch>
+              <a:fillRect/>
+            </a:stretch>
+          </p:blipFill>
+          <p:spPr>
+            <a:xfrm>
+              <a:off x="1429947" y="1577292"/>
+              <a:ext cx="636856" cy="636856"/>
+            </a:xfrm>
+            <a:prstGeom prst="rect">
+              <a:avLst/>
+            </a:prstGeom>
+          </p:spPr>
+        </p:pic>
+        <p:pic>
+          <p:nvPicPr>
+            <p:cNvPr id="111" name="Graphic 110" descr="Doctor female with solid fill">
+              <a:extLst>
+                <a:ext uri="{FF2B5EF4-FFF2-40B4-BE49-F238E27FC236}">
+                  <a16:creationId xmlns:a16="http://schemas.microsoft.com/office/drawing/2014/main" id="{6477F368-C4F4-683A-BC4C-444F35517229}"/>
+                </a:ext>
+              </a:extLst>
+            </p:cNvPr>
+            <p:cNvPicPr>
+              <a:picLocks noChangeAspect="1"/>
+            </p:cNvPicPr>
+            <p:nvPr/>
+          </p:nvPicPr>
+          <p:blipFill>
+            <a:blip>
+              <a:extLst>
+                <a:ext uri="{96DAC541-7B7A-43D3-8B79-37D633B846F1}">
+                  <asvg:svgBlip xmlns:asvg="http://schemas.microsoft.com/office/drawing/2016/SVG/main" r:embed="rId9"/>
+                </a:ext>
+              </a:extLst>
+            </a:blip>
+            <a:stretch>
+              <a:fillRect/>
+            </a:stretch>
+          </p:blipFill>
+          <p:spPr>
+            <a:xfrm>
+              <a:off x="5766321" y="1577292"/>
+              <a:ext cx="636856" cy="636856"/>
+            </a:xfrm>
+            <a:prstGeom prst="rect">
+              <a:avLst/>
+            </a:prstGeom>
+          </p:spPr>
+        </p:pic>
+        <p:sp>
+          <p:nvSpPr>
+            <p:cNvPr id="50" name="Left Bracket 49">
+              <a:extLst>
+                <a:ext uri="{FF2B5EF4-FFF2-40B4-BE49-F238E27FC236}">
+                  <a16:creationId xmlns:a16="http://schemas.microsoft.com/office/drawing/2014/main" id="{1C651EA5-DDEA-6F80-A382-B3F7904FEE48}"/>
+                </a:ext>
+              </a:extLst>
+            </p:cNvPr>
+            <p:cNvSpPr/>
+            <p:nvPr/>
+          </p:nvSpPr>
+          <p:spPr>
+            <a:xfrm rot="16200000">
+              <a:off x="5923026" y="887124"/>
+              <a:ext cx="369333" cy="901063"/>
+            </a:xfrm>
+            <a:prstGeom prst="leftBracket">
+              <a:avLst/>
+            </a:prstGeom>
+            <a:ln w="25400">
+              <a:solidFill>
+                <a:schemeClr val="tx1"/>
+              </a:solidFill>
+            </a:ln>
+          </p:spPr>
+          <p:style>
+            <a:lnRef idx="2">
+              <a:schemeClr val="accent1"/>
+            </a:lnRef>
+            <a:fillRef idx="0">
+              <a:schemeClr val="accent1"/>
+            </a:fillRef>
+            <a:effectRef idx="1">
+              <a:schemeClr val="accent1"/>
+            </a:effectRef>
+            <a:fontRef idx="minor">
+              <a:schemeClr val="tx1"/>
+            </a:fontRef>
+          </p:style>
+          <p:txBody>
+            <a:bodyPr rtlCol="0" anchor="ctr"/>
+            <a:lstStyle/>
+            <a:p>
+              <a:pPr algn="ctr"/>
+              <a:endParaRPr lang="en-US"/>
+            </a:p>
+          </p:txBody>
+        </p:sp>
+        <p:sp>
+          <p:nvSpPr>
+            <p:cNvPr id="51" name="Left Bracket 50">
+              <a:extLst>
+                <a:ext uri="{FF2B5EF4-FFF2-40B4-BE49-F238E27FC236}">
+                  <a16:creationId xmlns:a16="http://schemas.microsoft.com/office/drawing/2014/main" id="{3F391361-F5A2-AD35-2AE1-7E4A3C51D4BE}"/>
+                </a:ext>
+              </a:extLst>
+            </p:cNvPr>
+            <p:cNvSpPr/>
+            <p:nvPr/>
+          </p:nvSpPr>
+          <p:spPr>
+            <a:xfrm rot="16200000">
+              <a:off x="6999675" y="887124"/>
+              <a:ext cx="369333" cy="901063"/>
+            </a:xfrm>
+            <a:prstGeom prst="leftBracket">
+              <a:avLst/>
+            </a:prstGeom>
+            <a:ln w="25400">
+              <a:solidFill>
+                <a:schemeClr val="tx1"/>
+              </a:solidFill>
+            </a:ln>
+          </p:spPr>
+          <p:style>
+            <a:lnRef idx="2">
+              <a:schemeClr val="accent1"/>
+            </a:lnRef>
+            <a:fillRef idx="0">
+              <a:schemeClr val="accent1"/>
+            </a:fillRef>
+            <a:effectRef idx="1">
+              <a:schemeClr val="accent1"/>
+            </a:effectRef>
+            <a:fontRef idx="minor">
+              <a:schemeClr val="tx1"/>
+            </a:fontRef>
+          </p:style>
+          <p:txBody>
+            <a:bodyPr rtlCol="0" anchor="ctr"/>
+            <a:lstStyle/>
+            <a:p>
+              <a:pPr algn="ctr"/>
+              <a:endParaRPr lang="en-US"/>
+            </a:p>
+          </p:txBody>
+        </p:sp>
+        <p:pic>
+          <p:nvPicPr>
+            <p:cNvPr id="52" name="Graphic 51" descr="Doctor male with solid fill">
+              <a:extLst>
+                <a:ext uri="{FF2B5EF4-FFF2-40B4-BE49-F238E27FC236}">
+                  <a16:creationId xmlns:a16="http://schemas.microsoft.com/office/drawing/2014/main" id="{1B08D3DB-F643-53FF-40D1-29AD16AA17A3}"/>
+                </a:ext>
+              </a:extLst>
+            </p:cNvPr>
+            <p:cNvPicPr>
+              <a:picLocks noChangeAspect="1"/>
+            </p:cNvPicPr>
+            <p:nvPr/>
+          </p:nvPicPr>
+          <p:blipFill>
+            <a:blip>
+              <a:extLst>
+                <a:ext uri="{96DAC541-7B7A-43D3-8B79-37D633B846F1}">
+                  <asvg:svgBlip xmlns:asvg="http://schemas.microsoft.com/office/drawing/2016/SVG/main" r:embed="rId8"/>
+                </a:ext>
+              </a:extLst>
+            </a:blip>
+            <a:stretch>
+              <a:fillRect/>
+            </a:stretch>
+          </p:blipFill>
+          <p:spPr>
+            <a:xfrm>
+              <a:off x="6872004" y="1588917"/>
+              <a:ext cx="636856" cy="636856"/>
+            </a:xfrm>
+            <a:prstGeom prst="rect">
+              <a:avLst/>
+            </a:prstGeom>
+          </p:spPr>
+        </p:pic>
+        <p:sp>
+          <p:nvSpPr>
+            <p:cNvPr id="122" name="Rounded Rectangle 121">
+              <a:extLst>
+                <a:ext uri="{FF2B5EF4-FFF2-40B4-BE49-F238E27FC236}">
+                  <a16:creationId xmlns:a16="http://schemas.microsoft.com/office/drawing/2014/main" id="{2AD281CF-5C4E-BD61-EF88-5F6EE52F32D1}"/>
+                </a:ext>
+              </a:extLst>
+            </p:cNvPr>
+            <p:cNvSpPr/>
+            <p:nvPr/>
+          </p:nvSpPr>
+          <p:spPr>
+            <a:xfrm>
+              <a:off x="9043546" y="382354"/>
+              <a:ext cx="7791352" cy="2097152"/>
+            </a:xfrm>
+            <a:prstGeom prst="roundRect">
+              <a:avLst>
+                <a:gd name="adj" fmla="val 21519"/>
+              </a:avLst>
+            </a:prstGeom>
+            <a:solidFill>
+              <a:srgbClr val="00B0F0">
+                <a:alpha val="25714"/>
+              </a:srgbClr>
+            </a:solidFill>
+            <a:ln w="34925">
+              <a:solidFill>
+                <a:srgbClr val="0070C0"/>
+              </a:solidFill>
+            </a:ln>
+          </p:spPr>
+          <p:style>
+            <a:lnRef idx="2">
+              <a:schemeClr val="accent1">
+                <a:shade val="15000"/>
+              </a:schemeClr>
+            </a:lnRef>
+            <a:fillRef idx="1">
+              <a:schemeClr val="accent1"/>
+            </a:fillRef>
+            <a:effectRef idx="0">
+              <a:schemeClr val="accent1"/>
+            </a:effectRef>
+            <a:fontRef idx="minor">
+              <a:schemeClr val="lt1"/>
+            </a:fontRef>
+          </p:style>
+          <p:txBody>
+            <a:bodyPr rtlCol="0" anchor="ctr"/>
+            <a:lstStyle/>
+            <a:p>
+              <a:pPr algn="ctr"/>
+              <a:endParaRPr lang="en-US"/>
+            </a:p>
+          </p:txBody>
+        </p:sp>
+        <p:pic>
+          <p:nvPicPr>
+            <p:cNvPr id="123" name="Graphic 122" descr="Sleep with solid fill">
+              <a:extLst>
+                <a:ext uri="{FF2B5EF4-FFF2-40B4-BE49-F238E27FC236}">
+                  <a16:creationId xmlns:a16="http://schemas.microsoft.com/office/drawing/2014/main" id="{A04AD26A-82E5-E2AB-2942-A5BC344E20E3}"/>
+                </a:ext>
+              </a:extLst>
+            </p:cNvPr>
+            <p:cNvPicPr>
+              <a:picLocks noChangeAspect="1"/>
+            </p:cNvPicPr>
+            <p:nvPr/>
+          </p:nvPicPr>
+          <p:blipFill>
+            <a:blip>
+              <a:extLst>
+                <a:ext uri="{96DAC541-7B7A-43D3-8B79-37D633B846F1}">
+                  <asvg:svgBlip xmlns:asvg="http://schemas.microsoft.com/office/drawing/2016/SVG/main" r:embed="rId7"/>
+                </a:ext>
+              </a:extLst>
+            </a:blip>
+            <a:srcRect/>
+            <a:stretch/>
+          </p:blipFill>
+          <p:spPr>
+            <a:xfrm>
+              <a:off x="9323185" y="717940"/>
+              <a:ext cx="634696" cy="634696"/>
+            </a:xfrm>
+            <a:prstGeom prst="rect">
+              <a:avLst/>
+            </a:prstGeom>
+          </p:spPr>
+        </p:pic>
+        <p:pic>
+          <p:nvPicPr>
+            <p:cNvPr id="124" name="Graphic 123" descr="Sleep with solid fill">
+              <a:extLst>
+                <a:ext uri="{FF2B5EF4-FFF2-40B4-BE49-F238E27FC236}">
+                  <a16:creationId xmlns:a16="http://schemas.microsoft.com/office/drawing/2014/main" id="{E5C33630-689E-FA0E-98B1-6B33DBB3C03D}"/>
+                </a:ext>
+              </a:extLst>
+            </p:cNvPr>
+            <p:cNvPicPr>
+              <a:picLocks noChangeAspect="1"/>
+            </p:cNvPicPr>
+            <p:nvPr/>
+          </p:nvPicPr>
+          <p:blipFill>
+            <a:blip>
+              <a:extLst>
+                <a:ext uri="{96DAC541-7B7A-43D3-8B79-37D633B846F1}">
+                  <asvg:svgBlip xmlns:asvg="http://schemas.microsoft.com/office/drawing/2016/SVG/main" r:embed="rId5"/>
+                </a:ext>
+              </a:extLst>
+            </a:blip>
+            <a:srcRect/>
+            <a:stretch/>
+          </p:blipFill>
+          <p:spPr>
+            <a:xfrm>
+              <a:off x="10389017" y="717940"/>
+              <a:ext cx="634696" cy="634696"/>
+            </a:xfrm>
+            <a:prstGeom prst="rect">
+              <a:avLst/>
+            </a:prstGeom>
+          </p:spPr>
+        </p:pic>
+        <p:pic>
+          <p:nvPicPr>
+            <p:cNvPr id="125" name="Graphic 124" descr="Bed with solid fill">
+              <a:extLst>
+                <a:ext uri="{FF2B5EF4-FFF2-40B4-BE49-F238E27FC236}">
+                  <a16:creationId xmlns:a16="http://schemas.microsoft.com/office/drawing/2014/main" id="{9D5800A1-C62C-FF09-BD70-4648019B4319}"/>
+                </a:ext>
+              </a:extLst>
+            </p:cNvPr>
+            <p:cNvPicPr>
+              <a:picLocks noChangeAspect="1"/>
+            </p:cNvPicPr>
+            <p:nvPr/>
+          </p:nvPicPr>
+          <p:blipFill>
+            <a:blip>
+              <a:extLst>
+                <a:ext uri="{96DAC541-7B7A-43D3-8B79-37D633B846F1}">
+                  <asvg:svgBlip xmlns:asvg="http://schemas.microsoft.com/office/drawing/2016/SVG/main" r:embed="rId3"/>
+                </a:ext>
+              </a:extLst>
+            </a:blip>
+            <a:srcRect/>
+            <a:stretch/>
+          </p:blipFill>
+          <p:spPr>
+            <a:xfrm>
+              <a:off x="11498350" y="717940"/>
+              <a:ext cx="634696" cy="634696"/>
+            </a:xfrm>
+            <a:prstGeom prst="rect">
+              <a:avLst/>
+            </a:prstGeom>
+          </p:spPr>
+        </p:pic>
+        <p:pic>
+          <p:nvPicPr>
+            <p:cNvPr id="126" name="Graphic 125" descr="Sleep with solid fill">
+              <a:extLst>
+                <a:ext uri="{FF2B5EF4-FFF2-40B4-BE49-F238E27FC236}">
+                  <a16:creationId xmlns:a16="http://schemas.microsoft.com/office/drawing/2014/main" id="{204D9E95-8CF9-E29A-3131-97DD0A74A626}"/>
+                </a:ext>
+              </a:extLst>
+            </p:cNvPr>
+            <p:cNvPicPr>
+              <a:picLocks noChangeAspect="1"/>
+            </p:cNvPicPr>
+            <p:nvPr/>
+          </p:nvPicPr>
+          <p:blipFill>
+            <a:blip>
+              <a:extLst>
+                <a:ext uri="{96DAC541-7B7A-43D3-8B79-37D633B846F1}">
+                  <asvg:svgBlip xmlns:asvg="http://schemas.microsoft.com/office/drawing/2016/SVG/main" r:embed="rId5"/>
+                </a:ext>
+              </a:extLst>
+            </a:blip>
+            <a:srcRect/>
+            <a:stretch/>
+          </p:blipFill>
+          <p:spPr>
+            <a:xfrm>
+              <a:off x="12564182" y="717940"/>
+              <a:ext cx="634696" cy="634696"/>
+            </a:xfrm>
+            <a:prstGeom prst="rect">
+              <a:avLst/>
+            </a:prstGeom>
+          </p:spPr>
+        </p:pic>
+        <p:pic>
+          <p:nvPicPr>
+            <p:cNvPr id="127" name="Graphic 126" descr="Sleep with solid fill">
+              <a:extLst>
+                <a:ext uri="{FF2B5EF4-FFF2-40B4-BE49-F238E27FC236}">
+                  <a16:creationId xmlns:a16="http://schemas.microsoft.com/office/drawing/2014/main" id="{3ADD6AC0-AC70-8A86-F894-EF802C6F02C6}"/>
+                </a:ext>
+              </a:extLst>
+            </p:cNvPr>
+            <p:cNvPicPr>
+              <a:picLocks noChangeAspect="1"/>
+            </p:cNvPicPr>
+            <p:nvPr/>
+          </p:nvPicPr>
+          <p:blipFill>
+            <a:blip>
+              <a:extLst>
+                <a:ext uri="{96DAC541-7B7A-43D3-8B79-37D633B846F1}">
+                  <asvg:svgBlip xmlns:asvg="http://schemas.microsoft.com/office/drawing/2016/SVG/main" r:embed="rId6"/>
+                </a:ext>
+              </a:extLst>
+            </a:blip>
+            <a:srcRect/>
+            <a:stretch/>
+          </p:blipFill>
+          <p:spPr>
+            <a:xfrm>
+              <a:off x="13683583" y="717940"/>
+              <a:ext cx="634696" cy="634696"/>
+            </a:xfrm>
+            <a:prstGeom prst="rect">
+              <a:avLst/>
+            </a:prstGeom>
+          </p:spPr>
+        </p:pic>
+        <p:pic>
+          <p:nvPicPr>
+            <p:cNvPr id="128" name="Graphic 127" descr="Sleep with solid fill">
+              <a:extLst>
+                <a:ext uri="{FF2B5EF4-FFF2-40B4-BE49-F238E27FC236}">
+                  <a16:creationId xmlns:a16="http://schemas.microsoft.com/office/drawing/2014/main" id="{E56DBECC-1042-1B20-57D3-E112E86D2D64}"/>
+                </a:ext>
+              </a:extLst>
+            </p:cNvPr>
+            <p:cNvPicPr>
+              <a:picLocks noChangeAspect="1"/>
+            </p:cNvPicPr>
+            <p:nvPr/>
+          </p:nvPicPr>
+          <p:blipFill>
+            <a:blip>
+              <a:extLst>
+                <a:ext uri="{96DAC541-7B7A-43D3-8B79-37D633B846F1}">
+                  <asvg:svgBlip xmlns:asvg="http://schemas.microsoft.com/office/drawing/2016/SVG/main" r:embed="rId10"/>
+                </a:ext>
+              </a:extLst>
+            </a:blip>
+            <a:srcRect/>
+            <a:stretch/>
+          </p:blipFill>
+          <p:spPr>
+            <a:xfrm>
+              <a:off x="14749415" y="717940"/>
+              <a:ext cx="634696" cy="634696"/>
+            </a:xfrm>
+            <a:prstGeom prst="rect">
+              <a:avLst/>
+            </a:prstGeom>
+          </p:spPr>
+        </p:pic>
+        <p:pic>
+          <p:nvPicPr>
+            <p:cNvPr id="129" name="Graphic 128" descr="Bed with solid fill">
+              <a:extLst>
+                <a:ext uri="{FF2B5EF4-FFF2-40B4-BE49-F238E27FC236}">
+                  <a16:creationId xmlns:a16="http://schemas.microsoft.com/office/drawing/2014/main" id="{72E44A4C-2670-CBCE-C1D5-84D98A8CA9A0}"/>
+                </a:ext>
+              </a:extLst>
+            </p:cNvPr>
+            <p:cNvPicPr>
+              <a:picLocks noChangeAspect="1"/>
+            </p:cNvPicPr>
+            <p:nvPr/>
+          </p:nvPicPr>
+          <p:blipFill>
+            <a:blip>
+              <a:extLst>
+                <a:ext uri="{96DAC541-7B7A-43D3-8B79-37D633B846F1}">
+                  <asvg:svgBlip xmlns:asvg="http://schemas.microsoft.com/office/drawing/2016/SVG/main" r:embed="rId3"/>
+                </a:ext>
+              </a:extLst>
+            </a:blip>
+            <a:srcRect/>
+            <a:stretch/>
+          </p:blipFill>
+          <p:spPr>
+            <a:xfrm>
+              <a:off x="15858748" y="717940"/>
+              <a:ext cx="634696" cy="634696"/>
+            </a:xfrm>
+            <a:prstGeom prst="rect">
+              <a:avLst/>
+            </a:prstGeom>
+          </p:spPr>
+        </p:pic>
+        <p:sp>
+          <p:nvSpPr>
+            <p:cNvPr id="130" name="TextBox 129">
+              <a:extLst>
+                <a:ext uri="{FF2B5EF4-FFF2-40B4-BE49-F238E27FC236}">
+                  <a16:creationId xmlns:a16="http://schemas.microsoft.com/office/drawing/2014/main" id="{CD4384E5-8837-BEA9-9895-600762788AA3}"/>
+                </a:ext>
+              </a:extLst>
+            </p:cNvPr>
+            <p:cNvSpPr txBox="1"/>
+            <p:nvPr/>
+          </p:nvSpPr>
+          <p:spPr>
+            <a:xfrm>
+              <a:off x="9391633" y="563424"/>
+              <a:ext cx="570990" cy="369332"/>
+            </a:xfrm>
+            <a:prstGeom prst="rect">
+              <a:avLst/>
+            </a:prstGeom>
+            <a:noFill/>
+          </p:spPr>
+          <p:txBody>
+            <a:bodyPr wrap="none" rtlCol="0">
+              <a:spAutoFit/>
+            </a:bodyPr>
+            <a:lstStyle/>
+            <a:p>
+              <a:r>
+                <a:rPr lang="en-US" dirty="0"/>
+                <a:t>B08</a:t>
+              </a:r>
+            </a:p>
+          </p:txBody>
+        </p:sp>
+        <p:sp>
+          <p:nvSpPr>
+            <p:cNvPr id="131" name="TextBox 130">
+              <a:extLst>
+                <a:ext uri="{FF2B5EF4-FFF2-40B4-BE49-F238E27FC236}">
+                  <a16:creationId xmlns:a16="http://schemas.microsoft.com/office/drawing/2014/main" id="{720B53ED-B65C-00C1-3819-0D779E72A287}"/>
+                </a:ext>
+              </a:extLst>
+            </p:cNvPr>
+            <p:cNvSpPr txBox="1"/>
+            <p:nvPr/>
+          </p:nvSpPr>
+          <p:spPr>
+            <a:xfrm>
+              <a:off x="10453438" y="563424"/>
+              <a:ext cx="570990" cy="369332"/>
+            </a:xfrm>
+            <a:prstGeom prst="rect">
+              <a:avLst/>
+            </a:prstGeom>
+            <a:noFill/>
+          </p:spPr>
+          <p:txBody>
+            <a:bodyPr wrap="none" rtlCol="0">
+              <a:spAutoFit/>
+            </a:bodyPr>
+            <a:lstStyle/>
+            <a:p>
+              <a:r>
+                <a:rPr lang="en-US" dirty="0"/>
+                <a:t>B09</a:t>
+              </a:r>
+            </a:p>
+          </p:txBody>
+        </p:sp>
+        <p:sp>
+          <p:nvSpPr>
+            <p:cNvPr id="132" name="TextBox 131">
+              <a:extLst>
+                <a:ext uri="{FF2B5EF4-FFF2-40B4-BE49-F238E27FC236}">
+                  <a16:creationId xmlns:a16="http://schemas.microsoft.com/office/drawing/2014/main" id="{40D76A9A-0B46-7AC9-1EF3-ADDB3B6D34F9}"/>
+                </a:ext>
+              </a:extLst>
+            </p:cNvPr>
+            <p:cNvSpPr txBox="1"/>
+            <p:nvPr/>
+          </p:nvSpPr>
+          <p:spPr>
+            <a:xfrm>
+              <a:off x="11520098" y="563424"/>
+              <a:ext cx="570990" cy="369332"/>
+            </a:xfrm>
+            <a:prstGeom prst="rect">
+              <a:avLst/>
+            </a:prstGeom>
+            <a:noFill/>
+          </p:spPr>
+          <p:txBody>
+            <a:bodyPr wrap="none" rtlCol="0">
+              <a:spAutoFit/>
+            </a:bodyPr>
+            <a:lstStyle/>
+            <a:p>
+              <a:r>
+                <a:rPr lang="en-US" dirty="0"/>
+                <a:t>B10</a:t>
+              </a:r>
+            </a:p>
+          </p:txBody>
+        </p:sp>
+        <p:sp>
+          <p:nvSpPr>
+            <p:cNvPr id="133" name="TextBox 132">
+              <a:extLst>
+                <a:ext uri="{FF2B5EF4-FFF2-40B4-BE49-F238E27FC236}">
+                  <a16:creationId xmlns:a16="http://schemas.microsoft.com/office/drawing/2014/main" id="{C9A6E232-7D86-0921-3055-1AB5C464A4C5}"/>
+                </a:ext>
+              </a:extLst>
+            </p:cNvPr>
+            <p:cNvSpPr txBox="1"/>
+            <p:nvPr/>
+          </p:nvSpPr>
+          <p:spPr>
+            <a:xfrm>
+              <a:off x="12609658" y="563424"/>
+              <a:ext cx="570990" cy="369332"/>
+            </a:xfrm>
+            <a:prstGeom prst="rect">
+              <a:avLst/>
+            </a:prstGeom>
+            <a:noFill/>
+          </p:spPr>
+          <p:txBody>
+            <a:bodyPr wrap="none" rtlCol="0">
+              <a:spAutoFit/>
+            </a:bodyPr>
+            <a:lstStyle/>
+            <a:p>
+              <a:r>
+                <a:rPr lang="en-US" dirty="0"/>
+                <a:t>B11</a:t>
+              </a:r>
+            </a:p>
+          </p:txBody>
+        </p:sp>
+        <p:sp>
+          <p:nvSpPr>
+            <p:cNvPr id="134" name="TextBox 133">
+              <a:extLst>
+                <a:ext uri="{FF2B5EF4-FFF2-40B4-BE49-F238E27FC236}">
+                  <a16:creationId xmlns:a16="http://schemas.microsoft.com/office/drawing/2014/main" id="{48EF9BE3-C761-E7EB-0D98-2BCFCAEB9A0B}"/>
+                </a:ext>
+              </a:extLst>
+            </p:cNvPr>
+            <p:cNvSpPr txBox="1"/>
+            <p:nvPr/>
+          </p:nvSpPr>
+          <p:spPr>
+            <a:xfrm>
+              <a:off x="13729452" y="568013"/>
+              <a:ext cx="570990" cy="369332"/>
+            </a:xfrm>
+            <a:prstGeom prst="rect">
+              <a:avLst/>
+            </a:prstGeom>
+            <a:noFill/>
+          </p:spPr>
+          <p:txBody>
+            <a:bodyPr wrap="none" rtlCol="0">
+              <a:spAutoFit/>
+            </a:bodyPr>
+            <a:lstStyle/>
+            <a:p>
+              <a:r>
+                <a:rPr lang="en-US" dirty="0"/>
+                <a:t>B12</a:t>
+              </a:r>
+            </a:p>
+          </p:txBody>
+        </p:sp>
+        <p:sp>
+          <p:nvSpPr>
+            <p:cNvPr id="135" name="TextBox 134">
+              <a:extLst>
+                <a:ext uri="{FF2B5EF4-FFF2-40B4-BE49-F238E27FC236}">
+                  <a16:creationId xmlns:a16="http://schemas.microsoft.com/office/drawing/2014/main" id="{7F9B0C0E-EC46-745B-415D-C289DF5F77E6}"/>
+                </a:ext>
+              </a:extLst>
+            </p:cNvPr>
+            <p:cNvSpPr txBox="1"/>
+            <p:nvPr/>
+          </p:nvSpPr>
+          <p:spPr>
+            <a:xfrm>
+              <a:off x="14791257" y="568013"/>
+              <a:ext cx="570990" cy="369332"/>
+            </a:xfrm>
+            <a:prstGeom prst="rect">
+              <a:avLst/>
+            </a:prstGeom>
+            <a:noFill/>
+          </p:spPr>
+          <p:txBody>
+            <a:bodyPr wrap="none" rtlCol="0">
+              <a:spAutoFit/>
+            </a:bodyPr>
+            <a:lstStyle/>
+            <a:p>
+              <a:r>
+                <a:rPr lang="en-US" dirty="0"/>
+                <a:t>B13</a:t>
+              </a:r>
+            </a:p>
+          </p:txBody>
+        </p:sp>
+        <p:sp>
+          <p:nvSpPr>
+            <p:cNvPr id="136" name="TextBox 135">
+              <a:extLst>
+                <a:ext uri="{FF2B5EF4-FFF2-40B4-BE49-F238E27FC236}">
+                  <a16:creationId xmlns:a16="http://schemas.microsoft.com/office/drawing/2014/main" id="{288F23AE-403F-FA68-AFFA-04EDD53B0DCC}"/>
+                </a:ext>
+              </a:extLst>
+            </p:cNvPr>
+            <p:cNvSpPr txBox="1"/>
+            <p:nvPr/>
+          </p:nvSpPr>
+          <p:spPr>
+            <a:xfrm>
+              <a:off x="15857917" y="568013"/>
+              <a:ext cx="570990" cy="369332"/>
+            </a:xfrm>
+            <a:prstGeom prst="rect">
+              <a:avLst/>
+            </a:prstGeom>
+            <a:noFill/>
+          </p:spPr>
+          <p:txBody>
+            <a:bodyPr wrap="none" rtlCol="0">
+              <a:spAutoFit/>
+            </a:bodyPr>
+            <a:lstStyle/>
+            <a:p>
+              <a:r>
+                <a:rPr lang="en-US" dirty="0"/>
+                <a:t>B14</a:t>
+              </a:r>
+            </a:p>
+          </p:txBody>
+        </p:sp>
+        <p:sp>
+          <p:nvSpPr>
+            <p:cNvPr id="137" name="Left Bracket 136">
+              <a:extLst>
+                <a:ext uri="{FF2B5EF4-FFF2-40B4-BE49-F238E27FC236}">
+                  <a16:creationId xmlns:a16="http://schemas.microsoft.com/office/drawing/2014/main" id="{F4D21987-36AC-84E9-EEC6-FF13513A5E0F}"/>
+                </a:ext>
+              </a:extLst>
+            </p:cNvPr>
+            <p:cNvSpPr/>
+            <p:nvPr/>
+          </p:nvSpPr>
+          <p:spPr>
+            <a:xfrm rot="16200000">
+              <a:off x="13276901" y="346332"/>
+              <a:ext cx="369333" cy="2035851"/>
+            </a:xfrm>
+            <a:prstGeom prst="leftBracket">
+              <a:avLst/>
+            </a:prstGeom>
+            <a:ln w="25400">
+              <a:solidFill>
+                <a:schemeClr val="tx1"/>
+              </a:solidFill>
+            </a:ln>
+          </p:spPr>
+          <p:style>
+            <a:lnRef idx="2">
+              <a:schemeClr val="accent1"/>
+            </a:lnRef>
+            <a:fillRef idx="0">
+              <a:schemeClr val="accent1"/>
+            </a:fillRef>
+            <a:effectRef idx="1">
+              <a:schemeClr val="accent1"/>
+            </a:effectRef>
+            <a:fontRef idx="minor">
+              <a:schemeClr val="tx1"/>
+            </a:fontRef>
+          </p:style>
+          <p:txBody>
+            <a:bodyPr rtlCol="0" anchor="ctr"/>
+            <a:lstStyle/>
+            <a:p>
+              <a:pPr algn="ctr"/>
+              <a:endParaRPr lang="en-US"/>
+            </a:p>
+          </p:txBody>
+        </p:sp>
+        <p:sp>
+          <p:nvSpPr>
+            <p:cNvPr id="138" name="Left Bracket 137">
+              <a:extLst>
+                <a:ext uri="{FF2B5EF4-FFF2-40B4-BE49-F238E27FC236}">
+                  <a16:creationId xmlns:a16="http://schemas.microsoft.com/office/drawing/2014/main" id="{54A99B00-6DDC-81D6-A6FC-0F3EBC30FE47}"/>
+                </a:ext>
+              </a:extLst>
+            </p:cNvPr>
+            <p:cNvSpPr/>
+            <p:nvPr/>
+          </p:nvSpPr>
+          <p:spPr>
+            <a:xfrm rot="16200000">
+              <a:off x="10525253" y="902102"/>
+              <a:ext cx="369333" cy="901063"/>
+            </a:xfrm>
+            <a:prstGeom prst="leftBracket">
+              <a:avLst/>
+            </a:prstGeom>
+            <a:ln w="25400">
+              <a:solidFill>
+                <a:schemeClr val="tx1"/>
+              </a:solidFill>
+            </a:ln>
+          </p:spPr>
+          <p:style>
+            <a:lnRef idx="2">
+              <a:schemeClr val="accent1"/>
+            </a:lnRef>
+            <a:fillRef idx="0">
+              <a:schemeClr val="accent1"/>
+            </a:fillRef>
+            <a:effectRef idx="1">
+              <a:schemeClr val="accent1"/>
+            </a:effectRef>
+            <a:fontRef idx="minor">
+              <a:schemeClr val="tx1"/>
+            </a:fontRef>
+          </p:style>
+          <p:txBody>
+            <a:bodyPr rtlCol="0" anchor="ctr"/>
+            <a:lstStyle/>
+            <a:p>
+              <a:pPr algn="ctr"/>
+              <a:endParaRPr lang="en-US"/>
+            </a:p>
+          </p:txBody>
+        </p:sp>
+        <p:pic>
+          <p:nvPicPr>
+            <p:cNvPr id="139" name="Graphic 138" descr="Doctor male with solid fill">
+              <a:extLst>
+                <a:ext uri="{FF2B5EF4-FFF2-40B4-BE49-F238E27FC236}">
+                  <a16:creationId xmlns:a16="http://schemas.microsoft.com/office/drawing/2014/main" id="{039E4A87-493F-3C25-B1BD-AC0C02FEC46E}"/>
+                </a:ext>
+              </a:extLst>
+            </p:cNvPr>
+            <p:cNvPicPr>
+              <a:picLocks noChangeAspect="1"/>
+            </p:cNvPicPr>
+            <p:nvPr/>
+          </p:nvPicPr>
+          <p:blipFill>
+            <a:blip>
+              <a:extLst>
+                <a:ext uri="{96DAC541-7B7A-43D3-8B79-37D633B846F1}">
+                  <asvg:svgBlip xmlns:asvg="http://schemas.microsoft.com/office/drawing/2016/SVG/main" r:embed="rId8"/>
+                </a:ext>
+              </a:extLst>
+            </a:blip>
+            <a:stretch>
+              <a:fillRect/>
+            </a:stretch>
+          </p:blipFill>
+          <p:spPr>
+            <a:xfrm>
+              <a:off x="13143139" y="1599471"/>
+              <a:ext cx="636856" cy="636856"/>
+            </a:xfrm>
+            <a:prstGeom prst="rect">
+              <a:avLst/>
+            </a:prstGeom>
+          </p:spPr>
+        </p:pic>
+        <p:pic>
+          <p:nvPicPr>
+            <p:cNvPr id="140" name="Graphic 139" descr="Doctor female with solid fill">
+              <a:extLst>
+                <a:ext uri="{FF2B5EF4-FFF2-40B4-BE49-F238E27FC236}">
+                  <a16:creationId xmlns:a16="http://schemas.microsoft.com/office/drawing/2014/main" id="{7AFFC943-A35F-DB5A-0782-3F8228616BAC}"/>
+                </a:ext>
+              </a:extLst>
+            </p:cNvPr>
+            <p:cNvPicPr>
+              <a:picLocks noChangeAspect="1"/>
+            </p:cNvPicPr>
+            <p:nvPr/>
+          </p:nvPicPr>
+          <p:blipFill>
+            <a:blip>
+              <a:extLst>
+                <a:ext uri="{96DAC541-7B7A-43D3-8B79-37D633B846F1}">
+                  <asvg:svgBlip xmlns:asvg="http://schemas.microsoft.com/office/drawing/2016/SVG/main" r:embed="rId9"/>
+                </a:ext>
+              </a:extLst>
+            </a:blip>
+            <a:stretch>
+              <a:fillRect/>
+            </a:stretch>
+          </p:blipFill>
+          <p:spPr>
+            <a:xfrm>
+              <a:off x="10389017" y="1587847"/>
+              <a:ext cx="636856" cy="636856"/>
+            </a:xfrm>
+            <a:prstGeom prst="rect">
+              <a:avLst/>
+            </a:prstGeom>
+          </p:spPr>
+        </p:pic>
+        <p:pic>
+          <p:nvPicPr>
+            <p:cNvPr id="141" name="Graphic 140" descr="Doctor female with solid fill">
+              <a:extLst>
+                <a:ext uri="{FF2B5EF4-FFF2-40B4-BE49-F238E27FC236}">
+                  <a16:creationId xmlns:a16="http://schemas.microsoft.com/office/drawing/2014/main" id="{F89F9C15-6FCE-2348-F955-9C2213C094BF}"/>
+                </a:ext>
+              </a:extLst>
+            </p:cNvPr>
+            <p:cNvPicPr>
+              <a:picLocks noChangeAspect="1"/>
+            </p:cNvPicPr>
+            <p:nvPr/>
+          </p:nvPicPr>
+          <p:blipFill>
+            <a:blip>
+              <a:extLst>
+                <a:ext uri="{96DAC541-7B7A-43D3-8B79-37D633B846F1}">
+                  <asvg:svgBlip xmlns:asvg="http://schemas.microsoft.com/office/drawing/2016/SVG/main" r:embed="rId9"/>
+                </a:ext>
+              </a:extLst>
+            </a:blip>
+            <a:stretch>
+              <a:fillRect/>
+            </a:stretch>
+          </p:blipFill>
+          <p:spPr>
+            <a:xfrm>
+              <a:off x="14725391" y="1587847"/>
+              <a:ext cx="636856" cy="636856"/>
+            </a:xfrm>
+            <a:prstGeom prst="rect">
+              <a:avLst/>
+            </a:prstGeom>
+          </p:spPr>
+        </p:pic>
+        <p:sp>
+          <p:nvSpPr>
+            <p:cNvPr id="142" name="Left Bracket 141">
+              <a:extLst>
+                <a:ext uri="{FF2B5EF4-FFF2-40B4-BE49-F238E27FC236}">
+                  <a16:creationId xmlns:a16="http://schemas.microsoft.com/office/drawing/2014/main" id="{6190EF7B-D9B9-3B7E-4206-1AE47AFA0CBA}"/>
+                </a:ext>
+              </a:extLst>
+            </p:cNvPr>
+            <p:cNvSpPr/>
+            <p:nvPr/>
+          </p:nvSpPr>
+          <p:spPr>
+            <a:xfrm rot="16200000">
+              <a:off x="14882096" y="897679"/>
+              <a:ext cx="369333" cy="901063"/>
+            </a:xfrm>
+            <a:prstGeom prst="leftBracket">
+              <a:avLst/>
+            </a:prstGeom>
+            <a:ln w="25400">
+              <a:solidFill>
+                <a:schemeClr val="tx1"/>
+              </a:solidFill>
+            </a:ln>
+          </p:spPr>
+          <p:style>
+            <a:lnRef idx="2">
+              <a:schemeClr val="accent1"/>
+            </a:lnRef>
+            <a:fillRef idx="0">
+              <a:schemeClr val="accent1"/>
+            </a:fillRef>
+            <a:effectRef idx="1">
+              <a:schemeClr val="accent1"/>
+            </a:effectRef>
+            <a:fontRef idx="minor">
+              <a:schemeClr val="tx1"/>
+            </a:fontRef>
+          </p:style>
+          <p:txBody>
+            <a:bodyPr rtlCol="0" anchor="ctr"/>
+            <a:lstStyle/>
+            <a:p>
+              <a:pPr algn="ctr"/>
+              <a:endParaRPr lang="en-US"/>
+            </a:p>
+          </p:txBody>
+        </p:sp>
+        <p:sp>
+          <p:nvSpPr>
+            <p:cNvPr id="143" name="Left Bracket 142">
+              <a:extLst>
+                <a:ext uri="{FF2B5EF4-FFF2-40B4-BE49-F238E27FC236}">
+                  <a16:creationId xmlns:a16="http://schemas.microsoft.com/office/drawing/2014/main" id="{3A2E2A98-A02D-9E38-6F03-743B5043FE1A}"/>
+                </a:ext>
+              </a:extLst>
+            </p:cNvPr>
+            <p:cNvSpPr/>
+            <p:nvPr/>
+          </p:nvSpPr>
+          <p:spPr>
+            <a:xfrm rot="16200000">
+              <a:off x="9467346" y="897678"/>
+              <a:ext cx="369333" cy="901063"/>
+            </a:xfrm>
+            <a:prstGeom prst="leftBracket">
+              <a:avLst/>
+            </a:prstGeom>
+            <a:ln w="25400">
+              <a:solidFill>
+                <a:schemeClr val="tx1"/>
+              </a:solidFill>
+            </a:ln>
+          </p:spPr>
+          <p:style>
+            <a:lnRef idx="2">
+              <a:schemeClr val="accent1"/>
+            </a:lnRef>
+            <a:fillRef idx="0">
+              <a:schemeClr val="accent1"/>
+            </a:fillRef>
+            <a:effectRef idx="1">
+              <a:schemeClr val="accent1"/>
+            </a:effectRef>
+            <a:fontRef idx="minor">
+              <a:schemeClr val="tx1"/>
+            </a:fontRef>
+          </p:style>
+          <p:txBody>
+            <a:bodyPr rtlCol="0" anchor="ctr"/>
+            <a:lstStyle/>
+            <a:p>
+              <a:pPr algn="ctr"/>
+              <a:endParaRPr lang="en-US"/>
+            </a:p>
+          </p:txBody>
+        </p:sp>
+        <p:pic>
+          <p:nvPicPr>
+            <p:cNvPr id="144" name="Graphic 143" descr="Doctor male with solid fill">
+              <a:extLst>
+                <a:ext uri="{FF2B5EF4-FFF2-40B4-BE49-F238E27FC236}">
+                  <a16:creationId xmlns:a16="http://schemas.microsoft.com/office/drawing/2014/main" id="{21832ED5-DFE3-3B09-5031-0D5EF240EC4F}"/>
+                </a:ext>
+              </a:extLst>
+            </p:cNvPr>
+            <p:cNvPicPr>
+              <a:picLocks noChangeAspect="1"/>
+            </p:cNvPicPr>
+            <p:nvPr/>
+          </p:nvPicPr>
+          <p:blipFill>
+            <a:blip>
+              <a:extLst>
+                <a:ext uri="{96DAC541-7B7A-43D3-8B79-37D633B846F1}">
+                  <asvg:svgBlip xmlns:asvg="http://schemas.microsoft.com/office/drawing/2016/SVG/main" r:embed="rId8"/>
+                </a:ext>
+              </a:extLst>
+            </a:blip>
+            <a:stretch>
+              <a:fillRect/>
+            </a:stretch>
+          </p:blipFill>
+          <p:spPr>
+            <a:xfrm>
+              <a:off x="9339675" y="1599471"/>
+              <a:ext cx="636856" cy="636856"/>
+            </a:xfrm>
+            <a:prstGeom prst="rect">
+              <a:avLst/>
+            </a:prstGeom>
+          </p:spPr>
+        </p:pic>
+        <mc:AlternateContent xmlns:mc="http://schemas.openxmlformats.org/markup-compatibility/2006">
+          <mc:Choice xmlns:a14="http://schemas.microsoft.com/office/drawing/2010/main" Requires="a14">
+            <p:sp>
+              <p:nvSpPr>
+                <p:cNvPr id="149" name="TextBox 148">
+                  <a:extLst>
+                    <a:ext uri="{FF2B5EF4-FFF2-40B4-BE49-F238E27FC236}">
+                      <a16:creationId xmlns:a16="http://schemas.microsoft.com/office/drawing/2014/main" id="{84CAEA05-165D-1B21-E127-F9C4C0683491}"/>
+                    </a:ext>
+                  </a:extLst>
+                </p:cNvPr>
+                <p:cNvSpPr txBox="1"/>
+                <p:nvPr/>
+              </p:nvSpPr>
+              <p:spPr>
+                <a:xfrm>
+                  <a:off x="7896231" y="707385"/>
+                  <a:ext cx="1126912" cy="1477328"/>
+                </a:xfrm>
+                <a:prstGeom prst="rect">
+                  <a:avLst/>
+                </a:prstGeom>
+                <a:noFill/>
+              </p:spPr>
+              <p:txBody>
+                <a:bodyPr wrap="none" lIns="0" tIns="0" rIns="0" bIns="0" rtlCol="0">
+                  <a:spAutoFit/>
+                </a:bodyPr>
+                <a:lstStyle/>
+                <a:p>
+                  <a14:m>
+                    <m:oMathPara xmlns:m="http://schemas.openxmlformats.org/officeDocument/2006/math">
+                      <m:oMathParaPr>
+                        <m:jc m:val="centerGroup"/>
+                      </m:oMathParaPr>
+                      <m:oMath xmlns:m="http://schemas.openxmlformats.org/officeDocument/2006/math">
+                        <m:r>
+                          <a:rPr lang="en-GB" sz="9600" b="0" i="1" smtClean="0">
+                            <a:latin typeface="Cambria Math" panose="02040503050406030204" pitchFamily="18" charset="0"/>
+                          </a:rPr>
+                          <m:t>~</m:t>
+                        </m:r>
+                      </m:oMath>
+                    </m:oMathPara>
+                  </a14:m>
+                  <a:endParaRPr lang="en-US" sz="9600" dirty="0"/>
+                </a:p>
+              </p:txBody>
+            </p:sp>
+          </mc:Choice>
+          <mc:Fallback>
+            <p:sp>
+              <p:nvSpPr>
+                <p:cNvPr id="149" name="TextBox 148">
+                  <a:extLst>
+                    <a:ext uri="{FF2B5EF4-FFF2-40B4-BE49-F238E27FC236}">
+                      <a16:creationId xmlns:a16="http://schemas.microsoft.com/office/drawing/2014/main" id="{84CAEA05-165D-1B21-E127-F9C4C0683491}"/>
+                    </a:ext>
+                  </a:extLst>
+                </p:cNvPr>
+                <p:cNvSpPr txBox="1">
+                  <a:spLocks noRot="1" noChangeAspect="1" noMove="1" noResize="1" noEditPoints="1" noAdjustHandles="1" noChangeArrowheads="1" noChangeShapeType="1" noTextEdit="1"/>
+                </p:cNvSpPr>
+                <p:nvPr/>
+              </p:nvSpPr>
+              <p:spPr>
+                <a:xfrm>
+                  <a:off x="7896231" y="707385"/>
+                  <a:ext cx="1126912" cy="1477328"/>
+                </a:xfrm>
+                <a:prstGeom prst="rect">
+                  <a:avLst/>
+                </a:prstGeom>
+                <a:blipFill>
+                  <a:blip r:embed="rId11"/>
+                  <a:stretch>
+                    <a:fillRect l="-8889" r="-8889"/>
+                  </a:stretch>
+                </a:blipFill>
+              </p:spPr>
+              <p:txBody>
+                <a:bodyPr/>
+                <a:lstStyle/>
+                <a:p>
+                  <a:r>
+                    <a:rPr lang="en-US">
+                      <a:noFill/>
+                    </a:rPr>
+                    <a:t> </a:t>
+                  </a:r>
+                </a:p>
+              </p:txBody>
+            </p:sp>
+          </mc:Fallback>
+        </mc:AlternateContent>
+      </p:grpSp>
+    </p:spTree>
+    <p:extLst>
+      <p:ext uri="{BB962C8B-B14F-4D97-AF65-F5344CB8AC3E}">
+        <p14:creationId xmlns:p14="http://schemas.microsoft.com/office/powerpoint/2010/main" val="1953519320"/>
       </p:ext>
     </p:extLst>
   </p:cSld>

</xml_diff>

<commit_message>
add walls in the 7 bed ward for simplification
</commit_message>
<xml_diff>
--- a/images/icu.pptx
+++ b/images/icu.pptx
@@ -3900,10 +3900,10 @@
       </p:grpSpPr>
       <p:grpSp>
         <p:nvGrpSpPr>
-          <p:cNvPr id="8" name="Group 7">
+          <p:cNvPr id="28" name="Group 27">
             <a:extLst>
               <a:ext uri="{FF2B5EF4-FFF2-40B4-BE49-F238E27FC236}">
-                <a16:creationId xmlns:a16="http://schemas.microsoft.com/office/drawing/2014/main" id="{7819292F-E7D8-28A1-7327-66AE9B1ADB47}"/>
+                <a16:creationId xmlns:a16="http://schemas.microsoft.com/office/drawing/2014/main" id="{67B37151-7E1B-ABAC-85B2-A8D6273AA92E}"/>
               </a:ext>
             </a:extLst>
           </p:cNvPr>
@@ -3918,6 +3918,214 @@
             <a:chExt cx="14891756" cy="5751433"/>
           </a:xfrm>
         </p:grpSpPr>
+        <p:sp>
+          <p:nvSpPr>
+            <p:cNvPr id="21" name="Rounded Rectangle 20">
+              <a:extLst>
+                <a:ext uri="{FF2B5EF4-FFF2-40B4-BE49-F238E27FC236}">
+                  <a16:creationId xmlns:a16="http://schemas.microsoft.com/office/drawing/2014/main" id="{21C98AAB-6CA6-20DB-A41F-3B1994D7723E}"/>
+                </a:ext>
+              </a:extLst>
+            </p:cNvPr>
+            <p:cNvSpPr/>
+            <p:nvPr/>
+          </p:nvSpPr>
+          <p:spPr>
+            <a:xfrm>
+              <a:off x="6241624" y="1172581"/>
+              <a:ext cx="2667896" cy="740158"/>
+            </a:xfrm>
+            <a:prstGeom prst="roundRect">
+              <a:avLst>
+                <a:gd name="adj" fmla="val 12460"/>
+              </a:avLst>
+            </a:prstGeom>
+            <a:solidFill>
+              <a:schemeClr val="bg2"/>
+            </a:solidFill>
+            <a:ln w="38100"/>
+          </p:spPr>
+          <p:style>
+            <a:lnRef idx="2">
+              <a:schemeClr val="accent1">
+                <a:shade val="15000"/>
+              </a:schemeClr>
+            </a:lnRef>
+            <a:fillRef idx="1">
+              <a:schemeClr val="accent1"/>
+            </a:fillRef>
+            <a:effectRef idx="0">
+              <a:schemeClr val="accent1"/>
+            </a:effectRef>
+            <a:fontRef idx="minor">
+              <a:schemeClr val="lt1"/>
+            </a:fontRef>
+          </p:style>
+          <p:txBody>
+            <a:bodyPr rtlCol="0" anchor="ctr"/>
+            <a:lstStyle/>
+            <a:p>
+              <a:pPr algn="ctr"/>
+              <a:endParaRPr lang="en-US"/>
+            </a:p>
+          </p:txBody>
+        </p:sp>
+        <p:sp>
+          <p:nvSpPr>
+            <p:cNvPr id="22" name="Rounded Rectangle 21">
+              <a:extLst>
+                <a:ext uri="{FF2B5EF4-FFF2-40B4-BE49-F238E27FC236}">
+                  <a16:creationId xmlns:a16="http://schemas.microsoft.com/office/drawing/2014/main" id="{BC95A054-F441-EF31-B0FE-A824E31CF48E}"/>
+                </a:ext>
+              </a:extLst>
+            </p:cNvPr>
+            <p:cNvSpPr/>
+            <p:nvPr/>
+          </p:nvSpPr>
+          <p:spPr>
+            <a:xfrm>
+              <a:off x="9249480" y="1158429"/>
+              <a:ext cx="2667896" cy="740158"/>
+            </a:xfrm>
+            <a:prstGeom prst="roundRect">
+              <a:avLst>
+                <a:gd name="adj" fmla="val 12460"/>
+              </a:avLst>
+            </a:prstGeom>
+            <a:solidFill>
+              <a:schemeClr val="bg2"/>
+            </a:solidFill>
+            <a:ln w="38100"/>
+          </p:spPr>
+          <p:style>
+            <a:lnRef idx="2">
+              <a:schemeClr val="accent1">
+                <a:shade val="15000"/>
+              </a:schemeClr>
+            </a:lnRef>
+            <a:fillRef idx="1">
+              <a:schemeClr val="accent1"/>
+            </a:fillRef>
+            <a:effectRef idx="0">
+              <a:schemeClr val="accent1"/>
+            </a:effectRef>
+            <a:fontRef idx="minor">
+              <a:schemeClr val="lt1"/>
+            </a:fontRef>
+          </p:style>
+          <p:txBody>
+            <a:bodyPr rtlCol="0" anchor="ctr"/>
+            <a:lstStyle/>
+            <a:p>
+              <a:pPr algn="ctr"/>
+              <a:endParaRPr lang="en-US"/>
+            </a:p>
+          </p:txBody>
+        </p:sp>
+        <p:sp>
+          <p:nvSpPr>
+            <p:cNvPr id="19" name="Rounded Rectangle 18">
+              <a:extLst>
+                <a:ext uri="{FF2B5EF4-FFF2-40B4-BE49-F238E27FC236}">
+                  <a16:creationId xmlns:a16="http://schemas.microsoft.com/office/drawing/2014/main" id="{C0A9E794-92D6-58C9-F037-AC37A9A59019}"/>
+                </a:ext>
+              </a:extLst>
+            </p:cNvPr>
+            <p:cNvSpPr/>
+            <p:nvPr/>
+          </p:nvSpPr>
+          <p:spPr>
+            <a:xfrm>
+              <a:off x="3239846" y="2073805"/>
+              <a:ext cx="2667896" cy="740158"/>
+            </a:xfrm>
+            <a:prstGeom prst="roundRect">
+              <a:avLst>
+                <a:gd name="adj" fmla="val 10876"/>
+              </a:avLst>
+            </a:prstGeom>
+            <a:solidFill>
+              <a:schemeClr val="bg2"/>
+            </a:solidFill>
+            <a:ln w="38100"/>
+          </p:spPr>
+          <p:style>
+            <a:lnRef idx="2">
+              <a:schemeClr val="accent1">
+                <a:shade val="15000"/>
+              </a:schemeClr>
+            </a:lnRef>
+            <a:fillRef idx="1">
+              <a:schemeClr val="accent1"/>
+            </a:fillRef>
+            <a:effectRef idx="0">
+              <a:schemeClr val="accent1"/>
+            </a:effectRef>
+            <a:fontRef idx="minor">
+              <a:schemeClr val="lt1"/>
+            </a:fontRef>
+          </p:style>
+          <p:txBody>
+            <a:bodyPr rtlCol="0" anchor="ctr"/>
+            <a:lstStyle/>
+            <a:p>
+              <a:pPr algn="ctr"/>
+              <a:endParaRPr lang="en-US"/>
+            </a:p>
+          </p:txBody>
+        </p:sp>
+        <p:sp>
+          <p:nvSpPr>
+            <p:cNvPr id="20" name="Rounded Rectangle 19">
+              <a:extLst>
+                <a:ext uri="{FF2B5EF4-FFF2-40B4-BE49-F238E27FC236}">
+                  <a16:creationId xmlns:a16="http://schemas.microsoft.com/office/drawing/2014/main" id="{0B45577F-E9D8-9955-87C6-8CDD356067F0}"/>
+                </a:ext>
+              </a:extLst>
+            </p:cNvPr>
+            <p:cNvSpPr/>
+            <p:nvPr/>
+          </p:nvSpPr>
+          <p:spPr>
+            <a:xfrm>
+              <a:off x="3233768" y="1172581"/>
+              <a:ext cx="2667896" cy="740158"/>
+            </a:xfrm>
+            <a:prstGeom prst="roundRect">
+              <a:avLst>
+                <a:gd name="adj" fmla="val 12460"/>
+              </a:avLst>
+            </a:prstGeom>
+            <a:solidFill>
+              <a:schemeClr val="bg2"/>
+            </a:solidFill>
+            <a:ln w="38100"/>
+          </p:spPr>
+          <p:style>
+            <a:lnRef idx="2">
+              <a:schemeClr val="accent1">
+                <a:shade val="15000"/>
+              </a:schemeClr>
+            </a:lnRef>
+            <a:fillRef idx="1">
+              <a:schemeClr val="accent1"/>
+            </a:fillRef>
+            <a:effectRef idx="0">
+              <a:schemeClr val="accent1"/>
+            </a:effectRef>
+            <a:fontRef idx="minor">
+              <a:schemeClr val="lt1"/>
+            </a:fontRef>
+          </p:style>
+          <p:txBody>
+            <a:bodyPr rtlCol="0" anchor="ctr"/>
+            <a:lstStyle/>
+            <a:p>
+              <a:pPr algn="ctr"/>
+              <a:endParaRPr lang="en-US"/>
+            </a:p>
+          </p:txBody>
+        </p:sp>
         <p:sp>
           <p:nvSpPr>
             <p:cNvPr id="4" name="Rounded Rectangle 3">
@@ -3984,8 +4192,8 @@
           </p:nvSpPr>
           <p:spPr>
             <a:xfrm>
-              <a:off x="3239846" y="1172582"/>
-              <a:ext cx="2667896" cy="5228213"/>
+              <a:off x="3239846" y="2942492"/>
+              <a:ext cx="2667896" cy="3458303"/>
             </a:xfrm>
             <a:prstGeom prst="roundRect">
               <a:avLst>
@@ -4036,8 +4244,8 @@
           </p:nvSpPr>
           <p:spPr>
             <a:xfrm>
-              <a:off x="6253780" y="1172581"/>
-              <a:ext cx="2667896" cy="5228213"/>
+              <a:off x="6253780" y="2091537"/>
+              <a:ext cx="2667896" cy="4309257"/>
             </a:xfrm>
             <a:prstGeom prst="roundRect">
               <a:avLst>
@@ -4088,8 +4296,8 @@
           </p:nvSpPr>
           <p:spPr>
             <a:xfrm>
-              <a:off x="9267714" y="1172581"/>
-              <a:ext cx="2667896" cy="5228213"/>
+              <a:off x="9267714" y="2073805"/>
+              <a:ext cx="2667896" cy="4326989"/>
             </a:xfrm>
             <a:prstGeom prst="roundRect">
               <a:avLst>
@@ -4266,132 +4474,6 @@
             </a:p>
           </p:txBody>
         </p:sp>
-        <p:cxnSp>
-          <p:nvCxnSpPr>
-            <p:cNvPr id="23" name="Straight Connector 22">
-              <a:extLst>
-                <a:ext uri="{FF2B5EF4-FFF2-40B4-BE49-F238E27FC236}">
-                  <a16:creationId xmlns:a16="http://schemas.microsoft.com/office/drawing/2014/main" id="{1BEF9433-03AC-D6B3-A3B6-38D7FD92F7F8}"/>
-                </a:ext>
-              </a:extLst>
-            </p:cNvPr>
-            <p:cNvCxnSpPr/>
-            <p:nvPr/>
-          </p:nvCxnSpPr>
-          <p:spPr>
-            <a:xfrm>
-              <a:off x="3239846" y="1916653"/>
-              <a:ext cx="2667896" cy="0"/>
-            </a:xfrm>
-            <a:prstGeom prst="line">
-              <a:avLst/>
-            </a:prstGeom>
-            <a:ln w="34925">
-              <a:solidFill>
-                <a:schemeClr val="tx1"/>
-              </a:solidFill>
-              <a:prstDash val="dash"/>
-            </a:ln>
-          </p:spPr>
-          <p:style>
-            <a:lnRef idx="2">
-              <a:schemeClr val="accent1"/>
-            </a:lnRef>
-            <a:fillRef idx="0">
-              <a:schemeClr val="accent1"/>
-            </a:fillRef>
-            <a:effectRef idx="1">
-              <a:schemeClr val="accent1"/>
-            </a:effectRef>
-            <a:fontRef idx="minor">
-              <a:schemeClr val="tx1"/>
-            </a:fontRef>
-          </p:style>
-        </p:cxnSp>
-        <p:cxnSp>
-          <p:nvCxnSpPr>
-            <p:cNvPr id="32" name="Straight Connector 31">
-              <a:extLst>
-                <a:ext uri="{FF2B5EF4-FFF2-40B4-BE49-F238E27FC236}">
-                  <a16:creationId xmlns:a16="http://schemas.microsoft.com/office/drawing/2014/main" id="{7E0D07E9-5C9D-B412-BCED-1F0849BA94C1}"/>
-                </a:ext>
-              </a:extLst>
-            </p:cNvPr>
-            <p:cNvCxnSpPr/>
-            <p:nvPr/>
-          </p:nvCxnSpPr>
-          <p:spPr>
-            <a:xfrm>
-              <a:off x="6253780" y="1909480"/>
-              <a:ext cx="2667896" cy="0"/>
-            </a:xfrm>
-            <a:prstGeom prst="line">
-              <a:avLst/>
-            </a:prstGeom>
-            <a:ln w="34925">
-              <a:solidFill>
-                <a:schemeClr val="tx1"/>
-              </a:solidFill>
-              <a:prstDash val="dash"/>
-            </a:ln>
-          </p:spPr>
-          <p:style>
-            <a:lnRef idx="2">
-              <a:schemeClr val="accent1"/>
-            </a:lnRef>
-            <a:fillRef idx="0">
-              <a:schemeClr val="accent1"/>
-            </a:fillRef>
-            <a:effectRef idx="1">
-              <a:schemeClr val="accent1"/>
-            </a:effectRef>
-            <a:fontRef idx="minor">
-              <a:schemeClr val="tx1"/>
-            </a:fontRef>
-          </p:style>
-        </p:cxnSp>
-        <p:cxnSp>
-          <p:nvCxnSpPr>
-            <p:cNvPr id="33" name="Straight Connector 32">
-              <a:extLst>
-                <a:ext uri="{FF2B5EF4-FFF2-40B4-BE49-F238E27FC236}">
-                  <a16:creationId xmlns:a16="http://schemas.microsoft.com/office/drawing/2014/main" id="{0A6B6FB1-6B06-D93C-DA48-2B45E93F2615}"/>
-                </a:ext>
-              </a:extLst>
-            </p:cNvPr>
-            <p:cNvCxnSpPr/>
-            <p:nvPr/>
-          </p:nvCxnSpPr>
-          <p:spPr>
-            <a:xfrm>
-              <a:off x="9267714" y="1895134"/>
-              <a:ext cx="2667896" cy="0"/>
-            </a:xfrm>
-            <a:prstGeom prst="line">
-              <a:avLst/>
-            </a:prstGeom>
-            <a:ln w="34925">
-              <a:solidFill>
-                <a:schemeClr val="tx1"/>
-              </a:solidFill>
-              <a:prstDash val="dash"/>
-            </a:ln>
-          </p:spPr>
-          <p:style>
-            <a:lnRef idx="2">
-              <a:schemeClr val="accent1"/>
-            </a:lnRef>
-            <a:fillRef idx="0">
-              <a:schemeClr val="accent1"/>
-            </a:fillRef>
-            <a:effectRef idx="1">
-              <a:schemeClr val="accent1"/>
-            </a:effectRef>
-            <a:fontRef idx="minor">
-              <a:schemeClr val="tx1"/>
-            </a:fontRef>
-          </p:style>
-        </p:cxnSp>
         <p:pic>
           <p:nvPicPr>
             <p:cNvPr id="38" name="Graphic 37" descr="Sleep with solid fill">
@@ -4699,7 +4781,7 @@
           </p:blipFill>
           <p:spPr>
             <a:xfrm>
-              <a:off x="4256446" y="1265370"/>
+              <a:off x="4256446" y="1218478"/>
               <a:ext cx="634696" cy="634696"/>
             </a:xfrm>
             <a:prstGeom prst="rect">
@@ -4734,7 +4816,7 @@
           </p:blipFill>
           <p:spPr>
             <a:xfrm>
-              <a:off x="7270380" y="1261784"/>
+              <a:off x="7270380" y="1226615"/>
               <a:ext cx="634696" cy="634696"/>
             </a:xfrm>
             <a:prstGeom prst="rect">
@@ -4769,7 +4851,7 @@
           </p:blipFill>
           <p:spPr>
             <a:xfrm>
-              <a:off x="10284314" y="1261784"/>
+              <a:off x="10284314" y="1214892"/>
               <a:ext cx="634696" cy="634696"/>
             </a:xfrm>
             <a:prstGeom prst="rect">
@@ -5504,7 +5586,7 @@
           </p:blipFill>
           <p:spPr>
             <a:xfrm>
-              <a:off x="6737464" y="4073560"/>
+              <a:off x="6737464" y="4321078"/>
               <a:ext cx="634696" cy="634696"/>
             </a:xfrm>
             <a:prstGeom prst="rect">
@@ -5539,7 +5621,7 @@
           </p:blipFill>
           <p:spPr>
             <a:xfrm>
-              <a:off x="7803296" y="4073560"/>
+              <a:off x="7803296" y="4321078"/>
               <a:ext cx="634696" cy="634696"/>
             </a:xfrm>
             <a:prstGeom prst="rect">
@@ -5574,7 +5656,7 @@
           </p:blipFill>
           <p:spPr>
             <a:xfrm>
-              <a:off x="7232534" y="4912649"/>
+              <a:off x="7232534" y="5160167"/>
               <a:ext cx="634696" cy="634696"/>
             </a:xfrm>
             <a:prstGeom prst="rect">
@@ -5582,48 +5664,6 @@
             </a:prstGeom>
           </p:spPr>
         </p:pic>
-        <p:cxnSp>
-          <p:nvCxnSpPr>
-            <p:cNvPr id="141" name="Straight Connector 140">
-              <a:extLst>
-                <a:ext uri="{FF2B5EF4-FFF2-40B4-BE49-F238E27FC236}">
-                  <a16:creationId xmlns:a16="http://schemas.microsoft.com/office/drawing/2014/main" id="{F85ED1AE-129F-F15E-72DA-824C1F89B163}"/>
-                </a:ext>
-              </a:extLst>
-            </p:cNvPr>
-            <p:cNvCxnSpPr/>
-            <p:nvPr/>
-          </p:nvCxnSpPr>
-          <p:spPr>
-            <a:xfrm>
-              <a:off x="3239846" y="2754416"/>
-              <a:ext cx="2667896" cy="0"/>
-            </a:xfrm>
-            <a:prstGeom prst="line">
-              <a:avLst/>
-            </a:prstGeom>
-            <a:ln w="34925">
-              <a:solidFill>
-                <a:schemeClr val="tx1"/>
-              </a:solidFill>
-              <a:prstDash val="dash"/>
-            </a:ln>
-          </p:spPr>
-          <p:style>
-            <a:lnRef idx="2">
-              <a:schemeClr val="accent1"/>
-            </a:lnRef>
-            <a:fillRef idx="0">
-              <a:schemeClr val="accent1"/>
-            </a:fillRef>
-            <a:effectRef idx="1">
-              <a:schemeClr val="accent1"/>
-            </a:effectRef>
-            <a:fontRef idx="minor">
-              <a:schemeClr val="tx1"/>
-            </a:fontRef>
-          </p:style>
-        </p:cxnSp>
         <p:pic>
           <p:nvPicPr>
             <p:cNvPr id="142" name="Graphic 141" descr="Sleep with solid fill">
@@ -5651,7 +5691,7 @@
           </p:blipFill>
           <p:spPr>
             <a:xfrm>
-              <a:off x="4256446" y="2056368"/>
+              <a:off x="4256446" y="2103260"/>
               <a:ext cx="634696" cy="634696"/>
             </a:xfrm>
             <a:prstGeom prst="rect">
@@ -5900,7 +5940,7 @@
           <p:spPr>
             <a:xfrm>
               <a:off x="225912" y="3803847"/>
-              <a:ext cx="1456132" cy="0"/>
+              <a:ext cx="1866864" cy="8103"/>
             </a:xfrm>
             <a:prstGeom prst="line">
               <a:avLst/>
@@ -5944,7 +5984,95 @@
           <p:spPr>
             <a:xfrm>
               <a:off x="9267714" y="4122861"/>
-              <a:ext cx="1456132" cy="0"/>
+              <a:ext cx="1897342" cy="0"/>
+            </a:xfrm>
+            <a:prstGeom prst="line">
+              <a:avLst/>
+            </a:prstGeom>
+            <a:ln w="47625">
+              <a:solidFill>
+                <a:schemeClr val="tx1"/>
+              </a:solidFill>
+              <a:prstDash val="sysDot"/>
+            </a:ln>
+          </p:spPr>
+          <p:style>
+            <a:lnRef idx="2">
+              <a:schemeClr val="accent1"/>
+            </a:lnRef>
+            <a:fillRef idx="0">
+              <a:schemeClr val="accent1"/>
+            </a:fillRef>
+            <a:effectRef idx="1">
+              <a:schemeClr val="accent1"/>
+            </a:effectRef>
+            <a:fontRef idx="minor">
+              <a:schemeClr val="tx1"/>
+            </a:fontRef>
+          </p:style>
+        </p:cxnSp>
+        <p:cxnSp>
+          <p:nvCxnSpPr>
+            <p:cNvPr id="6" name="Straight Connector 5">
+              <a:extLst>
+                <a:ext uri="{FF2B5EF4-FFF2-40B4-BE49-F238E27FC236}">
+                  <a16:creationId xmlns:a16="http://schemas.microsoft.com/office/drawing/2014/main" id="{21B22427-5507-8097-FC57-9EDC00D8BF7F}"/>
+                </a:ext>
+              </a:extLst>
+            </p:cNvPr>
+            <p:cNvCxnSpPr>
+              <a:cxnSpLocks/>
+            </p:cNvCxnSpPr>
+            <p:nvPr/>
+          </p:nvCxnSpPr>
+          <p:spPr>
+            <a:xfrm>
+              <a:off x="3239846" y="4690380"/>
+              <a:ext cx="1866470" cy="17876"/>
+            </a:xfrm>
+            <a:prstGeom prst="line">
+              <a:avLst/>
+            </a:prstGeom>
+            <a:ln w="47625">
+              <a:solidFill>
+                <a:schemeClr val="tx1"/>
+              </a:solidFill>
+              <a:prstDash val="sysDot"/>
+            </a:ln>
+          </p:spPr>
+          <p:style>
+            <a:lnRef idx="2">
+              <a:schemeClr val="accent1"/>
+            </a:lnRef>
+            <a:fillRef idx="0">
+              <a:schemeClr val="accent1"/>
+            </a:fillRef>
+            <a:effectRef idx="1">
+              <a:schemeClr val="accent1"/>
+            </a:effectRef>
+            <a:fontRef idx="minor">
+              <a:schemeClr val="tx1"/>
+            </a:fontRef>
+          </p:style>
+        </p:cxnSp>
+        <p:cxnSp>
+          <p:nvCxnSpPr>
+            <p:cNvPr id="16" name="Straight Connector 15">
+              <a:extLst>
+                <a:ext uri="{FF2B5EF4-FFF2-40B4-BE49-F238E27FC236}">
+                  <a16:creationId xmlns:a16="http://schemas.microsoft.com/office/drawing/2014/main" id="{BE2184ED-F722-140A-3DE8-7AA5D8CD27E3}"/>
+                </a:ext>
+              </a:extLst>
+            </p:cNvPr>
+            <p:cNvCxnSpPr>
+              <a:cxnSpLocks/>
+            </p:cNvCxnSpPr>
+            <p:nvPr/>
+          </p:nvCxnSpPr>
+          <p:spPr>
+            <a:xfrm>
+              <a:off x="6253780" y="4184442"/>
+              <a:ext cx="1866864" cy="2074"/>
             </a:xfrm>
             <a:prstGeom prst="line">
               <a:avLst/>
@@ -11533,10 +11661,10 @@
       </p:grpSpPr>
       <p:grpSp>
         <p:nvGrpSpPr>
-          <p:cNvPr id="5" name="Group 4">
+          <p:cNvPr id="9" name="Group 8">
             <a:extLst>
               <a:ext uri="{FF2B5EF4-FFF2-40B4-BE49-F238E27FC236}">
-                <a16:creationId xmlns:a16="http://schemas.microsoft.com/office/drawing/2014/main" id="{F6595D03-EB6E-3E3E-BD60-5E2D5286FCE4}"/>
+                <a16:creationId xmlns:a16="http://schemas.microsoft.com/office/drawing/2014/main" id="{6135155F-FDB0-DFEE-0F54-FF0D62DFCAF6}"/>
               </a:ext>
             </a:extLst>
           </p:cNvPr>
@@ -12271,7 +12399,7 @@
           <p:spPr>
             <a:xfrm>
               <a:off x="558779" y="2753115"/>
-              <a:ext cx="7772421" cy="1216301"/>
+              <a:ext cx="4413929" cy="1216301"/>
             </a:xfrm>
             <a:prstGeom prst="roundRect">
               <a:avLst>
@@ -13041,6 +13169,64 @@
             <a:xfrm>
               <a:off x="5015752" y="4361056"/>
               <a:ext cx="4413929" cy="1216301"/>
+            </a:xfrm>
+            <a:prstGeom prst="roundRect">
+              <a:avLst>
+                <a:gd name="adj" fmla="val 36591"/>
+              </a:avLst>
+            </a:prstGeom>
+            <a:solidFill>
+              <a:srgbClr val="00B0F0">
+                <a:alpha val="25714"/>
+              </a:srgbClr>
+            </a:solidFill>
+            <a:ln w="34925">
+              <a:solidFill>
+                <a:srgbClr val="0070C0"/>
+              </a:solidFill>
+            </a:ln>
+          </p:spPr>
+          <p:style>
+            <a:lnRef idx="2">
+              <a:schemeClr val="accent1">
+                <a:shade val="15000"/>
+              </a:schemeClr>
+            </a:lnRef>
+            <a:fillRef idx="1">
+              <a:schemeClr val="accent1"/>
+            </a:fillRef>
+            <a:effectRef idx="0">
+              <a:schemeClr val="accent1"/>
+            </a:effectRef>
+            <a:fontRef idx="minor">
+              <a:schemeClr val="lt1"/>
+            </a:fontRef>
+          </p:style>
+          <p:txBody>
+            <a:bodyPr rtlCol="0" anchor="ctr"/>
+            <a:lstStyle/>
+            <a:p>
+              <a:pPr algn="ctr"/>
+              <a:endParaRPr lang="en-US"/>
+            </a:p>
+          </p:txBody>
+        </p:sp>
+        <p:sp>
+          <p:nvSpPr>
+            <p:cNvPr id="2" name="Rounded Rectangle 1">
+              <a:extLst>
+                <a:ext uri="{FF2B5EF4-FFF2-40B4-BE49-F238E27FC236}">
+                  <a16:creationId xmlns:a16="http://schemas.microsoft.com/office/drawing/2014/main" id="{4EAD0853-0B61-56E8-F5DF-732583AFBAA1}"/>
+                </a:ext>
+              </a:extLst>
+            </p:cNvPr>
+            <p:cNvSpPr/>
+            <p:nvPr/>
+          </p:nvSpPr>
+          <p:spPr>
+            <a:xfrm>
+              <a:off x="5044867" y="2769053"/>
+              <a:ext cx="3208180" cy="1216301"/>
             </a:xfrm>
             <a:prstGeom prst="roundRect">
               <a:avLst>
@@ -13122,10 +13308,10 @@
       </p:grpSpPr>
       <p:grpSp>
         <p:nvGrpSpPr>
-          <p:cNvPr id="4" name="Group 3">
+          <p:cNvPr id="11" name="Group 10">
             <a:extLst>
               <a:ext uri="{FF2B5EF4-FFF2-40B4-BE49-F238E27FC236}">
-                <a16:creationId xmlns:a16="http://schemas.microsoft.com/office/drawing/2014/main" id="{1A4A71B0-9642-F627-57C5-ED44E2AD9A09}"/>
+                <a16:creationId xmlns:a16="http://schemas.microsoft.com/office/drawing/2014/main" id="{FBD1AB9F-99B8-489C-7E92-38C8B550159A}"/>
               </a:ext>
             </a:extLst>
           </p:cNvPr>
@@ -13197,6 +13383,122 @@
         </p:sp>
         <p:sp>
           <p:nvSpPr>
+            <p:cNvPr id="2" name="Rounded Rectangle 1">
+              <a:extLst>
+                <a:ext uri="{FF2B5EF4-FFF2-40B4-BE49-F238E27FC236}">
+                  <a16:creationId xmlns:a16="http://schemas.microsoft.com/office/drawing/2014/main" id="{9F7A5CA0-D1B4-5B79-524D-9ED242F9E643}"/>
+                </a:ext>
+              </a:extLst>
+            </p:cNvPr>
+            <p:cNvSpPr/>
+            <p:nvPr/>
+          </p:nvSpPr>
+          <p:spPr>
+            <a:xfrm>
+              <a:off x="5255767" y="3614372"/>
+              <a:ext cx="4305899" cy="2097152"/>
+            </a:xfrm>
+            <a:prstGeom prst="roundRect">
+              <a:avLst>
+                <a:gd name="adj" fmla="val 21519"/>
+              </a:avLst>
+            </a:prstGeom>
+            <a:solidFill>
+              <a:srgbClr val="00B0F0">
+                <a:alpha val="25714"/>
+              </a:srgbClr>
+            </a:solidFill>
+            <a:ln w="34925">
+              <a:solidFill>
+                <a:srgbClr val="0070C0"/>
+              </a:solidFill>
+            </a:ln>
+          </p:spPr>
+          <p:style>
+            <a:lnRef idx="2">
+              <a:schemeClr val="accent1">
+                <a:shade val="15000"/>
+              </a:schemeClr>
+            </a:lnRef>
+            <a:fillRef idx="1">
+              <a:schemeClr val="accent1"/>
+            </a:fillRef>
+            <a:effectRef idx="0">
+              <a:schemeClr val="accent1"/>
+            </a:effectRef>
+            <a:fontRef idx="minor">
+              <a:schemeClr val="lt1"/>
+            </a:fontRef>
+          </p:style>
+          <p:txBody>
+            <a:bodyPr rtlCol="0" anchor="ctr"/>
+            <a:lstStyle/>
+            <a:p>
+              <a:pPr algn="ctr"/>
+              <a:endParaRPr lang="en-US"/>
+            </a:p>
+          </p:txBody>
+        </p:sp>
+        <p:sp>
+          <p:nvSpPr>
+            <p:cNvPr id="9" name="Rounded Rectangle 8">
+              <a:extLst>
+                <a:ext uri="{FF2B5EF4-FFF2-40B4-BE49-F238E27FC236}">
+                  <a16:creationId xmlns:a16="http://schemas.microsoft.com/office/drawing/2014/main" id="{76BC5ABA-6562-07B4-6926-71C292AA4F8B}"/>
+                </a:ext>
+              </a:extLst>
+            </p:cNvPr>
+            <p:cNvSpPr/>
+            <p:nvPr/>
+          </p:nvSpPr>
+          <p:spPr>
+            <a:xfrm>
+              <a:off x="5255766" y="1367293"/>
+              <a:ext cx="3360899" cy="2097152"/>
+            </a:xfrm>
+            <a:prstGeom prst="roundRect">
+              <a:avLst>
+                <a:gd name="adj" fmla="val 21519"/>
+              </a:avLst>
+            </a:prstGeom>
+            <a:solidFill>
+              <a:srgbClr val="00B0F0">
+                <a:alpha val="25714"/>
+              </a:srgbClr>
+            </a:solidFill>
+            <a:ln w="34925">
+              <a:solidFill>
+                <a:srgbClr val="0070C0"/>
+              </a:solidFill>
+            </a:ln>
+          </p:spPr>
+          <p:style>
+            <a:lnRef idx="2">
+              <a:schemeClr val="accent1">
+                <a:shade val="15000"/>
+              </a:schemeClr>
+            </a:lnRef>
+            <a:fillRef idx="1">
+              <a:schemeClr val="accent1"/>
+            </a:fillRef>
+            <a:effectRef idx="0">
+              <a:schemeClr val="accent1"/>
+            </a:effectRef>
+            <a:fontRef idx="minor">
+              <a:schemeClr val="lt1"/>
+            </a:fontRef>
+          </p:style>
+          <p:txBody>
+            <a:bodyPr rtlCol="0" anchor="ctr"/>
+            <a:lstStyle/>
+            <a:p>
+              <a:pPr algn="ctr"/>
+              <a:endParaRPr lang="en-US"/>
+            </a:p>
+          </p:txBody>
+        </p:sp>
+        <p:sp>
+          <p:nvSpPr>
             <p:cNvPr id="113" name="Rounded Rectangle 112">
               <a:extLst>
                 <a:ext uri="{FF2B5EF4-FFF2-40B4-BE49-F238E27FC236}">
@@ -13210,7 +13512,7 @@
           <p:spPr>
             <a:xfrm>
               <a:off x="667897" y="1373741"/>
-              <a:ext cx="7791352" cy="2097152"/>
+              <a:ext cx="4420820" cy="2097152"/>
             </a:xfrm>
             <a:prstGeom prst="roundRect">
               <a:avLst>
@@ -14463,7 +14765,7 @@
           </p:blipFill>
           <p:spPr>
             <a:xfrm>
-              <a:off x="5307934" y="1709327"/>
+              <a:off x="5507225" y="1709327"/>
               <a:ext cx="634696" cy="634696"/>
             </a:xfrm>
             <a:prstGeom prst="rect">
@@ -14498,7 +14800,7 @@
           </p:blipFill>
           <p:spPr>
             <a:xfrm>
-              <a:off x="6373766" y="1709327"/>
+              <a:off x="6573057" y="1709327"/>
               <a:ext cx="634696" cy="634696"/>
             </a:xfrm>
             <a:prstGeom prst="rect">
@@ -14533,7 +14835,7 @@
           </p:blipFill>
           <p:spPr>
             <a:xfrm>
-              <a:off x="7483099" y="1709327"/>
+              <a:off x="7682390" y="1709327"/>
               <a:ext cx="634696" cy="634696"/>
             </a:xfrm>
             <a:prstGeom prst="rect">
@@ -14695,7 +14997,7 @@
           </p:nvSpPr>
           <p:spPr>
             <a:xfrm>
-              <a:off x="5353803" y="1559400"/>
+              <a:off x="5553094" y="1559400"/>
               <a:ext cx="570990" cy="369332"/>
             </a:xfrm>
             <a:prstGeom prst="rect">
@@ -14730,7 +15032,7 @@
           </p:nvSpPr>
           <p:spPr>
             <a:xfrm>
-              <a:off x="6415608" y="1559400"/>
+              <a:off x="6614899" y="1559400"/>
               <a:ext cx="570990" cy="369332"/>
             </a:xfrm>
             <a:prstGeom prst="rect">
@@ -14765,7 +15067,7 @@
           </p:nvSpPr>
           <p:spPr>
             <a:xfrm>
-              <a:off x="7482268" y="1559400"/>
+              <a:off x="7681559" y="1559400"/>
               <a:ext cx="570990" cy="369332"/>
             </a:xfrm>
             <a:prstGeom prst="rect">
@@ -15020,7 +15322,7 @@
           </p:blipFill>
           <p:spPr>
             <a:xfrm>
-              <a:off x="5858049" y="2570222"/>
+              <a:off x="6057340" y="2570222"/>
               <a:ext cx="636856" cy="636856"/>
             </a:xfrm>
             <a:prstGeom prst="rect">
@@ -15219,7 +15521,7 @@
           </p:nvSpPr>
           <p:spPr>
             <a:xfrm rot="16200000">
-              <a:off x="5991811" y="1321673"/>
+              <a:off x="6191102" y="1321673"/>
               <a:ext cx="369333" cy="2035851"/>
             </a:xfrm>
             <a:prstGeom prst="leftBracket">
@@ -15467,64 +15769,6 @@
             </a:prstGeom>
           </p:spPr>
         </p:pic>
-        <p:sp>
-          <p:nvSpPr>
-            <p:cNvPr id="2" name="Rounded Rectangle 1">
-              <a:extLst>
-                <a:ext uri="{FF2B5EF4-FFF2-40B4-BE49-F238E27FC236}">
-                  <a16:creationId xmlns:a16="http://schemas.microsoft.com/office/drawing/2014/main" id="{9F7A5CA0-D1B4-5B79-524D-9ED242F9E643}"/>
-                </a:ext>
-              </a:extLst>
-            </p:cNvPr>
-            <p:cNvSpPr/>
-            <p:nvPr/>
-          </p:nvSpPr>
-          <p:spPr>
-            <a:xfrm>
-              <a:off x="5255767" y="3614372"/>
-              <a:ext cx="4305899" cy="2097152"/>
-            </a:xfrm>
-            <a:prstGeom prst="roundRect">
-              <a:avLst>
-                <a:gd name="adj" fmla="val 21519"/>
-              </a:avLst>
-            </a:prstGeom>
-            <a:solidFill>
-              <a:srgbClr val="00B0F0">
-                <a:alpha val="25714"/>
-              </a:srgbClr>
-            </a:solidFill>
-            <a:ln w="34925">
-              <a:solidFill>
-                <a:srgbClr val="0070C0"/>
-              </a:solidFill>
-            </a:ln>
-          </p:spPr>
-          <p:style>
-            <a:lnRef idx="2">
-              <a:schemeClr val="accent1">
-                <a:shade val="15000"/>
-              </a:schemeClr>
-            </a:lnRef>
-            <a:fillRef idx="1">
-              <a:schemeClr val="accent1"/>
-            </a:fillRef>
-            <a:effectRef idx="0">
-              <a:schemeClr val="accent1"/>
-            </a:effectRef>
-            <a:fontRef idx="minor">
-              <a:schemeClr val="lt1"/>
-            </a:fontRef>
-          </p:style>
-          <p:txBody>
-            <a:bodyPr rtlCol="0" anchor="ctr"/>
-            <a:lstStyle/>
-            <a:p>
-              <a:pPr algn="ctr"/>
-              <a:endParaRPr lang="en-US"/>
-            </a:p>
-          </p:txBody>
-        </p:sp>
       </p:grpSp>
     </p:spTree>
     <p:extLst>
@@ -17358,8 +17602,8 @@
             </a:prstGeom>
           </p:spPr>
         </p:pic>
-        <mc:AlternateContent xmlns:mc="http://schemas.openxmlformats.org/markup-compatibility/2006">
-          <mc:Choice xmlns:a14="http://schemas.microsoft.com/office/drawing/2010/main" Requires="a14">
+        <mc:AlternateContent xmlns:mc="http://schemas.openxmlformats.org/markup-compatibility/2006" xmlns:a14="http://schemas.microsoft.com/office/drawing/2010/main">
+          <mc:Choice Requires="a14">
             <p:sp>
               <p:nvSpPr>
                 <p:cNvPr id="149" name="TextBox 148">
@@ -17388,6 +17632,7 @@
                 </a:bodyPr>
                 <a:lstStyle/>
                 <a:p>
+                  <a:pPr/>
                   <a14:m>
                     <m:oMathPara xmlns:m="http://schemas.openxmlformats.org/officeDocument/2006/math">
                       <m:oMathParaPr>
@@ -17408,7 +17653,7 @@
               </p:txBody>
             </p:sp>
           </mc:Choice>
-          <mc:Fallback>
+          <mc:Fallback xmlns="">
             <p:sp>
               <p:nvSpPr>
                 <p:cNvPr id="149" name="TextBox 148">
@@ -17435,6 +17680,1139 @@
                   <a:blip r:embed="rId11"/>
                   <a:stretch>
                     <a:fillRect l="-8889" r="-8889"/>
+                  </a:stretch>
+                </a:blipFill>
+              </p:spPr>
+              <p:txBody>
+                <a:bodyPr/>
+                <a:lstStyle/>
+                <a:p>
+                  <a:r>
+                    <a:rPr lang="en-US">
+                      <a:noFill/>
+                    </a:rPr>
+                    <a:t> </a:t>
+                  </a:r>
+                </a:p>
+              </p:txBody>
+            </p:sp>
+          </mc:Fallback>
+        </mc:AlternateContent>
+      </p:grpSp>
+      <p:grpSp>
+        <p:nvGrpSpPr>
+          <p:cNvPr id="29" name="Group 28">
+            <a:extLst>
+              <a:ext uri="{FF2B5EF4-FFF2-40B4-BE49-F238E27FC236}">
+                <a16:creationId xmlns:a16="http://schemas.microsoft.com/office/drawing/2014/main" id="{177F633E-11C8-3738-4634-063B4163767D}"/>
+              </a:ext>
+            </a:extLst>
+          </p:cNvPr>
+          <p:cNvGrpSpPr/>
+          <p:nvPr/>
+        </p:nvGrpSpPr>
+        <p:grpSpPr>
+          <a:xfrm>
+            <a:off x="855237" y="3675232"/>
+            <a:ext cx="10006814" cy="2175446"/>
+            <a:chOff x="855237" y="3675232"/>
+            <a:chExt cx="10006814" cy="2175446"/>
+          </a:xfrm>
+        </p:grpSpPr>
+        <p:sp>
+          <p:nvSpPr>
+            <p:cNvPr id="2" name="Rounded Rectangle 1">
+              <a:extLst>
+                <a:ext uri="{FF2B5EF4-FFF2-40B4-BE49-F238E27FC236}">
+                  <a16:creationId xmlns:a16="http://schemas.microsoft.com/office/drawing/2014/main" id="{CA14CC8A-CB15-2D4D-8B37-87C9F7116876}"/>
+                </a:ext>
+              </a:extLst>
+            </p:cNvPr>
+            <p:cNvSpPr/>
+            <p:nvPr/>
+          </p:nvSpPr>
+          <p:spPr>
+            <a:xfrm>
+              <a:off x="855237" y="3753526"/>
+              <a:ext cx="4420820" cy="2097152"/>
+            </a:xfrm>
+            <a:prstGeom prst="roundRect">
+              <a:avLst>
+                <a:gd name="adj" fmla="val 21519"/>
+              </a:avLst>
+            </a:prstGeom>
+            <a:solidFill>
+              <a:srgbClr val="00B0F0">
+                <a:alpha val="25714"/>
+              </a:srgbClr>
+            </a:solidFill>
+            <a:ln w="34925">
+              <a:solidFill>
+                <a:srgbClr val="0070C0"/>
+              </a:solidFill>
+            </a:ln>
+          </p:spPr>
+          <p:style>
+            <a:lnRef idx="2">
+              <a:schemeClr val="accent1">
+                <a:shade val="15000"/>
+              </a:schemeClr>
+            </a:lnRef>
+            <a:fillRef idx="1">
+              <a:schemeClr val="accent1"/>
+            </a:fillRef>
+            <a:effectRef idx="0">
+              <a:schemeClr val="accent1"/>
+            </a:effectRef>
+            <a:fontRef idx="minor">
+              <a:schemeClr val="lt1"/>
+            </a:fontRef>
+          </p:style>
+          <p:txBody>
+            <a:bodyPr rtlCol="0" anchor="ctr"/>
+            <a:lstStyle/>
+            <a:p>
+              <a:pPr algn="ctr"/>
+              <a:endParaRPr lang="en-US"/>
+            </a:p>
+          </p:txBody>
+        </p:sp>
+        <p:pic>
+          <p:nvPicPr>
+            <p:cNvPr id="3" name="Graphic 2" descr="Bed with solid fill">
+              <a:extLst>
+                <a:ext uri="{FF2B5EF4-FFF2-40B4-BE49-F238E27FC236}">
+                  <a16:creationId xmlns:a16="http://schemas.microsoft.com/office/drawing/2014/main" id="{89198DAA-3B7D-5778-B142-450548E8B6B9}"/>
+                </a:ext>
+              </a:extLst>
+            </p:cNvPr>
+            <p:cNvPicPr>
+              <a:picLocks noChangeAspect="1"/>
+            </p:cNvPicPr>
+            <p:nvPr/>
+          </p:nvPicPr>
+          <p:blipFill>
+            <a:blip>
+              <a:extLst>
+                <a:ext uri="{96DAC541-7B7A-43D3-8B79-37D633B846F1}">
+                  <asvg:svgBlip xmlns:asvg="http://schemas.microsoft.com/office/drawing/2016/SVG/main" r:embed="rId3"/>
+                </a:ext>
+              </a:extLst>
+            </a:blip>
+            <a:srcRect/>
+            <a:stretch/>
+          </p:blipFill>
+          <p:spPr>
+            <a:xfrm>
+              <a:off x="1134876" y="4089112"/>
+              <a:ext cx="634696" cy="634696"/>
+            </a:xfrm>
+            <a:prstGeom prst="rect">
+              <a:avLst/>
+            </a:prstGeom>
+          </p:spPr>
+        </p:pic>
+        <p:pic>
+          <p:nvPicPr>
+            <p:cNvPr id="4" name="Graphic 3" descr="Sleep with solid fill">
+              <a:extLst>
+                <a:ext uri="{FF2B5EF4-FFF2-40B4-BE49-F238E27FC236}">
+                  <a16:creationId xmlns:a16="http://schemas.microsoft.com/office/drawing/2014/main" id="{7A5F4C1E-BB6A-E4EB-CEBC-513922071DA9}"/>
+                </a:ext>
+              </a:extLst>
+            </p:cNvPr>
+            <p:cNvPicPr>
+              <a:picLocks noChangeAspect="1"/>
+            </p:cNvPicPr>
+            <p:nvPr/>
+          </p:nvPicPr>
+          <p:blipFill>
+            <a:blip>
+              <a:extLst>
+                <a:ext uri="{96DAC541-7B7A-43D3-8B79-37D633B846F1}">
+                  <asvg:svgBlip xmlns:asvg="http://schemas.microsoft.com/office/drawing/2016/SVG/main" r:embed="rId4"/>
+                </a:ext>
+              </a:extLst>
+            </a:blip>
+            <a:srcRect/>
+            <a:stretch/>
+          </p:blipFill>
+          <p:spPr>
+            <a:xfrm>
+              <a:off x="2200708" y="4089112"/>
+              <a:ext cx="634696" cy="634696"/>
+            </a:xfrm>
+            <a:prstGeom prst="rect">
+              <a:avLst/>
+            </a:prstGeom>
+          </p:spPr>
+        </p:pic>
+        <p:pic>
+          <p:nvPicPr>
+            <p:cNvPr id="5" name="Graphic 4" descr="Sleep with solid fill">
+              <a:extLst>
+                <a:ext uri="{FF2B5EF4-FFF2-40B4-BE49-F238E27FC236}">
+                  <a16:creationId xmlns:a16="http://schemas.microsoft.com/office/drawing/2014/main" id="{FDE97C45-A821-4DA5-D46C-F6DE626D8217}"/>
+                </a:ext>
+              </a:extLst>
+            </p:cNvPr>
+            <p:cNvPicPr>
+              <a:picLocks noChangeAspect="1"/>
+            </p:cNvPicPr>
+            <p:nvPr/>
+          </p:nvPicPr>
+          <p:blipFill>
+            <a:blip>
+              <a:extLst>
+                <a:ext uri="{96DAC541-7B7A-43D3-8B79-37D633B846F1}">
+                  <asvg:svgBlip xmlns:asvg="http://schemas.microsoft.com/office/drawing/2016/SVG/main" r:embed="rId5"/>
+                </a:ext>
+              </a:extLst>
+            </a:blip>
+            <a:srcRect/>
+            <a:stretch/>
+          </p:blipFill>
+          <p:spPr>
+            <a:xfrm>
+              <a:off x="3310041" y="4089112"/>
+              <a:ext cx="634696" cy="634696"/>
+            </a:xfrm>
+            <a:prstGeom prst="rect">
+              <a:avLst/>
+            </a:prstGeom>
+          </p:spPr>
+        </p:pic>
+        <p:pic>
+          <p:nvPicPr>
+            <p:cNvPr id="6" name="Graphic 5" descr="Sleep with solid fill">
+              <a:extLst>
+                <a:ext uri="{FF2B5EF4-FFF2-40B4-BE49-F238E27FC236}">
+                  <a16:creationId xmlns:a16="http://schemas.microsoft.com/office/drawing/2014/main" id="{6436BDD8-8A02-9AD0-37E2-59F6A5F48533}"/>
+                </a:ext>
+              </a:extLst>
+            </p:cNvPr>
+            <p:cNvPicPr>
+              <a:picLocks noChangeAspect="1"/>
+            </p:cNvPicPr>
+            <p:nvPr/>
+          </p:nvPicPr>
+          <p:blipFill>
+            <a:blip>
+              <a:extLst>
+                <a:ext uri="{96DAC541-7B7A-43D3-8B79-37D633B846F1}">
+                  <asvg:svgBlip xmlns:asvg="http://schemas.microsoft.com/office/drawing/2016/SVG/main" r:embed="rId5"/>
+                </a:ext>
+              </a:extLst>
+            </a:blip>
+            <a:srcRect/>
+            <a:stretch/>
+          </p:blipFill>
+          <p:spPr>
+            <a:xfrm>
+              <a:off x="4375873" y="4089112"/>
+              <a:ext cx="634696" cy="634696"/>
+            </a:xfrm>
+            <a:prstGeom prst="rect">
+              <a:avLst/>
+            </a:prstGeom>
+          </p:spPr>
+        </p:pic>
+        <p:sp>
+          <p:nvSpPr>
+            <p:cNvPr id="7" name="TextBox 6">
+              <a:extLst>
+                <a:ext uri="{FF2B5EF4-FFF2-40B4-BE49-F238E27FC236}">
+                  <a16:creationId xmlns:a16="http://schemas.microsoft.com/office/drawing/2014/main" id="{BBA1CAFA-3829-27BF-EC04-1AC2C9820DE5}"/>
+                </a:ext>
+              </a:extLst>
+            </p:cNvPr>
+            <p:cNvSpPr txBox="1"/>
+            <p:nvPr/>
+          </p:nvSpPr>
+          <p:spPr>
+            <a:xfrm>
+              <a:off x="1203324" y="3934596"/>
+              <a:ext cx="570990" cy="369332"/>
+            </a:xfrm>
+            <a:prstGeom prst="rect">
+              <a:avLst/>
+            </a:prstGeom>
+            <a:noFill/>
+          </p:spPr>
+          <p:txBody>
+            <a:bodyPr wrap="none" rtlCol="0">
+              <a:spAutoFit/>
+            </a:bodyPr>
+            <a:lstStyle/>
+            <a:p>
+              <a:r>
+                <a:rPr lang="en-US" dirty="0"/>
+                <a:t>B08</a:t>
+              </a:r>
+            </a:p>
+          </p:txBody>
+        </p:sp>
+        <p:sp>
+          <p:nvSpPr>
+            <p:cNvPr id="8" name="TextBox 7">
+              <a:extLst>
+                <a:ext uri="{FF2B5EF4-FFF2-40B4-BE49-F238E27FC236}">
+                  <a16:creationId xmlns:a16="http://schemas.microsoft.com/office/drawing/2014/main" id="{6D339A65-703C-0012-3519-72D879974D34}"/>
+                </a:ext>
+              </a:extLst>
+            </p:cNvPr>
+            <p:cNvSpPr txBox="1"/>
+            <p:nvPr/>
+          </p:nvSpPr>
+          <p:spPr>
+            <a:xfrm>
+              <a:off x="2265129" y="3934596"/>
+              <a:ext cx="570990" cy="369332"/>
+            </a:xfrm>
+            <a:prstGeom prst="rect">
+              <a:avLst/>
+            </a:prstGeom>
+            <a:noFill/>
+          </p:spPr>
+          <p:txBody>
+            <a:bodyPr wrap="none" rtlCol="0">
+              <a:spAutoFit/>
+            </a:bodyPr>
+            <a:lstStyle/>
+            <a:p>
+              <a:r>
+                <a:rPr lang="en-US" dirty="0"/>
+                <a:t>B09</a:t>
+              </a:r>
+            </a:p>
+          </p:txBody>
+        </p:sp>
+        <p:sp>
+          <p:nvSpPr>
+            <p:cNvPr id="9" name="TextBox 8">
+              <a:extLst>
+                <a:ext uri="{FF2B5EF4-FFF2-40B4-BE49-F238E27FC236}">
+                  <a16:creationId xmlns:a16="http://schemas.microsoft.com/office/drawing/2014/main" id="{44CF676A-908A-F2D8-3E9B-7CBE0FF46FF7}"/>
+                </a:ext>
+              </a:extLst>
+            </p:cNvPr>
+            <p:cNvSpPr txBox="1"/>
+            <p:nvPr/>
+          </p:nvSpPr>
+          <p:spPr>
+            <a:xfrm>
+              <a:off x="3331789" y="3934596"/>
+              <a:ext cx="570990" cy="369332"/>
+            </a:xfrm>
+            <a:prstGeom prst="rect">
+              <a:avLst/>
+            </a:prstGeom>
+            <a:noFill/>
+          </p:spPr>
+          <p:txBody>
+            <a:bodyPr wrap="none" rtlCol="0">
+              <a:spAutoFit/>
+            </a:bodyPr>
+            <a:lstStyle/>
+            <a:p>
+              <a:r>
+                <a:rPr lang="en-US" dirty="0"/>
+                <a:t>B10</a:t>
+              </a:r>
+            </a:p>
+          </p:txBody>
+        </p:sp>
+        <p:sp>
+          <p:nvSpPr>
+            <p:cNvPr id="10" name="TextBox 9">
+              <a:extLst>
+                <a:ext uri="{FF2B5EF4-FFF2-40B4-BE49-F238E27FC236}">
+                  <a16:creationId xmlns:a16="http://schemas.microsoft.com/office/drawing/2014/main" id="{2D7E2F9C-CE41-FBA4-A08A-F985BBE3BBDD}"/>
+                </a:ext>
+              </a:extLst>
+            </p:cNvPr>
+            <p:cNvSpPr txBox="1"/>
+            <p:nvPr/>
+          </p:nvSpPr>
+          <p:spPr>
+            <a:xfrm>
+              <a:off x="4421349" y="3934596"/>
+              <a:ext cx="570990" cy="369332"/>
+            </a:xfrm>
+            <a:prstGeom prst="rect">
+              <a:avLst/>
+            </a:prstGeom>
+            <a:noFill/>
+          </p:spPr>
+          <p:txBody>
+            <a:bodyPr wrap="none" rtlCol="0">
+              <a:spAutoFit/>
+            </a:bodyPr>
+            <a:lstStyle/>
+            <a:p>
+              <a:r>
+                <a:rPr lang="en-US" dirty="0"/>
+                <a:t>B11</a:t>
+              </a:r>
+            </a:p>
+          </p:txBody>
+        </p:sp>
+        <p:sp>
+          <p:nvSpPr>
+            <p:cNvPr id="11" name="Left Bracket 10">
+              <a:extLst>
+                <a:ext uri="{FF2B5EF4-FFF2-40B4-BE49-F238E27FC236}">
+                  <a16:creationId xmlns:a16="http://schemas.microsoft.com/office/drawing/2014/main" id="{03C9E5CB-71A8-F93B-FC8D-3E86BFC6636E}"/>
+                </a:ext>
+              </a:extLst>
+            </p:cNvPr>
+            <p:cNvSpPr/>
+            <p:nvPr/>
+          </p:nvSpPr>
+          <p:spPr>
+            <a:xfrm rot="16200000">
+              <a:off x="3970170" y="3705880"/>
+              <a:ext cx="369333" cy="2035851"/>
+            </a:xfrm>
+            <a:prstGeom prst="leftBracket">
+              <a:avLst/>
+            </a:prstGeom>
+            <a:ln w="25400">
+              <a:solidFill>
+                <a:schemeClr val="tx1"/>
+              </a:solidFill>
+            </a:ln>
+          </p:spPr>
+          <p:style>
+            <a:lnRef idx="2">
+              <a:schemeClr val="accent1"/>
+            </a:lnRef>
+            <a:fillRef idx="0">
+              <a:schemeClr val="accent1"/>
+            </a:fillRef>
+            <a:effectRef idx="1">
+              <a:schemeClr val="accent1"/>
+            </a:effectRef>
+            <a:fontRef idx="minor">
+              <a:schemeClr val="tx1"/>
+            </a:fontRef>
+          </p:style>
+          <p:txBody>
+            <a:bodyPr rtlCol="0" anchor="ctr"/>
+            <a:lstStyle/>
+            <a:p>
+              <a:pPr algn="ctr"/>
+              <a:endParaRPr lang="en-US"/>
+            </a:p>
+          </p:txBody>
+        </p:sp>
+        <p:sp>
+          <p:nvSpPr>
+            <p:cNvPr id="12" name="Left Bracket 11">
+              <a:extLst>
+                <a:ext uri="{FF2B5EF4-FFF2-40B4-BE49-F238E27FC236}">
+                  <a16:creationId xmlns:a16="http://schemas.microsoft.com/office/drawing/2014/main" id="{49CDABFC-309B-BD04-A056-C66A4804FE2F}"/>
+                </a:ext>
+              </a:extLst>
+            </p:cNvPr>
+            <p:cNvSpPr/>
+            <p:nvPr/>
+          </p:nvSpPr>
+          <p:spPr>
+            <a:xfrm rot="16200000">
+              <a:off x="2336944" y="4273274"/>
+              <a:ext cx="369333" cy="901063"/>
+            </a:xfrm>
+            <a:prstGeom prst="leftBracket">
+              <a:avLst/>
+            </a:prstGeom>
+            <a:ln w="25400">
+              <a:solidFill>
+                <a:schemeClr val="tx1"/>
+              </a:solidFill>
+            </a:ln>
+          </p:spPr>
+          <p:style>
+            <a:lnRef idx="2">
+              <a:schemeClr val="accent1"/>
+            </a:lnRef>
+            <a:fillRef idx="0">
+              <a:schemeClr val="accent1"/>
+            </a:fillRef>
+            <a:effectRef idx="1">
+              <a:schemeClr val="accent1"/>
+            </a:effectRef>
+            <a:fontRef idx="minor">
+              <a:schemeClr val="tx1"/>
+            </a:fontRef>
+          </p:style>
+          <p:txBody>
+            <a:bodyPr rtlCol="0" anchor="ctr"/>
+            <a:lstStyle/>
+            <a:p>
+              <a:pPr algn="ctr"/>
+              <a:endParaRPr lang="en-US"/>
+            </a:p>
+          </p:txBody>
+        </p:sp>
+        <p:pic>
+          <p:nvPicPr>
+            <p:cNvPr id="13" name="Graphic 12" descr="Doctor male with solid fill">
+              <a:extLst>
+                <a:ext uri="{FF2B5EF4-FFF2-40B4-BE49-F238E27FC236}">
+                  <a16:creationId xmlns:a16="http://schemas.microsoft.com/office/drawing/2014/main" id="{D7F7D628-A794-DDD3-1EC2-F6D5F9C4D514}"/>
+                </a:ext>
+              </a:extLst>
+            </p:cNvPr>
+            <p:cNvPicPr>
+              <a:picLocks noChangeAspect="1"/>
+            </p:cNvPicPr>
+            <p:nvPr/>
+          </p:nvPicPr>
+          <p:blipFill>
+            <a:blip>
+              <a:extLst>
+                <a:ext uri="{96DAC541-7B7A-43D3-8B79-37D633B846F1}">
+                  <asvg:svgBlip xmlns:asvg="http://schemas.microsoft.com/office/drawing/2016/SVG/main" r:embed="rId8"/>
+                </a:ext>
+              </a:extLst>
+            </a:blip>
+            <a:stretch>
+              <a:fillRect/>
+            </a:stretch>
+          </p:blipFill>
+          <p:spPr>
+            <a:xfrm>
+              <a:off x="3836408" y="4959019"/>
+              <a:ext cx="636856" cy="636856"/>
+            </a:xfrm>
+            <a:prstGeom prst="rect">
+              <a:avLst/>
+            </a:prstGeom>
+          </p:spPr>
+        </p:pic>
+        <p:pic>
+          <p:nvPicPr>
+            <p:cNvPr id="14" name="Graphic 13" descr="Doctor female with solid fill">
+              <a:extLst>
+                <a:ext uri="{FF2B5EF4-FFF2-40B4-BE49-F238E27FC236}">
+                  <a16:creationId xmlns:a16="http://schemas.microsoft.com/office/drawing/2014/main" id="{A426156A-4081-20CD-CCC2-46A51FA648B9}"/>
+                </a:ext>
+              </a:extLst>
+            </p:cNvPr>
+            <p:cNvPicPr>
+              <a:picLocks noChangeAspect="1"/>
+            </p:cNvPicPr>
+            <p:nvPr/>
+          </p:nvPicPr>
+          <p:blipFill>
+            <a:blip>
+              <a:extLst>
+                <a:ext uri="{96DAC541-7B7A-43D3-8B79-37D633B846F1}">
+                  <asvg:svgBlip xmlns:asvg="http://schemas.microsoft.com/office/drawing/2016/SVG/main" r:embed="rId9"/>
+                </a:ext>
+              </a:extLst>
+            </a:blip>
+            <a:stretch>
+              <a:fillRect/>
+            </a:stretch>
+          </p:blipFill>
+          <p:spPr>
+            <a:xfrm>
+              <a:off x="2200708" y="4959019"/>
+              <a:ext cx="636856" cy="636856"/>
+            </a:xfrm>
+            <a:prstGeom prst="rect">
+              <a:avLst/>
+            </a:prstGeom>
+          </p:spPr>
+        </p:pic>
+        <p:sp>
+          <p:nvSpPr>
+            <p:cNvPr id="15" name="Rounded Rectangle 14">
+              <a:extLst>
+                <a:ext uri="{FF2B5EF4-FFF2-40B4-BE49-F238E27FC236}">
+                  <a16:creationId xmlns:a16="http://schemas.microsoft.com/office/drawing/2014/main" id="{46F3DA0C-BBE8-0BC7-2C26-398576EE798D}"/>
+                </a:ext>
+              </a:extLst>
+            </p:cNvPr>
+            <p:cNvSpPr/>
+            <p:nvPr/>
+          </p:nvSpPr>
+          <p:spPr>
+            <a:xfrm>
+              <a:off x="6441231" y="3675232"/>
+              <a:ext cx="4420820" cy="2097152"/>
+            </a:xfrm>
+            <a:prstGeom prst="roundRect">
+              <a:avLst>
+                <a:gd name="adj" fmla="val 21519"/>
+              </a:avLst>
+            </a:prstGeom>
+            <a:solidFill>
+              <a:srgbClr val="00B0F0">
+                <a:alpha val="25714"/>
+              </a:srgbClr>
+            </a:solidFill>
+            <a:ln w="34925">
+              <a:solidFill>
+                <a:srgbClr val="0070C0"/>
+              </a:solidFill>
+            </a:ln>
+          </p:spPr>
+          <p:style>
+            <a:lnRef idx="2">
+              <a:schemeClr val="accent1">
+                <a:shade val="15000"/>
+              </a:schemeClr>
+            </a:lnRef>
+            <a:fillRef idx="1">
+              <a:schemeClr val="accent1"/>
+            </a:fillRef>
+            <a:effectRef idx="0">
+              <a:schemeClr val="accent1"/>
+            </a:effectRef>
+            <a:fontRef idx="minor">
+              <a:schemeClr val="lt1"/>
+            </a:fontRef>
+          </p:style>
+          <p:txBody>
+            <a:bodyPr rtlCol="0" anchor="ctr"/>
+            <a:lstStyle/>
+            <a:p>
+              <a:pPr algn="ctr"/>
+              <a:endParaRPr lang="en-US"/>
+            </a:p>
+          </p:txBody>
+        </p:sp>
+        <p:pic>
+          <p:nvPicPr>
+            <p:cNvPr id="16" name="Graphic 15" descr="Sleep with solid fill">
+              <a:extLst>
+                <a:ext uri="{FF2B5EF4-FFF2-40B4-BE49-F238E27FC236}">
+                  <a16:creationId xmlns:a16="http://schemas.microsoft.com/office/drawing/2014/main" id="{F335BE43-8851-5AD4-6571-91107293C3A5}"/>
+                </a:ext>
+              </a:extLst>
+            </p:cNvPr>
+            <p:cNvPicPr>
+              <a:picLocks noChangeAspect="1"/>
+            </p:cNvPicPr>
+            <p:nvPr/>
+          </p:nvPicPr>
+          <p:blipFill>
+            <a:blip>
+              <a:extLst>
+                <a:ext uri="{96DAC541-7B7A-43D3-8B79-37D633B846F1}">
+                  <asvg:svgBlip xmlns:asvg="http://schemas.microsoft.com/office/drawing/2016/SVG/main" r:embed="rId6"/>
+                </a:ext>
+              </a:extLst>
+            </a:blip>
+            <a:srcRect/>
+            <a:stretch/>
+          </p:blipFill>
+          <p:spPr>
+            <a:xfrm>
+              <a:off x="6720870" y="4010818"/>
+              <a:ext cx="634696" cy="634696"/>
+            </a:xfrm>
+            <a:prstGeom prst="rect">
+              <a:avLst/>
+            </a:prstGeom>
+          </p:spPr>
+        </p:pic>
+        <p:pic>
+          <p:nvPicPr>
+            <p:cNvPr id="17" name="Graphic 16" descr="Sleep with solid fill">
+              <a:extLst>
+                <a:ext uri="{FF2B5EF4-FFF2-40B4-BE49-F238E27FC236}">
+                  <a16:creationId xmlns:a16="http://schemas.microsoft.com/office/drawing/2014/main" id="{E3439103-DBC8-E893-AFF9-81F586587F74}"/>
+                </a:ext>
+              </a:extLst>
+            </p:cNvPr>
+            <p:cNvPicPr>
+              <a:picLocks noChangeAspect="1"/>
+            </p:cNvPicPr>
+            <p:nvPr/>
+          </p:nvPicPr>
+          <p:blipFill>
+            <a:blip>
+              <a:extLst>
+                <a:ext uri="{96DAC541-7B7A-43D3-8B79-37D633B846F1}">
+                  <asvg:svgBlip xmlns:asvg="http://schemas.microsoft.com/office/drawing/2016/SVG/main" r:embed="rId5"/>
+                </a:ext>
+              </a:extLst>
+            </a:blip>
+            <a:srcRect/>
+            <a:stretch/>
+          </p:blipFill>
+          <p:spPr>
+            <a:xfrm>
+              <a:off x="7786702" y="4010818"/>
+              <a:ext cx="634696" cy="634696"/>
+            </a:xfrm>
+            <a:prstGeom prst="rect">
+              <a:avLst/>
+            </a:prstGeom>
+          </p:spPr>
+        </p:pic>
+        <p:pic>
+          <p:nvPicPr>
+            <p:cNvPr id="18" name="Graphic 17" descr="Sleep with solid fill">
+              <a:extLst>
+                <a:ext uri="{FF2B5EF4-FFF2-40B4-BE49-F238E27FC236}">
+                  <a16:creationId xmlns:a16="http://schemas.microsoft.com/office/drawing/2014/main" id="{099C2FEA-458B-E744-FE45-91818E01D296}"/>
+                </a:ext>
+              </a:extLst>
+            </p:cNvPr>
+            <p:cNvPicPr>
+              <a:picLocks noChangeAspect="1"/>
+            </p:cNvPicPr>
+            <p:nvPr/>
+          </p:nvPicPr>
+          <p:blipFill>
+            <a:blip>
+              <a:extLst>
+                <a:ext uri="{96DAC541-7B7A-43D3-8B79-37D633B846F1}">
+                  <asvg:svgBlip xmlns:asvg="http://schemas.microsoft.com/office/drawing/2016/SVG/main" r:embed="rId4"/>
+                </a:ext>
+              </a:extLst>
+            </a:blip>
+            <a:srcRect/>
+            <a:stretch/>
+          </p:blipFill>
+          <p:spPr>
+            <a:xfrm>
+              <a:off x="8896035" y="4010818"/>
+              <a:ext cx="634696" cy="634696"/>
+            </a:xfrm>
+            <a:prstGeom prst="rect">
+              <a:avLst/>
+            </a:prstGeom>
+          </p:spPr>
+        </p:pic>
+        <p:pic>
+          <p:nvPicPr>
+            <p:cNvPr id="19" name="Graphic 18" descr="Bed with solid fill">
+              <a:extLst>
+                <a:ext uri="{FF2B5EF4-FFF2-40B4-BE49-F238E27FC236}">
+                  <a16:creationId xmlns:a16="http://schemas.microsoft.com/office/drawing/2014/main" id="{8C4E4EB5-F427-5331-BEDB-E73245F476FE}"/>
+                </a:ext>
+              </a:extLst>
+            </p:cNvPr>
+            <p:cNvPicPr>
+              <a:picLocks noChangeAspect="1"/>
+            </p:cNvPicPr>
+            <p:nvPr/>
+          </p:nvPicPr>
+          <p:blipFill>
+            <a:blip>
+              <a:extLst>
+                <a:ext uri="{96DAC541-7B7A-43D3-8B79-37D633B846F1}">
+                  <asvg:svgBlip xmlns:asvg="http://schemas.microsoft.com/office/drawing/2016/SVG/main" r:embed="rId3"/>
+                </a:ext>
+              </a:extLst>
+            </a:blip>
+            <a:srcRect/>
+            <a:stretch/>
+          </p:blipFill>
+          <p:spPr>
+            <a:xfrm>
+              <a:off x="9961867" y="4010818"/>
+              <a:ext cx="634696" cy="634696"/>
+            </a:xfrm>
+            <a:prstGeom prst="rect">
+              <a:avLst/>
+            </a:prstGeom>
+          </p:spPr>
+        </p:pic>
+        <p:sp>
+          <p:nvSpPr>
+            <p:cNvPr id="20" name="TextBox 19">
+              <a:extLst>
+                <a:ext uri="{FF2B5EF4-FFF2-40B4-BE49-F238E27FC236}">
+                  <a16:creationId xmlns:a16="http://schemas.microsoft.com/office/drawing/2014/main" id="{666D3A7E-C03A-6501-BB4F-3BA1025BA944}"/>
+                </a:ext>
+              </a:extLst>
+            </p:cNvPr>
+            <p:cNvSpPr txBox="1"/>
+            <p:nvPr/>
+          </p:nvSpPr>
+          <p:spPr>
+            <a:xfrm>
+              <a:off x="6789318" y="3856302"/>
+              <a:ext cx="570990" cy="369332"/>
+            </a:xfrm>
+            <a:prstGeom prst="rect">
+              <a:avLst/>
+            </a:prstGeom>
+            <a:noFill/>
+          </p:spPr>
+          <p:txBody>
+            <a:bodyPr wrap="none" rtlCol="0">
+              <a:spAutoFit/>
+            </a:bodyPr>
+            <a:lstStyle/>
+            <a:p>
+              <a:r>
+                <a:rPr lang="en-US" dirty="0"/>
+                <a:t>B08</a:t>
+              </a:r>
+            </a:p>
+          </p:txBody>
+        </p:sp>
+        <p:sp>
+          <p:nvSpPr>
+            <p:cNvPr id="21" name="TextBox 20">
+              <a:extLst>
+                <a:ext uri="{FF2B5EF4-FFF2-40B4-BE49-F238E27FC236}">
+                  <a16:creationId xmlns:a16="http://schemas.microsoft.com/office/drawing/2014/main" id="{EB9040FB-C23E-E211-5224-07EC2B3AFC44}"/>
+                </a:ext>
+              </a:extLst>
+            </p:cNvPr>
+            <p:cNvSpPr txBox="1"/>
+            <p:nvPr/>
+          </p:nvSpPr>
+          <p:spPr>
+            <a:xfrm>
+              <a:off x="7851123" y="3856302"/>
+              <a:ext cx="570990" cy="369332"/>
+            </a:xfrm>
+            <a:prstGeom prst="rect">
+              <a:avLst/>
+            </a:prstGeom>
+            <a:noFill/>
+          </p:spPr>
+          <p:txBody>
+            <a:bodyPr wrap="none" rtlCol="0">
+              <a:spAutoFit/>
+            </a:bodyPr>
+            <a:lstStyle/>
+            <a:p>
+              <a:r>
+                <a:rPr lang="en-US" dirty="0"/>
+                <a:t>B09</a:t>
+              </a:r>
+            </a:p>
+          </p:txBody>
+        </p:sp>
+        <p:sp>
+          <p:nvSpPr>
+            <p:cNvPr id="22" name="TextBox 21">
+              <a:extLst>
+                <a:ext uri="{FF2B5EF4-FFF2-40B4-BE49-F238E27FC236}">
+                  <a16:creationId xmlns:a16="http://schemas.microsoft.com/office/drawing/2014/main" id="{D5E2F948-003F-A991-F97D-D7EC95DEBC8B}"/>
+                </a:ext>
+              </a:extLst>
+            </p:cNvPr>
+            <p:cNvSpPr txBox="1"/>
+            <p:nvPr/>
+          </p:nvSpPr>
+          <p:spPr>
+            <a:xfrm>
+              <a:off x="8917783" y="3856302"/>
+              <a:ext cx="570990" cy="369332"/>
+            </a:xfrm>
+            <a:prstGeom prst="rect">
+              <a:avLst/>
+            </a:prstGeom>
+            <a:noFill/>
+          </p:spPr>
+          <p:txBody>
+            <a:bodyPr wrap="none" rtlCol="0">
+              <a:spAutoFit/>
+            </a:bodyPr>
+            <a:lstStyle/>
+            <a:p>
+              <a:r>
+                <a:rPr lang="en-US" dirty="0"/>
+                <a:t>B10</a:t>
+              </a:r>
+            </a:p>
+          </p:txBody>
+        </p:sp>
+        <p:sp>
+          <p:nvSpPr>
+            <p:cNvPr id="23" name="TextBox 22">
+              <a:extLst>
+                <a:ext uri="{FF2B5EF4-FFF2-40B4-BE49-F238E27FC236}">
+                  <a16:creationId xmlns:a16="http://schemas.microsoft.com/office/drawing/2014/main" id="{E0AF3491-AF1F-3134-8947-9DE22B2707F3}"/>
+                </a:ext>
+              </a:extLst>
+            </p:cNvPr>
+            <p:cNvSpPr txBox="1"/>
+            <p:nvPr/>
+          </p:nvSpPr>
+          <p:spPr>
+            <a:xfrm>
+              <a:off x="10007343" y="3856302"/>
+              <a:ext cx="570990" cy="369332"/>
+            </a:xfrm>
+            <a:prstGeom prst="rect">
+              <a:avLst/>
+            </a:prstGeom>
+            <a:noFill/>
+          </p:spPr>
+          <p:txBody>
+            <a:bodyPr wrap="none" rtlCol="0">
+              <a:spAutoFit/>
+            </a:bodyPr>
+            <a:lstStyle/>
+            <a:p>
+              <a:r>
+                <a:rPr lang="en-US" dirty="0"/>
+                <a:t>B11</a:t>
+              </a:r>
+            </a:p>
+          </p:txBody>
+        </p:sp>
+        <p:sp>
+          <p:nvSpPr>
+            <p:cNvPr id="24" name="Left Bracket 23">
+              <a:extLst>
+                <a:ext uri="{FF2B5EF4-FFF2-40B4-BE49-F238E27FC236}">
+                  <a16:creationId xmlns:a16="http://schemas.microsoft.com/office/drawing/2014/main" id="{3A51DC4E-52DB-1E18-C464-A6B642BA704F}"/>
+                </a:ext>
+              </a:extLst>
+            </p:cNvPr>
+            <p:cNvSpPr/>
+            <p:nvPr/>
+          </p:nvSpPr>
+          <p:spPr>
+            <a:xfrm rot="16200000">
+              <a:off x="7404037" y="3627586"/>
+              <a:ext cx="369333" cy="2035851"/>
+            </a:xfrm>
+            <a:prstGeom prst="leftBracket">
+              <a:avLst/>
+            </a:prstGeom>
+            <a:ln w="25400">
+              <a:solidFill>
+                <a:schemeClr val="tx1"/>
+              </a:solidFill>
+            </a:ln>
+          </p:spPr>
+          <p:style>
+            <a:lnRef idx="2">
+              <a:schemeClr val="accent1"/>
+            </a:lnRef>
+            <a:fillRef idx="0">
+              <a:schemeClr val="accent1"/>
+            </a:fillRef>
+            <a:effectRef idx="1">
+              <a:schemeClr val="accent1"/>
+            </a:effectRef>
+            <a:fontRef idx="minor">
+              <a:schemeClr val="tx1"/>
+            </a:fontRef>
+          </p:style>
+          <p:txBody>
+            <a:bodyPr rtlCol="0" anchor="ctr"/>
+            <a:lstStyle/>
+            <a:p>
+              <a:pPr algn="ctr"/>
+              <a:endParaRPr lang="en-US"/>
+            </a:p>
+          </p:txBody>
+        </p:sp>
+        <p:sp>
+          <p:nvSpPr>
+            <p:cNvPr id="25" name="Left Bracket 24">
+              <a:extLst>
+                <a:ext uri="{FF2B5EF4-FFF2-40B4-BE49-F238E27FC236}">
+                  <a16:creationId xmlns:a16="http://schemas.microsoft.com/office/drawing/2014/main" id="{2DEF8DA3-CAC7-EBF9-EA14-44CFE67142DD}"/>
+                </a:ext>
+              </a:extLst>
+            </p:cNvPr>
+            <p:cNvSpPr/>
+            <p:nvPr/>
+          </p:nvSpPr>
+          <p:spPr>
+            <a:xfrm rot="16200000">
+              <a:off x="9048730" y="4194979"/>
+              <a:ext cx="369333" cy="901063"/>
+            </a:xfrm>
+            <a:prstGeom prst="leftBracket">
+              <a:avLst/>
+            </a:prstGeom>
+            <a:ln w="25400">
+              <a:solidFill>
+                <a:schemeClr val="tx1"/>
+              </a:solidFill>
+            </a:ln>
+          </p:spPr>
+          <p:style>
+            <a:lnRef idx="2">
+              <a:schemeClr val="accent1"/>
+            </a:lnRef>
+            <a:fillRef idx="0">
+              <a:schemeClr val="accent1"/>
+            </a:fillRef>
+            <a:effectRef idx="1">
+              <a:schemeClr val="accent1"/>
+            </a:effectRef>
+            <a:fontRef idx="minor">
+              <a:schemeClr val="tx1"/>
+            </a:fontRef>
+          </p:style>
+          <p:txBody>
+            <a:bodyPr rtlCol="0" anchor="ctr"/>
+            <a:lstStyle/>
+            <a:p>
+              <a:pPr algn="ctr"/>
+              <a:endParaRPr lang="en-US"/>
+            </a:p>
+          </p:txBody>
+        </p:sp>
+        <p:pic>
+          <p:nvPicPr>
+            <p:cNvPr id="26" name="Graphic 25" descr="Doctor male with solid fill">
+              <a:extLst>
+                <a:ext uri="{FF2B5EF4-FFF2-40B4-BE49-F238E27FC236}">
+                  <a16:creationId xmlns:a16="http://schemas.microsoft.com/office/drawing/2014/main" id="{C0EA918C-6248-8022-85FE-4252B5CC9FA1}"/>
+                </a:ext>
+              </a:extLst>
+            </p:cNvPr>
+            <p:cNvPicPr>
+              <a:picLocks noChangeAspect="1"/>
+            </p:cNvPicPr>
+            <p:nvPr/>
+          </p:nvPicPr>
+          <p:blipFill>
+            <a:blip>
+              <a:extLst>
+                <a:ext uri="{96DAC541-7B7A-43D3-8B79-37D633B846F1}">
+                  <asvg:svgBlip xmlns:asvg="http://schemas.microsoft.com/office/drawing/2016/SVG/main" r:embed="rId8"/>
+                </a:ext>
+              </a:extLst>
+            </a:blip>
+            <a:stretch>
+              <a:fillRect/>
+            </a:stretch>
+          </p:blipFill>
+          <p:spPr>
+            <a:xfrm>
+              <a:off x="7316445" y="4880725"/>
+              <a:ext cx="636856" cy="636856"/>
+            </a:xfrm>
+            <a:prstGeom prst="rect">
+              <a:avLst/>
+            </a:prstGeom>
+          </p:spPr>
+        </p:pic>
+        <p:pic>
+          <p:nvPicPr>
+            <p:cNvPr id="27" name="Graphic 26" descr="Doctor female with solid fill">
+              <a:extLst>
+                <a:ext uri="{FF2B5EF4-FFF2-40B4-BE49-F238E27FC236}">
+                  <a16:creationId xmlns:a16="http://schemas.microsoft.com/office/drawing/2014/main" id="{1EF3B3A6-8F8C-617D-C464-E6D8CBB3E0EC}"/>
+                </a:ext>
+              </a:extLst>
+            </p:cNvPr>
+            <p:cNvPicPr>
+              <a:picLocks noChangeAspect="1"/>
+            </p:cNvPicPr>
+            <p:nvPr/>
+          </p:nvPicPr>
+          <p:blipFill>
+            <a:blip>
+              <a:extLst>
+                <a:ext uri="{96DAC541-7B7A-43D3-8B79-37D633B846F1}">
+                  <asvg:svgBlip xmlns:asvg="http://schemas.microsoft.com/office/drawing/2016/SVG/main" r:embed="rId9"/>
+                </a:ext>
+              </a:extLst>
+            </a:blip>
+            <a:stretch>
+              <a:fillRect/>
+            </a:stretch>
+          </p:blipFill>
+          <p:spPr>
+            <a:xfrm>
+              <a:off x="8883053" y="4880454"/>
+              <a:ext cx="636856" cy="636856"/>
+            </a:xfrm>
+            <a:prstGeom prst="rect">
+              <a:avLst/>
+            </a:prstGeom>
+          </p:spPr>
+        </p:pic>
+        <mc:AlternateContent xmlns:mc="http://schemas.openxmlformats.org/markup-compatibility/2006">
+          <mc:Choice xmlns:a14="http://schemas.microsoft.com/office/drawing/2010/main" Requires="a14">
+            <p:sp>
+              <p:nvSpPr>
+                <p:cNvPr id="28" name="TextBox 27">
+                  <a:extLst>
+                    <a:ext uri="{FF2B5EF4-FFF2-40B4-BE49-F238E27FC236}">
+                      <a16:creationId xmlns:a16="http://schemas.microsoft.com/office/drawing/2014/main" id="{E689DF48-81DE-4FA9-BB31-E8187753F097}"/>
+                    </a:ext>
+                  </a:extLst>
+                </p:cNvPr>
+                <p:cNvSpPr txBox="1"/>
+                <p:nvPr/>
+              </p:nvSpPr>
+              <p:spPr>
+                <a:xfrm>
+                  <a:off x="5434255" y="4149177"/>
+                  <a:ext cx="844783" cy="1107996"/>
+                </a:xfrm>
+                <a:prstGeom prst="rect">
+                  <a:avLst/>
+                </a:prstGeom>
+                <a:noFill/>
+              </p:spPr>
+              <p:txBody>
+                <a:bodyPr wrap="none" lIns="0" tIns="0" rIns="0" bIns="0" rtlCol="0">
+                  <a:spAutoFit/>
+                </a:bodyPr>
+                <a:lstStyle/>
+                <a:p>
+                  <a:pPr/>
+                  <a14:m>
+                    <m:oMathPara xmlns:m="http://schemas.openxmlformats.org/officeDocument/2006/math">
+                      <m:oMathParaPr>
+                        <m:jc m:val="centerGroup"/>
+                      </m:oMathParaPr>
+                      <m:oMath xmlns:m="http://schemas.openxmlformats.org/officeDocument/2006/math">
+                        <m:r>
+                          <a:rPr lang="en-GB" sz="7200" b="0" i="1" smtClean="0">
+                            <a:latin typeface="Cambria Math" panose="02040503050406030204" pitchFamily="18" charset="0"/>
+                          </a:rPr>
+                          <m:t>~</m:t>
+                        </m:r>
+                      </m:oMath>
+                    </m:oMathPara>
+                  </a14:m>
+                  <a:endParaRPr lang="en-US" sz="7200" dirty="0"/>
+                </a:p>
+              </p:txBody>
+            </p:sp>
+          </mc:Choice>
+          <mc:Fallback>
+            <p:sp>
+              <p:nvSpPr>
+                <p:cNvPr id="28" name="TextBox 27">
+                  <a:extLst>
+                    <a:ext uri="{FF2B5EF4-FFF2-40B4-BE49-F238E27FC236}">
+                      <a16:creationId xmlns:a16="http://schemas.microsoft.com/office/drawing/2014/main" id="{E689DF48-81DE-4FA9-BB31-E8187753F097}"/>
+                    </a:ext>
+                  </a:extLst>
+                </p:cNvPr>
+                <p:cNvSpPr txBox="1">
+                  <a:spLocks noRot="1" noChangeAspect="1" noMove="1" noResize="1" noEditPoints="1" noAdjustHandles="1" noChangeArrowheads="1" noChangeShapeType="1" noTextEdit="1"/>
+                </p:cNvSpPr>
+                <p:nvPr/>
+              </p:nvSpPr>
+              <p:spPr>
+                <a:xfrm>
+                  <a:off x="5434255" y="4149177"/>
+                  <a:ext cx="844783" cy="1107996"/>
+                </a:xfrm>
+                <a:prstGeom prst="rect">
+                  <a:avLst/>
+                </a:prstGeom>
+                <a:blipFill>
+                  <a:blip r:embed="rId12"/>
+                  <a:stretch>
+                    <a:fillRect l="-8824" r="-8824"/>
                   </a:stretch>
                 </a:blipFill>
               </p:spPr>

</xml_diff>

<commit_message>
add action symmetries example; add author
</commit_message>
<xml_diff>
--- a/images/icu.pptx
+++ b/images/icu.pptx
@@ -5,7 +5,7 @@
     <p:sldMasterId id="2147483648" r:id="rId1"/>
   </p:sldMasterIdLst>
   <p:notesMasterIdLst>
-    <p:notesMasterId r:id="rId9"/>
+    <p:notesMasterId r:id="rId10"/>
   </p:notesMasterIdLst>
   <p:sldIdLst>
     <p:sldId id="256" r:id="rId2"/>
@@ -15,6 +15,7 @@
     <p:sldId id="260" r:id="rId6"/>
     <p:sldId id="262" r:id="rId7"/>
     <p:sldId id="263" r:id="rId8"/>
+    <p:sldId id="264" r:id="rId9"/>
   </p:sldIdLst>
   <p:sldSz cx="12192000" cy="6858000"/>
   <p:notesSz cx="6858000" cy="9144000"/>
@@ -203,7 +204,7 @@
           <a:p>
             <a:fld id="{AD42B31F-4ABA-274F-9BB4-DA3A6583FDB8}" type="datetimeFigureOut">
               <a:rPr lang="en-US" smtClean="0"/>
-              <a:t>5/18/26</a:t>
+              <a:t>5/22/26</a:t>
             </a:fld>
             <a:endParaRPr lang="en-US"/>
           </a:p>
@@ -663,6 +664,114 @@
 </p:notes>
 </file>
 
+<file path=ppt/notesSlides/notesSlide3.xml><?xml version="1.0" encoding="utf-8"?>
+<p:notes xmlns:a="http://schemas.openxmlformats.org/drawingml/2006/main" xmlns:r="http://schemas.openxmlformats.org/officeDocument/2006/relationships" xmlns:p="http://schemas.openxmlformats.org/presentationml/2006/main">
+  <p:cSld>
+    <p:spTree>
+      <p:nvGrpSpPr>
+        <p:cNvPr id="1" name="">
+          <a:extLst>
+            <a:ext uri="{FF2B5EF4-FFF2-40B4-BE49-F238E27FC236}">
+              <a16:creationId xmlns:a16="http://schemas.microsoft.com/office/drawing/2014/main" id="{D6FF0938-ECDA-DF2D-2F76-A82DEB325CB2}"/>
+            </a:ext>
+          </a:extLst>
+        </p:cNvPr>
+        <p:cNvGrpSpPr/>
+        <p:nvPr/>
+      </p:nvGrpSpPr>
+      <p:grpSpPr>
+        <a:xfrm>
+          <a:off x="0" y="0"/>
+          <a:ext cx="0" cy="0"/>
+          <a:chOff x="0" y="0"/>
+          <a:chExt cx="0" cy="0"/>
+        </a:xfrm>
+      </p:grpSpPr>
+      <p:sp>
+        <p:nvSpPr>
+          <p:cNvPr id="2" name="Slide Image Placeholder 1">
+            <a:extLst>
+              <a:ext uri="{FF2B5EF4-FFF2-40B4-BE49-F238E27FC236}">
+                <a16:creationId xmlns:a16="http://schemas.microsoft.com/office/drawing/2014/main" id="{BE66E0C7-AE41-3D7A-01BA-1B0CC9DF475A}"/>
+              </a:ext>
+            </a:extLst>
+          </p:cNvPr>
+          <p:cNvSpPr>
+            <a:spLocks noGrp="1" noRot="1" noChangeAspect="1"/>
+          </p:cNvSpPr>
+          <p:nvPr>
+            <p:ph type="sldImg"/>
+          </p:nvPr>
+        </p:nvSpPr>
+        <p:spPr/>
+      </p:sp>
+      <p:sp>
+        <p:nvSpPr>
+          <p:cNvPr id="3" name="Notes Placeholder 2">
+            <a:extLst>
+              <a:ext uri="{FF2B5EF4-FFF2-40B4-BE49-F238E27FC236}">
+                <a16:creationId xmlns:a16="http://schemas.microsoft.com/office/drawing/2014/main" id="{C17AD15E-E199-93B6-8FF2-8D4384C4511E}"/>
+              </a:ext>
+            </a:extLst>
+          </p:cNvPr>
+          <p:cNvSpPr>
+            <a:spLocks noGrp="1"/>
+          </p:cNvSpPr>
+          <p:nvPr>
+            <p:ph type="body" idx="1"/>
+          </p:nvPr>
+        </p:nvSpPr>
+        <p:spPr/>
+        <p:txBody>
+          <a:bodyPr/>
+          <a:lstStyle/>
+          <a:p>
+            <a:endParaRPr lang="en-US" dirty="0"/>
+          </a:p>
+        </p:txBody>
+      </p:sp>
+      <p:sp>
+        <p:nvSpPr>
+          <p:cNvPr id="4" name="Slide Number Placeholder 3">
+            <a:extLst>
+              <a:ext uri="{FF2B5EF4-FFF2-40B4-BE49-F238E27FC236}">
+                <a16:creationId xmlns:a16="http://schemas.microsoft.com/office/drawing/2014/main" id="{C80D4DFC-A1A4-5BE0-B3F5-1EE70B715470}"/>
+              </a:ext>
+            </a:extLst>
+          </p:cNvPr>
+          <p:cNvSpPr>
+            <a:spLocks noGrp="1"/>
+          </p:cNvSpPr>
+          <p:nvPr>
+            <p:ph type="sldNum" sz="quarter" idx="5"/>
+          </p:nvPr>
+        </p:nvSpPr>
+        <p:spPr/>
+        <p:txBody>
+          <a:bodyPr/>
+          <a:lstStyle/>
+          <a:p>
+            <a:fld id="{C0ECF21E-4684-E148-81FF-D3B1FD823314}" type="slidenum">
+              <a:rPr lang="en-US" smtClean="0"/>
+              <a:t>8</a:t>
+            </a:fld>
+            <a:endParaRPr lang="en-US"/>
+          </a:p>
+        </p:txBody>
+      </p:sp>
+    </p:spTree>
+    <p:extLst>
+      <p:ext uri="{BB962C8B-B14F-4D97-AF65-F5344CB8AC3E}">
+        <p14:creationId xmlns:p14="http://schemas.microsoft.com/office/powerpoint/2010/main" val="2707128037"/>
+      </p:ext>
+    </p:extLst>
+  </p:cSld>
+  <p:clrMapOvr>
+    <a:masterClrMapping/>
+  </p:clrMapOvr>
+</p:notes>
+</file>
+
 <file path=ppt/slideLayouts/slideLayout1.xml><?xml version="1.0" encoding="utf-8"?>
 <p:sldLayout xmlns:a="http://schemas.openxmlformats.org/drawingml/2006/main" xmlns:r="http://schemas.openxmlformats.org/officeDocument/2006/relationships" xmlns:p="http://schemas.openxmlformats.org/presentationml/2006/main" type="title" preserve="1">
   <p:cSld name="Title Slide">
@@ -812,7 +921,7 @@
           <a:p>
             <a:fld id="{0D21F05F-ACFB-0C4D-9827-53BE568178E4}" type="datetimeFigureOut">
               <a:rPr lang="en-US" smtClean="0"/>
-              <a:t>5/18/26</a:t>
+              <a:t>5/22/26</a:t>
             </a:fld>
             <a:endParaRPr lang="en-US"/>
           </a:p>
@@ -1012,7 +1121,7 @@
           <a:p>
             <a:fld id="{0D21F05F-ACFB-0C4D-9827-53BE568178E4}" type="datetimeFigureOut">
               <a:rPr lang="en-US" smtClean="0"/>
-              <a:t>5/18/26</a:t>
+              <a:t>5/22/26</a:t>
             </a:fld>
             <a:endParaRPr lang="en-US"/>
           </a:p>
@@ -1222,7 +1331,7 @@
           <a:p>
             <a:fld id="{0D21F05F-ACFB-0C4D-9827-53BE568178E4}" type="datetimeFigureOut">
               <a:rPr lang="en-US" smtClean="0"/>
-              <a:t>5/18/26</a:t>
+              <a:t>5/22/26</a:t>
             </a:fld>
             <a:endParaRPr lang="en-US"/>
           </a:p>
@@ -1422,7 +1531,7 @@
           <a:p>
             <a:fld id="{0D21F05F-ACFB-0C4D-9827-53BE568178E4}" type="datetimeFigureOut">
               <a:rPr lang="en-US" smtClean="0"/>
-              <a:t>5/18/26</a:t>
+              <a:t>5/22/26</a:t>
             </a:fld>
             <a:endParaRPr lang="en-US"/>
           </a:p>
@@ -1698,7 +1807,7 @@
           <a:p>
             <a:fld id="{0D21F05F-ACFB-0C4D-9827-53BE568178E4}" type="datetimeFigureOut">
               <a:rPr lang="en-US" smtClean="0"/>
-              <a:t>5/18/26</a:t>
+              <a:t>5/22/26</a:t>
             </a:fld>
             <a:endParaRPr lang="en-US"/>
           </a:p>
@@ -1966,7 +2075,7 @@
           <a:p>
             <a:fld id="{0D21F05F-ACFB-0C4D-9827-53BE568178E4}" type="datetimeFigureOut">
               <a:rPr lang="en-US" smtClean="0"/>
-              <a:t>5/18/26</a:t>
+              <a:t>5/22/26</a:t>
             </a:fld>
             <a:endParaRPr lang="en-US"/>
           </a:p>
@@ -2381,7 +2490,7 @@
           <a:p>
             <a:fld id="{0D21F05F-ACFB-0C4D-9827-53BE568178E4}" type="datetimeFigureOut">
               <a:rPr lang="en-US" smtClean="0"/>
-              <a:t>5/18/26</a:t>
+              <a:t>5/22/26</a:t>
             </a:fld>
             <a:endParaRPr lang="en-US"/>
           </a:p>
@@ -2523,7 +2632,7 @@
           <a:p>
             <a:fld id="{0D21F05F-ACFB-0C4D-9827-53BE568178E4}" type="datetimeFigureOut">
               <a:rPr lang="en-US" smtClean="0"/>
-              <a:t>5/18/26</a:t>
+              <a:t>5/22/26</a:t>
             </a:fld>
             <a:endParaRPr lang="en-US"/>
           </a:p>
@@ -2636,7 +2745,7 @@
           <a:p>
             <a:fld id="{0D21F05F-ACFB-0C4D-9827-53BE568178E4}" type="datetimeFigureOut">
               <a:rPr lang="en-US" smtClean="0"/>
-              <a:t>5/18/26</a:t>
+              <a:t>5/22/26</a:t>
             </a:fld>
             <a:endParaRPr lang="en-US"/>
           </a:p>
@@ -2949,7 +3058,7 @@
           <a:p>
             <a:fld id="{0D21F05F-ACFB-0C4D-9827-53BE568178E4}" type="datetimeFigureOut">
               <a:rPr lang="en-US" smtClean="0"/>
-              <a:t>5/18/26</a:t>
+              <a:t>5/22/26</a:t>
             </a:fld>
             <a:endParaRPr lang="en-US"/>
           </a:p>
@@ -3238,7 +3347,7 @@
           <a:p>
             <a:fld id="{0D21F05F-ACFB-0C4D-9827-53BE568178E4}" type="datetimeFigureOut">
               <a:rPr lang="en-US" smtClean="0"/>
-              <a:t>5/18/26</a:t>
+              <a:t>5/22/26</a:t>
             </a:fld>
             <a:endParaRPr lang="en-US"/>
           </a:p>
@@ -3481,7 +3590,7 @@
           <a:p>
             <a:fld id="{0D21F05F-ACFB-0C4D-9827-53BE568178E4}" type="datetimeFigureOut">
               <a:rPr lang="en-US" smtClean="0"/>
-              <a:t>5/18/26</a:t>
+              <a:t>5/22/26</a:t>
             </a:fld>
             <a:endParaRPr lang="en-US"/>
           </a:p>
@@ -18735,8 +18844,8 @@
             </a:prstGeom>
           </p:spPr>
         </p:pic>
-        <mc:AlternateContent xmlns:mc="http://schemas.openxmlformats.org/markup-compatibility/2006">
-          <mc:Choice xmlns:a14="http://schemas.microsoft.com/office/drawing/2010/main" Requires="a14">
+        <mc:AlternateContent xmlns:mc="http://schemas.openxmlformats.org/markup-compatibility/2006" xmlns:a14="http://schemas.microsoft.com/office/drawing/2010/main">
+          <mc:Choice Requires="a14">
             <p:sp>
               <p:nvSpPr>
                 <p:cNvPr id="28" name="TextBox 27">
@@ -18786,7 +18895,7 @@
               </p:txBody>
             </p:sp>
           </mc:Choice>
-          <mc:Fallback>
+          <mc:Fallback xmlns="">
             <p:sp>
               <p:nvSpPr>
                 <p:cNvPr id="28" name="TextBox 27">
@@ -18836,6 +18945,2343 @@
     <p:extLst>
       <p:ext uri="{BB962C8B-B14F-4D97-AF65-F5344CB8AC3E}">
         <p14:creationId xmlns:p14="http://schemas.microsoft.com/office/powerpoint/2010/main" val="1953519320"/>
+      </p:ext>
+    </p:extLst>
+  </p:cSld>
+  <p:clrMapOvr>
+    <a:masterClrMapping/>
+  </p:clrMapOvr>
+</p:sld>
+</file>
+
+<file path=ppt/slides/slide8.xml><?xml version="1.0" encoding="utf-8"?>
+<p:sld xmlns:a="http://schemas.openxmlformats.org/drawingml/2006/main" xmlns:r="http://schemas.openxmlformats.org/officeDocument/2006/relationships" xmlns:p="http://schemas.openxmlformats.org/presentationml/2006/main">
+  <p:cSld>
+    <p:spTree>
+      <p:nvGrpSpPr>
+        <p:cNvPr id="1" name="">
+          <a:extLst>
+            <a:ext uri="{FF2B5EF4-FFF2-40B4-BE49-F238E27FC236}">
+              <a16:creationId xmlns:a16="http://schemas.microsoft.com/office/drawing/2014/main" id="{2967923A-A64A-7447-5203-0016D3EF0F6F}"/>
+            </a:ext>
+          </a:extLst>
+        </p:cNvPr>
+        <p:cNvGrpSpPr/>
+        <p:nvPr/>
+      </p:nvGrpSpPr>
+      <p:grpSpPr>
+        <a:xfrm>
+          <a:off x="0" y="0"/>
+          <a:ext cx="0" cy="0"/>
+          <a:chOff x="0" y="0"/>
+          <a:chExt cx="0" cy="0"/>
+        </a:xfrm>
+      </p:grpSpPr>
+      <p:grpSp>
+        <p:nvGrpSpPr>
+          <p:cNvPr id="405" name="Group 404">
+            <a:extLst>
+              <a:ext uri="{FF2B5EF4-FFF2-40B4-BE49-F238E27FC236}">
+                <a16:creationId xmlns:a16="http://schemas.microsoft.com/office/drawing/2014/main" id="{86971060-49B2-7A99-5E28-88B7219789F2}"/>
+              </a:ext>
+            </a:extLst>
+          </p:cNvPr>
+          <p:cNvGrpSpPr/>
+          <p:nvPr/>
+        </p:nvGrpSpPr>
+        <p:grpSpPr>
+          <a:xfrm>
+            <a:off x="-3445945" y="-10479"/>
+            <a:ext cx="18999225" cy="5658105"/>
+            <a:chOff x="-3445945" y="-10479"/>
+            <a:chExt cx="18999225" cy="5658105"/>
+          </a:xfrm>
+        </p:grpSpPr>
+        <p:sp>
+          <p:nvSpPr>
+            <p:cNvPr id="337" name="Rectangle 336">
+              <a:extLst>
+                <a:ext uri="{FF2B5EF4-FFF2-40B4-BE49-F238E27FC236}">
+                  <a16:creationId xmlns:a16="http://schemas.microsoft.com/office/drawing/2014/main" id="{61F89ED9-9119-E662-712B-B7A671A387F0}"/>
+                </a:ext>
+              </a:extLst>
+            </p:cNvPr>
+            <p:cNvSpPr/>
+            <p:nvPr/>
+          </p:nvSpPr>
+          <p:spPr>
+            <a:xfrm>
+              <a:off x="7476080" y="3768026"/>
+              <a:ext cx="8077200" cy="1879600"/>
+            </a:xfrm>
+            <a:prstGeom prst="rect">
+              <a:avLst/>
+            </a:prstGeom>
+            <a:noFill/>
+            <a:ln>
+              <a:noFill/>
+            </a:ln>
+          </p:spPr>
+          <p:style>
+            <a:lnRef idx="2">
+              <a:schemeClr val="accent1">
+                <a:shade val="15000"/>
+              </a:schemeClr>
+            </a:lnRef>
+            <a:fillRef idx="1">
+              <a:schemeClr val="accent1"/>
+            </a:fillRef>
+            <a:effectRef idx="0">
+              <a:schemeClr val="accent1"/>
+            </a:effectRef>
+            <a:fontRef idx="minor">
+              <a:schemeClr val="lt1"/>
+            </a:fontRef>
+          </p:style>
+          <p:txBody>
+            <a:bodyPr rtlCol="0" anchor="ctr"/>
+            <a:lstStyle/>
+            <a:p>
+              <a:pPr algn="ctr"/>
+              <a:endParaRPr lang="en-US"/>
+            </a:p>
+          </p:txBody>
+        </p:sp>
+        <p:sp>
+          <p:nvSpPr>
+            <p:cNvPr id="338" name="Rectangle 337">
+              <a:extLst>
+                <a:ext uri="{FF2B5EF4-FFF2-40B4-BE49-F238E27FC236}">
+                  <a16:creationId xmlns:a16="http://schemas.microsoft.com/office/drawing/2014/main" id="{0EAA1071-5625-5587-6A42-56E972270A35}"/>
+                </a:ext>
+              </a:extLst>
+            </p:cNvPr>
+            <p:cNvSpPr/>
+            <p:nvPr/>
+          </p:nvSpPr>
+          <p:spPr>
+            <a:xfrm>
+              <a:off x="-3445945" y="3717244"/>
+              <a:ext cx="8077200" cy="1879600"/>
+            </a:xfrm>
+            <a:prstGeom prst="rect">
+              <a:avLst/>
+            </a:prstGeom>
+            <a:noFill/>
+            <a:ln>
+              <a:noFill/>
+            </a:ln>
+          </p:spPr>
+          <p:style>
+            <a:lnRef idx="2">
+              <a:schemeClr val="accent1">
+                <a:shade val="15000"/>
+              </a:schemeClr>
+            </a:lnRef>
+            <a:fillRef idx="1">
+              <a:schemeClr val="accent1"/>
+            </a:fillRef>
+            <a:effectRef idx="0">
+              <a:schemeClr val="accent1"/>
+            </a:effectRef>
+            <a:fontRef idx="minor">
+              <a:schemeClr val="lt1"/>
+            </a:fontRef>
+          </p:style>
+          <p:txBody>
+            <a:bodyPr rtlCol="0" anchor="ctr"/>
+            <a:lstStyle/>
+            <a:p>
+              <a:pPr algn="ctr"/>
+              <a:endParaRPr lang="en-US"/>
+            </a:p>
+          </p:txBody>
+        </p:sp>
+        <p:sp>
+          <p:nvSpPr>
+            <p:cNvPr id="367" name="Rectangle 366">
+              <a:extLst>
+                <a:ext uri="{FF2B5EF4-FFF2-40B4-BE49-F238E27FC236}">
+                  <a16:creationId xmlns:a16="http://schemas.microsoft.com/office/drawing/2014/main" id="{7175FE95-7A57-E4F8-E77E-DF2602A0BA2B}"/>
+                </a:ext>
+              </a:extLst>
+            </p:cNvPr>
+            <p:cNvSpPr/>
+            <p:nvPr/>
+          </p:nvSpPr>
+          <p:spPr>
+            <a:xfrm>
+              <a:off x="5556309" y="-10479"/>
+              <a:ext cx="959007" cy="1879600"/>
+            </a:xfrm>
+            <a:prstGeom prst="rect">
+              <a:avLst/>
+            </a:prstGeom>
+            <a:noFill/>
+            <a:ln>
+              <a:noFill/>
+            </a:ln>
+          </p:spPr>
+          <p:style>
+            <a:lnRef idx="2">
+              <a:schemeClr val="accent1">
+                <a:shade val="15000"/>
+              </a:schemeClr>
+            </a:lnRef>
+            <a:fillRef idx="1">
+              <a:schemeClr val="accent1"/>
+            </a:fillRef>
+            <a:effectRef idx="0">
+              <a:schemeClr val="accent1"/>
+            </a:effectRef>
+            <a:fontRef idx="minor">
+              <a:schemeClr val="lt1"/>
+            </a:fontRef>
+          </p:style>
+          <p:txBody>
+            <a:bodyPr rtlCol="0" anchor="ctr"/>
+            <a:lstStyle/>
+            <a:p>
+              <a:pPr algn="ctr"/>
+              <a:endParaRPr lang="en-US"/>
+            </a:p>
+          </p:txBody>
+        </p:sp>
+        <p:sp>
+          <p:nvSpPr>
+            <p:cNvPr id="368" name="Rectangle 367">
+              <a:extLst>
+                <a:ext uri="{FF2B5EF4-FFF2-40B4-BE49-F238E27FC236}">
+                  <a16:creationId xmlns:a16="http://schemas.microsoft.com/office/drawing/2014/main" id="{54E8CE25-7E6E-F727-0B17-7BCB16682BAA}"/>
+                </a:ext>
+              </a:extLst>
+            </p:cNvPr>
+            <p:cNvSpPr/>
+            <p:nvPr/>
+          </p:nvSpPr>
+          <p:spPr>
+            <a:xfrm>
+              <a:off x="6515317" y="0"/>
+              <a:ext cx="1027604" cy="1879600"/>
+            </a:xfrm>
+            <a:prstGeom prst="rect">
+              <a:avLst/>
+            </a:prstGeom>
+            <a:noFill/>
+            <a:ln>
+              <a:noFill/>
+            </a:ln>
+          </p:spPr>
+          <p:style>
+            <a:lnRef idx="2">
+              <a:schemeClr val="accent1">
+                <a:shade val="15000"/>
+              </a:schemeClr>
+            </a:lnRef>
+            <a:fillRef idx="1">
+              <a:schemeClr val="accent1"/>
+            </a:fillRef>
+            <a:effectRef idx="0">
+              <a:schemeClr val="accent1"/>
+            </a:effectRef>
+            <a:fontRef idx="minor">
+              <a:schemeClr val="lt1"/>
+            </a:fontRef>
+          </p:style>
+          <p:txBody>
+            <a:bodyPr rtlCol="0" anchor="ctr"/>
+            <a:lstStyle/>
+            <a:p>
+              <a:pPr algn="ctr"/>
+              <a:endParaRPr lang="en-US"/>
+            </a:p>
+          </p:txBody>
+        </p:sp>
+        <p:sp>
+          <p:nvSpPr>
+            <p:cNvPr id="248" name="Rounded Rectangle 247">
+              <a:extLst>
+                <a:ext uri="{FF2B5EF4-FFF2-40B4-BE49-F238E27FC236}">
+                  <a16:creationId xmlns:a16="http://schemas.microsoft.com/office/drawing/2014/main" id="{BAAB3F55-0282-BDD5-F488-5EA42E12816F}"/>
+                </a:ext>
+              </a:extLst>
+            </p:cNvPr>
+            <p:cNvSpPr/>
+            <p:nvPr/>
+          </p:nvSpPr>
+          <p:spPr>
+            <a:xfrm>
+              <a:off x="2524898" y="339099"/>
+              <a:ext cx="4413929" cy="1216301"/>
+            </a:xfrm>
+            <a:prstGeom prst="roundRect">
+              <a:avLst>
+                <a:gd name="adj" fmla="val 36591"/>
+              </a:avLst>
+            </a:prstGeom>
+            <a:solidFill>
+              <a:srgbClr val="00B0F0">
+                <a:alpha val="25714"/>
+              </a:srgbClr>
+            </a:solidFill>
+            <a:ln w="34925">
+              <a:solidFill>
+                <a:srgbClr val="0070C0"/>
+              </a:solidFill>
+            </a:ln>
+          </p:spPr>
+          <p:style>
+            <a:lnRef idx="2">
+              <a:schemeClr val="accent1">
+                <a:shade val="15000"/>
+              </a:schemeClr>
+            </a:lnRef>
+            <a:fillRef idx="1">
+              <a:schemeClr val="accent1"/>
+            </a:fillRef>
+            <a:effectRef idx="0">
+              <a:schemeClr val="accent1"/>
+            </a:effectRef>
+            <a:fontRef idx="minor">
+              <a:schemeClr val="lt1"/>
+            </a:fontRef>
+          </p:style>
+          <p:txBody>
+            <a:bodyPr rtlCol="0" anchor="ctr"/>
+            <a:lstStyle/>
+            <a:p>
+              <a:pPr algn="ctr"/>
+              <a:endParaRPr lang="en-US"/>
+            </a:p>
+          </p:txBody>
+        </p:sp>
+        <p:sp>
+          <p:nvSpPr>
+            <p:cNvPr id="269" name="Rounded Rectangle 268">
+              <a:extLst>
+                <a:ext uri="{FF2B5EF4-FFF2-40B4-BE49-F238E27FC236}">
+                  <a16:creationId xmlns:a16="http://schemas.microsoft.com/office/drawing/2014/main" id="{7A02F870-0B88-DB00-ADBB-6C43903FE80A}"/>
+                </a:ext>
+              </a:extLst>
+            </p:cNvPr>
+            <p:cNvSpPr/>
+            <p:nvPr/>
+          </p:nvSpPr>
+          <p:spPr>
+            <a:xfrm>
+              <a:off x="7010986" y="355037"/>
+              <a:ext cx="3208180" cy="1216301"/>
+            </a:xfrm>
+            <a:prstGeom prst="roundRect">
+              <a:avLst>
+                <a:gd name="adj" fmla="val 36591"/>
+              </a:avLst>
+            </a:prstGeom>
+            <a:solidFill>
+              <a:srgbClr val="00B0F0">
+                <a:alpha val="25714"/>
+              </a:srgbClr>
+            </a:solidFill>
+            <a:ln w="34925">
+              <a:solidFill>
+                <a:srgbClr val="0070C0"/>
+              </a:solidFill>
+            </a:ln>
+          </p:spPr>
+          <p:style>
+            <a:lnRef idx="2">
+              <a:schemeClr val="accent1">
+                <a:shade val="15000"/>
+              </a:schemeClr>
+            </a:lnRef>
+            <a:fillRef idx="1">
+              <a:schemeClr val="accent1"/>
+            </a:fillRef>
+            <a:effectRef idx="0">
+              <a:schemeClr val="accent1"/>
+            </a:effectRef>
+            <a:fontRef idx="minor">
+              <a:schemeClr val="lt1"/>
+            </a:fontRef>
+          </p:style>
+          <p:txBody>
+            <a:bodyPr rtlCol="0" anchor="ctr"/>
+            <a:lstStyle/>
+            <a:p>
+              <a:pPr algn="ctr"/>
+              <a:endParaRPr lang="en-US"/>
+            </a:p>
+          </p:txBody>
+        </p:sp>
+        <p:sp>
+          <p:nvSpPr>
+            <p:cNvPr id="277" name="Rounded Rectangle 276">
+              <a:extLst>
+                <a:ext uri="{FF2B5EF4-FFF2-40B4-BE49-F238E27FC236}">
+                  <a16:creationId xmlns:a16="http://schemas.microsoft.com/office/drawing/2014/main" id="{971150EC-FFA1-541A-EBA3-11E7F725F6CE}"/>
+                </a:ext>
+              </a:extLst>
+            </p:cNvPr>
+            <p:cNvSpPr/>
+            <p:nvPr/>
+          </p:nvSpPr>
+          <p:spPr>
+            <a:xfrm>
+              <a:off x="-3233232" y="3966219"/>
+              <a:ext cx="4413929" cy="1216301"/>
+            </a:xfrm>
+            <a:prstGeom prst="roundRect">
+              <a:avLst>
+                <a:gd name="adj" fmla="val 36591"/>
+              </a:avLst>
+            </a:prstGeom>
+            <a:solidFill>
+              <a:srgbClr val="00B0F0">
+                <a:alpha val="25714"/>
+              </a:srgbClr>
+            </a:solidFill>
+            <a:ln w="34925">
+              <a:solidFill>
+                <a:srgbClr val="0070C0"/>
+              </a:solidFill>
+            </a:ln>
+          </p:spPr>
+          <p:style>
+            <a:lnRef idx="2">
+              <a:schemeClr val="accent1">
+                <a:shade val="15000"/>
+              </a:schemeClr>
+            </a:lnRef>
+            <a:fillRef idx="1">
+              <a:schemeClr val="accent1"/>
+            </a:fillRef>
+            <a:effectRef idx="0">
+              <a:schemeClr val="accent1"/>
+            </a:effectRef>
+            <a:fontRef idx="minor">
+              <a:schemeClr val="lt1"/>
+            </a:fontRef>
+          </p:style>
+          <p:txBody>
+            <a:bodyPr rtlCol="0" anchor="ctr"/>
+            <a:lstStyle/>
+            <a:p>
+              <a:pPr algn="ctr"/>
+              <a:endParaRPr lang="en-US"/>
+            </a:p>
+          </p:txBody>
+        </p:sp>
+        <p:sp>
+          <p:nvSpPr>
+            <p:cNvPr id="285" name="Rounded Rectangle 284">
+              <a:extLst>
+                <a:ext uri="{FF2B5EF4-FFF2-40B4-BE49-F238E27FC236}">
+                  <a16:creationId xmlns:a16="http://schemas.microsoft.com/office/drawing/2014/main" id="{5E95108E-FF31-B567-B4D2-6C30A149F62F}"/>
+                </a:ext>
+              </a:extLst>
+            </p:cNvPr>
+            <p:cNvSpPr/>
+            <p:nvPr/>
+          </p:nvSpPr>
+          <p:spPr>
+            <a:xfrm>
+              <a:off x="1252856" y="3982157"/>
+              <a:ext cx="3208180" cy="1216301"/>
+            </a:xfrm>
+            <a:prstGeom prst="roundRect">
+              <a:avLst>
+                <a:gd name="adj" fmla="val 36591"/>
+              </a:avLst>
+            </a:prstGeom>
+            <a:solidFill>
+              <a:srgbClr val="00B0F0">
+                <a:alpha val="25714"/>
+              </a:srgbClr>
+            </a:solidFill>
+            <a:ln w="34925">
+              <a:solidFill>
+                <a:srgbClr val="0070C0"/>
+              </a:solidFill>
+            </a:ln>
+          </p:spPr>
+          <p:style>
+            <a:lnRef idx="2">
+              <a:schemeClr val="accent1">
+                <a:shade val="15000"/>
+              </a:schemeClr>
+            </a:lnRef>
+            <a:fillRef idx="1">
+              <a:schemeClr val="accent1"/>
+            </a:fillRef>
+            <a:effectRef idx="0">
+              <a:schemeClr val="accent1"/>
+            </a:effectRef>
+            <a:fontRef idx="minor">
+              <a:schemeClr val="lt1"/>
+            </a:fontRef>
+          </p:style>
+          <p:txBody>
+            <a:bodyPr rtlCol="0" anchor="ctr"/>
+            <a:lstStyle/>
+            <a:p>
+              <a:pPr algn="ctr"/>
+              <a:endParaRPr lang="en-US"/>
+            </a:p>
+          </p:txBody>
+        </p:sp>
+        <p:sp>
+          <p:nvSpPr>
+            <p:cNvPr id="293" name="Rounded Rectangle 292">
+              <a:extLst>
+                <a:ext uri="{FF2B5EF4-FFF2-40B4-BE49-F238E27FC236}">
+                  <a16:creationId xmlns:a16="http://schemas.microsoft.com/office/drawing/2014/main" id="{A784976C-518F-FCC3-2A5C-EC819D5E2FE9}"/>
+                </a:ext>
+              </a:extLst>
+            </p:cNvPr>
+            <p:cNvSpPr/>
+            <p:nvPr/>
+          </p:nvSpPr>
+          <p:spPr>
+            <a:xfrm>
+              <a:off x="7678423" y="3982157"/>
+              <a:ext cx="4413929" cy="1216301"/>
+            </a:xfrm>
+            <a:prstGeom prst="roundRect">
+              <a:avLst>
+                <a:gd name="adj" fmla="val 36591"/>
+              </a:avLst>
+            </a:prstGeom>
+            <a:solidFill>
+              <a:srgbClr val="00B0F0">
+                <a:alpha val="25714"/>
+              </a:srgbClr>
+            </a:solidFill>
+            <a:ln w="34925">
+              <a:solidFill>
+                <a:srgbClr val="0070C0"/>
+              </a:solidFill>
+            </a:ln>
+          </p:spPr>
+          <p:style>
+            <a:lnRef idx="2">
+              <a:schemeClr val="accent1">
+                <a:shade val="15000"/>
+              </a:schemeClr>
+            </a:lnRef>
+            <a:fillRef idx="1">
+              <a:schemeClr val="accent1"/>
+            </a:fillRef>
+            <a:effectRef idx="0">
+              <a:schemeClr val="accent1"/>
+            </a:effectRef>
+            <a:fontRef idx="minor">
+              <a:schemeClr val="lt1"/>
+            </a:fontRef>
+          </p:style>
+          <p:txBody>
+            <a:bodyPr rtlCol="0" anchor="ctr"/>
+            <a:lstStyle/>
+            <a:p>
+              <a:pPr algn="ctr"/>
+              <a:endParaRPr lang="en-US"/>
+            </a:p>
+          </p:txBody>
+        </p:sp>
+        <p:sp>
+          <p:nvSpPr>
+            <p:cNvPr id="301" name="Rounded Rectangle 300">
+              <a:extLst>
+                <a:ext uri="{FF2B5EF4-FFF2-40B4-BE49-F238E27FC236}">
+                  <a16:creationId xmlns:a16="http://schemas.microsoft.com/office/drawing/2014/main" id="{A623A268-B9AB-9E8E-BDB7-D1DB93E73FB8}"/>
+                </a:ext>
+              </a:extLst>
+            </p:cNvPr>
+            <p:cNvSpPr/>
+            <p:nvPr/>
+          </p:nvSpPr>
+          <p:spPr>
+            <a:xfrm>
+              <a:off x="12164511" y="3998095"/>
+              <a:ext cx="3208180" cy="1216301"/>
+            </a:xfrm>
+            <a:prstGeom prst="roundRect">
+              <a:avLst>
+                <a:gd name="adj" fmla="val 36591"/>
+              </a:avLst>
+            </a:prstGeom>
+            <a:solidFill>
+              <a:srgbClr val="00B0F0">
+                <a:alpha val="25714"/>
+              </a:srgbClr>
+            </a:solidFill>
+            <a:ln w="34925">
+              <a:solidFill>
+                <a:srgbClr val="0070C0"/>
+              </a:solidFill>
+            </a:ln>
+          </p:spPr>
+          <p:style>
+            <a:lnRef idx="2">
+              <a:schemeClr val="accent1">
+                <a:shade val="15000"/>
+              </a:schemeClr>
+            </a:lnRef>
+            <a:fillRef idx="1">
+              <a:schemeClr val="accent1"/>
+            </a:fillRef>
+            <a:effectRef idx="0">
+              <a:schemeClr val="accent1"/>
+            </a:effectRef>
+            <a:fontRef idx="minor">
+              <a:schemeClr val="lt1"/>
+            </a:fontRef>
+          </p:style>
+          <p:txBody>
+            <a:bodyPr rtlCol="0" anchor="ctr"/>
+            <a:lstStyle/>
+            <a:p>
+              <a:pPr algn="ctr"/>
+              <a:endParaRPr lang="en-US"/>
+            </a:p>
+          </p:txBody>
+        </p:sp>
+        <p:pic>
+          <p:nvPicPr>
+            <p:cNvPr id="240" name="Graphic 239" descr="Sleep with solid fill">
+              <a:extLst>
+                <a:ext uri="{FF2B5EF4-FFF2-40B4-BE49-F238E27FC236}">
+                  <a16:creationId xmlns:a16="http://schemas.microsoft.com/office/drawing/2014/main" id="{3CD1EC67-F57D-92F8-5DE2-7ABA01A32432}"/>
+                </a:ext>
+              </a:extLst>
+            </p:cNvPr>
+            <p:cNvPicPr>
+              <a:picLocks noChangeAspect="1"/>
+            </p:cNvPicPr>
+            <p:nvPr/>
+          </p:nvPicPr>
+          <p:blipFill>
+            <a:blip>
+              <a:extLst>
+                <a:ext uri="{96DAC541-7B7A-43D3-8B79-37D633B846F1}">
+                  <asvg:svgBlip xmlns:asvg="http://schemas.microsoft.com/office/drawing/2016/SVG/main" r:embed="rId3"/>
+                </a:ext>
+              </a:extLst>
+            </a:blip>
+            <a:srcRect/>
+            <a:stretch/>
+          </p:blipFill>
+          <p:spPr>
+            <a:xfrm>
+              <a:off x="2810982" y="696621"/>
+              <a:ext cx="634696" cy="634696"/>
+            </a:xfrm>
+            <a:prstGeom prst="rect">
+              <a:avLst/>
+            </a:prstGeom>
+          </p:spPr>
+        </p:pic>
+        <p:pic>
+          <p:nvPicPr>
+            <p:cNvPr id="241" name="Graphic 240" descr="Sleep with solid fill">
+              <a:extLst>
+                <a:ext uri="{FF2B5EF4-FFF2-40B4-BE49-F238E27FC236}">
+                  <a16:creationId xmlns:a16="http://schemas.microsoft.com/office/drawing/2014/main" id="{6695471A-D6A9-D1D1-0115-D8B3C2ADFD7A}"/>
+                </a:ext>
+              </a:extLst>
+            </p:cNvPr>
+            <p:cNvPicPr>
+              <a:picLocks noChangeAspect="1"/>
+            </p:cNvPicPr>
+            <p:nvPr/>
+          </p:nvPicPr>
+          <p:blipFill>
+            <a:blip>
+              <a:extLst>
+                <a:ext uri="{96DAC541-7B7A-43D3-8B79-37D633B846F1}">
+                  <asvg:svgBlip xmlns:asvg="http://schemas.microsoft.com/office/drawing/2016/SVG/main" r:embed="rId4"/>
+                </a:ext>
+              </a:extLst>
+            </a:blip>
+            <a:srcRect/>
+            <a:stretch/>
+          </p:blipFill>
+          <p:spPr>
+            <a:xfrm>
+              <a:off x="3876814" y="696621"/>
+              <a:ext cx="634696" cy="634696"/>
+            </a:xfrm>
+            <a:prstGeom prst="rect">
+              <a:avLst/>
+            </a:prstGeom>
+          </p:spPr>
+        </p:pic>
+        <p:pic>
+          <p:nvPicPr>
+            <p:cNvPr id="242" name="Graphic 241" descr="Sleep with solid fill">
+              <a:extLst>
+                <a:ext uri="{FF2B5EF4-FFF2-40B4-BE49-F238E27FC236}">
+                  <a16:creationId xmlns:a16="http://schemas.microsoft.com/office/drawing/2014/main" id="{0264FEF3-D28E-0981-9CCE-2AA9F871C976}"/>
+                </a:ext>
+              </a:extLst>
+            </p:cNvPr>
+            <p:cNvPicPr>
+              <a:picLocks noChangeAspect="1"/>
+            </p:cNvPicPr>
+            <p:nvPr/>
+          </p:nvPicPr>
+          <p:blipFill>
+            <a:blip>
+              <a:extLst>
+                <a:ext uri="{96DAC541-7B7A-43D3-8B79-37D633B846F1}">
+                  <asvg:svgBlip xmlns:asvg="http://schemas.microsoft.com/office/drawing/2016/SVG/main" r:embed="rId3"/>
+                </a:ext>
+              </a:extLst>
+            </a:blip>
+            <a:srcRect/>
+            <a:stretch/>
+          </p:blipFill>
+          <p:spPr>
+            <a:xfrm>
+              <a:off x="4986147" y="696621"/>
+              <a:ext cx="634696" cy="634696"/>
+            </a:xfrm>
+            <a:prstGeom prst="rect">
+              <a:avLst/>
+            </a:prstGeom>
+          </p:spPr>
+        </p:pic>
+        <p:pic>
+          <p:nvPicPr>
+            <p:cNvPr id="243" name="Graphic 242" descr="Sleep with solid fill">
+              <a:extLst>
+                <a:ext uri="{FF2B5EF4-FFF2-40B4-BE49-F238E27FC236}">
+                  <a16:creationId xmlns:a16="http://schemas.microsoft.com/office/drawing/2014/main" id="{852EF58C-A25F-A08D-7FC1-4CFE7D8566DF}"/>
+                </a:ext>
+              </a:extLst>
+            </p:cNvPr>
+            <p:cNvPicPr>
+              <a:picLocks noChangeAspect="1"/>
+            </p:cNvPicPr>
+            <p:nvPr/>
+          </p:nvPicPr>
+          <p:blipFill>
+            <a:blip>
+              <a:extLst>
+                <a:ext uri="{96DAC541-7B7A-43D3-8B79-37D633B846F1}">
+                  <asvg:svgBlip xmlns:asvg="http://schemas.microsoft.com/office/drawing/2016/SVG/main" r:embed="rId3"/>
+                </a:ext>
+              </a:extLst>
+            </a:blip>
+            <a:srcRect/>
+            <a:stretch/>
+          </p:blipFill>
+          <p:spPr>
+            <a:xfrm>
+              <a:off x="6051979" y="696621"/>
+              <a:ext cx="634696" cy="634696"/>
+            </a:xfrm>
+            <a:prstGeom prst="rect">
+              <a:avLst/>
+            </a:prstGeom>
+          </p:spPr>
+        </p:pic>
+        <p:pic>
+          <p:nvPicPr>
+            <p:cNvPr id="244" name="Graphic 243" descr="Sleep with solid fill">
+              <a:extLst>
+                <a:ext uri="{FF2B5EF4-FFF2-40B4-BE49-F238E27FC236}">
+                  <a16:creationId xmlns:a16="http://schemas.microsoft.com/office/drawing/2014/main" id="{4B20BE29-DA3F-0E0C-6A1C-67527BD12A8E}"/>
+                </a:ext>
+              </a:extLst>
+            </p:cNvPr>
+            <p:cNvPicPr>
+              <a:picLocks noChangeAspect="1"/>
+            </p:cNvPicPr>
+            <p:nvPr/>
+          </p:nvPicPr>
+          <p:blipFill>
+            <a:blip>
+              <a:extLst>
+                <a:ext uri="{96DAC541-7B7A-43D3-8B79-37D633B846F1}">
+                  <asvg:svgBlip xmlns:asvg="http://schemas.microsoft.com/office/drawing/2016/SVG/main" r:embed="rId4"/>
+                </a:ext>
+              </a:extLst>
+            </a:blip>
+            <a:srcRect/>
+            <a:stretch/>
+          </p:blipFill>
+          <p:spPr>
+            <a:xfrm>
+              <a:off x="7171380" y="696621"/>
+              <a:ext cx="634696" cy="634696"/>
+            </a:xfrm>
+            <a:prstGeom prst="rect">
+              <a:avLst/>
+            </a:prstGeom>
+          </p:spPr>
+        </p:pic>
+        <p:pic>
+          <p:nvPicPr>
+            <p:cNvPr id="245" name="Graphic 244" descr="Sleep with solid fill">
+              <a:extLst>
+                <a:ext uri="{FF2B5EF4-FFF2-40B4-BE49-F238E27FC236}">
+                  <a16:creationId xmlns:a16="http://schemas.microsoft.com/office/drawing/2014/main" id="{A52BDAD3-361C-1463-7E67-57050A94F947}"/>
+                </a:ext>
+              </a:extLst>
+            </p:cNvPr>
+            <p:cNvPicPr>
+              <a:picLocks noChangeAspect="1"/>
+            </p:cNvPicPr>
+            <p:nvPr/>
+          </p:nvPicPr>
+          <p:blipFill>
+            <a:blip>
+              <a:extLst>
+                <a:ext uri="{96DAC541-7B7A-43D3-8B79-37D633B846F1}">
+                  <asvg:svgBlip xmlns:asvg="http://schemas.microsoft.com/office/drawing/2016/SVG/main" r:embed="rId5"/>
+                </a:ext>
+              </a:extLst>
+            </a:blip>
+            <a:srcRect/>
+            <a:stretch/>
+          </p:blipFill>
+          <p:spPr>
+            <a:xfrm>
+              <a:off x="8237212" y="696621"/>
+              <a:ext cx="634696" cy="634696"/>
+            </a:xfrm>
+            <a:prstGeom prst="rect">
+              <a:avLst/>
+            </a:prstGeom>
+          </p:spPr>
+        </p:pic>
+        <p:pic>
+          <p:nvPicPr>
+            <p:cNvPr id="246" name="Graphic 245" descr="Sleep with solid fill">
+              <a:extLst>
+                <a:ext uri="{FF2B5EF4-FFF2-40B4-BE49-F238E27FC236}">
+                  <a16:creationId xmlns:a16="http://schemas.microsoft.com/office/drawing/2014/main" id="{974DDC70-6CF2-410F-B25B-2AFD0038F8AA}"/>
+                </a:ext>
+              </a:extLst>
+            </p:cNvPr>
+            <p:cNvPicPr>
+              <a:picLocks noChangeAspect="1"/>
+            </p:cNvPicPr>
+            <p:nvPr/>
+          </p:nvPicPr>
+          <p:blipFill>
+            <a:blip>
+              <a:extLst>
+                <a:ext uri="{96DAC541-7B7A-43D3-8B79-37D633B846F1}">
+                  <asvg:svgBlip xmlns:asvg="http://schemas.microsoft.com/office/drawing/2016/SVG/main" r:embed="rId4"/>
+                </a:ext>
+              </a:extLst>
+            </a:blip>
+            <a:srcRect/>
+            <a:stretch/>
+          </p:blipFill>
+          <p:spPr>
+            <a:xfrm>
+              <a:off x="9346545" y="696621"/>
+              <a:ext cx="634696" cy="634696"/>
+            </a:xfrm>
+            <a:prstGeom prst="rect">
+              <a:avLst/>
+            </a:prstGeom>
+          </p:spPr>
+        </p:pic>
+        <p:sp>
+          <p:nvSpPr>
+            <p:cNvPr id="259" name="TextBox 258">
+              <a:extLst>
+                <a:ext uri="{FF2B5EF4-FFF2-40B4-BE49-F238E27FC236}">
+                  <a16:creationId xmlns:a16="http://schemas.microsoft.com/office/drawing/2014/main" id="{B3FD82C9-05B8-E3C9-B9B4-B0259BB9BEEE}"/>
+                </a:ext>
+              </a:extLst>
+            </p:cNvPr>
+            <p:cNvSpPr txBox="1"/>
+            <p:nvPr/>
+          </p:nvSpPr>
+          <p:spPr>
+            <a:xfrm>
+              <a:off x="2879430" y="532896"/>
+              <a:ext cx="570990" cy="369332"/>
+            </a:xfrm>
+            <a:prstGeom prst="rect">
+              <a:avLst/>
+            </a:prstGeom>
+            <a:noFill/>
+          </p:spPr>
+          <p:txBody>
+            <a:bodyPr wrap="none" rtlCol="0">
+              <a:spAutoFit/>
+            </a:bodyPr>
+            <a:lstStyle/>
+            <a:p>
+              <a:r>
+                <a:rPr lang="en-US" dirty="0"/>
+                <a:t>B08</a:t>
+              </a:r>
+            </a:p>
+          </p:txBody>
+        </p:sp>
+        <p:sp>
+          <p:nvSpPr>
+            <p:cNvPr id="260" name="TextBox 259">
+              <a:extLst>
+                <a:ext uri="{FF2B5EF4-FFF2-40B4-BE49-F238E27FC236}">
+                  <a16:creationId xmlns:a16="http://schemas.microsoft.com/office/drawing/2014/main" id="{D393BF82-C0FA-9BC9-12B9-5A4E06DF7C10}"/>
+                </a:ext>
+              </a:extLst>
+            </p:cNvPr>
+            <p:cNvSpPr txBox="1"/>
+            <p:nvPr/>
+          </p:nvSpPr>
+          <p:spPr>
+            <a:xfrm>
+              <a:off x="3941235" y="532896"/>
+              <a:ext cx="570990" cy="369332"/>
+            </a:xfrm>
+            <a:prstGeom prst="rect">
+              <a:avLst/>
+            </a:prstGeom>
+            <a:noFill/>
+          </p:spPr>
+          <p:txBody>
+            <a:bodyPr wrap="none" rtlCol="0">
+              <a:spAutoFit/>
+            </a:bodyPr>
+            <a:lstStyle/>
+            <a:p>
+              <a:r>
+                <a:rPr lang="en-US" dirty="0"/>
+                <a:t>B09</a:t>
+              </a:r>
+            </a:p>
+          </p:txBody>
+        </p:sp>
+        <p:sp>
+          <p:nvSpPr>
+            <p:cNvPr id="261" name="TextBox 260">
+              <a:extLst>
+                <a:ext uri="{FF2B5EF4-FFF2-40B4-BE49-F238E27FC236}">
+                  <a16:creationId xmlns:a16="http://schemas.microsoft.com/office/drawing/2014/main" id="{1201AF27-DA83-14E9-C51A-E05979D3C19D}"/>
+                </a:ext>
+              </a:extLst>
+            </p:cNvPr>
+            <p:cNvSpPr txBox="1"/>
+            <p:nvPr/>
+          </p:nvSpPr>
+          <p:spPr>
+            <a:xfrm>
+              <a:off x="5007895" y="532896"/>
+              <a:ext cx="570990" cy="369332"/>
+            </a:xfrm>
+            <a:prstGeom prst="rect">
+              <a:avLst/>
+            </a:prstGeom>
+            <a:noFill/>
+          </p:spPr>
+          <p:txBody>
+            <a:bodyPr wrap="none" rtlCol="0">
+              <a:spAutoFit/>
+            </a:bodyPr>
+            <a:lstStyle/>
+            <a:p>
+              <a:r>
+                <a:rPr lang="en-US" dirty="0"/>
+                <a:t>B10</a:t>
+              </a:r>
+            </a:p>
+          </p:txBody>
+        </p:sp>
+        <p:sp>
+          <p:nvSpPr>
+            <p:cNvPr id="262" name="TextBox 261">
+              <a:extLst>
+                <a:ext uri="{FF2B5EF4-FFF2-40B4-BE49-F238E27FC236}">
+                  <a16:creationId xmlns:a16="http://schemas.microsoft.com/office/drawing/2014/main" id="{A90B992C-EF65-76BF-1DCD-EF0CC49AD157}"/>
+                </a:ext>
+              </a:extLst>
+            </p:cNvPr>
+            <p:cNvSpPr txBox="1"/>
+            <p:nvPr/>
+          </p:nvSpPr>
+          <p:spPr>
+            <a:xfrm>
+              <a:off x="6097455" y="532896"/>
+              <a:ext cx="570990" cy="369332"/>
+            </a:xfrm>
+            <a:prstGeom prst="rect">
+              <a:avLst/>
+            </a:prstGeom>
+            <a:noFill/>
+          </p:spPr>
+          <p:txBody>
+            <a:bodyPr wrap="none" rtlCol="0">
+              <a:spAutoFit/>
+            </a:bodyPr>
+            <a:lstStyle/>
+            <a:p>
+              <a:r>
+                <a:rPr lang="en-US" dirty="0"/>
+                <a:t>B11</a:t>
+              </a:r>
+            </a:p>
+          </p:txBody>
+        </p:sp>
+        <p:sp>
+          <p:nvSpPr>
+            <p:cNvPr id="263" name="TextBox 262">
+              <a:extLst>
+                <a:ext uri="{FF2B5EF4-FFF2-40B4-BE49-F238E27FC236}">
+                  <a16:creationId xmlns:a16="http://schemas.microsoft.com/office/drawing/2014/main" id="{0D523EF9-91C4-036C-795C-1B026539243D}"/>
+                </a:ext>
+              </a:extLst>
+            </p:cNvPr>
+            <p:cNvSpPr txBox="1"/>
+            <p:nvPr/>
+          </p:nvSpPr>
+          <p:spPr>
+            <a:xfrm>
+              <a:off x="7217249" y="537485"/>
+              <a:ext cx="570990" cy="369332"/>
+            </a:xfrm>
+            <a:prstGeom prst="rect">
+              <a:avLst/>
+            </a:prstGeom>
+            <a:noFill/>
+          </p:spPr>
+          <p:txBody>
+            <a:bodyPr wrap="none" rtlCol="0">
+              <a:spAutoFit/>
+            </a:bodyPr>
+            <a:lstStyle/>
+            <a:p>
+              <a:r>
+                <a:rPr lang="en-US" dirty="0"/>
+                <a:t>B12</a:t>
+              </a:r>
+            </a:p>
+          </p:txBody>
+        </p:sp>
+        <p:sp>
+          <p:nvSpPr>
+            <p:cNvPr id="264" name="TextBox 263">
+              <a:extLst>
+                <a:ext uri="{FF2B5EF4-FFF2-40B4-BE49-F238E27FC236}">
+                  <a16:creationId xmlns:a16="http://schemas.microsoft.com/office/drawing/2014/main" id="{B986ABA0-3C51-185E-C11A-8592C652D434}"/>
+                </a:ext>
+              </a:extLst>
+            </p:cNvPr>
+            <p:cNvSpPr txBox="1"/>
+            <p:nvPr/>
+          </p:nvSpPr>
+          <p:spPr>
+            <a:xfrm>
+              <a:off x="8279054" y="537485"/>
+              <a:ext cx="570990" cy="369332"/>
+            </a:xfrm>
+            <a:prstGeom prst="rect">
+              <a:avLst/>
+            </a:prstGeom>
+            <a:noFill/>
+          </p:spPr>
+          <p:txBody>
+            <a:bodyPr wrap="none" rtlCol="0">
+              <a:spAutoFit/>
+            </a:bodyPr>
+            <a:lstStyle/>
+            <a:p>
+              <a:r>
+                <a:rPr lang="en-US" dirty="0"/>
+                <a:t>B13</a:t>
+              </a:r>
+            </a:p>
+          </p:txBody>
+        </p:sp>
+        <p:sp>
+          <p:nvSpPr>
+            <p:cNvPr id="265" name="TextBox 264">
+              <a:extLst>
+                <a:ext uri="{FF2B5EF4-FFF2-40B4-BE49-F238E27FC236}">
+                  <a16:creationId xmlns:a16="http://schemas.microsoft.com/office/drawing/2014/main" id="{3F96256B-50FF-AD69-8DD0-E0CBBFDA869A}"/>
+                </a:ext>
+              </a:extLst>
+            </p:cNvPr>
+            <p:cNvSpPr txBox="1"/>
+            <p:nvPr/>
+          </p:nvSpPr>
+          <p:spPr>
+            <a:xfrm>
+              <a:off x="9345714" y="537485"/>
+              <a:ext cx="570990" cy="369332"/>
+            </a:xfrm>
+            <a:prstGeom prst="rect">
+              <a:avLst/>
+            </a:prstGeom>
+            <a:noFill/>
+          </p:spPr>
+          <p:txBody>
+            <a:bodyPr wrap="none" rtlCol="0">
+              <a:spAutoFit/>
+            </a:bodyPr>
+            <a:lstStyle/>
+            <a:p>
+              <a:r>
+                <a:rPr lang="en-US" dirty="0"/>
+                <a:t>B14</a:t>
+              </a:r>
+            </a:p>
+          </p:txBody>
+        </p:sp>
+        <p:pic>
+          <p:nvPicPr>
+            <p:cNvPr id="270" name="Graphic 269" descr="Sleep with solid fill">
+              <a:extLst>
+                <a:ext uri="{FF2B5EF4-FFF2-40B4-BE49-F238E27FC236}">
+                  <a16:creationId xmlns:a16="http://schemas.microsoft.com/office/drawing/2014/main" id="{28E915A9-6EF2-9344-3A9E-E49066F3D26B}"/>
+                </a:ext>
+              </a:extLst>
+            </p:cNvPr>
+            <p:cNvPicPr>
+              <a:picLocks noChangeAspect="1"/>
+            </p:cNvPicPr>
+            <p:nvPr/>
+          </p:nvPicPr>
+          <p:blipFill>
+            <a:blip>
+              <a:extLst>
+                <a:ext uri="{96DAC541-7B7A-43D3-8B79-37D633B846F1}">
+                  <asvg:svgBlip xmlns:asvg="http://schemas.microsoft.com/office/drawing/2016/SVG/main" r:embed="rId6"/>
+                </a:ext>
+              </a:extLst>
+            </a:blip>
+            <a:srcRect/>
+            <a:stretch/>
+          </p:blipFill>
+          <p:spPr>
+            <a:xfrm>
+              <a:off x="-2947148" y="4323741"/>
+              <a:ext cx="634696" cy="634696"/>
+            </a:xfrm>
+            <a:prstGeom prst="rect">
+              <a:avLst/>
+            </a:prstGeom>
+          </p:spPr>
+        </p:pic>
+        <p:pic>
+          <p:nvPicPr>
+            <p:cNvPr id="271" name="Graphic 270" descr="Sleep with solid fill">
+              <a:extLst>
+                <a:ext uri="{FF2B5EF4-FFF2-40B4-BE49-F238E27FC236}">
+                  <a16:creationId xmlns:a16="http://schemas.microsoft.com/office/drawing/2014/main" id="{3AD02126-D26D-185E-5798-D738A30FA30A}"/>
+                </a:ext>
+              </a:extLst>
+            </p:cNvPr>
+            <p:cNvPicPr>
+              <a:picLocks noChangeAspect="1"/>
+            </p:cNvPicPr>
+            <p:nvPr/>
+          </p:nvPicPr>
+          <p:blipFill>
+            <a:blip>
+              <a:extLst>
+                <a:ext uri="{96DAC541-7B7A-43D3-8B79-37D633B846F1}">
+                  <asvg:svgBlip xmlns:asvg="http://schemas.microsoft.com/office/drawing/2016/SVG/main" r:embed="rId4"/>
+                </a:ext>
+              </a:extLst>
+            </a:blip>
+            <a:srcRect/>
+            <a:stretch/>
+          </p:blipFill>
+          <p:spPr>
+            <a:xfrm>
+              <a:off x="-1881316" y="4323741"/>
+              <a:ext cx="634696" cy="634696"/>
+            </a:xfrm>
+            <a:prstGeom prst="rect">
+              <a:avLst/>
+            </a:prstGeom>
+          </p:spPr>
+        </p:pic>
+        <p:pic>
+          <p:nvPicPr>
+            <p:cNvPr id="272" name="Graphic 271" descr="Sleep with solid fill">
+              <a:extLst>
+                <a:ext uri="{FF2B5EF4-FFF2-40B4-BE49-F238E27FC236}">
+                  <a16:creationId xmlns:a16="http://schemas.microsoft.com/office/drawing/2014/main" id="{008EDC99-941D-828B-8EC7-38AD475AAC6A}"/>
+                </a:ext>
+              </a:extLst>
+            </p:cNvPr>
+            <p:cNvPicPr>
+              <a:picLocks noChangeAspect="1"/>
+            </p:cNvPicPr>
+            <p:nvPr/>
+          </p:nvPicPr>
+          <p:blipFill>
+            <a:blip>
+              <a:extLst>
+                <a:ext uri="{96DAC541-7B7A-43D3-8B79-37D633B846F1}">
+                  <asvg:svgBlip xmlns:asvg="http://schemas.microsoft.com/office/drawing/2016/SVG/main" r:embed="rId3"/>
+                </a:ext>
+              </a:extLst>
+            </a:blip>
+            <a:srcRect/>
+            <a:stretch/>
+          </p:blipFill>
+          <p:spPr>
+            <a:xfrm>
+              <a:off x="-771983" y="4323741"/>
+              <a:ext cx="634696" cy="634696"/>
+            </a:xfrm>
+            <a:prstGeom prst="rect">
+              <a:avLst/>
+            </a:prstGeom>
+          </p:spPr>
+        </p:pic>
+        <p:pic>
+          <p:nvPicPr>
+            <p:cNvPr id="273" name="Graphic 272" descr="Sleep with solid fill">
+              <a:extLst>
+                <a:ext uri="{FF2B5EF4-FFF2-40B4-BE49-F238E27FC236}">
+                  <a16:creationId xmlns:a16="http://schemas.microsoft.com/office/drawing/2014/main" id="{618EE3C0-CE81-31EA-64F9-B925DF4F6F9A}"/>
+                </a:ext>
+              </a:extLst>
+            </p:cNvPr>
+            <p:cNvPicPr>
+              <a:picLocks noChangeAspect="1"/>
+            </p:cNvPicPr>
+            <p:nvPr/>
+          </p:nvPicPr>
+          <p:blipFill>
+            <a:blip>
+              <a:extLst>
+                <a:ext uri="{96DAC541-7B7A-43D3-8B79-37D633B846F1}">
+                  <asvg:svgBlip xmlns:asvg="http://schemas.microsoft.com/office/drawing/2016/SVG/main" r:embed="rId3"/>
+                </a:ext>
+              </a:extLst>
+            </a:blip>
+            <a:srcRect/>
+            <a:stretch/>
+          </p:blipFill>
+          <p:spPr>
+            <a:xfrm>
+              <a:off x="293849" y="4323741"/>
+              <a:ext cx="634696" cy="634696"/>
+            </a:xfrm>
+            <a:prstGeom prst="rect">
+              <a:avLst/>
+            </a:prstGeom>
+          </p:spPr>
+        </p:pic>
+        <p:pic>
+          <p:nvPicPr>
+            <p:cNvPr id="274" name="Graphic 273" descr="Sleep with solid fill">
+              <a:extLst>
+                <a:ext uri="{FF2B5EF4-FFF2-40B4-BE49-F238E27FC236}">
+                  <a16:creationId xmlns:a16="http://schemas.microsoft.com/office/drawing/2014/main" id="{E2319643-9C7D-41EB-D781-DC621622927C}"/>
+                </a:ext>
+              </a:extLst>
+            </p:cNvPr>
+            <p:cNvPicPr>
+              <a:picLocks noChangeAspect="1"/>
+            </p:cNvPicPr>
+            <p:nvPr/>
+          </p:nvPicPr>
+          <p:blipFill>
+            <a:blip>
+              <a:extLst>
+                <a:ext uri="{96DAC541-7B7A-43D3-8B79-37D633B846F1}">
+                  <asvg:svgBlip xmlns:asvg="http://schemas.microsoft.com/office/drawing/2016/SVG/main" r:embed="rId3"/>
+                </a:ext>
+              </a:extLst>
+            </a:blip>
+            <a:srcRect/>
+            <a:stretch/>
+          </p:blipFill>
+          <p:spPr>
+            <a:xfrm>
+              <a:off x="1413250" y="4323741"/>
+              <a:ext cx="634696" cy="634696"/>
+            </a:xfrm>
+            <a:prstGeom prst="rect">
+              <a:avLst/>
+            </a:prstGeom>
+          </p:spPr>
+        </p:pic>
+        <p:pic>
+          <p:nvPicPr>
+            <p:cNvPr id="275" name="Graphic 274" descr="Sleep with solid fill">
+              <a:extLst>
+                <a:ext uri="{FF2B5EF4-FFF2-40B4-BE49-F238E27FC236}">
+                  <a16:creationId xmlns:a16="http://schemas.microsoft.com/office/drawing/2014/main" id="{26D8135D-81D4-0CCD-8ADB-A31CD6CDD895}"/>
+                </a:ext>
+              </a:extLst>
+            </p:cNvPr>
+            <p:cNvPicPr>
+              <a:picLocks noChangeAspect="1"/>
+            </p:cNvPicPr>
+            <p:nvPr/>
+          </p:nvPicPr>
+          <p:blipFill>
+            <a:blip>
+              <a:extLst>
+                <a:ext uri="{96DAC541-7B7A-43D3-8B79-37D633B846F1}">
+                  <asvg:svgBlip xmlns:asvg="http://schemas.microsoft.com/office/drawing/2016/SVG/main" r:embed="rId5"/>
+                </a:ext>
+              </a:extLst>
+            </a:blip>
+            <a:srcRect/>
+            <a:stretch/>
+          </p:blipFill>
+          <p:spPr>
+            <a:xfrm>
+              <a:off x="2479082" y="4323741"/>
+              <a:ext cx="634696" cy="634696"/>
+            </a:xfrm>
+            <a:prstGeom prst="rect">
+              <a:avLst/>
+            </a:prstGeom>
+          </p:spPr>
+        </p:pic>
+        <p:pic>
+          <p:nvPicPr>
+            <p:cNvPr id="276" name="Graphic 275" descr="Sleep with solid fill">
+              <a:extLst>
+                <a:ext uri="{FF2B5EF4-FFF2-40B4-BE49-F238E27FC236}">
+                  <a16:creationId xmlns:a16="http://schemas.microsoft.com/office/drawing/2014/main" id="{A6838EC2-96B2-7C1D-D399-403B6DDFB88C}"/>
+                </a:ext>
+              </a:extLst>
+            </p:cNvPr>
+            <p:cNvPicPr>
+              <a:picLocks noChangeAspect="1"/>
+            </p:cNvPicPr>
+            <p:nvPr/>
+          </p:nvPicPr>
+          <p:blipFill>
+            <a:blip>
+              <a:extLst>
+                <a:ext uri="{96DAC541-7B7A-43D3-8B79-37D633B846F1}">
+                  <asvg:svgBlip xmlns:asvg="http://schemas.microsoft.com/office/drawing/2016/SVG/main" r:embed="rId4"/>
+                </a:ext>
+              </a:extLst>
+            </a:blip>
+            <a:srcRect/>
+            <a:stretch/>
+          </p:blipFill>
+          <p:spPr>
+            <a:xfrm>
+              <a:off x="3588415" y="4323741"/>
+              <a:ext cx="634696" cy="634696"/>
+            </a:xfrm>
+            <a:prstGeom prst="rect">
+              <a:avLst/>
+            </a:prstGeom>
+          </p:spPr>
+        </p:pic>
+        <p:sp>
+          <p:nvSpPr>
+            <p:cNvPr id="278" name="TextBox 277">
+              <a:extLst>
+                <a:ext uri="{FF2B5EF4-FFF2-40B4-BE49-F238E27FC236}">
+                  <a16:creationId xmlns:a16="http://schemas.microsoft.com/office/drawing/2014/main" id="{B0EF4F86-F836-2A56-EE07-F00D75EA979A}"/>
+                </a:ext>
+              </a:extLst>
+            </p:cNvPr>
+            <p:cNvSpPr txBox="1"/>
+            <p:nvPr/>
+          </p:nvSpPr>
+          <p:spPr>
+            <a:xfrm>
+              <a:off x="-2878700" y="4160016"/>
+              <a:ext cx="570990" cy="369332"/>
+            </a:xfrm>
+            <a:prstGeom prst="rect">
+              <a:avLst/>
+            </a:prstGeom>
+            <a:noFill/>
+          </p:spPr>
+          <p:txBody>
+            <a:bodyPr wrap="none" rtlCol="0">
+              <a:spAutoFit/>
+            </a:bodyPr>
+            <a:lstStyle/>
+            <a:p>
+              <a:r>
+                <a:rPr lang="en-US" dirty="0"/>
+                <a:t>B08</a:t>
+              </a:r>
+            </a:p>
+          </p:txBody>
+        </p:sp>
+        <p:sp>
+          <p:nvSpPr>
+            <p:cNvPr id="279" name="TextBox 278">
+              <a:extLst>
+                <a:ext uri="{FF2B5EF4-FFF2-40B4-BE49-F238E27FC236}">
+                  <a16:creationId xmlns:a16="http://schemas.microsoft.com/office/drawing/2014/main" id="{18365E4F-02F6-B925-29B8-A37830051D8E}"/>
+                </a:ext>
+              </a:extLst>
+            </p:cNvPr>
+            <p:cNvSpPr txBox="1"/>
+            <p:nvPr/>
+          </p:nvSpPr>
+          <p:spPr>
+            <a:xfrm>
+              <a:off x="-1816895" y="4160016"/>
+              <a:ext cx="570990" cy="369332"/>
+            </a:xfrm>
+            <a:prstGeom prst="rect">
+              <a:avLst/>
+            </a:prstGeom>
+            <a:noFill/>
+          </p:spPr>
+          <p:txBody>
+            <a:bodyPr wrap="none" rtlCol="0">
+              <a:spAutoFit/>
+            </a:bodyPr>
+            <a:lstStyle/>
+            <a:p>
+              <a:r>
+                <a:rPr lang="en-US" dirty="0"/>
+                <a:t>B09</a:t>
+              </a:r>
+            </a:p>
+          </p:txBody>
+        </p:sp>
+        <p:sp>
+          <p:nvSpPr>
+            <p:cNvPr id="280" name="TextBox 279">
+              <a:extLst>
+                <a:ext uri="{FF2B5EF4-FFF2-40B4-BE49-F238E27FC236}">
+                  <a16:creationId xmlns:a16="http://schemas.microsoft.com/office/drawing/2014/main" id="{5DA25A8D-CFB6-115E-A353-50E967445F82}"/>
+                </a:ext>
+              </a:extLst>
+            </p:cNvPr>
+            <p:cNvSpPr txBox="1"/>
+            <p:nvPr/>
+          </p:nvSpPr>
+          <p:spPr>
+            <a:xfrm>
+              <a:off x="-750235" y="4160016"/>
+              <a:ext cx="570990" cy="369332"/>
+            </a:xfrm>
+            <a:prstGeom prst="rect">
+              <a:avLst/>
+            </a:prstGeom>
+            <a:noFill/>
+          </p:spPr>
+          <p:txBody>
+            <a:bodyPr wrap="none" rtlCol="0">
+              <a:spAutoFit/>
+            </a:bodyPr>
+            <a:lstStyle/>
+            <a:p>
+              <a:r>
+                <a:rPr lang="en-US" dirty="0"/>
+                <a:t>B10</a:t>
+              </a:r>
+            </a:p>
+          </p:txBody>
+        </p:sp>
+        <p:sp>
+          <p:nvSpPr>
+            <p:cNvPr id="281" name="TextBox 280">
+              <a:extLst>
+                <a:ext uri="{FF2B5EF4-FFF2-40B4-BE49-F238E27FC236}">
+                  <a16:creationId xmlns:a16="http://schemas.microsoft.com/office/drawing/2014/main" id="{AA4EF2EC-0A95-302A-BBB9-A51FAD9CF522}"/>
+                </a:ext>
+              </a:extLst>
+            </p:cNvPr>
+            <p:cNvSpPr txBox="1"/>
+            <p:nvPr/>
+          </p:nvSpPr>
+          <p:spPr>
+            <a:xfrm>
+              <a:off x="339325" y="4160016"/>
+              <a:ext cx="570990" cy="369332"/>
+            </a:xfrm>
+            <a:prstGeom prst="rect">
+              <a:avLst/>
+            </a:prstGeom>
+            <a:noFill/>
+          </p:spPr>
+          <p:txBody>
+            <a:bodyPr wrap="none" rtlCol="0">
+              <a:spAutoFit/>
+            </a:bodyPr>
+            <a:lstStyle/>
+            <a:p>
+              <a:r>
+                <a:rPr lang="en-US" dirty="0"/>
+                <a:t>B11</a:t>
+              </a:r>
+            </a:p>
+          </p:txBody>
+        </p:sp>
+        <p:sp>
+          <p:nvSpPr>
+            <p:cNvPr id="282" name="TextBox 281">
+              <a:extLst>
+                <a:ext uri="{FF2B5EF4-FFF2-40B4-BE49-F238E27FC236}">
+                  <a16:creationId xmlns:a16="http://schemas.microsoft.com/office/drawing/2014/main" id="{822F892A-50D6-795D-12D6-FC95AECF9B70}"/>
+                </a:ext>
+              </a:extLst>
+            </p:cNvPr>
+            <p:cNvSpPr txBox="1"/>
+            <p:nvPr/>
+          </p:nvSpPr>
+          <p:spPr>
+            <a:xfrm>
+              <a:off x="1459119" y="4164605"/>
+              <a:ext cx="570990" cy="369332"/>
+            </a:xfrm>
+            <a:prstGeom prst="rect">
+              <a:avLst/>
+            </a:prstGeom>
+            <a:noFill/>
+          </p:spPr>
+          <p:txBody>
+            <a:bodyPr wrap="none" rtlCol="0">
+              <a:spAutoFit/>
+            </a:bodyPr>
+            <a:lstStyle/>
+            <a:p>
+              <a:r>
+                <a:rPr lang="en-US" dirty="0"/>
+                <a:t>B12</a:t>
+              </a:r>
+            </a:p>
+          </p:txBody>
+        </p:sp>
+        <p:sp>
+          <p:nvSpPr>
+            <p:cNvPr id="283" name="TextBox 282">
+              <a:extLst>
+                <a:ext uri="{FF2B5EF4-FFF2-40B4-BE49-F238E27FC236}">
+                  <a16:creationId xmlns:a16="http://schemas.microsoft.com/office/drawing/2014/main" id="{4AFB4511-048E-A6B6-C284-7FBA3D93BE79}"/>
+                </a:ext>
+              </a:extLst>
+            </p:cNvPr>
+            <p:cNvSpPr txBox="1"/>
+            <p:nvPr/>
+          </p:nvSpPr>
+          <p:spPr>
+            <a:xfrm>
+              <a:off x="2520924" y="4164605"/>
+              <a:ext cx="570990" cy="369332"/>
+            </a:xfrm>
+            <a:prstGeom prst="rect">
+              <a:avLst/>
+            </a:prstGeom>
+            <a:noFill/>
+          </p:spPr>
+          <p:txBody>
+            <a:bodyPr wrap="none" rtlCol="0">
+              <a:spAutoFit/>
+            </a:bodyPr>
+            <a:lstStyle/>
+            <a:p>
+              <a:r>
+                <a:rPr lang="en-US" dirty="0"/>
+                <a:t>B13</a:t>
+              </a:r>
+            </a:p>
+          </p:txBody>
+        </p:sp>
+        <p:sp>
+          <p:nvSpPr>
+            <p:cNvPr id="284" name="TextBox 283">
+              <a:extLst>
+                <a:ext uri="{FF2B5EF4-FFF2-40B4-BE49-F238E27FC236}">
+                  <a16:creationId xmlns:a16="http://schemas.microsoft.com/office/drawing/2014/main" id="{88789750-A545-16E4-C7F6-B61CA1047C82}"/>
+                </a:ext>
+              </a:extLst>
+            </p:cNvPr>
+            <p:cNvSpPr txBox="1"/>
+            <p:nvPr/>
+          </p:nvSpPr>
+          <p:spPr>
+            <a:xfrm>
+              <a:off x="3587584" y="4164605"/>
+              <a:ext cx="570990" cy="369332"/>
+            </a:xfrm>
+            <a:prstGeom prst="rect">
+              <a:avLst/>
+            </a:prstGeom>
+            <a:noFill/>
+          </p:spPr>
+          <p:txBody>
+            <a:bodyPr wrap="none" rtlCol="0">
+              <a:spAutoFit/>
+            </a:bodyPr>
+            <a:lstStyle/>
+            <a:p>
+              <a:r>
+                <a:rPr lang="en-US" dirty="0"/>
+                <a:t>B14</a:t>
+              </a:r>
+            </a:p>
+          </p:txBody>
+        </p:sp>
+        <p:pic>
+          <p:nvPicPr>
+            <p:cNvPr id="286" name="Graphic 285" descr="Sleep with solid fill">
+              <a:extLst>
+                <a:ext uri="{FF2B5EF4-FFF2-40B4-BE49-F238E27FC236}">
+                  <a16:creationId xmlns:a16="http://schemas.microsoft.com/office/drawing/2014/main" id="{41DAC4C4-2D35-0E38-BB92-C52D09DDF2AF}"/>
+                </a:ext>
+              </a:extLst>
+            </p:cNvPr>
+            <p:cNvPicPr>
+              <a:picLocks noChangeAspect="1"/>
+            </p:cNvPicPr>
+            <p:nvPr/>
+          </p:nvPicPr>
+          <p:blipFill>
+            <a:blip>
+              <a:extLst>
+                <a:ext uri="{96DAC541-7B7A-43D3-8B79-37D633B846F1}">
+                  <asvg:svgBlip xmlns:asvg="http://schemas.microsoft.com/office/drawing/2016/SVG/main" r:embed="rId6"/>
+                </a:ext>
+              </a:extLst>
+            </a:blip>
+            <a:srcRect/>
+            <a:stretch/>
+          </p:blipFill>
+          <p:spPr>
+            <a:xfrm>
+              <a:off x="7964507" y="4339679"/>
+              <a:ext cx="634696" cy="634696"/>
+            </a:xfrm>
+            <a:prstGeom prst="rect">
+              <a:avLst/>
+            </a:prstGeom>
+          </p:spPr>
+        </p:pic>
+        <p:pic>
+          <p:nvPicPr>
+            <p:cNvPr id="287" name="Graphic 286" descr="Sleep with solid fill">
+              <a:extLst>
+                <a:ext uri="{FF2B5EF4-FFF2-40B4-BE49-F238E27FC236}">
+                  <a16:creationId xmlns:a16="http://schemas.microsoft.com/office/drawing/2014/main" id="{AB69509D-7147-3BF4-217F-AA9BD3D72CD2}"/>
+                </a:ext>
+              </a:extLst>
+            </p:cNvPr>
+            <p:cNvPicPr>
+              <a:picLocks noChangeAspect="1"/>
+            </p:cNvPicPr>
+            <p:nvPr/>
+          </p:nvPicPr>
+          <p:blipFill>
+            <a:blip>
+              <a:extLst>
+                <a:ext uri="{96DAC541-7B7A-43D3-8B79-37D633B846F1}">
+                  <asvg:svgBlip xmlns:asvg="http://schemas.microsoft.com/office/drawing/2016/SVG/main" r:embed="rId4"/>
+                </a:ext>
+              </a:extLst>
+            </a:blip>
+            <a:srcRect/>
+            <a:stretch/>
+          </p:blipFill>
+          <p:spPr>
+            <a:xfrm>
+              <a:off x="9030339" y="4339679"/>
+              <a:ext cx="634696" cy="634696"/>
+            </a:xfrm>
+            <a:prstGeom prst="rect">
+              <a:avLst/>
+            </a:prstGeom>
+          </p:spPr>
+        </p:pic>
+        <p:pic>
+          <p:nvPicPr>
+            <p:cNvPr id="288" name="Graphic 287" descr="Sleep with solid fill">
+              <a:extLst>
+                <a:ext uri="{FF2B5EF4-FFF2-40B4-BE49-F238E27FC236}">
+                  <a16:creationId xmlns:a16="http://schemas.microsoft.com/office/drawing/2014/main" id="{BFCAA446-8094-F6CF-3880-6B4AC9030990}"/>
+                </a:ext>
+              </a:extLst>
+            </p:cNvPr>
+            <p:cNvPicPr>
+              <a:picLocks noChangeAspect="1"/>
+            </p:cNvPicPr>
+            <p:nvPr/>
+          </p:nvPicPr>
+          <p:blipFill>
+            <a:blip>
+              <a:extLst>
+                <a:ext uri="{96DAC541-7B7A-43D3-8B79-37D633B846F1}">
+                  <asvg:svgBlip xmlns:asvg="http://schemas.microsoft.com/office/drawing/2016/SVG/main" r:embed="rId3"/>
+                </a:ext>
+              </a:extLst>
+            </a:blip>
+            <a:srcRect/>
+            <a:stretch/>
+          </p:blipFill>
+          <p:spPr>
+            <a:xfrm>
+              <a:off x="10139672" y="4339679"/>
+              <a:ext cx="634696" cy="634696"/>
+            </a:xfrm>
+            <a:prstGeom prst="rect">
+              <a:avLst/>
+            </a:prstGeom>
+          </p:spPr>
+        </p:pic>
+        <p:pic>
+          <p:nvPicPr>
+            <p:cNvPr id="289" name="Graphic 288" descr="Sleep with solid fill">
+              <a:extLst>
+                <a:ext uri="{FF2B5EF4-FFF2-40B4-BE49-F238E27FC236}">
+                  <a16:creationId xmlns:a16="http://schemas.microsoft.com/office/drawing/2014/main" id="{05862317-3920-C436-14DB-DF29141F48D8}"/>
+                </a:ext>
+              </a:extLst>
+            </p:cNvPr>
+            <p:cNvPicPr>
+              <a:picLocks noChangeAspect="1"/>
+            </p:cNvPicPr>
+            <p:nvPr/>
+          </p:nvPicPr>
+          <p:blipFill>
+            <a:blip>
+              <a:extLst>
+                <a:ext uri="{96DAC541-7B7A-43D3-8B79-37D633B846F1}">
+                  <asvg:svgBlip xmlns:asvg="http://schemas.microsoft.com/office/drawing/2016/SVG/main" r:embed="rId3"/>
+                </a:ext>
+              </a:extLst>
+            </a:blip>
+            <a:srcRect/>
+            <a:stretch/>
+          </p:blipFill>
+          <p:spPr>
+            <a:xfrm>
+              <a:off x="11205504" y="4339679"/>
+              <a:ext cx="634696" cy="634696"/>
+            </a:xfrm>
+            <a:prstGeom prst="rect">
+              <a:avLst/>
+            </a:prstGeom>
+          </p:spPr>
+        </p:pic>
+        <p:pic>
+          <p:nvPicPr>
+            <p:cNvPr id="290" name="Graphic 289" descr="Sleep with solid fill">
+              <a:extLst>
+                <a:ext uri="{FF2B5EF4-FFF2-40B4-BE49-F238E27FC236}">
+                  <a16:creationId xmlns:a16="http://schemas.microsoft.com/office/drawing/2014/main" id="{6F291145-7E91-9D86-6C7B-3E0B96671097}"/>
+                </a:ext>
+              </a:extLst>
+            </p:cNvPr>
+            <p:cNvPicPr>
+              <a:picLocks noChangeAspect="1"/>
+            </p:cNvPicPr>
+            <p:nvPr/>
+          </p:nvPicPr>
+          <p:blipFill>
+            <a:blip>
+              <a:extLst>
+                <a:ext uri="{96DAC541-7B7A-43D3-8B79-37D633B846F1}">
+                  <asvg:svgBlip xmlns:asvg="http://schemas.microsoft.com/office/drawing/2016/SVG/main" r:embed="rId4"/>
+                </a:ext>
+              </a:extLst>
+            </a:blip>
+            <a:srcRect/>
+            <a:stretch/>
+          </p:blipFill>
+          <p:spPr>
+            <a:xfrm>
+              <a:off x="12324905" y="4339679"/>
+              <a:ext cx="634696" cy="634696"/>
+            </a:xfrm>
+            <a:prstGeom prst="rect">
+              <a:avLst/>
+            </a:prstGeom>
+          </p:spPr>
+        </p:pic>
+        <p:pic>
+          <p:nvPicPr>
+            <p:cNvPr id="291" name="Graphic 290" descr="Sleep with solid fill">
+              <a:extLst>
+                <a:ext uri="{FF2B5EF4-FFF2-40B4-BE49-F238E27FC236}">
+                  <a16:creationId xmlns:a16="http://schemas.microsoft.com/office/drawing/2014/main" id="{29801570-734E-FFD7-ADFD-8ABC0B626F2E}"/>
+                </a:ext>
+              </a:extLst>
+            </p:cNvPr>
+            <p:cNvPicPr>
+              <a:picLocks noChangeAspect="1"/>
+            </p:cNvPicPr>
+            <p:nvPr/>
+          </p:nvPicPr>
+          <p:blipFill>
+            <a:blip>
+              <a:extLst>
+                <a:ext uri="{96DAC541-7B7A-43D3-8B79-37D633B846F1}">
+                  <asvg:svgBlip xmlns:asvg="http://schemas.microsoft.com/office/drawing/2016/SVG/main" r:embed="rId5"/>
+                </a:ext>
+              </a:extLst>
+            </a:blip>
+            <a:srcRect/>
+            <a:stretch/>
+          </p:blipFill>
+          <p:spPr>
+            <a:xfrm>
+              <a:off x="13390737" y="4339679"/>
+              <a:ext cx="634696" cy="634696"/>
+            </a:xfrm>
+            <a:prstGeom prst="rect">
+              <a:avLst/>
+            </a:prstGeom>
+          </p:spPr>
+        </p:pic>
+        <p:pic>
+          <p:nvPicPr>
+            <p:cNvPr id="292" name="Graphic 291" descr="Sleep with solid fill">
+              <a:extLst>
+                <a:ext uri="{FF2B5EF4-FFF2-40B4-BE49-F238E27FC236}">
+                  <a16:creationId xmlns:a16="http://schemas.microsoft.com/office/drawing/2014/main" id="{96CF86F5-C9AC-B702-B7EE-0B5A9C430BB5}"/>
+                </a:ext>
+              </a:extLst>
+            </p:cNvPr>
+            <p:cNvPicPr>
+              <a:picLocks noChangeAspect="1"/>
+            </p:cNvPicPr>
+            <p:nvPr/>
+          </p:nvPicPr>
+          <p:blipFill>
+            <a:blip>
+              <a:extLst>
+                <a:ext uri="{96DAC541-7B7A-43D3-8B79-37D633B846F1}">
+                  <asvg:svgBlip xmlns:asvg="http://schemas.microsoft.com/office/drawing/2016/SVG/main" r:embed="rId3"/>
+                </a:ext>
+              </a:extLst>
+            </a:blip>
+            <a:srcRect/>
+            <a:stretch/>
+          </p:blipFill>
+          <p:spPr>
+            <a:xfrm>
+              <a:off x="14500070" y="4339679"/>
+              <a:ext cx="634696" cy="634696"/>
+            </a:xfrm>
+            <a:prstGeom prst="rect">
+              <a:avLst/>
+            </a:prstGeom>
+          </p:spPr>
+        </p:pic>
+        <p:sp>
+          <p:nvSpPr>
+            <p:cNvPr id="294" name="TextBox 293">
+              <a:extLst>
+                <a:ext uri="{FF2B5EF4-FFF2-40B4-BE49-F238E27FC236}">
+                  <a16:creationId xmlns:a16="http://schemas.microsoft.com/office/drawing/2014/main" id="{E4F45338-0124-C328-F687-2EF60A1D6D5B}"/>
+                </a:ext>
+              </a:extLst>
+            </p:cNvPr>
+            <p:cNvSpPr txBox="1"/>
+            <p:nvPr/>
+          </p:nvSpPr>
+          <p:spPr>
+            <a:xfrm>
+              <a:off x="8032955" y="4175954"/>
+              <a:ext cx="570990" cy="369332"/>
+            </a:xfrm>
+            <a:prstGeom prst="rect">
+              <a:avLst/>
+            </a:prstGeom>
+            <a:noFill/>
+          </p:spPr>
+          <p:txBody>
+            <a:bodyPr wrap="none" rtlCol="0">
+              <a:spAutoFit/>
+            </a:bodyPr>
+            <a:lstStyle/>
+            <a:p>
+              <a:r>
+                <a:rPr lang="en-US" dirty="0"/>
+                <a:t>B08</a:t>
+              </a:r>
+            </a:p>
+          </p:txBody>
+        </p:sp>
+        <p:sp>
+          <p:nvSpPr>
+            <p:cNvPr id="295" name="TextBox 294">
+              <a:extLst>
+                <a:ext uri="{FF2B5EF4-FFF2-40B4-BE49-F238E27FC236}">
+                  <a16:creationId xmlns:a16="http://schemas.microsoft.com/office/drawing/2014/main" id="{47881DA7-4F8F-1A1C-11BB-959818467CCD}"/>
+                </a:ext>
+              </a:extLst>
+            </p:cNvPr>
+            <p:cNvSpPr txBox="1"/>
+            <p:nvPr/>
+          </p:nvSpPr>
+          <p:spPr>
+            <a:xfrm>
+              <a:off x="9094760" y="4175954"/>
+              <a:ext cx="570990" cy="369332"/>
+            </a:xfrm>
+            <a:prstGeom prst="rect">
+              <a:avLst/>
+            </a:prstGeom>
+            <a:noFill/>
+          </p:spPr>
+          <p:txBody>
+            <a:bodyPr wrap="none" rtlCol="0">
+              <a:spAutoFit/>
+            </a:bodyPr>
+            <a:lstStyle/>
+            <a:p>
+              <a:r>
+                <a:rPr lang="en-US" dirty="0"/>
+                <a:t>B09</a:t>
+              </a:r>
+            </a:p>
+          </p:txBody>
+        </p:sp>
+        <p:sp>
+          <p:nvSpPr>
+            <p:cNvPr id="296" name="TextBox 295">
+              <a:extLst>
+                <a:ext uri="{FF2B5EF4-FFF2-40B4-BE49-F238E27FC236}">
+                  <a16:creationId xmlns:a16="http://schemas.microsoft.com/office/drawing/2014/main" id="{82C8151D-9672-9457-E681-B8A5A402647F}"/>
+                </a:ext>
+              </a:extLst>
+            </p:cNvPr>
+            <p:cNvSpPr txBox="1"/>
+            <p:nvPr/>
+          </p:nvSpPr>
+          <p:spPr>
+            <a:xfrm>
+              <a:off x="10161420" y="4175954"/>
+              <a:ext cx="570990" cy="369332"/>
+            </a:xfrm>
+            <a:prstGeom prst="rect">
+              <a:avLst/>
+            </a:prstGeom>
+            <a:noFill/>
+          </p:spPr>
+          <p:txBody>
+            <a:bodyPr wrap="none" rtlCol="0">
+              <a:spAutoFit/>
+            </a:bodyPr>
+            <a:lstStyle/>
+            <a:p>
+              <a:r>
+                <a:rPr lang="en-US" dirty="0"/>
+                <a:t>B10</a:t>
+              </a:r>
+            </a:p>
+          </p:txBody>
+        </p:sp>
+        <p:sp>
+          <p:nvSpPr>
+            <p:cNvPr id="297" name="TextBox 296">
+              <a:extLst>
+                <a:ext uri="{FF2B5EF4-FFF2-40B4-BE49-F238E27FC236}">
+                  <a16:creationId xmlns:a16="http://schemas.microsoft.com/office/drawing/2014/main" id="{7A0222E8-9FB4-C559-C8E7-5052D81977D8}"/>
+                </a:ext>
+              </a:extLst>
+            </p:cNvPr>
+            <p:cNvSpPr txBox="1"/>
+            <p:nvPr/>
+          </p:nvSpPr>
+          <p:spPr>
+            <a:xfrm>
+              <a:off x="11250980" y="4175954"/>
+              <a:ext cx="570990" cy="369332"/>
+            </a:xfrm>
+            <a:prstGeom prst="rect">
+              <a:avLst/>
+            </a:prstGeom>
+            <a:noFill/>
+          </p:spPr>
+          <p:txBody>
+            <a:bodyPr wrap="none" rtlCol="0">
+              <a:spAutoFit/>
+            </a:bodyPr>
+            <a:lstStyle/>
+            <a:p>
+              <a:r>
+                <a:rPr lang="en-US" dirty="0"/>
+                <a:t>B11</a:t>
+              </a:r>
+            </a:p>
+          </p:txBody>
+        </p:sp>
+        <p:sp>
+          <p:nvSpPr>
+            <p:cNvPr id="298" name="TextBox 297">
+              <a:extLst>
+                <a:ext uri="{FF2B5EF4-FFF2-40B4-BE49-F238E27FC236}">
+                  <a16:creationId xmlns:a16="http://schemas.microsoft.com/office/drawing/2014/main" id="{DBC210EE-4FD5-6956-C91F-FCEE52A950FC}"/>
+                </a:ext>
+              </a:extLst>
+            </p:cNvPr>
+            <p:cNvSpPr txBox="1"/>
+            <p:nvPr/>
+          </p:nvSpPr>
+          <p:spPr>
+            <a:xfrm>
+              <a:off x="12370774" y="4180543"/>
+              <a:ext cx="570990" cy="369332"/>
+            </a:xfrm>
+            <a:prstGeom prst="rect">
+              <a:avLst/>
+            </a:prstGeom>
+            <a:noFill/>
+          </p:spPr>
+          <p:txBody>
+            <a:bodyPr wrap="none" rtlCol="0">
+              <a:spAutoFit/>
+            </a:bodyPr>
+            <a:lstStyle/>
+            <a:p>
+              <a:r>
+                <a:rPr lang="en-US" dirty="0"/>
+                <a:t>B12</a:t>
+              </a:r>
+            </a:p>
+          </p:txBody>
+        </p:sp>
+        <p:sp>
+          <p:nvSpPr>
+            <p:cNvPr id="299" name="TextBox 298">
+              <a:extLst>
+                <a:ext uri="{FF2B5EF4-FFF2-40B4-BE49-F238E27FC236}">
+                  <a16:creationId xmlns:a16="http://schemas.microsoft.com/office/drawing/2014/main" id="{FA4EB08A-BE4C-9DD9-5183-0CB1D923EC6C}"/>
+                </a:ext>
+              </a:extLst>
+            </p:cNvPr>
+            <p:cNvSpPr txBox="1"/>
+            <p:nvPr/>
+          </p:nvSpPr>
+          <p:spPr>
+            <a:xfrm>
+              <a:off x="13432579" y="4180543"/>
+              <a:ext cx="570990" cy="369332"/>
+            </a:xfrm>
+            <a:prstGeom prst="rect">
+              <a:avLst/>
+            </a:prstGeom>
+            <a:noFill/>
+          </p:spPr>
+          <p:txBody>
+            <a:bodyPr wrap="none" rtlCol="0">
+              <a:spAutoFit/>
+            </a:bodyPr>
+            <a:lstStyle/>
+            <a:p>
+              <a:r>
+                <a:rPr lang="en-US" dirty="0"/>
+                <a:t>B13</a:t>
+              </a:r>
+            </a:p>
+          </p:txBody>
+        </p:sp>
+        <p:sp>
+          <p:nvSpPr>
+            <p:cNvPr id="300" name="TextBox 299">
+              <a:extLst>
+                <a:ext uri="{FF2B5EF4-FFF2-40B4-BE49-F238E27FC236}">
+                  <a16:creationId xmlns:a16="http://schemas.microsoft.com/office/drawing/2014/main" id="{9FC043E2-D286-4FCD-FE0B-B9D4F043E80A}"/>
+                </a:ext>
+              </a:extLst>
+            </p:cNvPr>
+            <p:cNvSpPr txBox="1"/>
+            <p:nvPr/>
+          </p:nvSpPr>
+          <p:spPr>
+            <a:xfrm>
+              <a:off x="14499239" y="4180543"/>
+              <a:ext cx="570990" cy="369332"/>
+            </a:xfrm>
+            <a:prstGeom prst="rect">
+              <a:avLst/>
+            </a:prstGeom>
+            <a:noFill/>
+          </p:spPr>
+          <p:txBody>
+            <a:bodyPr wrap="none" rtlCol="0">
+              <a:spAutoFit/>
+            </a:bodyPr>
+            <a:lstStyle/>
+            <a:p>
+              <a:r>
+                <a:rPr lang="en-US" dirty="0"/>
+                <a:t>B14</a:t>
+              </a:r>
+            </a:p>
+          </p:txBody>
+        </p:sp>
+        <p:cxnSp>
+          <p:nvCxnSpPr>
+            <p:cNvPr id="370" name="Curved Connector 369">
+              <a:extLst>
+                <a:ext uri="{FF2B5EF4-FFF2-40B4-BE49-F238E27FC236}">
+                  <a16:creationId xmlns:a16="http://schemas.microsoft.com/office/drawing/2014/main" id="{F770DA12-8A00-8462-2276-77838D5C4159}"/>
+                </a:ext>
+              </a:extLst>
+            </p:cNvPr>
+            <p:cNvCxnSpPr>
+              <a:cxnSpLocks/>
+              <a:stCxn id="367" idx="2"/>
+              <a:endCxn id="338" idx="0"/>
+            </p:cNvCxnSpPr>
+            <p:nvPr/>
+          </p:nvCxnSpPr>
+          <p:spPr>
+            <a:xfrm rot="5400000">
+              <a:off x="2390173" y="71603"/>
+              <a:ext cx="1848123" cy="5443158"/>
+            </a:xfrm>
+            <a:prstGeom prst="curvedConnector3">
+              <a:avLst/>
+            </a:prstGeom>
+            <a:ln w="28575">
+              <a:solidFill>
+                <a:schemeClr val="tx1"/>
+              </a:solidFill>
+              <a:prstDash val="sysDash"/>
+              <a:tailEnd type="triangle" w="lg" len="lg"/>
+            </a:ln>
+          </p:spPr>
+          <p:style>
+            <a:lnRef idx="2">
+              <a:schemeClr val="accent1"/>
+            </a:lnRef>
+            <a:fillRef idx="0">
+              <a:schemeClr val="accent1"/>
+            </a:fillRef>
+            <a:effectRef idx="1">
+              <a:schemeClr val="accent1"/>
+            </a:effectRef>
+            <a:fontRef idx="minor">
+              <a:schemeClr val="tx1"/>
+            </a:fontRef>
+          </p:style>
+        </p:cxnSp>
+        <p:cxnSp>
+          <p:nvCxnSpPr>
+            <p:cNvPr id="371" name="Curved Connector 370">
+              <a:extLst>
+                <a:ext uri="{FF2B5EF4-FFF2-40B4-BE49-F238E27FC236}">
+                  <a16:creationId xmlns:a16="http://schemas.microsoft.com/office/drawing/2014/main" id="{CE1E082B-E486-D051-28C0-4A74130CC283}"/>
+                </a:ext>
+              </a:extLst>
+            </p:cNvPr>
+            <p:cNvCxnSpPr>
+              <a:cxnSpLocks/>
+              <a:stCxn id="368" idx="2"/>
+              <a:endCxn id="337" idx="0"/>
+            </p:cNvCxnSpPr>
+            <p:nvPr/>
+          </p:nvCxnSpPr>
+          <p:spPr>
+            <a:xfrm rot="16200000" flipH="1">
+              <a:off x="8327686" y="581032"/>
+              <a:ext cx="1888426" cy="4485561"/>
+            </a:xfrm>
+            <a:prstGeom prst="curvedConnector3">
+              <a:avLst>
+                <a:gd name="adj1" fmla="val 50000"/>
+              </a:avLst>
+            </a:prstGeom>
+            <a:ln w="28575">
+              <a:solidFill>
+                <a:schemeClr val="tx1"/>
+              </a:solidFill>
+              <a:prstDash val="sysDash"/>
+              <a:tailEnd type="triangle" w="lg" len="lg"/>
+            </a:ln>
+          </p:spPr>
+          <p:style>
+            <a:lnRef idx="2">
+              <a:schemeClr val="accent1"/>
+            </a:lnRef>
+            <a:fillRef idx="0">
+              <a:schemeClr val="accent1"/>
+            </a:fillRef>
+            <a:effectRef idx="1">
+              <a:schemeClr val="accent1"/>
+            </a:effectRef>
+            <a:fontRef idx="minor">
+              <a:schemeClr val="tx1"/>
+            </a:fontRef>
+          </p:style>
+        </p:cxnSp>
+        <p:sp>
+          <p:nvSpPr>
+            <p:cNvPr id="393" name="TextBox 392">
+              <a:extLst>
+                <a:ext uri="{FF2B5EF4-FFF2-40B4-BE49-F238E27FC236}">
+                  <a16:creationId xmlns:a16="http://schemas.microsoft.com/office/drawing/2014/main" id="{D42B1870-1611-E601-8405-D1736C1AEC3D}"/>
+                </a:ext>
+              </a:extLst>
+            </p:cNvPr>
+            <p:cNvSpPr txBox="1"/>
+            <p:nvPr/>
+          </p:nvSpPr>
+          <p:spPr>
+            <a:xfrm>
+              <a:off x="1391158" y="2967224"/>
+              <a:ext cx="2101857" cy="646331"/>
+            </a:xfrm>
+            <a:prstGeom prst="rect">
+              <a:avLst/>
+            </a:prstGeom>
+            <a:noFill/>
+          </p:spPr>
+          <p:txBody>
+            <a:bodyPr wrap="none" rtlCol="0">
+              <a:spAutoFit/>
+            </a:bodyPr>
+            <a:lstStyle/>
+            <a:p>
+              <a:r>
+                <a:rPr lang="en-US" sz="3600" dirty="0"/>
+                <a:t>a = (8, 12)</a:t>
+              </a:r>
+            </a:p>
+          </p:txBody>
+        </p:sp>
+        <p:sp>
+          <p:nvSpPr>
+            <p:cNvPr id="396" name="TextBox 395">
+              <a:extLst>
+                <a:ext uri="{FF2B5EF4-FFF2-40B4-BE49-F238E27FC236}">
+                  <a16:creationId xmlns:a16="http://schemas.microsoft.com/office/drawing/2014/main" id="{CD121AEC-29B3-4495-0A8D-29E77A1E758F}"/>
+                </a:ext>
+              </a:extLst>
+            </p:cNvPr>
+            <p:cNvSpPr txBox="1"/>
+            <p:nvPr/>
+          </p:nvSpPr>
+          <p:spPr>
+            <a:xfrm>
+              <a:off x="8371523" y="2998530"/>
+              <a:ext cx="2101857" cy="646331"/>
+            </a:xfrm>
+            <a:prstGeom prst="rect">
+              <a:avLst/>
+            </a:prstGeom>
+            <a:noFill/>
+          </p:spPr>
+          <p:txBody>
+            <a:bodyPr wrap="none" rtlCol="0">
+              <a:spAutoFit/>
+            </a:bodyPr>
+            <a:lstStyle/>
+            <a:p>
+              <a:r>
+                <a:rPr lang="en-US" sz="3600" dirty="0"/>
+                <a:t>a = (8, 14)</a:t>
+              </a:r>
+            </a:p>
+          </p:txBody>
+        </p:sp>
+        <mc:AlternateContent xmlns:mc="http://schemas.openxmlformats.org/markup-compatibility/2006">
+          <mc:Choice xmlns:a14="http://schemas.microsoft.com/office/drawing/2010/main" Requires="a14">
+            <p:sp>
+              <p:nvSpPr>
+                <p:cNvPr id="404" name="TextBox 403">
+                  <a:extLst>
+                    <a:ext uri="{FF2B5EF4-FFF2-40B4-BE49-F238E27FC236}">
+                      <a16:creationId xmlns:a16="http://schemas.microsoft.com/office/drawing/2014/main" id="{18E1D77A-D35E-53BD-B06F-9D4FD86ADB9D}"/>
+                    </a:ext>
+                  </a:extLst>
+                </p:cNvPr>
+                <p:cNvSpPr txBox="1"/>
+                <p:nvPr/>
+              </p:nvSpPr>
+              <p:spPr>
+                <a:xfrm>
+                  <a:off x="5765091" y="4103046"/>
+                  <a:ext cx="844783" cy="1107996"/>
+                </a:xfrm>
+                <a:prstGeom prst="rect">
+                  <a:avLst/>
+                </a:prstGeom>
+                <a:noFill/>
+              </p:spPr>
+              <p:txBody>
+                <a:bodyPr wrap="none" lIns="0" tIns="0" rIns="0" bIns="0" rtlCol="0">
+                  <a:spAutoFit/>
+                </a:bodyPr>
+                <a:lstStyle/>
+                <a:p>
+                  <a:pPr/>
+                  <a14:m>
+                    <m:oMathPara xmlns:m="http://schemas.openxmlformats.org/officeDocument/2006/math">
+                      <m:oMathParaPr>
+                        <m:jc m:val="centerGroup"/>
+                      </m:oMathParaPr>
+                      <m:oMath xmlns:m="http://schemas.openxmlformats.org/officeDocument/2006/math">
+                        <m:r>
+                          <a:rPr lang="en-GB" sz="7200" b="0" i="1" smtClean="0">
+                            <a:latin typeface="Cambria Math" panose="02040503050406030204" pitchFamily="18" charset="0"/>
+                          </a:rPr>
+                          <m:t>~</m:t>
+                        </m:r>
+                      </m:oMath>
+                    </m:oMathPara>
+                  </a14:m>
+                  <a:endParaRPr lang="en-US" sz="7200" dirty="0"/>
+                </a:p>
+              </p:txBody>
+            </p:sp>
+          </mc:Choice>
+          <mc:Fallback>
+            <p:sp>
+              <p:nvSpPr>
+                <p:cNvPr id="404" name="TextBox 403">
+                  <a:extLst>
+                    <a:ext uri="{FF2B5EF4-FFF2-40B4-BE49-F238E27FC236}">
+                      <a16:creationId xmlns:a16="http://schemas.microsoft.com/office/drawing/2014/main" id="{18E1D77A-D35E-53BD-B06F-9D4FD86ADB9D}"/>
+                    </a:ext>
+                  </a:extLst>
+                </p:cNvPr>
+                <p:cNvSpPr txBox="1">
+                  <a:spLocks noRot="1" noChangeAspect="1" noMove="1" noResize="1" noEditPoints="1" noAdjustHandles="1" noChangeArrowheads="1" noChangeShapeType="1" noTextEdit="1"/>
+                </p:cNvSpPr>
+                <p:nvPr/>
+              </p:nvSpPr>
+              <p:spPr>
+                <a:xfrm>
+                  <a:off x="5765091" y="4103046"/>
+                  <a:ext cx="844783" cy="1107996"/>
+                </a:xfrm>
+                <a:prstGeom prst="rect">
+                  <a:avLst/>
+                </a:prstGeom>
+                <a:blipFill>
+                  <a:blip r:embed="rId7"/>
+                  <a:stretch>
+                    <a:fillRect l="-10448" r="-8955"/>
+                  </a:stretch>
+                </a:blipFill>
+              </p:spPr>
+              <p:txBody>
+                <a:bodyPr/>
+                <a:lstStyle/>
+                <a:p>
+                  <a:r>
+                    <a:rPr lang="en-US">
+                      <a:noFill/>
+                    </a:rPr>
+                    <a:t> </a:t>
+                  </a:r>
+                </a:p>
+              </p:txBody>
+            </p:sp>
+          </mc:Fallback>
+        </mc:AlternateContent>
+      </p:grpSp>
+    </p:spTree>
+    <p:extLst>
+      <p:ext uri="{BB962C8B-B14F-4D97-AF65-F5344CB8AC3E}">
+        <p14:creationId xmlns:p14="http://schemas.microsoft.com/office/powerpoint/2010/main" val="2642535439"/>
       </p:ext>
     </p:extLst>
   </p:cSld>

</xml_diff>

<commit_message>
fix bug with block structure mixup
</commit_message>
<xml_diff>
--- a/images/icu.pptx
+++ b/images/icu.pptx
@@ -6922,10 +6922,10 @@
       </p:grpSpPr>
       <p:grpSp>
         <p:nvGrpSpPr>
-          <p:cNvPr id="11" name="Group 10">
+          <p:cNvPr id="32" name="Group 31">
             <a:extLst>
               <a:ext uri="{FF2B5EF4-FFF2-40B4-BE49-F238E27FC236}">
-                <a16:creationId xmlns:a16="http://schemas.microsoft.com/office/drawing/2014/main" id="{5003E878-E299-B5E5-89E5-C1453CD14CFA}"/>
+                <a16:creationId xmlns:a16="http://schemas.microsoft.com/office/drawing/2014/main" id="{1C7713F5-0FDF-9235-9A4C-E932B7478D85}"/>
               </a:ext>
             </a:extLst>
           </p:cNvPr>
@@ -6934,10 +6934,10 @@
         </p:nvGrpSpPr>
         <p:grpSpPr>
           <a:xfrm>
-            <a:off x="338600" y="2325510"/>
-            <a:ext cx="9499881" cy="3575753"/>
-            <a:chOff x="338600" y="2325510"/>
-            <a:chExt cx="9499881" cy="3575753"/>
+            <a:off x="637952" y="2456121"/>
+            <a:ext cx="10228521" cy="3445142"/>
+            <a:chOff x="637952" y="2456121"/>
+            <a:chExt cx="10228521" cy="3445142"/>
           </a:xfrm>
         </p:grpSpPr>
         <p:sp>
@@ -6954,8 +6954,8 @@
           </p:nvSpPr>
           <p:spPr>
             <a:xfrm>
-              <a:off x="338600" y="2325510"/>
-              <a:ext cx="9499881" cy="3575753"/>
+              <a:off x="637952" y="2456121"/>
+              <a:ext cx="10228521" cy="3445142"/>
             </a:xfrm>
             <a:prstGeom prst="roundRect">
               <a:avLst>
@@ -7019,7 +7019,7 @@
           </p:blipFill>
           <p:spPr>
             <a:xfrm>
-              <a:off x="8650724" y="3124451"/>
+              <a:off x="9607658" y="3124451"/>
               <a:ext cx="634696" cy="634696"/>
             </a:xfrm>
             <a:prstGeom prst="rect">
@@ -7054,7 +7054,7 @@
           </p:blipFill>
           <p:spPr>
             <a:xfrm>
-              <a:off x="844863" y="4754391"/>
+              <a:off x="1174474" y="4754391"/>
               <a:ext cx="634696" cy="634696"/>
             </a:xfrm>
             <a:prstGeom prst="rect">
@@ -7089,7 +7089,7 @@
           </p:blipFill>
           <p:spPr>
             <a:xfrm>
-              <a:off x="1910695" y="4754391"/>
+              <a:off x="2240306" y="4754391"/>
               <a:ext cx="634696" cy="634696"/>
             </a:xfrm>
             <a:prstGeom prst="rect">
@@ -7124,7 +7124,7 @@
           </p:blipFill>
           <p:spPr>
             <a:xfrm>
-              <a:off x="8616035" y="4774079"/>
+              <a:off x="9572969" y="4774079"/>
               <a:ext cx="634696" cy="634696"/>
             </a:xfrm>
             <a:prstGeom prst="rect">
@@ -7159,7 +7159,7 @@
           </p:blipFill>
           <p:spPr>
             <a:xfrm>
-              <a:off x="3020028" y="4754391"/>
+              <a:off x="3349639" y="4754391"/>
               <a:ext cx="634696" cy="634696"/>
             </a:xfrm>
             <a:prstGeom prst="rect">
@@ -7194,7 +7194,7 @@
           </p:blipFill>
           <p:spPr>
             <a:xfrm>
-              <a:off x="4085860" y="4754391"/>
+              <a:off x="4415471" y="4754391"/>
               <a:ext cx="634696" cy="634696"/>
             </a:xfrm>
             <a:prstGeom prst="rect">
@@ -7229,7 +7229,7 @@
           </p:blipFill>
           <p:spPr>
             <a:xfrm>
-              <a:off x="5205261" y="4754391"/>
+              <a:off x="5821951" y="4754391"/>
               <a:ext cx="634696" cy="634696"/>
             </a:xfrm>
             <a:prstGeom prst="rect">
@@ -7264,7 +7264,7 @@
           </p:blipFill>
           <p:spPr>
             <a:xfrm>
-              <a:off x="6271093" y="4754391"/>
+              <a:off x="6887783" y="4754391"/>
               <a:ext cx="634696" cy="634696"/>
             </a:xfrm>
             <a:prstGeom prst="rect">
@@ -7299,7 +7299,7 @@
           </p:blipFill>
           <p:spPr>
             <a:xfrm>
-              <a:off x="7380426" y="4754391"/>
+              <a:off x="7997116" y="4754391"/>
               <a:ext cx="634696" cy="634696"/>
             </a:xfrm>
             <a:prstGeom prst="rect">
@@ -7334,7 +7334,7 @@
           </p:blipFill>
           <p:spPr>
             <a:xfrm>
-              <a:off x="844863" y="3110637"/>
+              <a:off x="1174474" y="3110637"/>
               <a:ext cx="634696" cy="634696"/>
             </a:xfrm>
             <a:prstGeom prst="rect">
@@ -7369,7 +7369,7 @@
           </p:blipFill>
           <p:spPr>
             <a:xfrm>
-              <a:off x="1910695" y="3110637"/>
+              <a:off x="2240306" y="3110637"/>
               <a:ext cx="634696" cy="634696"/>
             </a:xfrm>
             <a:prstGeom prst="rect">
@@ -7404,7 +7404,7 @@
           </p:blipFill>
           <p:spPr>
             <a:xfrm>
-              <a:off x="3020028" y="3110637"/>
+              <a:off x="3349639" y="3110637"/>
               <a:ext cx="634696" cy="634696"/>
             </a:xfrm>
             <a:prstGeom prst="rect">
@@ -7439,7 +7439,7 @@
           </p:blipFill>
           <p:spPr>
             <a:xfrm>
-              <a:off x="4085860" y="3110637"/>
+              <a:off x="4415471" y="3110637"/>
               <a:ext cx="634696" cy="634696"/>
             </a:xfrm>
             <a:prstGeom prst="rect">
@@ -7474,7 +7474,7 @@
           </p:blipFill>
           <p:spPr>
             <a:xfrm>
-              <a:off x="5205261" y="3110637"/>
+              <a:off x="5821951" y="3110637"/>
               <a:ext cx="634696" cy="634696"/>
             </a:xfrm>
             <a:prstGeom prst="rect">
@@ -7509,7 +7509,7 @@
           </p:blipFill>
           <p:spPr>
             <a:xfrm>
-              <a:off x="6271093" y="3110637"/>
+              <a:off x="6887783" y="3110637"/>
               <a:ext cx="634696" cy="634696"/>
             </a:xfrm>
             <a:prstGeom prst="rect">
@@ -7544,7 +7544,7 @@
           </p:blipFill>
           <p:spPr>
             <a:xfrm>
-              <a:off x="7380426" y="3110637"/>
+              <a:off x="7997116" y="3110637"/>
               <a:ext cx="634696" cy="634696"/>
             </a:xfrm>
             <a:prstGeom prst="rect">
@@ -7566,7 +7566,7 @@
           </p:nvSpPr>
           <p:spPr>
             <a:xfrm>
-              <a:off x="519315" y="4402744"/>
+              <a:off x="848926" y="4402744"/>
               <a:ext cx="4413929" cy="1216301"/>
             </a:xfrm>
             <a:prstGeom prst="roundRect">
@@ -7624,7 +7624,7 @@
           </p:nvSpPr>
           <p:spPr>
             <a:xfrm>
-              <a:off x="558779" y="2753115"/>
+              <a:off x="888390" y="2753115"/>
               <a:ext cx="4413929" cy="1216301"/>
             </a:xfrm>
             <a:prstGeom prst="roundRect">
@@ -7682,7 +7682,7 @@
           </p:nvSpPr>
           <p:spPr>
             <a:xfrm>
-              <a:off x="8314691" y="4435481"/>
+              <a:off x="9271625" y="4435481"/>
               <a:ext cx="1306761" cy="1216301"/>
             </a:xfrm>
             <a:prstGeom prst="roundRect">
@@ -7740,7 +7740,7 @@
           </p:nvSpPr>
           <p:spPr>
             <a:xfrm>
-              <a:off x="8314691" y="2772345"/>
+              <a:off x="9271625" y="2772345"/>
               <a:ext cx="1306761" cy="1216301"/>
             </a:xfrm>
             <a:prstGeom prst="roundRect">
@@ -7798,7 +7798,7 @@
           </p:nvSpPr>
           <p:spPr>
             <a:xfrm>
-              <a:off x="913311" y="4599875"/>
+              <a:off x="1242922" y="4599875"/>
               <a:ext cx="570990" cy="369332"/>
             </a:xfrm>
             <a:prstGeom prst="rect">
@@ -7833,7 +7833,7 @@
           </p:nvSpPr>
           <p:spPr>
             <a:xfrm>
-              <a:off x="1975116" y="4599875"/>
+              <a:off x="2304727" y="4599875"/>
               <a:ext cx="570990" cy="369332"/>
             </a:xfrm>
             <a:prstGeom prst="rect">
@@ -7868,7 +7868,7 @@
           </p:nvSpPr>
           <p:spPr>
             <a:xfrm>
-              <a:off x="3041776" y="4599875"/>
+              <a:off x="3371387" y="4599875"/>
               <a:ext cx="570990" cy="369332"/>
             </a:xfrm>
             <a:prstGeom prst="rect">
@@ -7903,7 +7903,7 @@
           </p:nvSpPr>
           <p:spPr>
             <a:xfrm>
-              <a:off x="4131336" y="4599875"/>
+              <a:off x="4460947" y="4599875"/>
               <a:ext cx="570990" cy="369332"/>
             </a:xfrm>
             <a:prstGeom prst="rect">
@@ -7938,7 +7938,7 @@
           </p:nvSpPr>
           <p:spPr>
             <a:xfrm>
-              <a:off x="5251130" y="4604464"/>
+              <a:off x="5867820" y="4604464"/>
               <a:ext cx="570990" cy="369332"/>
             </a:xfrm>
             <a:prstGeom prst="rect">
@@ -7973,7 +7973,7 @@
           </p:nvSpPr>
           <p:spPr>
             <a:xfrm>
-              <a:off x="6312935" y="4604464"/>
+              <a:off x="6929625" y="4604464"/>
               <a:ext cx="570990" cy="369332"/>
             </a:xfrm>
             <a:prstGeom prst="rect">
@@ -8008,7 +8008,7 @@
           </p:nvSpPr>
           <p:spPr>
             <a:xfrm>
-              <a:off x="7379595" y="4604464"/>
+              <a:off x="7996285" y="4604464"/>
               <a:ext cx="570990" cy="369332"/>
             </a:xfrm>
             <a:prstGeom prst="rect">
@@ -8043,7 +8043,7 @@
           </p:nvSpPr>
           <p:spPr>
             <a:xfrm>
-              <a:off x="913311" y="2946912"/>
+              <a:off x="1242922" y="2946912"/>
               <a:ext cx="570990" cy="369332"/>
             </a:xfrm>
             <a:prstGeom prst="rect">
@@ -8078,7 +8078,7 @@
           </p:nvSpPr>
           <p:spPr>
             <a:xfrm>
-              <a:off x="1975116" y="2946912"/>
+              <a:off x="2304727" y="2946912"/>
               <a:ext cx="570990" cy="369332"/>
             </a:xfrm>
             <a:prstGeom prst="rect">
@@ -8113,7 +8113,7 @@
           </p:nvSpPr>
           <p:spPr>
             <a:xfrm>
-              <a:off x="3041776" y="2946912"/>
+              <a:off x="3371387" y="2946912"/>
               <a:ext cx="570990" cy="369332"/>
             </a:xfrm>
             <a:prstGeom prst="rect">
@@ -8148,7 +8148,7 @@
           </p:nvSpPr>
           <p:spPr>
             <a:xfrm>
-              <a:off x="4131336" y="2946912"/>
+              <a:off x="4460947" y="2946912"/>
               <a:ext cx="570990" cy="369332"/>
             </a:xfrm>
             <a:prstGeom prst="rect">
@@ -8183,7 +8183,7 @@
           </p:nvSpPr>
           <p:spPr>
             <a:xfrm>
-              <a:off x="5251130" y="2951501"/>
+              <a:off x="5867820" y="2951501"/>
               <a:ext cx="570990" cy="369332"/>
             </a:xfrm>
             <a:prstGeom prst="rect">
@@ -8218,7 +8218,7 @@
           </p:nvSpPr>
           <p:spPr>
             <a:xfrm>
-              <a:off x="6312935" y="2951501"/>
+              <a:off x="6929625" y="2951501"/>
               <a:ext cx="570990" cy="369332"/>
             </a:xfrm>
             <a:prstGeom prst="rect">
@@ -8253,7 +8253,7 @@
           </p:nvSpPr>
           <p:spPr>
             <a:xfrm>
-              <a:off x="7379595" y="2951501"/>
+              <a:off x="7996285" y="2951501"/>
               <a:ext cx="570990" cy="369332"/>
             </a:xfrm>
             <a:prstGeom prst="rect">
@@ -8288,7 +8288,7 @@
           </p:nvSpPr>
           <p:spPr>
             <a:xfrm>
-              <a:off x="8689618" y="4657969"/>
+              <a:off x="9646552" y="4657969"/>
               <a:ext cx="570990" cy="369332"/>
             </a:xfrm>
             <a:prstGeom prst="rect">
@@ -8323,7 +8323,7 @@
           </p:nvSpPr>
           <p:spPr>
             <a:xfrm>
-              <a:off x="8714430" y="3008341"/>
+              <a:off x="9671364" y="3008341"/>
               <a:ext cx="570990" cy="369332"/>
             </a:xfrm>
             <a:prstGeom prst="rect">
@@ -8358,7 +8358,7 @@
           </p:nvSpPr>
           <p:spPr>
             <a:xfrm>
-              <a:off x="5064037" y="2782328"/>
+              <a:off x="5680727" y="2782328"/>
               <a:ext cx="3153989" cy="1216301"/>
             </a:xfrm>
             <a:prstGeom prst="roundRect">
@@ -8416,7 +8416,7 @@
           </p:nvSpPr>
           <p:spPr>
             <a:xfrm>
-              <a:off x="5064037" y="4415710"/>
+              <a:off x="5680727" y="4415710"/>
               <a:ext cx="3153989" cy="1216301"/>
             </a:xfrm>
             <a:prstGeom prst="roundRect">
@@ -8460,6 +8460,94 @@
             </a:p>
           </p:txBody>
         </p:sp>
+        <p:cxnSp>
+          <p:nvCxnSpPr>
+            <p:cNvPr id="2" name="Straight Connector 1">
+              <a:extLst>
+                <a:ext uri="{FF2B5EF4-FFF2-40B4-BE49-F238E27FC236}">
+                  <a16:creationId xmlns:a16="http://schemas.microsoft.com/office/drawing/2014/main" id="{2FD956A6-2CE6-30AD-2444-D97B04A6F43C}"/>
+                </a:ext>
+              </a:extLst>
+            </p:cNvPr>
+            <p:cNvCxnSpPr>
+              <a:cxnSpLocks/>
+            </p:cNvCxnSpPr>
+            <p:nvPr/>
+          </p:nvCxnSpPr>
+          <p:spPr>
+            <a:xfrm flipV="1">
+              <a:off x="5507658" y="2456121"/>
+              <a:ext cx="0" cy="3445142"/>
+            </a:xfrm>
+            <a:prstGeom prst="line">
+              <a:avLst/>
+            </a:prstGeom>
+            <a:ln w="47625">
+              <a:solidFill>
+                <a:schemeClr val="tx1"/>
+              </a:solidFill>
+              <a:prstDash val="sysDot"/>
+            </a:ln>
+          </p:spPr>
+          <p:style>
+            <a:lnRef idx="2">
+              <a:schemeClr val="accent1"/>
+            </a:lnRef>
+            <a:fillRef idx="0">
+              <a:schemeClr val="accent1"/>
+            </a:fillRef>
+            <a:effectRef idx="1">
+              <a:schemeClr val="accent1"/>
+            </a:effectRef>
+            <a:fontRef idx="minor">
+              <a:schemeClr val="tx1"/>
+            </a:fontRef>
+          </p:style>
+        </p:cxnSp>
+        <p:cxnSp>
+          <p:nvCxnSpPr>
+            <p:cNvPr id="13" name="Straight Connector 12">
+              <a:extLst>
+                <a:ext uri="{FF2B5EF4-FFF2-40B4-BE49-F238E27FC236}">
+                  <a16:creationId xmlns:a16="http://schemas.microsoft.com/office/drawing/2014/main" id="{7D8A89CE-0F1B-3442-724D-BD1E2189ED50}"/>
+                </a:ext>
+              </a:extLst>
+            </p:cNvPr>
+            <p:cNvCxnSpPr>
+              <a:cxnSpLocks/>
+            </p:cNvCxnSpPr>
+            <p:nvPr/>
+          </p:nvCxnSpPr>
+          <p:spPr>
+            <a:xfrm flipV="1">
+              <a:off x="9069577" y="2456121"/>
+              <a:ext cx="0" cy="3445142"/>
+            </a:xfrm>
+            <a:prstGeom prst="line">
+              <a:avLst/>
+            </a:prstGeom>
+            <a:ln w="47625">
+              <a:solidFill>
+                <a:schemeClr val="tx1"/>
+              </a:solidFill>
+              <a:prstDash val="sysDot"/>
+            </a:ln>
+          </p:spPr>
+          <p:style>
+            <a:lnRef idx="2">
+              <a:schemeClr val="accent1"/>
+            </a:lnRef>
+            <a:fillRef idx="0">
+              <a:schemeClr val="accent1"/>
+            </a:fillRef>
+            <a:effectRef idx="1">
+              <a:schemeClr val="accent1"/>
+            </a:effectRef>
+            <a:fontRef idx="minor">
+              <a:schemeClr val="tx1"/>
+            </a:fontRef>
+          </p:style>
+        </p:cxnSp>
       </p:grpSp>
     </p:spTree>
     <p:extLst>
@@ -8499,10 +8587,10 @@
       </p:grpSpPr>
       <p:grpSp>
         <p:nvGrpSpPr>
-          <p:cNvPr id="4" name="Group 3">
+          <p:cNvPr id="22" name="Group 21">
             <a:extLst>
               <a:ext uri="{FF2B5EF4-FFF2-40B4-BE49-F238E27FC236}">
-                <a16:creationId xmlns:a16="http://schemas.microsoft.com/office/drawing/2014/main" id="{F8DACEA2-E486-B018-30AF-CB8DB19D4EB3}"/>
+                <a16:creationId xmlns:a16="http://schemas.microsoft.com/office/drawing/2014/main" id="{A9619962-32E2-7C58-352A-F3B8E35E3E49}"/>
               </a:ext>
             </a:extLst>
           </p:cNvPr>
@@ -8512,9 +8600,9 @@
         <p:grpSpPr>
           <a:xfrm>
             <a:off x="410218" y="1098449"/>
-            <a:ext cx="10283551" cy="4907241"/>
+            <a:ext cx="10983050" cy="4907241"/>
             <a:chOff x="410218" y="1098449"/>
-            <a:chExt cx="10283551" cy="4907241"/>
+            <a:chExt cx="10983050" cy="4907241"/>
           </a:xfrm>
         </p:grpSpPr>
         <p:sp>
@@ -8532,7 +8620,7 @@
           <p:spPr>
             <a:xfrm>
               <a:off x="410218" y="1098449"/>
-              <a:ext cx="10283551" cy="4907241"/>
+              <a:ext cx="10983050" cy="4907241"/>
             </a:xfrm>
             <a:prstGeom prst="roundRect">
               <a:avLst>
@@ -8586,7 +8674,7 @@
           </p:nvSpPr>
           <p:spPr>
             <a:xfrm>
-              <a:off x="5255768" y="3614372"/>
+              <a:off x="5627904" y="3614372"/>
               <a:ext cx="3360898" cy="2097152"/>
             </a:xfrm>
             <a:prstGeom prst="roundRect">
@@ -8644,7 +8732,7 @@
           </p:nvSpPr>
           <p:spPr>
             <a:xfrm>
-              <a:off x="5255766" y="1367293"/>
+              <a:off x="5627902" y="1367293"/>
               <a:ext cx="3360899" cy="2097152"/>
             </a:xfrm>
             <a:prstGeom prst="roundRect">
@@ -8971,7 +9059,7 @@
           </p:blipFill>
           <p:spPr>
             <a:xfrm>
-              <a:off x="5515521" y="3977496"/>
+              <a:off x="5887657" y="3977496"/>
               <a:ext cx="634696" cy="634696"/>
             </a:xfrm>
             <a:prstGeom prst="rect">
@@ -9006,7 +9094,7 @@
           </p:blipFill>
           <p:spPr>
             <a:xfrm>
-              <a:off x="6624854" y="3977496"/>
+              <a:off x="6996990" y="3977496"/>
               <a:ext cx="634696" cy="634696"/>
             </a:xfrm>
             <a:prstGeom prst="rect">
@@ -9041,7 +9129,7 @@
           </p:blipFill>
           <p:spPr>
             <a:xfrm>
-              <a:off x="7690686" y="3977496"/>
+              <a:off x="8062822" y="3977496"/>
               <a:ext cx="634696" cy="634696"/>
             </a:xfrm>
             <a:prstGeom prst="rect">
@@ -9203,7 +9291,7 @@
           </p:nvSpPr>
           <p:spPr>
             <a:xfrm>
-              <a:off x="5557363" y="3827569"/>
+              <a:off x="5929499" y="3827569"/>
               <a:ext cx="570990" cy="369332"/>
             </a:xfrm>
             <a:prstGeom prst="rect">
@@ -9238,7 +9326,7 @@
           </p:nvSpPr>
           <p:spPr>
             <a:xfrm>
-              <a:off x="6624023" y="3827569"/>
+              <a:off x="6996159" y="3827569"/>
               <a:ext cx="570990" cy="369332"/>
             </a:xfrm>
             <a:prstGeom prst="rect">
@@ -9273,7 +9361,7 @@
           </p:nvSpPr>
           <p:spPr>
             <a:xfrm>
-              <a:off x="7713583" y="3827569"/>
+              <a:off x="8085719" y="3827569"/>
               <a:ext cx="570990" cy="369332"/>
             </a:xfrm>
             <a:prstGeom prst="rect">
@@ -9455,7 +9543,7 @@
           </p:nvSpPr>
           <p:spPr>
             <a:xfrm rot="16200000">
-              <a:off x="5648202" y="4161658"/>
+              <a:off x="6020338" y="4161658"/>
               <a:ext cx="369333" cy="901063"/>
             </a:xfrm>
             <a:prstGeom prst="leftBracket">
@@ -9504,7 +9592,7 @@
           </p:nvSpPr>
           <p:spPr>
             <a:xfrm rot="16200000">
-              <a:off x="7866869" y="4161658"/>
+              <a:off x="8239005" y="4161658"/>
               <a:ext cx="369333" cy="901063"/>
             </a:xfrm>
             <a:prstGeom prst="leftBracket">
@@ -9639,7 +9727,7 @@
           </p:blipFill>
           <p:spPr>
             <a:xfrm>
-              <a:off x="5524430" y="4851763"/>
+              <a:off x="5896566" y="4851763"/>
               <a:ext cx="636856" cy="636856"/>
             </a:xfrm>
             <a:prstGeom prst="rect">
@@ -9711,7 +9799,7 @@
           </p:blipFill>
           <p:spPr>
             <a:xfrm>
-              <a:off x="7733107" y="4842814"/>
+              <a:off x="8105243" y="4842814"/>
               <a:ext cx="636856" cy="636856"/>
             </a:xfrm>
             <a:prstGeom prst="rect">
@@ -9886,7 +9974,7 @@
           </p:blipFill>
           <p:spPr>
             <a:xfrm>
-              <a:off x="5507225" y="1709327"/>
+              <a:off x="5879361" y="1709327"/>
               <a:ext cx="634696" cy="634696"/>
             </a:xfrm>
             <a:prstGeom prst="rect">
@@ -9921,7 +10009,7 @@
           </p:blipFill>
           <p:spPr>
             <a:xfrm>
-              <a:off x="6573057" y="1709327"/>
+              <a:off x="6945193" y="1709327"/>
               <a:ext cx="634696" cy="634696"/>
             </a:xfrm>
             <a:prstGeom prst="rect">
@@ -9956,7 +10044,7 @@
           </p:blipFill>
           <p:spPr>
             <a:xfrm>
-              <a:off x="7682390" y="1709327"/>
+              <a:off x="8054526" y="1709327"/>
               <a:ext cx="634696" cy="634696"/>
             </a:xfrm>
             <a:prstGeom prst="rect">
@@ -10118,7 +10206,7 @@
           </p:nvSpPr>
           <p:spPr>
             <a:xfrm>
-              <a:off x="5553094" y="1559400"/>
+              <a:off x="5925230" y="1559400"/>
               <a:ext cx="570990" cy="369332"/>
             </a:xfrm>
             <a:prstGeom prst="rect">
@@ -10153,7 +10241,7 @@
           </p:nvSpPr>
           <p:spPr>
             <a:xfrm>
-              <a:off x="6614899" y="1559400"/>
+              <a:off x="6987035" y="1559400"/>
               <a:ext cx="570990" cy="369332"/>
             </a:xfrm>
             <a:prstGeom prst="rect">
@@ -10188,7 +10276,7 @@
           </p:nvSpPr>
           <p:spPr>
             <a:xfrm>
-              <a:off x="7681559" y="1559400"/>
+              <a:off x="8053695" y="1559400"/>
               <a:ext cx="570990" cy="369332"/>
             </a:xfrm>
             <a:prstGeom prst="rect">
@@ -10407,7 +10495,7 @@
           </p:blipFill>
           <p:spPr>
             <a:xfrm>
-              <a:off x="9285550" y="2524265"/>
+              <a:off x="10019194" y="2524265"/>
               <a:ext cx="636856" cy="636856"/>
             </a:xfrm>
             <a:prstGeom prst="rect">
@@ -10443,7 +10531,7 @@
           </p:blipFill>
           <p:spPr>
             <a:xfrm>
-              <a:off x="6057340" y="2570222"/>
+              <a:off x="6429476" y="2570222"/>
               <a:ext cx="636856" cy="636856"/>
             </a:xfrm>
             <a:prstGeom prst="rect">
@@ -10465,7 +10553,7 @@
           </p:nvSpPr>
           <p:spPr>
             <a:xfrm>
-              <a:off x="8772875" y="1367293"/>
+              <a:off x="9506519" y="1367293"/>
               <a:ext cx="1662206" cy="2097152"/>
             </a:xfrm>
             <a:prstGeom prst="roundRect">
@@ -10536,7 +10624,7 @@
           </p:blipFill>
           <p:spPr>
             <a:xfrm>
-              <a:off x="9243129" y="1636349"/>
+              <a:off x="9976773" y="1636349"/>
               <a:ext cx="634696" cy="634696"/>
             </a:xfrm>
             <a:prstGeom prst="rect">
@@ -10558,7 +10646,7 @@
           </p:nvSpPr>
           <p:spPr>
             <a:xfrm>
-              <a:off x="9266026" y="1486422"/>
+              <a:off x="9999670" y="1486422"/>
               <a:ext cx="570990" cy="369332"/>
             </a:xfrm>
             <a:prstGeom prst="rect">
@@ -10593,7 +10681,7 @@
           </p:nvSpPr>
           <p:spPr>
             <a:xfrm rot="16200000">
-              <a:off x="9375810" y="1829502"/>
+              <a:off x="10109454" y="1829502"/>
               <a:ext cx="369333" cy="901063"/>
             </a:xfrm>
             <a:prstGeom prst="leftBracket">
@@ -10642,7 +10730,7 @@
           </p:nvSpPr>
           <p:spPr>
             <a:xfrm rot="16200000">
-              <a:off x="6191102" y="1321673"/>
+              <a:off x="6563238" y="1321673"/>
               <a:ext cx="369333" cy="2035851"/>
             </a:xfrm>
             <a:prstGeom prst="leftBracket">
@@ -10691,7 +10779,7 @@
           </p:nvSpPr>
           <p:spPr>
             <a:xfrm>
-              <a:off x="8772875" y="3637753"/>
+              <a:off x="9506519" y="3637753"/>
               <a:ext cx="1662206" cy="2097152"/>
             </a:xfrm>
             <a:prstGeom prst="roundRect">
@@ -10762,7 +10850,7 @@
           </p:blipFill>
           <p:spPr>
             <a:xfrm>
-              <a:off x="9243129" y="3906809"/>
+              <a:off x="9976773" y="3906809"/>
               <a:ext cx="634696" cy="634696"/>
             </a:xfrm>
             <a:prstGeom prst="rect">
@@ -10784,7 +10872,7 @@
           </p:nvSpPr>
           <p:spPr>
             <a:xfrm>
-              <a:off x="9266026" y="3756882"/>
+              <a:off x="9999670" y="3756882"/>
               <a:ext cx="570990" cy="369332"/>
             </a:xfrm>
             <a:prstGeom prst="rect">
@@ -10819,7 +10907,7 @@
           </p:nvSpPr>
           <p:spPr>
             <a:xfrm rot="16200000">
-              <a:off x="9366214" y="4100317"/>
+              <a:off x="10099858" y="4100317"/>
               <a:ext cx="369333" cy="901063"/>
             </a:xfrm>
             <a:prstGeom prst="leftBracket">
@@ -10882,7 +10970,7 @@
           </p:blipFill>
           <p:spPr>
             <a:xfrm>
-              <a:off x="9232453" y="4842814"/>
+              <a:off x="9966097" y="4842814"/>
               <a:ext cx="636856" cy="636856"/>
             </a:xfrm>
             <a:prstGeom prst="rect">
@@ -10890,6 +10978,94 @@
             </a:prstGeom>
           </p:spPr>
         </p:pic>
+        <p:cxnSp>
+          <p:nvCxnSpPr>
+            <p:cNvPr id="5" name="Straight Connector 4">
+              <a:extLst>
+                <a:ext uri="{FF2B5EF4-FFF2-40B4-BE49-F238E27FC236}">
+                  <a16:creationId xmlns:a16="http://schemas.microsoft.com/office/drawing/2014/main" id="{EF3B7E46-F956-D3E2-B099-81D5FFBE7BE0}"/>
+                </a:ext>
+              </a:extLst>
+            </p:cNvPr>
+            <p:cNvCxnSpPr>
+              <a:cxnSpLocks/>
+            </p:cNvCxnSpPr>
+            <p:nvPr/>
+          </p:nvCxnSpPr>
+          <p:spPr>
+            <a:xfrm flipV="1">
+              <a:off x="5359476" y="1098449"/>
+              <a:ext cx="0" cy="4907241"/>
+            </a:xfrm>
+            <a:prstGeom prst="line">
+              <a:avLst/>
+            </a:prstGeom>
+            <a:ln w="47625">
+              <a:solidFill>
+                <a:schemeClr val="tx1"/>
+              </a:solidFill>
+              <a:prstDash val="sysDot"/>
+            </a:ln>
+          </p:spPr>
+          <p:style>
+            <a:lnRef idx="2">
+              <a:schemeClr val="accent1"/>
+            </a:lnRef>
+            <a:fillRef idx="0">
+              <a:schemeClr val="accent1"/>
+            </a:fillRef>
+            <a:effectRef idx="1">
+              <a:schemeClr val="accent1"/>
+            </a:effectRef>
+            <a:fontRef idx="minor">
+              <a:schemeClr val="tx1"/>
+            </a:fontRef>
+          </p:style>
+        </p:cxnSp>
+        <p:cxnSp>
+          <p:nvCxnSpPr>
+            <p:cNvPr id="11" name="Straight Connector 10">
+              <a:extLst>
+                <a:ext uri="{FF2B5EF4-FFF2-40B4-BE49-F238E27FC236}">
+                  <a16:creationId xmlns:a16="http://schemas.microsoft.com/office/drawing/2014/main" id="{32F9B20D-004F-6B52-CF4E-485C435A49D3}"/>
+                </a:ext>
+              </a:extLst>
+            </p:cNvPr>
+            <p:cNvCxnSpPr>
+              <a:cxnSpLocks/>
+            </p:cNvCxnSpPr>
+            <p:nvPr/>
+          </p:nvCxnSpPr>
+          <p:spPr>
+            <a:xfrm flipV="1">
+              <a:off x="9251006" y="1098449"/>
+              <a:ext cx="0" cy="4907241"/>
+            </a:xfrm>
+            <a:prstGeom prst="line">
+              <a:avLst/>
+            </a:prstGeom>
+            <a:ln w="47625">
+              <a:solidFill>
+                <a:schemeClr val="tx1"/>
+              </a:solidFill>
+              <a:prstDash val="sysDot"/>
+            </a:ln>
+          </p:spPr>
+          <p:style>
+            <a:lnRef idx="2">
+              <a:schemeClr val="accent1"/>
+            </a:lnRef>
+            <a:fillRef idx="0">
+              <a:schemeClr val="accent1"/>
+            </a:fillRef>
+            <a:effectRef idx="1">
+              <a:schemeClr val="accent1"/>
+            </a:effectRef>
+            <a:fontRef idx="minor">
+              <a:schemeClr val="tx1"/>
+            </a:fontRef>
+          </p:style>
+        </p:cxnSp>
       </p:grpSp>
     </p:spTree>
     <p:extLst>

</xml_diff>

<commit_message>
correct action equivalencies results, add helper functions
</commit_message>
<xml_diff>
--- a/images/icu.pptx
+++ b/images/icu.pptx
@@ -203,7 +203,7 @@
           <a:p>
             <a:fld id="{AD42B31F-4ABA-274F-9BB4-DA3A6583FDB8}" type="datetimeFigureOut">
               <a:rPr lang="en-US" smtClean="0"/>
-              <a:t>8/10/26</a:t>
+              <a:t>8/11/26</a:t>
             </a:fld>
             <a:endParaRPr lang="en-US"/>
           </a:p>
@@ -1112,7 +1112,7 @@
           <a:p>
             <a:fld id="{0D21F05F-ACFB-0C4D-9827-53BE568178E4}" type="datetimeFigureOut">
               <a:rPr lang="en-US" smtClean="0"/>
-              <a:t>8/10/26</a:t>
+              <a:t>8/11/26</a:t>
             </a:fld>
             <a:endParaRPr lang="en-US"/>
           </a:p>
@@ -1312,7 +1312,7 @@
           <a:p>
             <a:fld id="{0D21F05F-ACFB-0C4D-9827-53BE568178E4}" type="datetimeFigureOut">
               <a:rPr lang="en-US" smtClean="0"/>
-              <a:t>8/10/26</a:t>
+              <a:t>8/11/26</a:t>
             </a:fld>
             <a:endParaRPr lang="en-US"/>
           </a:p>
@@ -1522,7 +1522,7 @@
           <a:p>
             <a:fld id="{0D21F05F-ACFB-0C4D-9827-53BE568178E4}" type="datetimeFigureOut">
               <a:rPr lang="en-US" smtClean="0"/>
-              <a:t>8/10/26</a:t>
+              <a:t>8/11/26</a:t>
             </a:fld>
             <a:endParaRPr lang="en-US"/>
           </a:p>
@@ -1722,7 +1722,7 @@
           <a:p>
             <a:fld id="{0D21F05F-ACFB-0C4D-9827-53BE568178E4}" type="datetimeFigureOut">
               <a:rPr lang="en-US" smtClean="0"/>
-              <a:t>8/10/26</a:t>
+              <a:t>8/11/26</a:t>
             </a:fld>
             <a:endParaRPr lang="en-US"/>
           </a:p>
@@ -1998,7 +1998,7 @@
           <a:p>
             <a:fld id="{0D21F05F-ACFB-0C4D-9827-53BE568178E4}" type="datetimeFigureOut">
               <a:rPr lang="en-US" smtClean="0"/>
-              <a:t>8/10/26</a:t>
+              <a:t>8/11/26</a:t>
             </a:fld>
             <a:endParaRPr lang="en-US"/>
           </a:p>
@@ -2266,7 +2266,7 @@
           <a:p>
             <a:fld id="{0D21F05F-ACFB-0C4D-9827-53BE568178E4}" type="datetimeFigureOut">
               <a:rPr lang="en-US" smtClean="0"/>
-              <a:t>8/10/26</a:t>
+              <a:t>8/11/26</a:t>
             </a:fld>
             <a:endParaRPr lang="en-US"/>
           </a:p>
@@ -2681,7 +2681,7 @@
           <a:p>
             <a:fld id="{0D21F05F-ACFB-0C4D-9827-53BE568178E4}" type="datetimeFigureOut">
               <a:rPr lang="en-US" smtClean="0"/>
-              <a:t>8/10/26</a:t>
+              <a:t>8/11/26</a:t>
             </a:fld>
             <a:endParaRPr lang="en-US"/>
           </a:p>
@@ -2823,7 +2823,7 @@
           <a:p>
             <a:fld id="{0D21F05F-ACFB-0C4D-9827-53BE568178E4}" type="datetimeFigureOut">
               <a:rPr lang="en-US" smtClean="0"/>
-              <a:t>8/10/26</a:t>
+              <a:t>8/11/26</a:t>
             </a:fld>
             <a:endParaRPr lang="en-US"/>
           </a:p>
@@ -2936,7 +2936,7 @@
           <a:p>
             <a:fld id="{0D21F05F-ACFB-0C4D-9827-53BE568178E4}" type="datetimeFigureOut">
               <a:rPr lang="en-US" smtClean="0"/>
-              <a:t>8/10/26</a:t>
+              <a:t>8/11/26</a:t>
             </a:fld>
             <a:endParaRPr lang="en-US"/>
           </a:p>
@@ -3249,7 +3249,7 @@
           <a:p>
             <a:fld id="{0D21F05F-ACFB-0C4D-9827-53BE568178E4}" type="datetimeFigureOut">
               <a:rPr lang="en-US" smtClean="0"/>
-              <a:t>8/10/26</a:t>
+              <a:t>8/11/26</a:t>
             </a:fld>
             <a:endParaRPr lang="en-US"/>
           </a:p>
@@ -3538,7 +3538,7 @@
           <a:p>
             <a:fld id="{0D21F05F-ACFB-0C4D-9827-53BE568178E4}" type="datetimeFigureOut">
               <a:rPr lang="en-US" smtClean="0"/>
-              <a:t>8/10/26</a:t>
+              <a:t>8/11/26</a:t>
             </a:fld>
             <a:endParaRPr lang="en-US"/>
           </a:p>
@@ -3781,7 +3781,7 @@
           <a:p>
             <a:fld id="{0D21F05F-ACFB-0C4D-9827-53BE568178E4}" type="datetimeFigureOut">
               <a:rPr lang="en-US" smtClean="0"/>
-              <a:t>8/10/26</a:t>
+              <a:t>8/11/26</a:t>
             </a:fld>
             <a:endParaRPr lang="en-US"/>
           </a:p>
@@ -16120,10 +16120,10 @@
       </p:grpSpPr>
       <p:grpSp>
         <p:nvGrpSpPr>
-          <p:cNvPr id="236" name="Group 235">
+          <p:cNvPr id="100" name="Group 99">
             <a:extLst>
               <a:ext uri="{FF2B5EF4-FFF2-40B4-BE49-F238E27FC236}">
-                <a16:creationId xmlns:a16="http://schemas.microsoft.com/office/drawing/2014/main" id="{3EE945A8-BD10-05A2-3F7E-DF13B63670C7}"/>
+                <a16:creationId xmlns:a16="http://schemas.microsoft.com/office/drawing/2014/main" id="{9E65C308-C099-68DE-CE62-7931B7024718}"/>
               </a:ext>
             </a:extLst>
           </p:cNvPr>
@@ -16132,10 +16132,10 @@
         </p:nvGrpSpPr>
         <p:grpSpPr>
           <a:xfrm>
-            <a:off x="-1168710" y="946448"/>
-            <a:ext cx="15349915" cy="9048426"/>
-            <a:chOff x="-1168710" y="946448"/>
-            <a:chExt cx="15349915" cy="9048426"/>
+            <a:off x="-734906" y="949292"/>
+            <a:ext cx="15171293" cy="9057340"/>
+            <a:chOff x="-734906" y="949292"/>
+            <a:chExt cx="15171293" cy="9057340"/>
           </a:xfrm>
         </p:grpSpPr>
         <p:sp>
@@ -16152,8 +16152,8 @@
           </p:nvSpPr>
           <p:spPr>
             <a:xfrm>
-              <a:off x="7117820" y="8270799"/>
-              <a:ext cx="7063385" cy="1654885"/>
+              <a:off x="7276781" y="8281432"/>
+              <a:ext cx="7159606" cy="1654885"/>
             </a:xfrm>
             <a:prstGeom prst="rect">
               <a:avLst/>
@@ -16202,7 +16202,7 @@
           </p:nvSpPr>
           <p:spPr>
             <a:xfrm>
-              <a:off x="5059165" y="1420328"/>
+              <a:off x="5314346" y="1430961"/>
               <a:ext cx="2691250" cy="369332"/>
             </a:xfrm>
             <a:prstGeom prst="rect">
@@ -16253,7 +16253,7 @@
           </p:nvSpPr>
           <p:spPr>
             <a:xfrm>
-              <a:off x="456210" y="3540243"/>
+              <a:off x="711391" y="3550876"/>
               <a:ext cx="1779654" cy="369332"/>
             </a:xfrm>
             <a:prstGeom prst="rect">
@@ -16300,7 +16300,7 @@
           </p:nvSpPr>
           <p:spPr>
             <a:xfrm>
-              <a:off x="3981382" y="3540243"/>
+              <a:off x="4236563" y="3550876"/>
               <a:ext cx="1370888" cy="369332"/>
             </a:xfrm>
             <a:prstGeom prst="rect">
@@ -16347,7 +16347,7 @@
           </p:nvSpPr>
           <p:spPr>
             <a:xfrm>
-              <a:off x="7382499" y="3534667"/>
+              <a:off x="7637680" y="3545300"/>
               <a:ext cx="1370888" cy="369332"/>
             </a:xfrm>
             <a:prstGeom prst="rect">
@@ -16394,7 +16394,7 @@
           </p:nvSpPr>
           <p:spPr>
             <a:xfrm>
-              <a:off x="10941974" y="3542703"/>
+              <a:off x="11197155" y="3553336"/>
               <a:ext cx="652743" cy="369332"/>
             </a:xfrm>
             <a:prstGeom prst="rect">
@@ -16430,7 +16430,7 @@
           </p:nvSpPr>
           <p:spPr>
             <a:xfrm>
-              <a:off x="10211787" y="4666390"/>
+              <a:off x="10466968" y="4677023"/>
               <a:ext cx="2202334" cy="369332"/>
             </a:xfrm>
             <a:prstGeom prst="rect">
@@ -16473,7 +16473,7 @@
           </p:nvSpPr>
           <p:spPr>
             <a:xfrm>
-              <a:off x="309507" y="4584747"/>
+              <a:off x="564688" y="4595380"/>
               <a:ext cx="2202334" cy="369332"/>
             </a:xfrm>
             <a:prstGeom prst="rect">
@@ -16516,7 +16516,7 @@
           </p:nvSpPr>
           <p:spPr>
             <a:xfrm>
-              <a:off x="-411298" y="6227028"/>
+              <a:off x="-156117" y="6237661"/>
               <a:ext cx="527645" cy="369332"/>
             </a:xfrm>
             <a:prstGeom prst="rect">
@@ -16552,7 +16552,7 @@
           </p:nvSpPr>
           <p:spPr>
             <a:xfrm>
-              <a:off x="2833741" y="6227028"/>
+              <a:off x="3088922" y="6237661"/>
               <a:ext cx="474810" cy="369332"/>
             </a:xfrm>
             <a:prstGeom prst="rect">
@@ -16588,7 +16588,7 @@
           </p:nvSpPr>
           <p:spPr>
             <a:xfrm>
-              <a:off x="9485334" y="6308671"/>
+              <a:off x="9740515" y="6319304"/>
               <a:ext cx="527645" cy="369332"/>
             </a:xfrm>
             <a:prstGeom prst="rect">
@@ -16624,7 +16624,7 @@
           </p:nvSpPr>
           <p:spPr>
             <a:xfrm>
-              <a:off x="12730373" y="6308671"/>
+              <a:off x="12985554" y="6319304"/>
               <a:ext cx="474810" cy="369332"/>
             </a:xfrm>
             <a:prstGeom prst="rect">
@@ -16660,8 +16660,8 @@
           </p:nvSpPr>
           <p:spPr>
             <a:xfrm>
-              <a:off x="1855676" y="7286911"/>
-              <a:ext cx="2590261" cy="369332"/>
+              <a:off x="1852062" y="7263038"/>
+              <a:ext cx="2978188" cy="369332"/>
             </a:xfrm>
             <a:prstGeom prst="rect">
               <a:avLst/>
@@ -16688,6 +16688,14 @@
               </a:r>
               <a:r>
                 <a:rPr lang="en-US" baseline="-25000" dirty="0"/>
+                <a:t>3</a:t>
+              </a:r>
+              <a:r>
+                <a:rPr lang="en-US" dirty="0"/>
+                <a:t> ∘ T</a:t>
+              </a:r>
+              <a:r>
+                <a:rPr lang="en-US" baseline="-25000" dirty="0"/>
                 <a:t>5</a:t>
               </a:r>
               <a:r>
@@ -16711,7 +16719,7 @@
           </p:nvSpPr>
           <p:spPr>
             <a:xfrm>
-              <a:off x="1231443" y="9098242"/>
+              <a:off x="1486624" y="9108875"/>
               <a:ext cx="527645" cy="369332"/>
             </a:xfrm>
             <a:prstGeom prst="rect">
@@ -16747,7 +16755,7 @@
           </p:nvSpPr>
           <p:spPr>
             <a:xfrm>
-              <a:off x="4476482" y="9098242"/>
+              <a:off x="4731663" y="9108875"/>
               <a:ext cx="474810" cy="369332"/>
             </a:xfrm>
             <a:prstGeom prst="rect">
@@ -16786,7 +16794,7 @@
           </p:nvCxnSpPr>
           <p:spPr>
             <a:xfrm flipH="1">
-              <a:off x="1346037" y="1886830"/>
+              <a:off x="1601218" y="1897463"/>
               <a:ext cx="3954167" cy="1653413"/>
             </a:xfrm>
             <a:prstGeom prst="straightConnector1">
@@ -16831,7 +16839,7 @@
           </p:nvCxnSpPr>
           <p:spPr>
             <a:xfrm>
-              <a:off x="7540857" y="1879288"/>
+              <a:off x="7796038" y="1889921"/>
               <a:ext cx="3727489" cy="1663415"/>
             </a:xfrm>
             <a:prstGeom prst="straightConnector1">
@@ -16876,7 +16884,7 @@
           </p:nvCxnSpPr>
           <p:spPr>
             <a:xfrm flipH="1">
-              <a:off x="4666826" y="1879782"/>
+              <a:off x="4922007" y="1890415"/>
               <a:ext cx="1443299" cy="1660461"/>
             </a:xfrm>
             <a:prstGeom prst="straightConnector1">
@@ -16921,7 +16929,7 @@
           </p:nvCxnSpPr>
           <p:spPr>
             <a:xfrm>
-              <a:off x="6795569" y="1879782"/>
+              <a:off x="7050750" y="1890415"/>
               <a:ext cx="1272374" cy="1654885"/>
             </a:xfrm>
             <a:prstGeom prst="straightConnector1">
@@ -16966,7 +16974,7 @@
           </p:nvCxnSpPr>
           <p:spPr>
             <a:xfrm flipH="1">
-              <a:off x="-147475" y="5008963"/>
+              <a:off x="107706" y="5019596"/>
               <a:ext cx="1274935" cy="1218065"/>
             </a:xfrm>
             <a:prstGeom prst="straightConnector1">
@@ -17011,7 +17019,7 @@
           </p:nvCxnSpPr>
           <p:spPr>
             <a:xfrm>
-              <a:off x="1773684" y="5008963"/>
+              <a:off x="2028865" y="5019596"/>
               <a:ext cx="1297462" cy="1218065"/>
             </a:xfrm>
             <a:prstGeom prst="straightConnector1">
@@ -17056,7 +17064,7 @@
           </p:nvCxnSpPr>
           <p:spPr>
             <a:xfrm flipH="1">
-              <a:off x="9749157" y="5090606"/>
+              <a:off x="10004338" y="5101239"/>
               <a:ext cx="1399478" cy="1218065"/>
             </a:xfrm>
             <a:prstGeom prst="straightConnector1">
@@ -17101,7 +17109,7 @@
           </p:nvCxnSpPr>
           <p:spPr>
             <a:xfrm>
-              <a:off x="11594717" y="5090606"/>
+              <a:off x="11849898" y="5101239"/>
               <a:ext cx="1373061" cy="1218065"/>
             </a:xfrm>
             <a:prstGeom prst="straightConnector1">
@@ -17146,7 +17154,7 @@
           </p:nvCxnSpPr>
           <p:spPr>
             <a:xfrm flipH="1">
-              <a:off x="1495266" y="7712226"/>
+              <a:off x="1750447" y="7722859"/>
               <a:ext cx="1270491" cy="1386016"/>
             </a:xfrm>
             <a:prstGeom prst="straightConnector1">
@@ -17191,7 +17199,7 @@
           </p:nvCxnSpPr>
           <p:spPr>
             <a:xfrm>
-              <a:off x="3469813" y="7712226"/>
+              <a:off x="3724994" y="7722859"/>
               <a:ext cx="1244074" cy="1386016"/>
             </a:xfrm>
             <a:prstGeom prst="straightConnector1">
@@ -17233,110 +17241,10 @@
           </p:nvSpPr>
           <p:spPr>
             <a:xfrm>
-              <a:off x="7387746" y="8595545"/>
-              <a:ext cx="4254192" cy="940967"/>
+              <a:off x="7392799" y="8617612"/>
+              <a:ext cx="4295202" cy="1159540"/>
             </a:xfrm>
             <a:prstGeom prst="roundRect">
-              <a:avLst/>
-            </a:prstGeom>
-            <a:solidFill>
-              <a:schemeClr val="bg2"/>
-            </a:solidFill>
-            <a:ln w="22225"/>
-          </p:spPr>
-          <p:style>
-            <a:lnRef idx="2">
-              <a:schemeClr val="accent1">
-                <a:shade val="15000"/>
-              </a:schemeClr>
-            </a:lnRef>
-            <a:fillRef idx="1">
-              <a:schemeClr val="accent1"/>
-            </a:fillRef>
-            <a:effectRef idx="0">
-              <a:schemeClr val="accent1"/>
-            </a:effectRef>
-            <a:fontRef idx="minor">
-              <a:schemeClr val="lt1"/>
-            </a:fontRef>
-          </p:style>
-          <p:txBody>
-            <a:bodyPr rtlCol="0" anchor="ctr"/>
-            <a:lstStyle/>
-            <a:p>
-              <a:pPr algn="ctr"/>
-              <a:endParaRPr lang="en-US" sz="1600"/>
-            </a:p>
-          </p:txBody>
-        </p:sp>
-        <p:sp>
-          <p:nvSpPr>
-            <p:cNvPr id="197" name="Oval 196">
-              <a:extLst>
-                <a:ext uri="{FF2B5EF4-FFF2-40B4-BE49-F238E27FC236}">
-                  <a16:creationId xmlns:a16="http://schemas.microsoft.com/office/drawing/2014/main" id="{E5016161-360C-309B-E1F3-E1ACCAF33FA3}"/>
-                </a:ext>
-              </a:extLst>
-            </p:cNvPr>
-            <p:cNvSpPr/>
-            <p:nvPr/>
-          </p:nvSpPr>
-          <p:spPr>
-            <a:xfrm>
-              <a:off x="7537154" y="8687694"/>
-              <a:ext cx="684999" cy="689246"/>
-            </a:xfrm>
-            <a:prstGeom prst="ellipse">
-              <a:avLst/>
-            </a:prstGeom>
-            <a:solidFill>
-              <a:schemeClr val="bg2"/>
-            </a:solidFill>
-            <a:ln w="22225"/>
-          </p:spPr>
-          <p:style>
-            <a:lnRef idx="2">
-              <a:schemeClr val="accent1">
-                <a:shade val="15000"/>
-              </a:schemeClr>
-            </a:lnRef>
-            <a:fillRef idx="1">
-              <a:schemeClr val="accent1"/>
-            </a:fillRef>
-            <a:effectRef idx="0">
-              <a:schemeClr val="accent1"/>
-            </a:effectRef>
-            <a:fontRef idx="minor">
-              <a:schemeClr val="lt1"/>
-            </a:fontRef>
-          </p:style>
-          <p:txBody>
-            <a:bodyPr rtlCol="0" anchor="ctr"/>
-            <a:lstStyle/>
-            <a:p>
-              <a:pPr algn="ctr"/>
-              <a:endParaRPr lang="en-US" sz="1600"/>
-            </a:p>
-          </p:txBody>
-        </p:sp>
-        <p:sp>
-          <p:nvSpPr>
-            <p:cNvPr id="205" name="Oval 204">
-              <a:extLst>
-                <a:ext uri="{FF2B5EF4-FFF2-40B4-BE49-F238E27FC236}">
-                  <a16:creationId xmlns:a16="http://schemas.microsoft.com/office/drawing/2014/main" id="{7A41D075-CE16-5107-F667-22526F4EAAE6}"/>
-                </a:ext>
-              </a:extLst>
-            </p:cNvPr>
-            <p:cNvSpPr/>
-            <p:nvPr/>
-          </p:nvSpPr>
-          <p:spPr>
-            <a:xfrm>
-              <a:off x="8326827" y="8687694"/>
-              <a:ext cx="684999" cy="689246"/>
-            </a:xfrm>
-            <a:prstGeom prst="ellipse">
               <a:avLst/>
             </a:prstGeom>
             <a:solidFill>
@@ -17383,108 +17291,8 @@
           </p:nvSpPr>
           <p:spPr>
             <a:xfrm>
-              <a:off x="9968651" y="8687694"/>
-              <a:ext cx="684999" cy="689246"/>
-            </a:xfrm>
-            <a:prstGeom prst="ellipse">
-              <a:avLst/>
-            </a:prstGeom>
-            <a:solidFill>
-              <a:schemeClr val="bg2"/>
-            </a:solidFill>
-            <a:ln w="22225"/>
-          </p:spPr>
-          <p:style>
-            <a:lnRef idx="2">
-              <a:schemeClr val="accent1">
-                <a:shade val="15000"/>
-              </a:schemeClr>
-            </a:lnRef>
-            <a:fillRef idx="1">
-              <a:schemeClr val="accent1"/>
-            </a:fillRef>
-            <a:effectRef idx="0">
-              <a:schemeClr val="accent1"/>
-            </a:effectRef>
-            <a:fontRef idx="minor">
-              <a:schemeClr val="lt1"/>
-            </a:fontRef>
-          </p:style>
-          <p:txBody>
-            <a:bodyPr rtlCol="0" anchor="ctr"/>
-            <a:lstStyle/>
-            <a:p>
-              <a:pPr algn="ctr"/>
-              <a:endParaRPr lang="en-US" sz="1600"/>
-            </a:p>
-          </p:txBody>
-        </p:sp>
-        <p:sp>
-          <p:nvSpPr>
-            <p:cNvPr id="207" name="Oval 206">
-              <a:extLst>
-                <a:ext uri="{FF2B5EF4-FFF2-40B4-BE49-F238E27FC236}">
-                  <a16:creationId xmlns:a16="http://schemas.microsoft.com/office/drawing/2014/main" id="{A77B2F02-5765-FED8-94E3-734B2F32FFD4}"/>
-                </a:ext>
-              </a:extLst>
-            </p:cNvPr>
-            <p:cNvSpPr/>
-            <p:nvPr/>
-          </p:nvSpPr>
-          <p:spPr>
-            <a:xfrm>
-              <a:off x="9116500" y="8687694"/>
-              <a:ext cx="684999" cy="689246"/>
-            </a:xfrm>
-            <a:prstGeom prst="ellipse">
-              <a:avLst/>
-            </a:prstGeom>
-            <a:solidFill>
-              <a:schemeClr val="bg2"/>
-            </a:solidFill>
-            <a:ln w="22225"/>
-          </p:spPr>
-          <p:style>
-            <a:lnRef idx="2">
-              <a:schemeClr val="accent1">
-                <a:shade val="15000"/>
-              </a:schemeClr>
-            </a:lnRef>
-            <a:fillRef idx="1">
-              <a:schemeClr val="accent1"/>
-            </a:fillRef>
-            <a:effectRef idx="0">
-              <a:schemeClr val="accent1"/>
-            </a:effectRef>
-            <a:fontRef idx="minor">
-              <a:schemeClr val="lt1"/>
-            </a:fontRef>
-          </p:style>
-          <p:txBody>
-            <a:bodyPr rtlCol="0" anchor="ctr"/>
-            <a:lstStyle/>
-            <a:p>
-              <a:pPr algn="ctr"/>
-              <a:endParaRPr lang="en-US" sz="1600"/>
-            </a:p>
-          </p:txBody>
-        </p:sp>
-        <p:sp>
-          <p:nvSpPr>
-            <p:cNvPr id="208" name="Oval 207">
-              <a:extLst>
-                <a:ext uri="{FF2B5EF4-FFF2-40B4-BE49-F238E27FC236}">
-                  <a16:creationId xmlns:a16="http://schemas.microsoft.com/office/drawing/2014/main" id="{C37EBCCB-94B2-2036-31B8-B52F3DE42280}"/>
-                </a:ext>
-              </a:extLst>
-            </p:cNvPr>
-            <p:cNvSpPr/>
-            <p:nvPr/>
-          </p:nvSpPr>
-          <p:spPr>
-            <a:xfrm>
-              <a:off x="10766637" y="8687694"/>
-              <a:ext cx="684999" cy="689246"/>
+              <a:off x="10654941" y="8729498"/>
+              <a:ext cx="894965" cy="896381"/>
             </a:xfrm>
             <a:prstGeom prst="ellipse">
               <a:avLst/>
@@ -17533,8 +17341,8 @@
           </p:nvSpPr>
           <p:spPr>
             <a:xfrm>
-              <a:off x="9918448" y="8867647"/>
-              <a:ext cx="796638" cy="338554"/>
+              <a:off x="10629179" y="9025058"/>
+              <a:ext cx="945168" cy="307777"/>
             </a:xfrm>
             <a:prstGeom prst="rect">
               <a:avLst/>
@@ -17549,7 +17357,7 @@
             <a:p>
               <a:pPr algn="ctr"/>
               <a:r>
-                <a:rPr lang="en-US" sz="1600" dirty="0">
+                <a:rPr lang="en-US" sz="1400" dirty="0">
                   <a:solidFill>
                     <a:schemeClr val="tx1"/>
                   </a:solidFill>
@@ -17557,7 +17365,7 @@
                 <a:t>T</a:t>
               </a:r>
               <a:r>
-                <a:rPr lang="en-US" sz="1600" baseline="-25000" dirty="0">
+                <a:rPr lang="en-US" sz="1400" baseline="-25000" dirty="0">
                   <a:solidFill>
                     <a:schemeClr val="tx1"/>
                   </a:solidFill>
@@ -17565,56 +17373,27 @@
                 <a:t>1</a:t>
               </a:r>
               <a:r>
-                <a:rPr lang="en-US" sz="1600" dirty="0">
+                <a:rPr lang="en-US" sz="1400" dirty="0">
                   <a:solidFill>
                     <a:schemeClr val="tx1"/>
                   </a:solidFill>
                 </a:rPr>
-                <a:t> ∘ T</a:t>
+                <a:t> </a:t>
               </a:r>
               <a:r>
-                <a:rPr lang="en-US" sz="1600" baseline="-25000" dirty="0">
-                  <a:solidFill>
-                    <a:schemeClr val="tx1"/>
-                  </a:solidFill>
-                </a:rPr>
-                <a:t>5</a:t>
+                <a:rPr lang="en-US" sz="1400" dirty="0"/>
+                <a:t>∘ T</a:t>
               </a:r>
-              <a:endParaRPr lang="en-US" sz="1600" baseline="-25000" dirty="0"/>
-            </a:p>
-          </p:txBody>
-        </p:sp>
-        <p:sp>
-          <p:nvSpPr>
-            <p:cNvPr id="212" name="TextBox 211">
-              <a:extLst>
-                <a:ext uri="{FF2B5EF4-FFF2-40B4-BE49-F238E27FC236}">
-                  <a16:creationId xmlns:a16="http://schemas.microsoft.com/office/drawing/2014/main" id="{B463F4F8-1288-6257-F382-B06872FB2040}"/>
-                </a:ext>
-              </a:extLst>
-            </p:cNvPr>
-            <p:cNvSpPr txBox="1"/>
-            <p:nvPr/>
-          </p:nvSpPr>
-          <p:spPr>
-            <a:xfrm>
-              <a:off x="10717782" y="8867647"/>
-              <a:ext cx="796638" cy="338554"/>
-            </a:xfrm>
-            <a:prstGeom prst="rect">
-              <a:avLst/>
-            </a:prstGeom>
-            <a:noFill/>
-          </p:spPr>
-          <p:txBody>
-            <a:bodyPr wrap="square">
-              <a:spAutoFit/>
-            </a:bodyPr>
-            <a:lstStyle/>
-            <a:p>
-              <a:pPr algn="ctr"/>
               <a:r>
-                <a:rPr lang="en-US" sz="1600" dirty="0">
+                <a:rPr lang="en-US" sz="1400" baseline="-25000" dirty="0"/>
+                <a:t>3</a:t>
+              </a:r>
+              <a:r>
+                <a:rPr lang="en-US" sz="1400" dirty="0"/>
+                <a:t> ∘ </a:t>
+              </a:r>
+              <a:r>
+                <a:rPr lang="en-US" sz="1400" dirty="0">
                   <a:solidFill>
                     <a:schemeClr val="tx1"/>
                   </a:solidFill>
@@ -17622,168 +17401,14 @@
                 <a:t>T</a:t>
               </a:r>
               <a:r>
-                <a:rPr lang="en-US" sz="1600" baseline="-25000" dirty="0"/>
-                <a:t>3</a:t>
-              </a:r>
-              <a:r>
-                <a:rPr lang="en-US" sz="1600" dirty="0">
-                  <a:solidFill>
-                    <a:schemeClr val="tx1"/>
-                  </a:solidFill>
-                </a:rPr>
-                <a:t> ∘ T</a:t>
-              </a:r>
-              <a:r>
-                <a:rPr lang="en-US" sz="1600" baseline="-25000" dirty="0">
+                <a:rPr lang="en-US" sz="1400" baseline="-25000" dirty="0">
                   <a:solidFill>
                     <a:schemeClr val="tx1"/>
                   </a:solidFill>
                 </a:rPr>
                 <a:t>5</a:t>
               </a:r>
-              <a:endParaRPr lang="en-US" sz="1600" baseline="-25000" dirty="0"/>
-            </a:p>
-          </p:txBody>
-        </p:sp>
-        <p:sp>
-          <p:nvSpPr>
-            <p:cNvPr id="213" name="TextBox 212">
-              <a:extLst>
-                <a:ext uri="{FF2B5EF4-FFF2-40B4-BE49-F238E27FC236}">
-                  <a16:creationId xmlns:a16="http://schemas.microsoft.com/office/drawing/2014/main" id="{732C086B-4413-0501-4613-C4C93A65D112}"/>
-                </a:ext>
-              </a:extLst>
-            </p:cNvPr>
-            <p:cNvSpPr txBox="1"/>
-            <p:nvPr/>
-          </p:nvSpPr>
-          <p:spPr>
-            <a:xfrm>
-              <a:off x="7488917" y="8867647"/>
-              <a:ext cx="796638" cy="338554"/>
-            </a:xfrm>
-            <a:prstGeom prst="rect">
-              <a:avLst/>
-            </a:prstGeom>
-            <a:noFill/>
-          </p:spPr>
-          <p:txBody>
-            <a:bodyPr wrap="square">
-              <a:spAutoFit/>
-            </a:bodyPr>
-            <a:lstStyle/>
-            <a:p>
-              <a:pPr algn="ctr"/>
-              <a:r>
-                <a:rPr lang="en-US" sz="1600" dirty="0">
-                  <a:solidFill>
-                    <a:schemeClr val="tx1"/>
-                  </a:solidFill>
-                </a:rPr>
-                <a:t>T</a:t>
-              </a:r>
-              <a:r>
-                <a:rPr lang="en-US" sz="1600" baseline="-25000" dirty="0">
-                  <a:solidFill>
-                    <a:schemeClr val="tx1"/>
-                  </a:solidFill>
-                </a:rPr>
-                <a:t>1</a:t>
-              </a:r>
-              <a:endParaRPr lang="en-US" sz="1600" baseline="-25000" dirty="0"/>
-            </a:p>
-          </p:txBody>
-        </p:sp>
-        <p:sp>
-          <p:nvSpPr>
-            <p:cNvPr id="214" name="TextBox 213">
-              <a:extLst>
-                <a:ext uri="{FF2B5EF4-FFF2-40B4-BE49-F238E27FC236}">
-                  <a16:creationId xmlns:a16="http://schemas.microsoft.com/office/drawing/2014/main" id="{FD363BB7-0CD7-BA65-202C-1A2468D2DD94}"/>
-                </a:ext>
-              </a:extLst>
-            </p:cNvPr>
-            <p:cNvSpPr txBox="1"/>
-            <p:nvPr/>
-          </p:nvSpPr>
-          <p:spPr>
-            <a:xfrm>
-              <a:off x="8278590" y="8873118"/>
-              <a:ext cx="796638" cy="338554"/>
-            </a:xfrm>
-            <a:prstGeom prst="rect">
-              <a:avLst/>
-            </a:prstGeom>
-            <a:noFill/>
-          </p:spPr>
-          <p:txBody>
-            <a:bodyPr wrap="square">
-              <a:spAutoFit/>
-            </a:bodyPr>
-            <a:lstStyle/>
-            <a:p>
-              <a:pPr algn="ctr"/>
-              <a:r>
-                <a:rPr lang="en-US" sz="1600" dirty="0">
-                  <a:solidFill>
-                    <a:schemeClr val="tx1"/>
-                  </a:solidFill>
-                </a:rPr>
-                <a:t>T</a:t>
-              </a:r>
-              <a:r>
-                <a:rPr lang="en-US" sz="1600" baseline="-25000" dirty="0">
-                  <a:solidFill>
-                    <a:schemeClr val="tx1"/>
-                  </a:solidFill>
-                </a:rPr>
-                <a:t>3</a:t>
-              </a:r>
-              <a:endParaRPr lang="en-US" sz="1600" baseline="-25000" dirty="0"/>
-            </a:p>
-          </p:txBody>
-        </p:sp>
-        <p:sp>
-          <p:nvSpPr>
-            <p:cNvPr id="215" name="TextBox 214">
-              <a:extLst>
-                <a:ext uri="{FF2B5EF4-FFF2-40B4-BE49-F238E27FC236}">
-                  <a16:creationId xmlns:a16="http://schemas.microsoft.com/office/drawing/2014/main" id="{0549EFD8-C758-6BBE-F799-2AE2940C7A74}"/>
-                </a:ext>
-              </a:extLst>
-            </p:cNvPr>
-            <p:cNvSpPr txBox="1"/>
-            <p:nvPr/>
-          </p:nvSpPr>
-          <p:spPr>
-            <a:xfrm>
-              <a:off x="9075228" y="8866865"/>
-              <a:ext cx="796638" cy="338554"/>
-            </a:xfrm>
-            <a:prstGeom prst="rect">
-              <a:avLst/>
-            </a:prstGeom>
-            <a:noFill/>
-          </p:spPr>
-          <p:txBody>
-            <a:bodyPr wrap="square">
-              <a:spAutoFit/>
-            </a:bodyPr>
-            <a:lstStyle/>
-            <a:p>
-              <a:pPr algn="ctr"/>
-              <a:r>
-                <a:rPr lang="en-US" sz="1600" dirty="0">
-                  <a:solidFill>
-                    <a:schemeClr val="tx1"/>
-                  </a:solidFill>
-                </a:rPr>
-                <a:t>T</a:t>
-              </a:r>
-              <a:r>
-                <a:rPr lang="en-US" sz="1600" baseline="-25000" dirty="0"/>
-                <a:t>5</a:t>
-              </a:r>
+              <a:endParaRPr lang="en-US" sz="1400" baseline="-25000" dirty="0"/>
             </a:p>
           </p:txBody>
         </p:sp>
@@ -17801,7 +17426,7 @@
           </p:nvSpPr>
           <p:spPr>
             <a:xfrm>
-              <a:off x="11853017" y="8459753"/>
+              <a:off x="12108198" y="8470386"/>
               <a:ext cx="267629" cy="267629"/>
             </a:xfrm>
             <a:prstGeom prst="ellipse">
@@ -17851,7 +17476,7 @@
           </p:nvSpPr>
           <p:spPr>
             <a:xfrm>
-              <a:off x="11866792" y="8913481"/>
+              <a:off x="12121973" y="8924114"/>
               <a:ext cx="267629" cy="267629"/>
             </a:xfrm>
             <a:prstGeom prst="ellipse">
@@ -17901,7 +17526,7 @@
           </p:nvSpPr>
           <p:spPr>
             <a:xfrm>
-              <a:off x="11866791" y="9373054"/>
+              <a:off x="12121972" y="9383687"/>
               <a:ext cx="267629" cy="267629"/>
             </a:xfrm>
             <a:prstGeom prst="ellipse">
@@ -17955,7 +17580,7 @@
           </p:nvSpPr>
           <p:spPr>
             <a:xfrm>
-              <a:off x="12156372" y="8408901"/>
+              <a:off x="12411553" y="8419534"/>
               <a:ext cx="1673663" cy="369332"/>
             </a:xfrm>
             <a:prstGeom prst="rect">
@@ -17990,7 +17615,7 @@
           </p:nvSpPr>
           <p:spPr>
             <a:xfrm>
-              <a:off x="12156372" y="8862629"/>
+              <a:off x="12411553" y="8873262"/>
               <a:ext cx="1400833" cy="369332"/>
             </a:xfrm>
             <a:prstGeom prst="rect">
@@ -18025,7 +17650,7 @@
           </p:nvSpPr>
           <p:spPr>
             <a:xfrm>
-              <a:off x="12156372" y="9322202"/>
+              <a:off x="12411553" y="9332835"/>
               <a:ext cx="1799980" cy="369332"/>
             </a:xfrm>
             <a:prstGeom prst="rect">
@@ -18046,12 +17671,57 @@
             </a:p>
           </p:txBody>
         </p:sp>
+        <p:sp>
+          <p:nvSpPr>
+            <p:cNvPr id="235" name="TextBox 234">
+              <a:extLst>
+                <a:ext uri="{FF2B5EF4-FFF2-40B4-BE49-F238E27FC236}">
+                  <a16:creationId xmlns:a16="http://schemas.microsoft.com/office/drawing/2014/main" id="{77D7C0AB-C5FA-CF36-50C6-FFFC45935BEB}"/>
+                </a:ext>
+              </a:extLst>
+            </p:cNvPr>
+            <p:cNvSpPr txBox="1"/>
+            <p:nvPr/>
+          </p:nvSpPr>
+          <p:spPr>
+            <a:xfrm>
+              <a:off x="7703904" y="8098255"/>
+              <a:ext cx="575607" cy="400110"/>
+            </a:xfrm>
+            <a:prstGeom prst="rect">
+              <a:avLst/>
+            </a:prstGeom>
+            <a:solidFill>
+              <a:schemeClr val="bg1"/>
+            </a:solidFill>
+            <a:ln w="19050">
+              <a:solidFill>
+                <a:schemeClr val="accent1">
+                  <a:shade val="15000"/>
+                </a:schemeClr>
+              </a:solidFill>
+              <a:prstDash val="sysDash"/>
+            </a:ln>
+          </p:spPr>
+          <p:txBody>
+            <a:bodyPr wrap="none" rtlCol="0">
+              <a:spAutoFit/>
+            </a:bodyPr>
+            <a:lstStyle/>
+            <a:p>
+              <a:r>
+                <a:rPr lang="en-US" sz="2000" dirty="0"/>
+                <a:t>Key</a:t>
+              </a:r>
+            </a:p>
+          </p:txBody>
+        </p:sp>
         <p:grpSp>
           <p:nvGrpSpPr>
-            <p:cNvPr id="17" name="Group 16">
-              <a:extLst>
-                <a:ext uri="{FF2B5EF4-FFF2-40B4-BE49-F238E27FC236}">
-                  <a16:creationId xmlns:a16="http://schemas.microsoft.com/office/drawing/2014/main" id="{6A6FB9AD-CEFF-370F-D268-AD54FC435EA4}"/>
+            <p:cNvPr id="13" name="Group 12">
+              <a:extLst>
+                <a:ext uri="{FF2B5EF4-FFF2-40B4-BE49-F238E27FC236}">
+                  <a16:creationId xmlns:a16="http://schemas.microsoft.com/office/drawing/2014/main" id="{18BEDD3B-D933-15D2-7522-A992F7991ABF}"/>
                 </a:ext>
               </a:extLst>
             </p:cNvPr>
@@ -18060,18 +17730,18 @@
           </p:nvGrpSpPr>
           <p:grpSpPr>
             <a:xfrm>
-              <a:off x="5340031" y="946448"/>
-              <a:ext cx="2042468" cy="473633"/>
-              <a:chOff x="-4846261" y="583986"/>
-              <a:chExt cx="2042468" cy="473633"/>
+              <a:off x="5780928" y="949292"/>
+              <a:ext cx="1671045" cy="473633"/>
+              <a:chOff x="343224" y="555912"/>
+              <a:chExt cx="1671045" cy="473633"/>
             </a:xfrm>
           </p:grpSpPr>
           <p:sp>
             <p:nvSpPr>
-              <p:cNvPr id="4" name="Rounded Rectangle 3">
+              <p:cNvPr id="3" name="Rounded Rectangle 2">
                 <a:extLst>
                   <a:ext uri="{FF2B5EF4-FFF2-40B4-BE49-F238E27FC236}">
-                    <a16:creationId xmlns:a16="http://schemas.microsoft.com/office/drawing/2014/main" id="{4CB7E85A-74DE-8F41-CDE2-E4CE9533CB0B}"/>
+                    <a16:creationId xmlns:a16="http://schemas.microsoft.com/office/drawing/2014/main" id="{7B1269EE-803F-0D02-DDBD-B7BCA712750D}"/>
                   </a:ext>
                 </a:extLst>
               </p:cNvPr>
@@ -18080,8 +17750,8 @@
             </p:nvSpPr>
             <p:spPr>
               <a:xfrm>
-                <a:off x="-4846261" y="583986"/>
-                <a:ext cx="2042468" cy="473633"/>
+                <a:off x="343224" y="555912"/>
+                <a:ext cx="1671045" cy="473633"/>
               </a:xfrm>
               <a:prstGeom prst="roundRect">
                 <a:avLst/>
@@ -18118,10 +17788,10 @@
           </p:sp>
           <p:sp>
             <p:nvSpPr>
-              <p:cNvPr id="5" name="Oval 4">
+              <p:cNvPr id="6" name="Oval 5">
                 <a:extLst>
                   <a:ext uri="{FF2B5EF4-FFF2-40B4-BE49-F238E27FC236}">
-                    <a16:creationId xmlns:a16="http://schemas.microsoft.com/office/drawing/2014/main" id="{C8850932-98D2-21D3-FA26-A4835580E2EA}"/>
+                    <a16:creationId xmlns:a16="http://schemas.microsoft.com/office/drawing/2014/main" id="{ABD0020E-2C4E-2A10-A214-48AF62A1B094}"/>
                   </a:ext>
                 </a:extLst>
               </p:cNvPr>
@@ -18130,7 +17800,7 @@
             </p:nvSpPr>
             <p:spPr>
               <a:xfrm>
-                <a:off x="-4723598" y="678771"/>
+                <a:off x="465887" y="650697"/>
                 <a:ext cx="267629" cy="267629"/>
               </a:xfrm>
               <a:prstGeom prst="ellipse">
@@ -18168,10 +17838,10 @@
           </p:sp>
           <p:sp>
             <p:nvSpPr>
-              <p:cNvPr id="7" name="Oval 6">
+              <p:cNvPr id="8" name="Oval 7">
                 <a:extLst>
                   <a:ext uri="{FF2B5EF4-FFF2-40B4-BE49-F238E27FC236}">
-                    <a16:creationId xmlns:a16="http://schemas.microsoft.com/office/drawing/2014/main" id="{8E080A93-7496-02C9-2FD7-433726C1D17A}"/>
+                    <a16:creationId xmlns:a16="http://schemas.microsoft.com/office/drawing/2014/main" id="{873CEA07-345C-9B7C-FADC-4FD05CD46EBD}"/>
                   </a:ext>
                 </a:extLst>
               </p:cNvPr>
@@ -18180,7 +17850,7 @@
             </p:nvSpPr>
             <p:spPr>
               <a:xfrm>
-                <a:off x="-4333307" y="678771"/>
+                <a:off x="856178" y="650697"/>
                 <a:ext cx="267629" cy="267629"/>
               </a:xfrm>
               <a:prstGeom prst="ellipse">
@@ -18218,10 +17888,10 @@
           </p:sp>
           <p:sp>
             <p:nvSpPr>
-              <p:cNvPr id="9" name="Oval 8">
+              <p:cNvPr id="10" name="Oval 9">
                 <a:extLst>
                   <a:ext uri="{FF2B5EF4-FFF2-40B4-BE49-F238E27FC236}">
-                    <a16:creationId xmlns:a16="http://schemas.microsoft.com/office/drawing/2014/main" id="{63AD1EAE-2667-13A3-F743-EC861DAF22BB}"/>
+                    <a16:creationId xmlns:a16="http://schemas.microsoft.com/office/drawing/2014/main" id="{78BAA630-1A49-ABF7-5C4F-97951032481D}"/>
                   </a:ext>
                 </a:extLst>
               </p:cNvPr>
@@ -18230,7 +17900,7 @@
             </p:nvSpPr>
             <p:spPr>
               <a:xfrm>
-                <a:off x="-3965321" y="678771"/>
+                <a:off x="1224164" y="650697"/>
                 <a:ext cx="267629" cy="267629"/>
               </a:xfrm>
               <a:prstGeom prst="ellipse">
@@ -18268,10 +17938,10 @@
           </p:sp>
           <p:sp>
             <p:nvSpPr>
-              <p:cNvPr id="15" name="Oval 14">
+              <p:cNvPr id="11" name="Oval 10">
                 <a:extLst>
                   <a:ext uri="{FF2B5EF4-FFF2-40B4-BE49-F238E27FC236}">
-                    <a16:creationId xmlns:a16="http://schemas.microsoft.com/office/drawing/2014/main" id="{D3B3AC56-ED2E-AFCC-5613-1A648E1B92D1}"/>
+                    <a16:creationId xmlns:a16="http://schemas.microsoft.com/office/drawing/2014/main" id="{AA0278AB-7ACD-6FC6-A8BB-A06EB5BDB080}"/>
                   </a:ext>
                 </a:extLst>
               </p:cNvPr>
@@ -18280,57 +17950,7 @@
             </p:nvSpPr>
             <p:spPr>
               <a:xfrm>
-                <a:off x="-3574981" y="681233"/>
-                <a:ext cx="267629" cy="267629"/>
-              </a:xfrm>
-              <a:prstGeom prst="ellipse">
-                <a:avLst/>
-              </a:prstGeom>
-              <a:solidFill>
-                <a:schemeClr val="bg2"/>
-              </a:solidFill>
-              <a:ln w="22225"/>
-            </p:spPr>
-            <p:style>
-              <a:lnRef idx="2">
-                <a:schemeClr val="accent1">
-                  <a:shade val="15000"/>
-                </a:schemeClr>
-              </a:lnRef>
-              <a:fillRef idx="1">
-                <a:schemeClr val="accent1"/>
-              </a:fillRef>
-              <a:effectRef idx="0">
-                <a:schemeClr val="accent1"/>
-              </a:effectRef>
-              <a:fontRef idx="minor">
-                <a:schemeClr val="lt1"/>
-              </a:fontRef>
-            </p:style>
-            <p:txBody>
-              <a:bodyPr rtlCol="0" anchor="ctr"/>
-              <a:lstStyle/>
-              <a:p>
-                <a:pPr algn="ctr"/>
-                <a:endParaRPr lang="en-US"/>
-              </a:p>
-            </p:txBody>
-          </p:sp>
-          <p:sp>
-            <p:nvSpPr>
-              <p:cNvPr id="16" name="Oval 15">
-                <a:extLst>
-                  <a:ext uri="{FF2B5EF4-FFF2-40B4-BE49-F238E27FC236}">
-                    <a16:creationId xmlns:a16="http://schemas.microsoft.com/office/drawing/2014/main" id="{D9533773-1BD2-B13C-7A54-8BBEF44F6BA0}"/>
-                  </a:ext>
-                </a:extLst>
-              </p:cNvPr>
-              <p:cNvSpPr/>
-              <p:nvPr/>
-            </p:nvSpPr>
-            <p:spPr>
-              <a:xfrm>
-                <a:off x="-3206995" y="681233"/>
+                <a:off x="1614504" y="653159"/>
                 <a:ext cx="267629" cy="267629"/>
               </a:xfrm>
               <a:prstGeom prst="ellipse">
@@ -18369,10 +17989,10 @@
         </p:grpSp>
         <p:grpSp>
           <p:nvGrpSpPr>
-            <p:cNvPr id="18" name="Group 17">
-              <a:extLst>
-                <a:ext uri="{FF2B5EF4-FFF2-40B4-BE49-F238E27FC236}">
-                  <a16:creationId xmlns:a16="http://schemas.microsoft.com/office/drawing/2014/main" id="{7F0EF33E-0241-B99A-9745-5B1C303EBD40}"/>
+            <p:cNvPr id="14" name="Group 13">
+              <a:extLst>
+                <a:ext uri="{FF2B5EF4-FFF2-40B4-BE49-F238E27FC236}">
+                  <a16:creationId xmlns:a16="http://schemas.microsoft.com/office/drawing/2014/main" id="{A2354EEC-2A47-EE60-73CE-A4DF5E0CD61E}"/>
                 </a:ext>
               </a:extLst>
             </p:cNvPr>
@@ -18381,18 +18001,18 @@
           </p:nvGrpSpPr>
           <p:grpSpPr>
             <a:xfrm>
-              <a:off x="389440" y="3964459"/>
-              <a:ext cx="2042468" cy="473633"/>
-              <a:chOff x="-4846261" y="583986"/>
-              <a:chExt cx="2042468" cy="473633"/>
+              <a:off x="830332" y="3976516"/>
+              <a:ext cx="1671045" cy="473633"/>
+              <a:chOff x="343224" y="555912"/>
+              <a:chExt cx="1671045" cy="473633"/>
             </a:xfrm>
           </p:grpSpPr>
           <p:sp>
             <p:nvSpPr>
-              <p:cNvPr id="19" name="Rounded Rectangle 18">
+              <p:cNvPr id="30" name="Rounded Rectangle 29">
                 <a:extLst>
                   <a:ext uri="{FF2B5EF4-FFF2-40B4-BE49-F238E27FC236}">
-                    <a16:creationId xmlns:a16="http://schemas.microsoft.com/office/drawing/2014/main" id="{EED0A924-CDAE-B69C-CF49-4BCE900FBDBB}"/>
+                    <a16:creationId xmlns:a16="http://schemas.microsoft.com/office/drawing/2014/main" id="{5EE1C7A5-D013-1733-4188-F3A770999077}"/>
                   </a:ext>
                 </a:extLst>
               </p:cNvPr>
@@ -18401,8 +18021,8 @@
             </p:nvSpPr>
             <p:spPr>
               <a:xfrm>
-                <a:off x="-4846261" y="583986"/>
-                <a:ext cx="2042468" cy="473633"/>
+                <a:off x="343224" y="555912"/>
+                <a:ext cx="1671045" cy="473633"/>
               </a:xfrm>
               <a:prstGeom prst="roundRect">
                 <a:avLst/>
@@ -18439,10 +18059,10 @@
           </p:sp>
           <p:sp>
             <p:nvSpPr>
-              <p:cNvPr id="20" name="Oval 19">
+              <p:cNvPr id="31" name="Oval 30">
                 <a:extLst>
                   <a:ext uri="{FF2B5EF4-FFF2-40B4-BE49-F238E27FC236}">
-                    <a16:creationId xmlns:a16="http://schemas.microsoft.com/office/drawing/2014/main" id="{210238D1-84E7-4D73-E03C-93D2AABD2F4D}"/>
+                    <a16:creationId xmlns:a16="http://schemas.microsoft.com/office/drawing/2014/main" id="{531215EC-11F6-DB2A-0B97-473DBFAE0649}"/>
                   </a:ext>
                 </a:extLst>
               </p:cNvPr>
@@ -18451,7 +18071,7 @@
             </p:nvSpPr>
             <p:spPr>
               <a:xfrm>
-                <a:off x="-4723598" y="678771"/>
+                <a:off x="465887" y="650697"/>
                 <a:ext cx="267629" cy="267629"/>
               </a:xfrm>
               <a:prstGeom prst="ellipse">
@@ -18489,10 +18109,10 @@
           </p:sp>
           <p:sp>
             <p:nvSpPr>
-              <p:cNvPr id="21" name="Oval 20">
+              <p:cNvPr id="32" name="Oval 31">
                 <a:extLst>
                   <a:ext uri="{FF2B5EF4-FFF2-40B4-BE49-F238E27FC236}">
-                    <a16:creationId xmlns:a16="http://schemas.microsoft.com/office/drawing/2014/main" id="{8067705C-D380-DEE2-3328-BAC1561EA6EF}"/>
+                    <a16:creationId xmlns:a16="http://schemas.microsoft.com/office/drawing/2014/main" id="{613CD9D3-C21A-E19B-8C8E-7B44A70FE67D}"/>
                   </a:ext>
                 </a:extLst>
               </p:cNvPr>
@@ -18501,7 +18121,7 @@
             </p:nvSpPr>
             <p:spPr>
               <a:xfrm>
-                <a:off x="-4333307" y="678771"/>
+                <a:off x="856178" y="650697"/>
                 <a:ext cx="267629" cy="267629"/>
               </a:xfrm>
               <a:prstGeom prst="ellipse">
@@ -18539,10 +18159,10 @@
           </p:sp>
           <p:sp>
             <p:nvSpPr>
-              <p:cNvPr id="22" name="Oval 21">
+              <p:cNvPr id="33" name="Oval 32">
                 <a:extLst>
                   <a:ext uri="{FF2B5EF4-FFF2-40B4-BE49-F238E27FC236}">
-                    <a16:creationId xmlns:a16="http://schemas.microsoft.com/office/drawing/2014/main" id="{3008032A-E6D4-03C0-E225-4F459C4408E2}"/>
+                    <a16:creationId xmlns:a16="http://schemas.microsoft.com/office/drawing/2014/main" id="{928F5E96-F737-8A58-9070-B6217F9ADC10}"/>
                   </a:ext>
                 </a:extLst>
               </p:cNvPr>
@@ -18551,7 +18171,7 @@
             </p:nvSpPr>
             <p:spPr>
               <a:xfrm>
-                <a:off x="-3965321" y="678771"/>
+                <a:off x="1224164" y="650697"/>
                 <a:ext cx="267629" cy="267629"/>
               </a:xfrm>
               <a:prstGeom prst="ellipse">
@@ -18589,10 +18209,10 @@
           </p:sp>
           <p:sp>
             <p:nvSpPr>
-              <p:cNvPr id="23" name="Oval 22">
+              <p:cNvPr id="34" name="Oval 33">
                 <a:extLst>
                   <a:ext uri="{FF2B5EF4-FFF2-40B4-BE49-F238E27FC236}">
-                    <a16:creationId xmlns:a16="http://schemas.microsoft.com/office/drawing/2014/main" id="{CA5C127E-E199-0BB8-08F3-67019A83E4EC}"/>
+                    <a16:creationId xmlns:a16="http://schemas.microsoft.com/office/drawing/2014/main" id="{0C91DBE6-9984-EEC1-9FFF-32CAB10E34DF}"/>
                   </a:ext>
                 </a:extLst>
               </p:cNvPr>
@@ -18601,57 +18221,7 @@
             </p:nvSpPr>
             <p:spPr>
               <a:xfrm>
-                <a:off x="-3574981" y="681233"/>
-                <a:ext cx="267629" cy="267629"/>
-              </a:xfrm>
-              <a:prstGeom prst="ellipse">
-                <a:avLst/>
-              </a:prstGeom>
-              <a:solidFill>
-                <a:schemeClr val="bg2"/>
-              </a:solidFill>
-              <a:ln w="22225"/>
-            </p:spPr>
-            <p:style>
-              <a:lnRef idx="2">
-                <a:schemeClr val="accent1">
-                  <a:shade val="15000"/>
-                </a:schemeClr>
-              </a:lnRef>
-              <a:fillRef idx="1">
-                <a:schemeClr val="accent1"/>
-              </a:fillRef>
-              <a:effectRef idx="0">
-                <a:schemeClr val="accent1"/>
-              </a:effectRef>
-              <a:fontRef idx="minor">
-                <a:schemeClr val="lt1"/>
-              </a:fontRef>
-            </p:style>
-            <p:txBody>
-              <a:bodyPr rtlCol="0" anchor="ctr"/>
-              <a:lstStyle/>
-              <a:p>
-                <a:pPr algn="ctr"/>
-                <a:endParaRPr lang="en-US"/>
-              </a:p>
-            </p:txBody>
-          </p:sp>
-          <p:sp>
-            <p:nvSpPr>
-              <p:cNvPr id="24" name="Oval 23">
-                <a:extLst>
-                  <a:ext uri="{FF2B5EF4-FFF2-40B4-BE49-F238E27FC236}">
-                    <a16:creationId xmlns:a16="http://schemas.microsoft.com/office/drawing/2014/main" id="{8E8E94DC-5271-C51C-C9C5-B7078E3A3D65}"/>
-                  </a:ext>
-                </a:extLst>
-              </p:cNvPr>
-              <p:cNvSpPr/>
-              <p:nvPr/>
-            </p:nvSpPr>
-            <p:spPr>
-              <a:xfrm>
-                <a:off x="-3206995" y="681233"/>
+                <a:off x="1614504" y="653159"/>
                 <a:ext cx="267629" cy="267629"/>
               </a:xfrm>
               <a:prstGeom prst="ellipse">
@@ -18690,10 +18260,10 @@
         </p:grpSp>
         <p:grpSp>
           <p:nvGrpSpPr>
-            <p:cNvPr id="25" name="Group 24">
-              <a:extLst>
-                <a:ext uri="{FF2B5EF4-FFF2-40B4-BE49-F238E27FC236}">
-                  <a16:creationId xmlns:a16="http://schemas.microsoft.com/office/drawing/2014/main" id="{F0420CA2-4417-9DDA-A420-D39AA7316D0B}"/>
+            <p:cNvPr id="35" name="Group 34">
+              <a:extLst>
+                <a:ext uri="{FF2B5EF4-FFF2-40B4-BE49-F238E27FC236}">
+                  <a16:creationId xmlns:a16="http://schemas.microsoft.com/office/drawing/2014/main" id="{F6613A23-8992-5756-682B-6953C355C6B1}"/>
                 </a:ext>
               </a:extLst>
             </p:cNvPr>
@@ -18702,18 +18272,18 @@
           </p:nvGrpSpPr>
           <p:grpSpPr>
             <a:xfrm>
-              <a:off x="3645592" y="3965558"/>
-              <a:ext cx="2042468" cy="473633"/>
-              <a:chOff x="-4846261" y="583986"/>
-              <a:chExt cx="2042468" cy="473633"/>
+              <a:off x="4086484" y="3976191"/>
+              <a:ext cx="1671045" cy="473633"/>
+              <a:chOff x="343224" y="555912"/>
+              <a:chExt cx="1671045" cy="473633"/>
             </a:xfrm>
           </p:grpSpPr>
           <p:sp>
             <p:nvSpPr>
-              <p:cNvPr id="26" name="Rounded Rectangle 25">
+              <p:cNvPr id="36" name="Rounded Rectangle 35">
                 <a:extLst>
                   <a:ext uri="{FF2B5EF4-FFF2-40B4-BE49-F238E27FC236}">
-                    <a16:creationId xmlns:a16="http://schemas.microsoft.com/office/drawing/2014/main" id="{025C2D03-F3DF-8E6C-71E8-27D7E6323C47}"/>
+                    <a16:creationId xmlns:a16="http://schemas.microsoft.com/office/drawing/2014/main" id="{7C1E1C08-B98E-BBD1-F52B-34E0C716F586}"/>
                   </a:ext>
                 </a:extLst>
               </p:cNvPr>
@@ -18722,8 +18292,8 @@
             </p:nvSpPr>
             <p:spPr>
               <a:xfrm>
-                <a:off x="-4846261" y="583986"/>
-                <a:ext cx="2042468" cy="473633"/>
+                <a:off x="343224" y="555912"/>
+                <a:ext cx="1671045" cy="473633"/>
               </a:xfrm>
               <a:prstGeom prst="roundRect">
                 <a:avLst/>
@@ -18760,10 +18330,10 @@
           </p:sp>
           <p:sp>
             <p:nvSpPr>
-              <p:cNvPr id="27" name="Oval 26">
+              <p:cNvPr id="37" name="Oval 36">
                 <a:extLst>
                   <a:ext uri="{FF2B5EF4-FFF2-40B4-BE49-F238E27FC236}">
-                    <a16:creationId xmlns:a16="http://schemas.microsoft.com/office/drawing/2014/main" id="{985730C1-6C56-FEC1-41A0-1A33F746B011}"/>
+                    <a16:creationId xmlns:a16="http://schemas.microsoft.com/office/drawing/2014/main" id="{A9B7E52D-398D-95FD-39EB-03CA3382FCBC}"/>
                   </a:ext>
                 </a:extLst>
               </p:cNvPr>
@@ -18772,7 +18342,7 @@
             </p:nvSpPr>
             <p:spPr>
               <a:xfrm>
-                <a:off x="-4723598" y="678771"/>
+                <a:off x="465887" y="650697"/>
                 <a:ext cx="267629" cy="267629"/>
               </a:xfrm>
               <a:prstGeom prst="ellipse">
@@ -18810,10 +18380,10 @@
           </p:sp>
           <p:sp>
             <p:nvSpPr>
-              <p:cNvPr id="28" name="Oval 27">
+              <p:cNvPr id="39" name="Oval 38">
                 <a:extLst>
                   <a:ext uri="{FF2B5EF4-FFF2-40B4-BE49-F238E27FC236}">
-                    <a16:creationId xmlns:a16="http://schemas.microsoft.com/office/drawing/2014/main" id="{FF9ECF22-9880-8BE9-031D-B84FF85CF7B1}"/>
+                    <a16:creationId xmlns:a16="http://schemas.microsoft.com/office/drawing/2014/main" id="{B0509D31-3E9D-1F44-8430-91D197F6FACD}"/>
                   </a:ext>
                 </a:extLst>
               </p:cNvPr>
@@ -18822,7 +18392,7 @@
             </p:nvSpPr>
             <p:spPr>
               <a:xfrm>
-                <a:off x="-4333307" y="678771"/>
+                <a:off x="856178" y="650697"/>
                 <a:ext cx="267629" cy="267629"/>
               </a:xfrm>
               <a:prstGeom prst="ellipse">
@@ -18860,10 +18430,10 @@
           </p:sp>
           <p:sp>
             <p:nvSpPr>
-              <p:cNvPr id="29" name="Oval 28">
+              <p:cNvPr id="40" name="Oval 39">
                 <a:extLst>
                   <a:ext uri="{FF2B5EF4-FFF2-40B4-BE49-F238E27FC236}">
-                    <a16:creationId xmlns:a16="http://schemas.microsoft.com/office/drawing/2014/main" id="{D9F9DDF4-66B1-291B-7865-39685EC77173}"/>
+                    <a16:creationId xmlns:a16="http://schemas.microsoft.com/office/drawing/2014/main" id="{E783B98D-A97F-C5FC-01C0-15929E446448}"/>
                   </a:ext>
                 </a:extLst>
               </p:cNvPr>
@@ -18872,7 +18442,7 @@
             </p:nvSpPr>
             <p:spPr>
               <a:xfrm>
-                <a:off x="-3965321" y="678771"/>
+                <a:off x="1224164" y="650697"/>
                 <a:ext cx="267629" cy="267629"/>
               </a:xfrm>
               <a:prstGeom prst="ellipse">
@@ -18910,10 +18480,10 @@
           </p:sp>
           <p:sp>
             <p:nvSpPr>
-              <p:cNvPr id="38" name="Oval 37">
+              <p:cNvPr id="41" name="Oval 40">
                 <a:extLst>
                   <a:ext uri="{FF2B5EF4-FFF2-40B4-BE49-F238E27FC236}">
-                    <a16:creationId xmlns:a16="http://schemas.microsoft.com/office/drawing/2014/main" id="{F36EE89F-A9E2-CE0A-4124-8D908E05E28F}"/>
+                    <a16:creationId xmlns:a16="http://schemas.microsoft.com/office/drawing/2014/main" id="{BF02967A-A49F-9E48-2A95-E666F7795DEC}"/>
                   </a:ext>
                 </a:extLst>
               </p:cNvPr>
@@ -18922,57 +18492,7 @@
             </p:nvSpPr>
             <p:spPr>
               <a:xfrm>
-                <a:off x="-3574981" y="681233"/>
-                <a:ext cx="267629" cy="267629"/>
-              </a:xfrm>
-              <a:prstGeom prst="ellipse">
-                <a:avLst/>
-              </a:prstGeom>
-              <a:solidFill>
-                <a:srgbClr val="FF0000"/>
-              </a:solidFill>
-              <a:ln w="22225"/>
-            </p:spPr>
-            <p:style>
-              <a:lnRef idx="2">
-                <a:schemeClr val="accent1">
-                  <a:shade val="15000"/>
-                </a:schemeClr>
-              </a:lnRef>
-              <a:fillRef idx="1">
-                <a:schemeClr val="accent1"/>
-              </a:fillRef>
-              <a:effectRef idx="0">
-                <a:schemeClr val="accent1"/>
-              </a:effectRef>
-              <a:fontRef idx="minor">
-                <a:schemeClr val="lt1"/>
-              </a:fontRef>
-            </p:style>
-            <p:txBody>
-              <a:bodyPr rtlCol="0" anchor="ctr"/>
-              <a:lstStyle/>
-              <a:p>
-                <a:pPr algn="ctr"/>
-                <a:endParaRPr lang="en-US"/>
-              </a:p>
-            </p:txBody>
-          </p:sp>
-          <p:sp>
-            <p:nvSpPr>
-              <p:cNvPr id="144" name="Oval 143">
-                <a:extLst>
-                  <a:ext uri="{FF2B5EF4-FFF2-40B4-BE49-F238E27FC236}">
-                    <a16:creationId xmlns:a16="http://schemas.microsoft.com/office/drawing/2014/main" id="{3382AFD5-7381-3132-D54E-57DCC0259AE6}"/>
-                  </a:ext>
-                </a:extLst>
-              </p:cNvPr>
-              <p:cNvSpPr/>
-              <p:nvPr/>
-            </p:nvSpPr>
-            <p:spPr>
-              <a:xfrm>
-                <a:off x="-3206995" y="681233"/>
+                <a:off x="1614504" y="653159"/>
                 <a:ext cx="267629" cy="267629"/>
               </a:xfrm>
               <a:prstGeom prst="ellipse">
@@ -19011,10 +18531,10 @@
         </p:grpSp>
         <p:grpSp>
           <p:nvGrpSpPr>
-            <p:cNvPr id="147" name="Group 146">
-              <a:extLst>
-                <a:ext uri="{FF2B5EF4-FFF2-40B4-BE49-F238E27FC236}">
-                  <a16:creationId xmlns:a16="http://schemas.microsoft.com/office/drawing/2014/main" id="{C7AABAF7-D364-D468-AF58-5C7C6B79732E}"/>
+            <p:cNvPr id="42" name="Group 41">
+              <a:extLst>
+                <a:ext uri="{FF2B5EF4-FFF2-40B4-BE49-F238E27FC236}">
+                  <a16:creationId xmlns:a16="http://schemas.microsoft.com/office/drawing/2014/main" id="{45603744-A350-C330-1239-F697AA631B9F}"/>
                 </a:ext>
               </a:extLst>
             </p:cNvPr>
@@ -19023,18 +18543,18 @@
           </p:nvGrpSpPr>
           <p:grpSpPr>
             <a:xfrm>
-              <a:off x="6944676" y="3996148"/>
-              <a:ext cx="2042468" cy="473633"/>
-              <a:chOff x="-4846261" y="583986"/>
-              <a:chExt cx="2042468" cy="473633"/>
+              <a:off x="7373001" y="4006781"/>
+              <a:ext cx="1671045" cy="473633"/>
+              <a:chOff x="343224" y="555912"/>
+              <a:chExt cx="1671045" cy="473633"/>
             </a:xfrm>
           </p:grpSpPr>
           <p:sp>
             <p:nvSpPr>
-              <p:cNvPr id="148" name="Rounded Rectangle 147">
+              <p:cNvPr id="43" name="Rounded Rectangle 42">
                 <a:extLst>
                   <a:ext uri="{FF2B5EF4-FFF2-40B4-BE49-F238E27FC236}">
-                    <a16:creationId xmlns:a16="http://schemas.microsoft.com/office/drawing/2014/main" id="{14E03437-72E6-BBA4-956A-896FA1D9FD8A}"/>
+                    <a16:creationId xmlns:a16="http://schemas.microsoft.com/office/drawing/2014/main" id="{FE757683-A5D3-D9A7-DE27-56D1B7710E3F}"/>
                   </a:ext>
                 </a:extLst>
               </p:cNvPr>
@@ -19043,8 +18563,8 @@
             </p:nvSpPr>
             <p:spPr>
               <a:xfrm>
-                <a:off x="-4846261" y="583986"/>
-                <a:ext cx="2042468" cy="473633"/>
+                <a:off x="343224" y="555912"/>
+                <a:ext cx="1671045" cy="473633"/>
               </a:xfrm>
               <a:prstGeom prst="roundRect">
                 <a:avLst/>
@@ -19081,10 +18601,10 @@
           </p:sp>
           <p:sp>
             <p:nvSpPr>
-              <p:cNvPr id="150" name="Oval 149">
+              <p:cNvPr id="44" name="Oval 43">
                 <a:extLst>
                   <a:ext uri="{FF2B5EF4-FFF2-40B4-BE49-F238E27FC236}">
-                    <a16:creationId xmlns:a16="http://schemas.microsoft.com/office/drawing/2014/main" id="{B961F2FD-A388-D4F4-3C77-E228B4DFDB49}"/>
+                    <a16:creationId xmlns:a16="http://schemas.microsoft.com/office/drawing/2014/main" id="{E603DB83-8CF7-35D8-0290-2EC10BEE825D}"/>
                   </a:ext>
                 </a:extLst>
               </p:cNvPr>
@@ -19093,7 +18613,7 @@
             </p:nvSpPr>
             <p:spPr>
               <a:xfrm>
-                <a:off x="-4723598" y="678771"/>
+                <a:off x="465887" y="650697"/>
                 <a:ext cx="267629" cy="267629"/>
               </a:xfrm>
               <a:prstGeom prst="ellipse">
@@ -19131,10 +18651,10 @@
           </p:sp>
           <p:sp>
             <p:nvSpPr>
-              <p:cNvPr id="151" name="Oval 150">
+              <p:cNvPr id="45" name="Oval 44">
                 <a:extLst>
                   <a:ext uri="{FF2B5EF4-FFF2-40B4-BE49-F238E27FC236}">
-                    <a16:creationId xmlns:a16="http://schemas.microsoft.com/office/drawing/2014/main" id="{DF908C2F-AFD7-65E4-0B02-F1A34BA966B7}"/>
+                    <a16:creationId xmlns:a16="http://schemas.microsoft.com/office/drawing/2014/main" id="{B6290318-F576-1A0B-0EFC-14BB6C464674}"/>
                   </a:ext>
                 </a:extLst>
               </p:cNvPr>
@@ -19143,7 +18663,7 @@
             </p:nvSpPr>
             <p:spPr>
               <a:xfrm>
-                <a:off x="-4333307" y="678771"/>
+                <a:off x="856178" y="650697"/>
                 <a:ext cx="267629" cy="267629"/>
               </a:xfrm>
               <a:prstGeom prst="ellipse">
@@ -19181,10 +18701,10 @@
           </p:sp>
           <p:sp>
             <p:nvSpPr>
-              <p:cNvPr id="152" name="Oval 151">
+              <p:cNvPr id="46" name="Oval 45">
                 <a:extLst>
                   <a:ext uri="{FF2B5EF4-FFF2-40B4-BE49-F238E27FC236}">
-                    <a16:creationId xmlns:a16="http://schemas.microsoft.com/office/drawing/2014/main" id="{09B93D00-89BE-47C7-BA05-B5259BFA776F}"/>
+                    <a16:creationId xmlns:a16="http://schemas.microsoft.com/office/drawing/2014/main" id="{D0FB732C-BE70-FACE-C580-39387E0EFE36}"/>
                   </a:ext>
                 </a:extLst>
               </p:cNvPr>
@@ -19193,7 +18713,7 @@
             </p:nvSpPr>
             <p:spPr>
               <a:xfrm>
-                <a:off x="-3965321" y="678771"/>
+                <a:off x="1224164" y="650697"/>
                 <a:ext cx="267629" cy="267629"/>
               </a:xfrm>
               <a:prstGeom prst="ellipse">
@@ -19231,10 +18751,10 @@
           </p:sp>
           <p:sp>
             <p:nvSpPr>
-              <p:cNvPr id="153" name="Oval 152">
+              <p:cNvPr id="47" name="Oval 46">
                 <a:extLst>
                   <a:ext uri="{FF2B5EF4-FFF2-40B4-BE49-F238E27FC236}">
-                    <a16:creationId xmlns:a16="http://schemas.microsoft.com/office/drawing/2014/main" id="{01AD31AE-A698-CCE5-DB1E-148F14509709}"/>
+                    <a16:creationId xmlns:a16="http://schemas.microsoft.com/office/drawing/2014/main" id="{205E0C5D-0E85-EA82-7DA7-072D1E7928E7}"/>
                   </a:ext>
                 </a:extLst>
               </p:cNvPr>
@@ -19243,57 +18763,7 @@
             </p:nvSpPr>
             <p:spPr>
               <a:xfrm>
-                <a:off x="-3574981" y="681233"/>
-                <a:ext cx="267629" cy="267629"/>
-              </a:xfrm>
-              <a:prstGeom prst="ellipse">
-                <a:avLst/>
-              </a:prstGeom>
-              <a:solidFill>
-                <a:srgbClr val="FF0000"/>
-              </a:solidFill>
-              <a:ln w="22225"/>
-            </p:spPr>
-            <p:style>
-              <a:lnRef idx="2">
-                <a:schemeClr val="accent1">
-                  <a:shade val="15000"/>
-                </a:schemeClr>
-              </a:lnRef>
-              <a:fillRef idx="1">
-                <a:schemeClr val="accent1"/>
-              </a:fillRef>
-              <a:effectRef idx="0">
-                <a:schemeClr val="accent1"/>
-              </a:effectRef>
-              <a:fontRef idx="minor">
-                <a:schemeClr val="lt1"/>
-              </a:fontRef>
-            </p:style>
-            <p:txBody>
-              <a:bodyPr rtlCol="0" anchor="ctr"/>
-              <a:lstStyle/>
-              <a:p>
-                <a:pPr algn="ctr"/>
-                <a:endParaRPr lang="en-US"/>
-              </a:p>
-            </p:txBody>
-          </p:sp>
-          <p:sp>
-            <p:nvSpPr>
-              <p:cNvPr id="155" name="Oval 154">
-                <a:extLst>
-                  <a:ext uri="{FF2B5EF4-FFF2-40B4-BE49-F238E27FC236}">
-                    <a16:creationId xmlns:a16="http://schemas.microsoft.com/office/drawing/2014/main" id="{3D0BA777-3C6C-173B-CCC8-E99AE3E6C507}"/>
-                  </a:ext>
-                </a:extLst>
-              </p:cNvPr>
-              <p:cNvSpPr/>
-              <p:nvPr/>
-            </p:nvSpPr>
-            <p:spPr>
-              <a:xfrm>
-                <a:off x="-3206995" y="681233"/>
+                <a:off x="1614504" y="653159"/>
                 <a:ext cx="267629" cy="267629"/>
               </a:xfrm>
               <a:prstGeom prst="ellipse">
@@ -19332,10 +18802,10 @@
         </p:grpSp>
         <p:grpSp>
           <p:nvGrpSpPr>
-            <p:cNvPr id="156" name="Group 155">
-              <a:extLst>
-                <a:ext uri="{FF2B5EF4-FFF2-40B4-BE49-F238E27FC236}">
-                  <a16:creationId xmlns:a16="http://schemas.microsoft.com/office/drawing/2014/main" id="{CFE256D3-04E8-442A-1DA6-CA6327002990}"/>
+            <p:cNvPr id="48" name="Group 47">
+              <a:extLst>
+                <a:ext uri="{FF2B5EF4-FFF2-40B4-BE49-F238E27FC236}">
+                  <a16:creationId xmlns:a16="http://schemas.microsoft.com/office/drawing/2014/main" id="{DAAC3E4F-60BB-6972-3BD5-09841070F7AA}"/>
                 </a:ext>
               </a:extLst>
             </p:cNvPr>
@@ -19344,18 +18814,18 @@
           </p:nvGrpSpPr>
           <p:grpSpPr>
             <a:xfrm>
-              <a:off x="10211787" y="3966919"/>
-              <a:ext cx="2042468" cy="473633"/>
-              <a:chOff x="-4846261" y="583986"/>
-              <a:chExt cx="2042468" cy="473633"/>
+              <a:off x="10638112" y="3977552"/>
+              <a:ext cx="1671045" cy="473633"/>
+              <a:chOff x="343224" y="555912"/>
+              <a:chExt cx="1671045" cy="473633"/>
             </a:xfrm>
           </p:grpSpPr>
           <p:sp>
             <p:nvSpPr>
-              <p:cNvPr id="157" name="Rounded Rectangle 156">
+              <p:cNvPr id="49" name="Rounded Rectangle 48">
                 <a:extLst>
                   <a:ext uri="{FF2B5EF4-FFF2-40B4-BE49-F238E27FC236}">
-                    <a16:creationId xmlns:a16="http://schemas.microsoft.com/office/drawing/2014/main" id="{8B7D9BE0-E83E-D30A-5123-08A47EBC92EC}"/>
+                    <a16:creationId xmlns:a16="http://schemas.microsoft.com/office/drawing/2014/main" id="{AF2858D9-DBA1-958F-9999-FA8335E8D0D2}"/>
                   </a:ext>
                 </a:extLst>
               </p:cNvPr>
@@ -19364,8 +18834,8 @@
             </p:nvSpPr>
             <p:spPr>
               <a:xfrm>
-                <a:off x="-4846261" y="583986"/>
-                <a:ext cx="2042468" cy="473633"/>
+                <a:off x="343224" y="555912"/>
+                <a:ext cx="1671045" cy="473633"/>
               </a:xfrm>
               <a:prstGeom prst="roundRect">
                 <a:avLst/>
@@ -19402,10 +18872,10 @@
           </p:sp>
           <p:sp>
             <p:nvSpPr>
-              <p:cNvPr id="158" name="Oval 157">
+              <p:cNvPr id="50" name="Oval 49">
                 <a:extLst>
                   <a:ext uri="{FF2B5EF4-FFF2-40B4-BE49-F238E27FC236}">
-                    <a16:creationId xmlns:a16="http://schemas.microsoft.com/office/drawing/2014/main" id="{4A256447-0243-7B31-27E5-498FF1585366}"/>
+                    <a16:creationId xmlns:a16="http://schemas.microsoft.com/office/drawing/2014/main" id="{54C36190-E5E9-7F10-3A61-752B0484AFED}"/>
                   </a:ext>
                 </a:extLst>
               </p:cNvPr>
@@ -19414,7 +18884,7 @@
             </p:nvSpPr>
             <p:spPr>
               <a:xfrm>
-                <a:off x="-4723598" y="678771"/>
+                <a:off x="465887" y="650697"/>
                 <a:ext cx="267629" cy="267629"/>
               </a:xfrm>
               <a:prstGeom prst="ellipse">
@@ -19452,10 +18922,10 @@
           </p:sp>
           <p:sp>
             <p:nvSpPr>
-              <p:cNvPr id="159" name="Oval 158">
+              <p:cNvPr id="51" name="Oval 50">
                 <a:extLst>
                   <a:ext uri="{FF2B5EF4-FFF2-40B4-BE49-F238E27FC236}">
-                    <a16:creationId xmlns:a16="http://schemas.microsoft.com/office/drawing/2014/main" id="{90374730-F617-8011-1103-9F905254F4D9}"/>
+                    <a16:creationId xmlns:a16="http://schemas.microsoft.com/office/drawing/2014/main" id="{1D2C1EBF-5248-E1EC-FA1E-33A56ED9B59A}"/>
                   </a:ext>
                 </a:extLst>
               </p:cNvPr>
@@ -19464,7 +18934,7 @@
             </p:nvSpPr>
             <p:spPr>
               <a:xfrm>
-                <a:off x="-4333307" y="678771"/>
+                <a:off x="856178" y="650697"/>
                 <a:ext cx="267629" cy="267629"/>
               </a:xfrm>
               <a:prstGeom prst="ellipse">
@@ -19502,10 +18972,10 @@
           </p:sp>
           <p:sp>
             <p:nvSpPr>
-              <p:cNvPr id="160" name="Oval 159">
+              <p:cNvPr id="52" name="Oval 51">
                 <a:extLst>
                   <a:ext uri="{FF2B5EF4-FFF2-40B4-BE49-F238E27FC236}">
-                    <a16:creationId xmlns:a16="http://schemas.microsoft.com/office/drawing/2014/main" id="{E8760936-9F5F-E1F8-EAC3-97B114EFAA97}"/>
+                    <a16:creationId xmlns:a16="http://schemas.microsoft.com/office/drawing/2014/main" id="{9D7331E2-155A-FDF3-6252-37B3991F927E}"/>
                   </a:ext>
                 </a:extLst>
               </p:cNvPr>
@@ -19514,7 +18984,7 @@
             </p:nvSpPr>
             <p:spPr>
               <a:xfrm>
-                <a:off x="-3965321" y="678771"/>
+                <a:off x="1224164" y="650697"/>
                 <a:ext cx="267629" cy="267629"/>
               </a:xfrm>
               <a:prstGeom prst="ellipse">
@@ -19552,10 +19022,10 @@
           </p:sp>
           <p:sp>
             <p:nvSpPr>
-              <p:cNvPr id="162" name="Oval 161">
+              <p:cNvPr id="53" name="Oval 52">
                 <a:extLst>
                   <a:ext uri="{FF2B5EF4-FFF2-40B4-BE49-F238E27FC236}">
-                    <a16:creationId xmlns:a16="http://schemas.microsoft.com/office/drawing/2014/main" id="{6F20D6C5-B10F-3A1E-E87A-5C72FC433CC3}"/>
+                    <a16:creationId xmlns:a16="http://schemas.microsoft.com/office/drawing/2014/main" id="{B4D888DE-C45F-7C7A-49FE-7FB6D9EAE5C5}"/>
                   </a:ext>
                 </a:extLst>
               </p:cNvPr>
@@ -19564,57 +19034,7 @@
             </p:nvSpPr>
             <p:spPr>
               <a:xfrm>
-                <a:off x="-3574981" y="681233"/>
-                <a:ext cx="267629" cy="267629"/>
-              </a:xfrm>
-              <a:prstGeom prst="ellipse">
-                <a:avLst/>
-              </a:prstGeom>
-              <a:solidFill>
-                <a:schemeClr val="bg2"/>
-              </a:solidFill>
-              <a:ln w="22225"/>
-            </p:spPr>
-            <p:style>
-              <a:lnRef idx="2">
-                <a:schemeClr val="accent1">
-                  <a:shade val="15000"/>
-                </a:schemeClr>
-              </a:lnRef>
-              <a:fillRef idx="1">
-                <a:schemeClr val="accent1"/>
-              </a:fillRef>
-              <a:effectRef idx="0">
-                <a:schemeClr val="accent1"/>
-              </a:effectRef>
-              <a:fontRef idx="minor">
-                <a:schemeClr val="lt1"/>
-              </a:fontRef>
-            </p:style>
-            <p:txBody>
-              <a:bodyPr rtlCol="0" anchor="ctr"/>
-              <a:lstStyle/>
-              <a:p>
-                <a:pPr algn="ctr"/>
-                <a:endParaRPr lang="en-US"/>
-              </a:p>
-            </p:txBody>
-          </p:sp>
-          <p:sp>
-            <p:nvSpPr>
-              <p:cNvPr id="163" name="Oval 162">
-                <a:extLst>
-                  <a:ext uri="{FF2B5EF4-FFF2-40B4-BE49-F238E27FC236}">
-                    <a16:creationId xmlns:a16="http://schemas.microsoft.com/office/drawing/2014/main" id="{FE7CB567-D3C7-C346-89D6-EC104DF3B76F}"/>
-                  </a:ext>
-                </a:extLst>
-              </p:cNvPr>
-              <p:cNvSpPr/>
-              <p:nvPr/>
-            </p:nvSpPr>
-            <p:spPr>
-              <a:xfrm>
-                <a:off x="-3206995" y="681233"/>
+                <a:off x="1614504" y="653159"/>
                 <a:ext cx="267629" cy="267629"/>
               </a:xfrm>
               <a:prstGeom prst="ellipse">
@@ -19653,10 +19073,10 @@
         </p:grpSp>
         <p:grpSp>
           <p:nvGrpSpPr>
-            <p:cNvPr id="165" name="Group 164">
-              <a:extLst>
-                <a:ext uri="{FF2B5EF4-FFF2-40B4-BE49-F238E27FC236}">
-                  <a16:creationId xmlns:a16="http://schemas.microsoft.com/office/drawing/2014/main" id="{04F034E3-7698-1B5E-6EDA-F681C4086854}"/>
+            <p:cNvPr id="54" name="Group 53">
+              <a:extLst>
+                <a:ext uri="{FF2B5EF4-FFF2-40B4-BE49-F238E27FC236}">
+                  <a16:creationId xmlns:a16="http://schemas.microsoft.com/office/drawing/2014/main" id="{87992DEC-0E60-F47D-03F1-7250256D01D3}"/>
                 </a:ext>
               </a:extLst>
             </p:cNvPr>
@@ -19665,18 +19085,18 @@
           </p:nvGrpSpPr>
           <p:grpSpPr>
             <a:xfrm>
-              <a:off x="-1168710" y="6666830"/>
-              <a:ext cx="2042468" cy="473633"/>
-              <a:chOff x="-4846261" y="583986"/>
-              <a:chExt cx="2042468" cy="473633"/>
+              <a:off x="9154071" y="6706902"/>
+              <a:ext cx="1671045" cy="473633"/>
+              <a:chOff x="343224" y="555912"/>
+              <a:chExt cx="1671045" cy="473633"/>
             </a:xfrm>
           </p:grpSpPr>
           <p:sp>
             <p:nvSpPr>
-              <p:cNvPr id="166" name="Rounded Rectangle 165">
+              <p:cNvPr id="55" name="Rounded Rectangle 54">
                 <a:extLst>
                   <a:ext uri="{FF2B5EF4-FFF2-40B4-BE49-F238E27FC236}">
-                    <a16:creationId xmlns:a16="http://schemas.microsoft.com/office/drawing/2014/main" id="{B35C3A83-819A-EA16-C0EF-88C72653F875}"/>
+                    <a16:creationId xmlns:a16="http://schemas.microsoft.com/office/drawing/2014/main" id="{F61F116C-CAD1-5D3F-DB48-E1C29AAF8EAD}"/>
                   </a:ext>
                 </a:extLst>
               </p:cNvPr>
@@ -19685,8 +19105,8 @@
             </p:nvSpPr>
             <p:spPr>
               <a:xfrm>
-                <a:off x="-4846261" y="583986"/>
-                <a:ext cx="2042468" cy="473633"/>
+                <a:off x="343224" y="555912"/>
+                <a:ext cx="1671045" cy="473633"/>
               </a:xfrm>
               <a:prstGeom prst="roundRect">
                 <a:avLst/>
@@ -19723,10 +19143,10 @@
           </p:sp>
           <p:sp>
             <p:nvSpPr>
-              <p:cNvPr id="167" name="Oval 166">
+              <p:cNvPr id="56" name="Oval 55">
                 <a:extLst>
                   <a:ext uri="{FF2B5EF4-FFF2-40B4-BE49-F238E27FC236}">
-                    <a16:creationId xmlns:a16="http://schemas.microsoft.com/office/drawing/2014/main" id="{FDF9DB3B-7B7F-3209-700E-67C71442664A}"/>
+                    <a16:creationId xmlns:a16="http://schemas.microsoft.com/office/drawing/2014/main" id="{95BFC3F8-358E-4FE2-F4D9-2FDD4DD3AC79}"/>
                   </a:ext>
                 </a:extLst>
               </p:cNvPr>
@@ -19735,7 +19155,378 @@
             </p:nvSpPr>
             <p:spPr>
               <a:xfrm>
-                <a:off x="-4723598" y="678771"/>
+                <a:off x="465887" y="650697"/>
+                <a:ext cx="267629" cy="267629"/>
+              </a:xfrm>
+              <a:prstGeom prst="ellipse">
+                <a:avLst/>
+              </a:prstGeom>
+              <a:solidFill>
+                <a:srgbClr val="00B050"/>
+              </a:solidFill>
+              <a:ln w="22225"/>
+            </p:spPr>
+            <p:style>
+              <a:lnRef idx="2">
+                <a:schemeClr val="accent1">
+                  <a:shade val="15000"/>
+                </a:schemeClr>
+              </a:lnRef>
+              <a:fillRef idx="1">
+                <a:schemeClr val="accent1"/>
+              </a:fillRef>
+              <a:effectRef idx="0">
+                <a:schemeClr val="accent1"/>
+              </a:effectRef>
+              <a:fontRef idx="minor">
+                <a:schemeClr val="lt1"/>
+              </a:fontRef>
+            </p:style>
+            <p:txBody>
+              <a:bodyPr rtlCol="0" anchor="ctr"/>
+              <a:lstStyle/>
+              <a:p>
+                <a:pPr algn="ctr"/>
+                <a:endParaRPr lang="en-US"/>
+              </a:p>
+            </p:txBody>
+          </p:sp>
+          <p:sp>
+            <p:nvSpPr>
+              <p:cNvPr id="57" name="Oval 56">
+                <a:extLst>
+                  <a:ext uri="{FF2B5EF4-FFF2-40B4-BE49-F238E27FC236}">
+                    <a16:creationId xmlns:a16="http://schemas.microsoft.com/office/drawing/2014/main" id="{2475B3B9-A011-AC56-6AE4-3E663BC8C85C}"/>
+                  </a:ext>
+                </a:extLst>
+              </p:cNvPr>
+              <p:cNvSpPr/>
+              <p:nvPr/>
+            </p:nvSpPr>
+            <p:spPr>
+              <a:xfrm>
+                <a:off x="856178" y="650697"/>
+                <a:ext cx="267629" cy="267629"/>
+              </a:xfrm>
+              <a:prstGeom prst="ellipse">
+                <a:avLst/>
+              </a:prstGeom>
+              <a:solidFill>
+                <a:srgbClr val="00B050"/>
+              </a:solidFill>
+              <a:ln w="22225"/>
+            </p:spPr>
+            <p:style>
+              <a:lnRef idx="2">
+                <a:schemeClr val="accent1">
+                  <a:shade val="15000"/>
+                </a:schemeClr>
+              </a:lnRef>
+              <a:fillRef idx="1">
+                <a:schemeClr val="accent1"/>
+              </a:fillRef>
+              <a:effectRef idx="0">
+                <a:schemeClr val="accent1"/>
+              </a:effectRef>
+              <a:fontRef idx="minor">
+                <a:schemeClr val="lt1"/>
+              </a:fontRef>
+            </p:style>
+            <p:txBody>
+              <a:bodyPr rtlCol="0" anchor="ctr"/>
+              <a:lstStyle/>
+              <a:p>
+                <a:pPr algn="ctr"/>
+                <a:endParaRPr lang="en-US"/>
+              </a:p>
+            </p:txBody>
+          </p:sp>
+          <p:sp>
+            <p:nvSpPr>
+              <p:cNvPr id="58" name="Oval 57">
+                <a:extLst>
+                  <a:ext uri="{FF2B5EF4-FFF2-40B4-BE49-F238E27FC236}">
+                    <a16:creationId xmlns:a16="http://schemas.microsoft.com/office/drawing/2014/main" id="{5FCAD21F-2E97-2A02-46BE-C6EAB2D17BCC}"/>
+                  </a:ext>
+                </a:extLst>
+              </p:cNvPr>
+              <p:cNvSpPr/>
+              <p:nvPr/>
+            </p:nvSpPr>
+            <p:spPr>
+              <a:xfrm>
+                <a:off x="1224164" y="650697"/>
+                <a:ext cx="267629" cy="267629"/>
+              </a:xfrm>
+              <a:prstGeom prst="ellipse">
+                <a:avLst/>
+              </a:prstGeom>
+              <a:solidFill>
+                <a:srgbClr val="00B050"/>
+              </a:solidFill>
+              <a:ln w="22225"/>
+            </p:spPr>
+            <p:style>
+              <a:lnRef idx="2">
+                <a:schemeClr val="accent1">
+                  <a:shade val="15000"/>
+                </a:schemeClr>
+              </a:lnRef>
+              <a:fillRef idx="1">
+                <a:schemeClr val="accent1"/>
+              </a:fillRef>
+              <a:effectRef idx="0">
+                <a:schemeClr val="accent1"/>
+              </a:effectRef>
+              <a:fontRef idx="minor">
+                <a:schemeClr val="lt1"/>
+              </a:fontRef>
+            </p:style>
+            <p:txBody>
+              <a:bodyPr rtlCol="0" anchor="ctr"/>
+              <a:lstStyle/>
+              <a:p>
+                <a:pPr algn="ctr"/>
+                <a:endParaRPr lang="en-US"/>
+              </a:p>
+            </p:txBody>
+          </p:sp>
+          <p:sp>
+            <p:nvSpPr>
+              <p:cNvPr id="59" name="Oval 58">
+                <a:extLst>
+                  <a:ext uri="{FF2B5EF4-FFF2-40B4-BE49-F238E27FC236}">
+                    <a16:creationId xmlns:a16="http://schemas.microsoft.com/office/drawing/2014/main" id="{F02918E6-1154-4D75-DF0D-057990C091A2}"/>
+                  </a:ext>
+                </a:extLst>
+              </p:cNvPr>
+              <p:cNvSpPr/>
+              <p:nvPr/>
+            </p:nvSpPr>
+            <p:spPr>
+              <a:xfrm>
+                <a:off x="1614504" y="653159"/>
+                <a:ext cx="267629" cy="267629"/>
+              </a:xfrm>
+              <a:prstGeom prst="ellipse">
+                <a:avLst/>
+              </a:prstGeom>
+              <a:solidFill>
+                <a:srgbClr val="00B050"/>
+              </a:solidFill>
+              <a:ln w="22225"/>
+            </p:spPr>
+            <p:style>
+              <a:lnRef idx="2">
+                <a:schemeClr val="accent1">
+                  <a:shade val="15000"/>
+                </a:schemeClr>
+              </a:lnRef>
+              <a:fillRef idx="1">
+                <a:schemeClr val="accent1"/>
+              </a:fillRef>
+              <a:effectRef idx="0">
+                <a:schemeClr val="accent1"/>
+              </a:effectRef>
+              <a:fontRef idx="minor">
+                <a:schemeClr val="lt1"/>
+              </a:fontRef>
+            </p:style>
+            <p:txBody>
+              <a:bodyPr rtlCol="0" anchor="ctr"/>
+              <a:lstStyle/>
+              <a:p>
+                <a:pPr algn="ctr"/>
+                <a:endParaRPr lang="en-US"/>
+              </a:p>
+            </p:txBody>
+          </p:sp>
+        </p:grpSp>
+        <p:grpSp>
+          <p:nvGrpSpPr>
+            <p:cNvPr id="60" name="Group 59">
+              <a:extLst>
+                <a:ext uri="{FF2B5EF4-FFF2-40B4-BE49-F238E27FC236}">
+                  <a16:creationId xmlns:a16="http://schemas.microsoft.com/office/drawing/2014/main" id="{23890C77-D3BA-BC61-63F7-2A05A48F513D}"/>
+                </a:ext>
+              </a:extLst>
+            </p:cNvPr>
+            <p:cNvGrpSpPr/>
+            <p:nvPr/>
+          </p:nvGrpSpPr>
+          <p:grpSpPr>
+            <a:xfrm>
+              <a:off x="12365007" y="6698034"/>
+              <a:ext cx="1671045" cy="473633"/>
+              <a:chOff x="343224" y="555912"/>
+              <a:chExt cx="1671045" cy="473633"/>
+            </a:xfrm>
+          </p:grpSpPr>
+          <p:sp>
+            <p:nvSpPr>
+              <p:cNvPr id="61" name="Rounded Rectangle 60">
+                <a:extLst>
+                  <a:ext uri="{FF2B5EF4-FFF2-40B4-BE49-F238E27FC236}">
+                    <a16:creationId xmlns:a16="http://schemas.microsoft.com/office/drawing/2014/main" id="{0B3C3F81-50B7-8DE9-4F14-B54B4DE6B949}"/>
+                  </a:ext>
+                </a:extLst>
+              </p:cNvPr>
+              <p:cNvSpPr/>
+              <p:nvPr/>
+            </p:nvSpPr>
+            <p:spPr>
+              <a:xfrm>
+                <a:off x="343224" y="555912"/>
+                <a:ext cx="1671045" cy="473633"/>
+              </a:xfrm>
+              <a:prstGeom prst="roundRect">
+                <a:avLst/>
+              </a:prstGeom>
+              <a:solidFill>
+                <a:schemeClr val="bg2"/>
+              </a:solidFill>
+              <a:ln w="22225"/>
+            </p:spPr>
+            <p:style>
+              <a:lnRef idx="2">
+                <a:schemeClr val="accent1">
+                  <a:shade val="15000"/>
+                </a:schemeClr>
+              </a:lnRef>
+              <a:fillRef idx="1">
+                <a:schemeClr val="accent1"/>
+              </a:fillRef>
+              <a:effectRef idx="0">
+                <a:schemeClr val="accent1"/>
+              </a:effectRef>
+              <a:fontRef idx="minor">
+                <a:schemeClr val="lt1"/>
+              </a:fontRef>
+            </p:style>
+            <p:txBody>
+              <a:bodyPr rtlCol="0" anchor="ctr"/>
+              <a:lstStyle/>
+              <a:p>
+                <a:pPr algn="ctr"/>
+                <a:endParaRPr lang="en-US"/>
+              </a:p>
+            </p:txBody>
+          </p:sp>
+          <p:sp>
+            <p:nvSpPr>
+              <p:cNvPr id="62" name="Oval 61">
+                <a:extLst>
+                  <a:ext uri="{FF2B5EF4-FFF2-40B4-BE49-F238E27FC236}">
+                    <a16:creationId xmlns:a16="http://schemas.microsoft.com/office/drawing/2014/main" id="{55C4E3E3-7831-8E75-5EA8-61042E77FB58}"/>
+                  </a:ext>
+                </a:extLst>
+              </p:cNvPr>
+              <p:cNvSpPr/>
+              <p:nvPr/>
+            </p:nvSpPr>
+            <p:spPr>
+              <a:xfrm>
+                <a:off x="465887" y="650697"/>
+                <a:ext cx="267629" cy="267629"/>
+              </a:xfrm>
+              <a:prstGeom prst="ellipse">
+                <a:avLst/>
+              </a:prstGeom>
+              <a:solidFill>
+                <a:srgbClr val="00B050"/>
+              </a:solidFill>
+              <a:ln w="22225"/>
+            </p:spPr>
+            <p:style>
+              <a:lnRef idx="2">
+                <a:schemeClr val="accent1">
+                  <a:shade val="15000"/>
+                </a:schemeClr>
+              </a:lnRef>
+              <a:fillRef idx="1">
+                <a:schemeClr val="accent1"/>
+              </a:fillRef>
+              <a:effectRef idx="0">
+                <a:schemeClr val="accent1"/>
+              </a:effectRef>
+              <a:fontRef idx="minor">
+                <a:schemeClr val="lt1"/>
+              </a:fontRef>
+            </p:style>
+            <p:txBody>
+              <a:bodyPr rtlCol="0" anchor="ctr"/>
+              <a:lstStyle/>
+              <a:p>
+                <a:pPr algn="ctr"/>
+                <a:endParaRPr lang="en-US"/>
+              </a:p>
+            </p:txBody>
+          </p:sp>
+          <p:sp>
+            <p:nvSpPr>
+              <p:cNvPr id="63" name="Oval 62">
+                <a:extLst>
+                  <a:ext uri="{FF2B5EF4-FFF2-40B4-BE49-F238E27FC236}">
+                    <a16:creationId xmlns:a16="http://schemas.microsoft.com/office/drawing/2014/main" id="{1909CBB9-8983-6F7F-C062-3F7E94DDD9CB}"/>
+                  </a:ext>
+                </a:extLst>
+              </p:cNvPr>
+              <p:cNvSpPr/>
+              <p:nvPr/>
+            </p:nvSpPr>
+            <p:spPr>
+              <a:xfrm>
+                <a:off x="856178" y="650697"/>
+                <a:ext cx="267629" cy="267629"/>
+              </a:xfrm>
+              <a:prstGeom prst="ellipse">
+                <a:avLst/>
+              </a:prstGeom>
+              <a:solidFill>
+                <a:srgbClr val="00B050"/>
+              </a:solidFill>
+              <a:ln w="22225"/>
+            </p:spPr>
+            <p:style>
+              <a:lnRef idx="2">
+                <a:schemeClr val="accent1">
+                  <a:shade val="15000"/>
+                </a:schemeClr>
+              </a:lnRef>
+              <a:fillRef idx="1">
+                <a:schemeClr val="accent1"/>
+              </a:fillRef>
+              <a:effectRef idx="0">
+                <a:schemeClr val="accent1"/>
+              </a:effectRef>
+              <a:fontRef idx="minor">
+                <a:schemeClr val="lt1"/>
+              </a:fontRef>
+            </p:style>
+            <p:txBody>
+              <a:bodyPr rtlCol="0" anchor="ctr"/>
+              <a:lstStyle/>
+              <a:p>
+                <a:pPr algn="ctr"/>
+                <a:endParaRPr lang="en-US"/>
+              </a:p>
+            </p:txBody>
+          </p:sp>
+          <p:sp>
+            <p:nvSpPr>
+              <p:cNvPr id="64" name="Oval 63">
+                <a:extLst>
+                  <a:ext uri="{FF2B5EF4-FFF2-40B4-BE49-F238E27FC236}">
+                    <a16:creationId xmlns:a16="http://schemas.microsoft.com/office/drawing/2014/main" id="{DA09A74A-1D43-B21A-20E8-1FE0EF308010}"/>
+                  </a:ext>
+                </a:extLst>
+              </p:cNvPr>
+              <p:cNvSpPr/>
+              <p:nvPr/>
+            </p:nvSpPr>
+            <p:spPr>
+              <a:xfrm>
+                <a:off x="1224164" y="650697"/>
                 <a:ext cx="267629" cy="267629"/>
               </a:xfrm>
               <a:prstGeom prst="ellipse">
@@ -19773,10 +19564,10 @@
           </p:sp>
           <p:sp>
             <p:nvSpPr>
-              <p:cNvPr id="168" name="Oval 167">
+              <p:cNvPr id="65" name="Oval 64">
                 <a:extLst>
                   <a:ext uri="{FF2B5EF4-FFF2-40B4-BE49-F238E27FC236}">
-                    <a16:creationId xmlns:a16="http://schemas.microsoft.com/office/drawing/2014/main" id="{B9231D36-A325-5C20-189D-5C05CD599144}"/>
+                    <a16:creationId xmlns:a16="http://schemas.microsoft.com/office/drawing/2014/main" id="{83E18EA1-57C1-AD00-A68B-8FD16F0FDDED}"/>
                   </a:ext>
                 </a:extLst>
               </p:cNvPr>
@@ -19785,157 +19576,7 @@
             </p:nvSpPr>
             <p:spPr>
               <a:xfrm>
-                <a:off x="-4333307" y="678771"/>
-                <a:ext cx="267629" cy="267629"/>
-              </a:xfrm>
-              <a:prstGeom prst="ellipse">
-                <a:avLst/>
-              </a:prstGeom>
-              <a:solidFill>
-                <a:srgbClr val="FF0000"/>
-              </a:solidFill>
-              <a:ln w="22225"/>
-            </p:spPr>
-            <p:style>
-              <a:lnRef idx="2">
-                <a:schemeClr val="accent1">
-                  <a:shade val="15000"/>
-                </a:schemeClr>
-              </a:lnRef>
-              <a:fillRef idx="1">
-                <a:schemeClr val="accent1"/>
-              </a:fillRef>
-              <a:effectRef idx="0">
-                <a:schemeClr val="accent1"/>
-              </a:effectRef>
-              <a:fontRef idx="minor">
-                <a:schemeClr val="lt1"/>
-              </a:fontRef>
-            </p:style>
-            <p:txBody>
-              <a:bodyPr rtlCol="0" anchor="ctr"/>
-              <a:lstStyle/>
-              <a:p>
-                <a:pPr algn="ctr"/>
-                <a:endParaRPr lang="en-US"/>
-              </a:p>
-            </p:txBody>
-          </p:sp>
-          <p:sp>
-            <p:nvSpPr>
-              <p:cNvPr id="169" name="Oval 168">
-                <a:extLst>
-                  <a:ext uri="{FF2B5EF4-FFF2-40B4-BE49-F238E27FC236}">
-                    <a16:creationId xmlns:a16="http://schemas.microsoft.com/office/drawing/2014/main" id="{1F75044C-7CDF-331D-6184-4A919717E53F}"/>
-                  </a:ext>
-                </a:extLst>
-              </p:cNvPr>
-              <p:cNvSpPr/>
-              <p:nvPr/>
-            </p:nvSpPr>
-            <p:spPr>
-              <a:xfrm>
-                <a:off x="-3965321" y="678771"/>
-                <a:ext cx="267629" cy="267629"/>
-              </a:xfrm>
-              <a:prstGeom prst="ellipse">
-                <a:avLst/>
-              </a:prstGeom>
-              <a:solidFill>
-                <a:srgbClr val="00B050"/>
-              </a:solidFill>
-              <a:ln w="22225"/>
-            </p:spPr>
-            <p:style>
-              <a:lnRef idx="2">
-                <a:schemeClr val="accent1">
-                  <a:shade val="15000"/>
-                </a:schemeClr>
-              </a:lnRef>
-              <a:fillRef idx="1">
-                <a:schemeClr val="accent1"/>
-              </a:fillRef>
-              <a:effectRef idx="0">
-                <a:schemeClr val="accent1"/>
-              </a:effectRef>
-              <a:fontRef idx="minor">
-                <a:schemeClr val="lt1"/>
-              </a:fontRef>
-            </p:style>
-            <p:txBody>
-              <a:bodyPr rtlCol="0" anchor="ctr"/>
-              <a:lstStyle/>
-              <a:p>
-                <a:pPr algn="ctr"/>
-                <a:endParaRPr lang="en-US"/>
-              </a:p>
-            </p:txBody>
-          </p:sp>
-          <p:sp>
-            <p:nvSpPr>
-              <p:cNvPr id="172" name="Oval 171">
-                <a:extLst>
-                  <a:ext uri="{FF2B5EF4-FFF2-40B4-BE49-F238E27FC236}">
-                    <a16:creationId xmlns:a16="http://schemas.microsoft.com/office/drawing/2014/main" id="{7A0FDFD3-1771-DA7A-5B06-F4369831F8D3}"/>
-                  </a:ext>
-                </a:extLst>
-              </p:cNvPr>
-              <p:cNvSpPr/>
-              <p:nvPr/>
-            </p:nvSpPr>
-            <p:spPr>
-              <a:xfrm>
-                <a:off x="-3574981" y="681233"/>
-                <a:ext cx="267629" cy="267629"/>
-              </a:xfrm>
-              <a:prstGeom prst="ellipse">
-                <a:avLst/>
-              </a:prstGeom>
-              <a:solidFill>
-                <a:srgbClr val="FF0000"/>
-              </a:solidFill>
-              <a:ln w="22225"/>
-            </p:spPr>
-            <p:style>
-              <a:lnRef idx="2">
-                <a:schemeClr val="accent1">
-                  <a:shade val="15000"/>
-                </a:schemeClr>
-              </a:lnRef>
-              <a:fillRef idx="1">
-                <a:schemeClr val="accent1"/>
-              </a:fillRef>
-              <a:effectRef idx="0">
-                <a:schemeClr val="accent1"/>
-              </a:effectRef>
-              <a:fontRef idx="minor">
-                <a:schemeClr val="lt1"/>
-              </a:fontRef>
-            </p:style>
-            <p:txBody>
-              <a:bodyPr rtlCol="0" anchor="ctr"/>
-              <a:lstStyle/>
-              <a:p>
-                <a:pPr algn="ctr"/>
-                <a:endParaRPr lang="en-US"/>
-              </a:p>
-            </p:txBody>
-          </p:sp>
-          <p:sp>
-            <p:nvSpPr>
-              <p:cNvPr id="173" name="Oval 172">
-                <a:extLst>
-                  <a:ext uri="{FF2B5EF4-FFF2-40B4-BE49-F238E27FC236}">
-                    <a16:creationId xmlns:a16="http://schemas.microsoft.com/office/drawing/2014/main" id="{A6EED840-CD01-64F5-4C8D-8CA632D33101}"/>
-                  </a:ext>
-                </a:extLst>
-              </p:cNvPr>
-              <p:cNvSpPr/>
-              <p:nvPr/>
-            </p:nvSpPr>
-            <p:spPr>
-              <a:xfrm>
-                <a:off x="-3206995" y="681233"/>
+                <a:off x="1614504" y="653159"/>
                 <a:ext cx="267629" cy="267629"/>
               </a:xfrm>
               <a:prstGeom prst="ellipse">
@@ -19974,10 +19615,10 @@
         </p:grpSp>
         <p:grpSp>
           <p:nvGrpSpPr>
-            <p:cNvPr id="174" name="Group 173">
-              <a:extLst>
-                <a:ext uri="{FF2B5EF4-FFF2-40B4-BE49-F238E27FC236}">
-                  <a16:creationId xmlns:a16="http://schemas.microsoft.com/office/drawing/2014/main" id="{6288357B-2D2D-3718-98E2-5DEA7A119A50}"/>
+            <p:cNvPr id="66" name="Group 65">
+              <a:extLst>
+                <a:ext uri="{FF2B5EF4-FFF2-40B4-BE49-F238E27FC236}">
+                  <a16:creationId xmlns:a16="http://schemas.microsoft.com/office/drawing/2014/main" id="{449D3CAA-4CB9-1F83-EEA1-78C387861C03}"/>
                 </a:ext>
               </a:extLst>
             </p:cNvPr>
@@ -19986,18 +19627,18 @@
           </p:nvGrpSpPr>
           <p:grpSpPr>
             <a:xfrm>
-              <a:off x="2049912" y="6652343"/>
-              <a:ext cx="2042468" cy="473633"/>
-              <a:chOff x="-4846261" y="583986"/>
-              <a:chExt cx="2042468" cy="473633"/>
+              <a:off x="922672" y="9532999"/>
+              <a:ext cx="1671045" cy="473633"/>
+              <a:chOff x="343224" y="555912"/>
+              <a:chExt cx="1671045" cy="473633"/>
             </a:xfrm>
           </p:grpSpPr>
           <p:sp>
             <p:nvSpPr>
-              <p:cNvPr id="175" name="Rounded Rectangle 174">
+              <p:cNvPr id="67" name="Rounded Rectangle 66">
                 <a:extLst>
                   <a:ext uri="{FF2B5EF4-FFF2-40B4-BE49-F238E27FC236}">
-                    <a16:creationId xmlns:a16="http://schemas.microsoft.com/office/drawing/2014/main" id="{D8862FBF-5D19-8CCD-1795-EF7E665D8E70}"/>
+                    <a16:creationId xmlns:a16="http://schemas.microsoft.com/office/drawing/2014/main" id="{1ACCDD10-20D1-B93F-07C2-16742D7D27B3}"/>
                   </a:ext>
                 </a:extLst>
               </p:cNvPr>
@@ -20006,8 +19647,8 @@
             </p:nvSpPr>
             <p:spPr>
               <a:xfrm>
-                <a:off x="-4846261" y="583986"/>
-                <a:ext cx="2042468" cy="473633"/>
+                <a:off x="343224" y="555912"/>
+                <a:ext cx="1671045" cy="473633"/>
               </a:xfrm>
               <a:prstGeom prst="roundRect">
                 <a:avLst/>
@@ -20044,10 +19685,10 @@
           </p:sp>
           <p:sp>
             <p:nvSpPr>
-              <p:cNvPr id="176" name="Oval 175">
+              <p:cNvPr id="68" name="Oval 67">
                 <a:extLst>
                   <a:ext uri="{FF2B5EF4-FFF2-40B4-BE49-F238E27FC236}">
-                    <a16:creationId xmlns:a16="http://schemas.microsoft.com/office/drawing/2014/main" id="{34F0122E-5996-C600-6774-4CFD8C87BCE1}"/>
+                    <a16:creationId xmlns:a16="http://schemas.microsoft.com/office/drawing/2014/main" id="{8753501F-37EE-38E6-D604-0B9F7CED8D0F}"/>
                   </a:ext>
                 </a:extLst>
               </p:cNvPr>
@@ -20056,7 +19697,7 @@
             </p:nvSpPr>
             <p:spPr>
               <a:xfrm>
-                <a:off x="-4723598" y="678771"/>
+                <a:off x="465887" y="650697"/>
                 <a:ext cx="267629" cy="267629"/>
               </a:xfrm>
               <a:prstGeom prst="ellipse">
@@ -20094,10 +19735,10 @@
           </p:sp>
           <p:sp>
             <p:nvSpPr>
-              <p:cNvPr id="177" name="Oval 176">
+              <p:cNvPr id="69" name="Oval 68">
                 <a:extLst>
                   <a:ext uri="{FF2B5EF4-FFF2-40B4-BE49-F238E27FC236}">
-                    <a16:creationId xmlns:a16="http://schemas.microsoft.com/office/drawing/2014/main" id="{3E7413BA-F4F7-5078-3B3C-EFB51B4FDDEF}"/>
+                    <a16:creationId xmlns:a16="http://schemas.microsoft.com/office/drawing/2014/main" id="{FBC3065D-842D-5059-AC91-59191FC7B272}"/>
                   </a:ext>
                 </a:extLst>
               </p:cNvPr>
@@ -20106,7 +19747,7 @@
             </p:nvSpPr>
             <p:spPr>
               <a:xfrm>
-                <a:off x="-4333307" y="678771"/>
+                <a:off x="856178" y="650697"/>
                 <a:ext cx="267629" cy="267629"/>
               </a:xfrm>
               <a:prstGeom prst="ellipse">
@@ -20144,10 +19785,10 @@
           </p:sp>
           <p:sp>
             <p:nvSpPr>
-              <p:cNvPr id="180" name="Oval 179">
+              <p:cNvPr id="70" name="Oval 69">
                 <a:extLst>
                   <a:ext uri="{FF2B5EF4-FFF2-40B4-BE49-F238E27FC236}">
-                    <a16:creationId xmlns:a16="http://schemas.microsoft.com/office/drawing/2014/main" id="{CE010673-FC1D-5526-8D1B-413AC21E2793}"/>
+                    <a16:creationId xmlns:a16="http://schemas.microsoft.com/office/drawing/2014/main" id="{26D866B9-3123-D437-A969-619DCCB10EF8}"/>
                   </a:ext>
                 </a:extLst>
               </p:cNvPr>
@@ -20156,7 +19797,7 @@
             </p:nvSpPr>
             <p:spPr>
               <a:xfrm>
-                <a:off x="-3965321" y="678771"/>
+                <a:off x="1224164" y="650697"/>
                 <a:ext cx="267629" cy="267629"/>
               </a:xfrm>
               <a:prstGeom prst="ellipse">
@@ -20194,10 +19835,10 @@
           </p:sp>
           <p:sp>
             <p:nvSpPr>
-              <p:cNvPr id="181" name="Oval 180">
+              <p:cNvPr id="71" name="Oval 70">
                 <a:extLst>
                   <a:ext uri="{FF2B5EF4-FFF2-40B4-BE49-F238E27FC236}">
-                    <a16:creationId xmlns:a16="http://schemas.microsoft.com/office/drawing/2014/main" id="{6701A573-85FA-4B54-ED9C-84DBFBECE80A}"/>
+                    <a16:creationId xmlns:a16="http://schemas.microsoft.com/office/drawing/2014/main" id="{33D09218-9DD6-99A2-6D49-7BA7E18F52DC}"/>
                   </a:ext>
                 </a:extLst>
               </p:cNvPr>
@@ -20206,10 +19847,81 @@
             </p:nvSpPr>
             <p:spPr>
               <a:xfrm>
-                <a:off x="-3574981" y="681233"/>
+                <a:off x="1614504" y="653159"/>
                 <a:ext cx="267629" cy="267629"/>
               </a:xfrm>
               <a:prstGeom prst="ellipse">
+                <a:avLst/>
+              </a:prstGeom>
+              <a:solidFill>
+                <a:srgbClr val="00B050"/>
+              </a:solidFill>
+              <a:ln w="22225"/>
+            </p:spPr>
+            <p:style>
+              <a:lnRef idx="2">
+                <a:schemeClr val="accent1">
+                  <a:shade val="15000"/>
+                </a:schemeClr>
+              </a:lnRef>
+              <a:fillRef idx="1">
+                <a:schemeClr val="accent1"/>
+              </a:fillRef>
+              <a:effectRef idx="0">
+                <a:schemeClr val="accent1"/>
+              </a:effectRef>
+              <a:fontRef idx="minor">
+                <a:schemeClr val="lt1"/>
+              </a:fontRef>
+            </p:style>
+            <p:txBody>
+              <a:bodyPr rtlCol="0" anchor="ctr"/>
+              <a:lstStyle/>
+              <a:p>
+                <a:pPr algn="ctr"/>
+                <a:endParaRPr lang="en-US"/>
+              </a:p>
+            </p:txBody>
+          </p:sp>
+        </p:grpSp>
+        <p:grpSp>
+          <p:nvGrpSpPr>
+            <p:cNvPr id="72" name="Group 71">
+              <a:extLst>
+                <a:ext uri="{FF2B5EF4-FFF2-40B4-BE49-F238E27FC236}">
+                  <a16:creationId xmlns:a16="http://schemas.microsoft.com/office/drawing/2014/main" id="{01E78D64-3CB0-09A6-3CC0-2D8AF09152D5}"/>
+                </a:ext>
+              </a:extLst>
+            </p:cNvPr>
+            <p:cNvGrpSpPr/>
+            <p:nvPr/>
+          </p:nvGrpSpPr>
+          <p:grpSpPr>
+            <a:xfrm>
+              <a:off x="2490804" y="6662976"/>
+              <a:ext cx="1671045" cy="473633"/>
+              <a:chOff x="343224" y="555912"/>
+              <a:chExt cx="1671045" cy="473633"/>
+            </a:xfrm>
+          </p:grpSpPr>
+          <p:sp>
+            <p:nvSpPr>
+              <p:cNvPr id="73" name="Rounded Rectangle 72">
+                <a:extLst>
+                  <a:ext uri="{FF2B5EF4-FFF2-40B4-BE49-F238E27FC236}">
+                    <a16:creationId xmlns:a16="http://schemas.microsoft.com/office/drawing/2014/main" id="{00FE1E01-3E7C-B2E8-FF96-6BF0B5602FCF}"/>
+                  </a:ext>
+                </a:extLst>
+              </p:cNvPr>
+              <p:cNvSpPr/>
+              <p:nvPr/>
+            </p:nvSpPr>
+            <p:spPr>
+              <a:xfrm>
+                <a:off x="343224" y="555912"/>
+                <a:ext cx="1671045" cy="473633"/>
+              </a:xfrm>
+              <a:prstGeom prst="roundRect">
                 <a:avLst/>
               </a:prstGeom>
               <a:solidFill>
@@ -20244,10 +19956,10 @@
           </p:sp>
           <p:sp>
             <p:nvSpPr>
-              <p:cNvPr id="182" name="Oval 181">
+              <p:cNvPr id="74" name="Oval 73">
                 <a:extLst>
                   <a:ext uri="{FF2B5EF4-FFF2-40B4-BE49-F238E27FC236}">
-                    <a16:creationId xmlns:a16="http://schemas.microsoft.com/office/drawing/2014/main" id="{231C180D-1B0E-B2C5-D484-89D5C70D93D0}"/>
+                    <a16:creationId xmlns:a16="http://schemas.microsoft.com/office/drawing/2014/main" id="{44D49F02-0326-F49B-8950-CBC3220A63DB}"/>
                   </a:ext>
                 </a:extLst>
               </p:cNvPr>
@@ -20256,7 +19968,157 @@
             </p:nvSpPr>
             <p:spPr>
               <a:xfrm>
-                <a:off x="-3206995" y="681233"/>
+                <a:off x="465887" y="650697"/>
+                <a:ext cx="267629" cy="267629"/>
+              </a:xfrm>
+              <a:prstGeom prst="ellipse">
+                <a:avLst/>
+              </a:prstGeom>
+              <a:solidFill>
+                <a:srgbClr val="FF0000"/>
+              </a:solidFill>
+              <a:ln w="22225"/>
+            </p:spPr>
+            <p:style>
+              <a:lnRef idx="2">
+                <a:schemeClr val="accent1">
+                  <a:shade val="15000"/>
+                </a:schemeClr>
+              </a:lnRef>
+              <a:fillRef idx="1">
+                <a:schemeClr val="accent1"/>
+              </a:fillRef>
+              <a:effectRef idx="0">
+                <a:schemeClr val="accent1"/>
+              </a:effectRef>
+              <a:fontRef idx="minor">
+                <a:schemeClr val="lt1"/>
+              </a:fontRef>
+            </p:style>
+            <p:txBody>
+              <a:bodyPr rtlCol="0" anchor="ctr"/>
+              <a:lstStyle/>
+              <a:p>
+                <a:pPr algn="ctr"/>
+                <a:endParaRPr lang="en-US"/>
+              </a:p>
+            </p:txBody>
+          </p:sp>
+          <p:sp>
+            <p:nvSpPr>
+              <p:cNvPr id="75" name="Oval 74">
+                <a:extLst>
+                  <a:ext uri="{FF2B5EF4-FFF2-40B4-BE49-F238E27FC236}">
+                    <a16:creationId xmlns:a16="http://schemas.microsoft.com/office/drawing/2014/main" id="{5FE4B235-7657-41BC-1742-77ABBC88F80A}"/>
+                  </a:ext>
+                </a:extLst>
+              </p:cNvPr>
+              <p:cNvSpPr/>
+              <p:nvPr/>
+            </p:nvSpPr>
+            <p:spPr>
+              <a:xfrm>
+                <a:off x="856178" y="650697"/>
+                <a:ext cx="267629" cy="267629"/>
+              </a:xfrm>
+              <a:prstGeom prst="ellipse">
+                <a:avLst/>
+              </a:prstGeom>
+              <a:solidFill>
+                <a:srgbClr val="FF0000"/>
+              </a:solidFill>
+              <a:ln w="22225"/>
+            </p:spPr>
+            <p:style>
+              <a:lnRef idx="2">
+                <a:schemeClr val="accent1">
+                  <a:shade val="15000"/>
+                </a:schemeClr>
+              </a:lnRef>
+              <a:fillRef idx="1">
+                <a:schemeClr val="accent1"/>
+              </a:fillRef>
+              <a:effectRef idx="0">
+                <a:schemeClr val="accent1"/>
+              </a:effectRef>
+              <a:fontRef idx="minor">
+                <a:schemeClr val="lt1"/>
+              </a:fontRef>
+            </p:style>
+            <p:txBody>
+              <a:bodyPr rtlCol="0" anchor="ctr"/>
+              <a:lstStyle/>
+              <a:p>
+                <a:pPr algn="ctr"/>
+                <a:endParaRPr lang="en-US"/>
+              </a:p>
+            </p:txBody>
+          </p:sp>
+          <p:sp>
+            <p:nvSpPr>
+              <p:cNvPr id="83" name="Oval 82">
+                <a:extLst>
+                  <a:ext uri="{FF2B5EF4-FFF2-40B4-BE49-F238E27FC236}">
+                    <a16:creationId xmlns:a16="http://schemas.microsoft.com/office/drawing/2014/main" id="{75ECD5D3-05FB-FC10-B2A1-F4AF93AB107A}"/>
+                  </a:ext>
+                </a:extLst>
+              </p:cNvPr>
+              <p:cNvSpPr/>
+              <p:nvPr/>
+            </p:nvSpPr>
+            <p:spPr>
+              <a:xfrm>
+                <a:off x="1224164" y="650697"/>
+                <a:ext cx="267629" cy="267629"/>
+              </a:xfrm>
+              <a:prstGeom prst="ellipse">
+                <a:avLst/>
+              </a:prstGeom>
+              <a:solidFill>
+                <a:srgbClr val="FF0000"/>
+              </a:solidFill>
+              <a:ln w="22225"/>
+            </p:spPr>
+            <p:style>
+              <a:lnRef idx="2">
+                <a:schemeClr val="accent1">
+                  <a:shade val="15000"/>
+                </a:schemeClr>
+              </a:lnRef>
+              <a:fillRef idx="1">
+                <a:schemeClr val="accent1"/>
+              </a:fillRef>
+              <a:effectRef idx="0">
+                <a:schemeClr val="accent1"/>
+              </a:effectRef>
+              <a:fontRef idx="minor">
+                <a:schemeClr val="lt1"/>
+              </a:fontRef>
+            </p:style>
+            <p:txBody>
+              <a:bodyPr rtlCol="0" anchor="ctr"/>
+              <a:lstStyle/>
+              <a:p>
+                <a:pPr algn="ctr"/>
+                <a:endParaRPr lang="en-US"/>
+              </a:p>
+            </p:txBody>
+          </p:sp>
+          <p:sp>
+            <p:nvSpPr>
+              <p:cNvPr id="84" name="Oval 83">
+                <a:extLst>
+                  <a:ext uri="{FF2B5EF4-FFF2-40B4-BE49-F238E27FC236}">
+                    <a16:creationId xmlns:a16="http://schemas.microsoft.com/office/drawing/2014/main" id="{2D5CF6B1-CE80-9DCB-2588-89DDC8F68699}"/>
+                  </a:ext>
+                </a:extLst>
+              </p:cNvPr>
+              <p:cNvSpPr/>
+              <p:nvPr/>
+            </p:nvSpPr>
+            <p:spPr>
+              <a:xfrm>
+                <a:off x="1614504" y="653159"/>
                 <a:ext cx="267629" cy="267629"/>
               </a:xfrm>
               <a:prstGeom prst="ellipse">
@@ -20295,10 +20157,10 @@
         </p:grpSp>
         <p:grpSp>
           <p:nvGrpSpPr>
-            <p:cNvPr id="183" name="Group 182">
-              <a:extLst>
-                <a:ext uri="{FF2B5EF4-FFF2-40B4-BE49-F238E27FC236}">
-                  <a16:creationId xmlns:a16="http://schemas.microsoft.com/office/drawing/2014/main" id="{B874B7DE-7D17-7594-8765-3F8B21F0BFDA}"/>
+            <p:cNvPr id="85" name="Group 84">
+              <a:extLst>
+                <a:ext uri="{FF2B5EF4-FFF2-40B4-BE49-F238E27FC236}">
+                  <a16:creationId xmlns:a16="http://schemas.microsoft.com/office/drawing/2014/main" id="{B8FFA319-105C-8719-7AC1-80135F2CB906}"/>
                 </a:ext>
               </a:extLst>
             </p:cNvPr>
@@ -20307,18 +20169,18 @@
           </p:nvGrpSpPr>
           <p:grpSpPr>
             <a:xfrm>
-              <a:off x="8727922" y="6698343"/>
-              <a:ext cx="2042468" cy="473633"/>
-              <a:chOff x="-4846261" y="583986"/>
-              <a:chExt cx="2042468" cy="473633"/>
+              <a:off x="-734906" y="6674460"/>
+              <a:ext cx="1671045" cy="473633"/>
+              <a:chOff x="343224" y="555912"/>
+              <a:chExt cx="1671045" cy="473633"/>
             </a:xfrm>
           </p:grpSpPr>
           <p:sp>
             <p:nvSpPr>
-              <p:cNvPr id="184" name="Rounded Rectangle 183">
+              <p:cNvPr id="86" name="Rounded Rectangle 85">
                 <a:extLst>
                   <a:ext uri="{FF2B5EF4-FFF2-40B4-BE49-F238E27FC236}">
-                    <a16:creationId xmlns:a16="http://schemas.microsoft.com/office/drawing/2014/main" id="{50BBB71D-3E87-2891-71F1-831B7548FABA}"/>
+                    <a16:creationId xmlns:a16="http://schemas.microsoft.com/office/drawing/2014/main" id="{37F09ADE-5429-C4C9-BE45-91CFD5667D08}"/>
                   </a:ext>
                 </a:extLst>
               </p:cNvPr>
@@ -20327,8 +20189,8 @@
             </p:nvSpPr>
             <p:spPr>
               <a:xfrm>
-                <a:off x="-4846261" y="583986"/>
-                <a:ext cx="2042468" cy="473633"/>
+                <a:off x="343224" y="555912"/>
+                <a:ext cx="1671045" cy="473633"/>
               </a:xfrm>
               <a:prstGeom prst="roundRect">
                 <a:avLst/>
@@ -20365,10 +20227,10 @@
           </p:sp>
           <p:sp>
             <p:nvSpPr>
-              <p:cNvPr id="185" name="Oval 184">
+              <p:cNvPr id="87" name="Oval 86">
                 <a:extLst>
                   <a:ext uri="{FF2B5EF4-FFF2-40B4-BE49-F238E27FC236}">
-                    <a16:creationId xmlns:a16="http://schemas.microsoft.com/office/drawing/2014/main" id="{7B8421C5-4A27-34F7-F412-F6B7E8E3478B}"/>
+                    <a16:creationId xmlns:a16="http://schemas.microsoft.com/office/drawing/2014/main" id="{FE21E09C-6D1E-51E8-4753-9E4020CFEB27}"/>
                   </a:ext>
                 </a:extLst>
               </p:cNvPr>
@@ -20377,7 +20239,107 @@
             </p:nvSpPr>
             <p:spPr>
               <a:xfrm>
-                <a:off x="-4723598" y="678771"/>
+                <a:off x="465887" y="650697"/>
+                <a:ext cx="267629" cy="267629"/>
+              </a:xfrm>
+              <a:prstGeom prst="ellipse">
+                <a:avLst/>
+              </a:prstGeom>
+              <a:solidFill>
+                <a:srgbClr val="FF0000"/>
+              </a:solidFill>
+              <a:ln w="22225"/>
+            </p:spPr>
+            <p:style>
+              <a:lnRef idx="2">
+                <a:schemeClr val="accent1">
+                  <a:shade val="15000"/>
+                </a:schemeClr>
+              </a:lnRef>
+              <a:fillRef idx="1">
+                <a:schemeClr val="accent1"/>
+              </a:fillRef>
+              <a:effectRef idx="0">
+                <a:schemeClr val="accent1"/>
+              </a:effectRef>
+              <a:fontRef idx="minor">
+                <a:schemeClr val="lt1"/>
+              </a:fontRef>
+            </p:style>
+            <p:txBody>
+              <a:bodyPr rtlCol="0" anchor="ctr"/>
+              <a:lstStyle/>
+              <a:p>
+                <a:pPr algn="ctr"/>
+                <a:endParaRPr lang="en-US"/>
+              </a:p>
+            </p:txBody>
+          </p:sp>
+          <p:sp>
+            <p:nvSpPr>
+              <p:cNvPr id="88" name="Oval 87">
+                <a:extLst>
+                  <a:ext uri="{FF2B5EF4-FFF2-40B4-BE49-F238E27FC236}">
+                    <a16:creationId xmlns:a16="http://schemas.microsoft.com/office/drawing/2014/main" id="{8AC74043-A6EB-37B3-88EC-26680C779BBC}"/>
+                  </a:ext>
+                </a:extLst>
+              </p:cNvPr>
+              <p:cNvSpPr/>
+              <p:nvPr/>
+            </p:nvSpPr>
+            <p:spPr>
+              <a:xfrm>
+                <a:off x="856178" y="650697"/>
+                <a:ext cx="267629" cy="267629"/>
+              </a:xfrm>
+              <a:prstGeom prst="ellipse">
+                <a:avLst/>
+              </a:prstGeom>
+              <a:solidFill>
+                <a:srgbClr val="FF0000"/>
+              </a:solidFill>
+              <a:ln w="22225"/>
+            </p:spPr>
+            <p:style>
+              <a:lnRef idx="2">
+                <a:schemeClr val="accent1">
+                  <a:shade val="15000"/>
+                </a:schemeClr>
+              </a:lnRef>
+              <a:fillRef idx="1">
+                <a:schemeClr val="accent1"/>
+              </a:fillRef>
+              <a:effectRef idx="0">
+                <a:schemeClr val="accent1"/>
+              </a:effectRef>
+              <a:fontRef idx="minor">
+                <a:schemeClr val="lt1"/>
+              </a:fontRef>
+            </p:style>
+            <p:txBody>
+              <a:bodyPr rtlCol="0" anchor="ctr"/>
+              <a:lstStyle/>
+              <a:p>
+                <a:pPr algn="ctr"/>
+                <a:endParaRPr lang="en-US"/>
+              </a:p>
+            </p:txBody>
+          </p:sp>
+          <p:sp>
+            <p:nvSpPr>
+              <p:cNvPr id="89" name="Oval 88">
+                <a:extLst>
+                  <a:ext uri="{FF2B5EF4-FFF2-40B4-BE49-F238E27FC236}">
+                    <a16:creationId xmlns:a16="http://schemas.microsoft.com/office/drawing/2014/main" id="{24809D62-DCB5-DAD1-1424-3B9EF59773E8}"/>
+                  </a:ext>
+                </a:extLst>
+              </p:cNvPr>
+              <p:cNvSpPr/>
+              <p:nvPr/>
+            </p:nvSpPr>
+            <p:spPr>
+              <a:xfrm>
+                <a:off x="1224164" y="650697"/>
                 <a:ext cx="267629" cy="267629"/>
               </a:xfrm>
               <a:prstGeom prst="ellipse">
@@ -20415,10 +20377,10 @@
           </p:sp>
           <p:sp>
             <p:nvSpPr>
-              <p:cNvPr id="186" name="Oval 185">
+              <p:cNvPr id="90" name="Oval 89">
                 <a:extLst>
                   <a:ext uri="{FF2B5EF4-FFF2-40B4-BE49-F238E27FC236}">
-                    <a16:creationId xmlns:a16="http://schemas.microsoft.com/office/drawing/2014/main" id="{34E12A0E-42DD-460E-4507-E1BEBE26347A}"/>
+                    <a16:creationId xmlns:a16="http://schemas.microsoft.com/office/drawing/2014/main" id="{31C7E47D-78B8-1EF7-F86F-F17DF3055412}"/>
                   </a:ext>
                 </a:extLst>
               </p:cNvPr>
@@ -20427,478 +20389,7 @@
             </p:nvSpPr>
             <p:spPr>
               <a:xfrm>
-                <a:off x="-4333307" y="678771"/>
-                <a:ext cx="267629" cy="267629"/>
-              </a:xfrm>
-              <a:prstGeom prst="ellipse">
-                <a:avLst/>
-              </a:prstGeom>
-              <a:solidFill>
-                <a:srgbClr val="00B050"/>
-              </a:solidFill>
-              <a:ln w="22225"/>
-            </p:spPr>
-            <p:style>
-              <a:lnRef idx="2">
-                <a:schemeClr val="accent1">
-                  <a:shade val="15000"/>
-                </a:schemeClr>
-              </a:lnRef>
-              <a:fillRef idx="1">
-                <a:schemeClr val="accent1"/>
-              </a:fillRef>
-              <a:effectRef idx="0">
-                <a:schemeClr val="accent1"/>
-              </a:effectRef>
-              <a:fontRef idx="minor">
-                <a:schemeClr val="lt1"/>
-              </a:fontRef>
-            </p:style>
-            <p:txBody>
-              <a:bodyPr rtlCol="0" anchor="ctr"/>
-              <a:lstStyle/>
-              <a:p>
-                <a:pPr algn="ctr"/>
-                <a:endParaRPr lang="en-US"/>
-              </a:p>
-            </p:txBody>
-          </p:sp>
-          <p:sp>
-            <p:nvSpPr>
-              <p:cNvPr id="187" name="Oval 186">
-                <a:extLst>
-                  <a:ext uri="{FF2B5EF4-FFF2-40B4-BE49-F238E27FC236}">
-                    <a16:creationId xmlns:a16="http://schemas.microsoft.com/office/drawing/2014/main" id="{906C8111-2B1D-E073-0718-762635FBED05}"/>
-                  </a:ext>
-                </a:extLst>
-              </p:cNvPr>
-              <p:cNvSpPr/>
-              <p:nvPr/>
-            </p:nvSpPr>
-            <p:spPr>
-              <a:xfrm>
-                <a:off x="-3965321" y="678771"/>
-                <a:ext cx="267629" cy="267629"/>
-              </a:xfrm>
-              <a:prstGeom prst="ellipse">
-                <a:avLst/>
-              </a:prstGeom>
-              <a:solidFill>
-                <a:srgbClr val="00B050"/>
-              </a:solidFill>
-              <a:ln w="22225"/>
-            </p:spPr>
-            <p:style>
-              <a:lnRef idx="2">
-                <a:schemeClr val="accent1">
-                  <a:shade val="15000"/>
-                </a:schemeClr>
-              </a:lnRef>
-              <a:fillRef idx="1">
-                <a:schemeClr val="accent1"/>
-              </a:fillRef>
-              <a:effectRef idx="0">
-                <a:schemeClr val="accent1"/>
-              </a:effectRef>
-              <a:fontRef idx="minor">
-                <a:schemeClr val="lt1"/>
-              </a:fontRef>
-            </p:style>
-            <p:txBody>
-              <a:bodyPr rtlCol="0" anchor="ctr"/>
-              <a:lstStyle/>
-              <a:p>
-                <a:pPr algn="ctr"/>
-                <a:endParaRPr lang="en-US"/>
-              </a:p>
-            </p:txBody>
-          </p:sp>
-          <p:sp>
-            <p:nvSpPr>
-              <p:cNvPr id="188" name="Oval 187">
-                <a:extLst>
-                  <a:ext uri="{FF2B5EF4-FFF2-40B4-BE49-F238E27FC236}">
-                    <a16:creationId xmlns:a16="http://schemas.microsoft.com/office/drawing/2014/main" id="{0EF14BA9-80F1-F9BF-408E-2D7CF7B4C17E}"/>
-                  </a:ext>
-                </a:extLst>
-              </p:cNvPr>
-              <p:cNvSpPr/>
-              <p:nvPr/>
-            </p:nvSpPr>
-            <p:spPr>
-              <a:xfrm>
-                <a:off x="-3574981" y="681233"/>
-                <a:ext cx="267629" cy="267629"/>
-              </a:xfrm>
-              <a:prstGeom prst="ellipse">
-                <a:avLst/>
-              </a:prstGeom>
-              <a:solidFill>
-                <a:srgbClr val="00B050"/>
-              </a:solidFill>
-              <a:ln w="22225"/>
-            </p:spPr>
-            <p:style>
-              <a:lnRef idx="2">
-                <a:schemeClr val="accent1">
-                  <a:shade val="15000"/>
-                </a:schemeClr>
-              </a:lnRef>
-              <a:fillRef idx="1">
-                <a:schemeClr val="accent1"/>
-              </a:fillRef>
-              <a:effectRef idx="0">
-                <a:schemeClr val="accent1"/>
-              </a:effectRef>
-              <a:fontRef idx="minor">
-                <a:schemeClr val="lt1"/>
-              </a:fontRef>
-            </p:style>
-            <p:txBody>
-              <a:bodyPr rtlCol="0" anchor="ctr"/>
-              <a:lstStyle/>
-              <a:p>
-                <a:pPr algn="ctr"/>
-                <a:endParaRPr lang="en-US"/>
-              </a:p>
-            </p:txBody>
-          </p:sp>
-          <p:sp>
-            <p:nvSpPr>
-              <p:cNvPr id="189" name="Oval 188">
-                <a:extLst>
-                  <a:ext uri="{FF2B5EF4-FFF2-40B4-BE49-F238E27FC236}">
-                    <a16:creationId xmlns:a16="http://schemas.microsoft.com/office/drawing/2014/main" id="{578EAFA5-091D-92F9-62C7-739962777885}"/>
-                  </a:ext>
-                </a:extLst>
-              </p:cNvPr>
-              <p:cNvSpPr/>
-              <p:nvPr/>
-            </p:nvSpPr>
-            <p:spPr>
-              <a:xfrm>
-                <a:off x="-3206995" y="681233"/>
-                <a:ext cx="267629" cy="267629"/>
-              </a:xfrm>
-              <a:prstGeom prst="ellipse">
-                <a:avLst/>
-              </a:prstGeom>
-              <a:solidFill>
-                <a:srgbClr val="00B050"/>
-              </a:solidFill>
-              <a:ln w="22225"/>
-            </p:spPr>
-            <p:style>
-              <a:lnRef idx="2">
-                <a:schemeClr val="accent1">
-                  <a:shade val="15000"/>
-                </a:schemeClr>
-              </a:lnRef>
-              <a:fillRef idx="1">
-                <a:schemeClr val="accent1"/>
-              </a:fillRef>
-              <a:effectRef idx="0">
-                <a:schemeClr val="accent1"/>
-              </a:effectRef>
-              <a:fontRef idx="minor">
-                <a:schemeClr val="lt1"/>
-              </a:fontRef>
-            </p:style>
-            <p:txBody>
-              <a:bodyPr rtlCol="0" anchor="ctr"/>
-              <a:lstStyle/>
-              <a:p>
-                <a:pPr algn="ctr"/>
-                <a:endParaRPr lang="en-US"/>
-              </a:p>
-            </p:txBody>
-          </p:sp>
-        </p:grpSp>
-        <p:grpSp>
-          <p:nvGrpSpPr>
-            <p:cNvPr id="191" name="Group 190">
-              <a:extLst>
-                <a:ext uri="{FF2B5EF4-FFF2-40B4-BE49-F238E27FC236}">
-                  <a16:creationId xmlns:a16="http://schemas.microsoft.com/office/drawing/2014/main" id="{D4FCF598-A02B-7464-4635-C166E5214A9D}"/>
-                </a:ext>
-              </a:extLst>
-            </p:cNvPr>
-            <p:cNvGrpSpPr/>
-            <p:nvPr/>
-          </p:nvGrpSpPr>
-          <p:grpSpPr>
-            <a:xfrm>
-              <a:off x="11934019" y="6688236"/>
-              <a:ext cx="2042468" cy="473633"/>
-              <a:chOff x="-4846261" y="583986"/>
-              <a:chExt cx="2042468" cy="473633"/>
-            </a:xfrm>
-          </p:grpSpPr>
-          <p:sp>
-            <p:nvSpPr>
-              <p:cNvPr id="192" name="Rounded Rectangle 191">
-                <a:extLst>
-                  <a:ext uri="{FF2B5EF4-FFF2-40B4-BE49-F238E27FC236}">
-                    <a16:creationId xmlns:a16="http://schemas.microsoft.com/office/drawing/2014/main" id="{E8B367A6-4DEE-76D6-FB1B-F63C5285EC1F}"/>
-                  </a:ext>
-                </a:extLst>
-              </p:cNvPr>
-              <p:cNvSpPr/>
-              <p:nvPr/>
-            </p:nvSpPr>
-            <p:spPr>
-              <a:xfrm>
-                <a:off x="-4846261" y="583986"/>
-                <a:ext cx="2042468" cy="473633"/>
-              </a:xfrm>
-              <a:prstGeom prst="roundRect">
-                <a:avLst/>
-              </a:prstGeom>
-              <a:solidFill>
-                <a:schemeClr val="bg2"/>
-              </a:solidFill>
-              <a:ln w="22225"/>
-            </p:spPr>
-            <p:style>
-              <a:lnRef idx="2">
-                <a:schemeClr val="accent1">
-                  <a:shade val="15000"/>
-                </a:schemeClr>
-              </a:lnRef>
-              <a:fillRef idx="1">
-                <a:schemeClr val="accent1"/>
-              </a:fillRef>
-              <a:effectRef idx="0">
-                <a:schemeClr val="accent1"/>
-              </a:effectRef>
-              <a:fontRef idx="minor">
-                <a:schemeClr val="lt1"/>
-              </a:fontRef>
-            </p:style>
-            <p:txBody>
-              <a:bodyPr rtlCol="0" anchor="ctr"/>
-              <a:lstStyle/>
-              <a:p>
-                <a:pPr algn="ctr"/>
-                <a:endParaRPr lang="en-US"/>
-              </a:p>
-            </p:txBody>
-          </p:sp>
-          <p:sp>
-            <p:nvSpPr>
-              <p:cNvPr id="193" name="Oval 192">
-                <a:extLst>
-                  <a:ext uri="{FF2B5EF4-FFF2-40B4-BE49-F238E27FC236}">
-                    <a16:creationId xmlns:a16="http://schemas.microsoft.com/office/drawing/2014/main" id="{5E0606BF-DD1B-1536-8293-5713D2645BAF}"/>
-                  </a:ext>
-                </a:extLst>
-              </p:cNvPr>
-              <p:cNvSpPr/>
-              <p:nvPr/>
-            </p:nvSpPr>
-            <p:spPr>
-              <a:xfrm>
-                <a:off x="-4723598" y="678771"/>
-                <a:ext cx="267629" cy="267629"/>
-              </a:xfrm>
-              <a:prstGeom prst="ellipse">
-                <a:avLst/>
-              </a:prstGeom>
-              <a:solidFill>
-                <a:srgbClr val="00B050"/>
-              </a:solidFill>
-              <a:ln w="22225"/>
-            </p:spPr>
-            <p:style>
-              <a:lnRef idx="2">
-                <a:schemeClr val="accent1">
-                  <a:shade val="15000"/>
-                </a:schemeClr>
-              </a:lnRef>
-              <a:fillRef idx="1">
-                <a:schemeClr val="accent1"/>
-              </a:fillRef>
-              <a:effectRef idx="0">
-                <a:schemeClr val="accent1"/>
-              </a:effectRef>
-              <a:fontRef idx="minor">
-                <a:schemeClr val="lt1"/>
-              </a:fontRef>
-            </p:style>
-            <p:txBody>
-              <a:bodyPr rtlCol="0" anchor="ctr"/>
-              <a:lstStyle/>
-              <a:p>
-                <a:pPr algn="ctr"/>
-                <a:endParaRPr lang="en-US"/>
-              </a:p>
-            </p:txBody>
-          </p:sp>
-          <p:sp>
-            <p:nvSpPr>
-              <p:cNvPr id="194" name="Oval 193">
-                <a:extLst>
-                  <a:ext uri="{FF2B5EF4-FFF2-40B4-BE49-F238E27FC236}">
-                    <a16:creationId xmlns:a16="http://schemas.microsoft.com/office/drawing/2014/main" id="{82B82AC5-396F-EF35-5D1B-F1845A0997C2}"/>
-                  </a:ext>
-                </a:extLst>
-              </p:cNvPr>
-              <p:cNvSpPr/>
-              <p:nvPr/>
-            </p:nvSpPr>
-            <p:spPr>
-              <a:xfrm>
-                <a:off x="-4333307" y="678771"/>
-                <a:ext cx="267629" cy="267629"/>
-              </a:xfrm>
-              <a:prstGeom prst="ellipse">
-                <a:avLst/>
-              </a:prstGeom>
-              <a:solidFill>
-                <a:srgbClr val="00B050"/>
-              </a:solidFill>
-              <a:ln w="22225"/>
-            </p:spPr>
-            <p:style>
-              <a:lnRef idx="2">
-                <a:schemeClr val="accent1">
-                  <a:shade val="15000"/>
-                </a:schemeClr>
-              </a:lnRef>
-              <a:fillRef idx="1">
-                <a:schemeClr val="accent1"/>
-              </a:fillRef>
-              <a:effectRef idx="0">
-                <a:schemeClr val="accent1"/>
-              </a:effectRef>
-              <a:fontRef idx="minor">
-                <a:schemeClr val="lt1"/>
-              </a:fontRef>
-            </p:style>
-            <p:txBody>
-              <a:bodyPr rtlCol="0" anchor="ctr"/>
-              <a:lstStyle/>
-              <a:p>
-                <a:pPr algn="ctr"/>
-                <a:endParaRPr lang="en-US"/>
-              </a:p>
-            </p:txBody>
-          </p:sp>
-          <p:sp>
-            <p:nvSpPr>
-              <p:cNvPr id="195" name="Oval 194">
-                <a:extLst>
-                  <a:ext uri="{FF2B5EF4-FFF2-40B4-BE49-F238E27FC236}">
-                    <a16:creationId xmlns:a16="http://schemas.microsoft.com/office/drawing/2014/main" id="{B7099D5B-1102-E229-842E-CB5A7BE04E22}"/>
-                  </a:ext>
-                </a:extLst>
-              </p:cNvPr>
-              <p:cNvSpPr/>
-              <p:nvPr/>
-            </p:nvSpPr>
-            <p:spPr>
-              <a:xfrm>
-                <a:off x="-3965321" y="678771"/>
-                <a:ext cx="267629" cy="267629"/>
-              </a:xfrm>
-              <a:prstGeom prst="ellipse">
-                <a:avLst/>
-              </a:prstGeom>
-              <a:solidFill>
-                <a:srgbClr val="FF0000"/>
-              </a:solidFill>
-              <a:ln w="22225"/>
-            </p:spPr>
-            <p:style>
-              <a:lnRef idx="2">
-                <a:schemeClr val="accent1">
-                  <a:shade val="15000"/>
-                </a:schemeClr>
-              </a:lnRef>
-              <a:fillRef idx="1">
-                <a:schemeClr val="accent1"/>
-              </a:fillRef>
-              <a:effectRef idx="0">
-                <a:schemeClr val="accent1"/>
-              </a:effectRef>
-              <a:fontRef idx="minor">
-                <a:schemeClr val="lt1"/>
-              </a:fontRef>
-            </p:style>
-            <p:txBody>
-              <a:bodyPr rtlCol="0" anchor="ctr"/>
-              <a:lstStyle/>
-              <a:p>
-                <a:pPr algn="ctr"/>
-                <a:endParaRPr lang="en-US"/>
-              </a:p>
-            </p:txBody>
-          </p:sp>
-          <p:sp>
-            <p:nvSpPr>
-              <p:cNvPr id="196" name="Oval 195">
-                <a:extLst>
-                  <a:ext uri="{FF2B5EF4-FFF2-40B4-BE49-F238E27FC236}">
-                    <a16:creationId xmlns:a16="http://schemas.microsoft.com/office/drawing/2014/main" id="{3CB6FB05-1DB2-FAD8-5C19-C65DB4DCA68A}"/>
-                  </a:ext>
-                </a:extLst>
-              </p:cNvPr>
-              <p:cNvSpPr/>
-              <p:nvPr/>
-            </p:nvSpPr>
-            <p:spPr>
-              <a:xfrm>
-                <a:off x="-3574981" y="681233"/>
-                <a:ext cx="267629" cy="267629"/>
-              </a:xfrm>
-              <a:prstGeom prst="ellipse">
-                <a:avLst/>
-              </a:prstGeom>
-              <a:solidFill>
-                <a:srgbClr val="FF0000"/>
-              </a:solidFill>
-              <a:ln w="22225"/>
-            </p:spPr>
-            <p:style>
-              <a:lnRef idx="2">
-                <a:schemeClr val="accent1">
-                  <a:shade val="15000"/>
-                </a:schemeClr>
-              </a:lnRef>
-              <a:fillRef idx="1">
-                <a:schemeClr val="accent1"/>
-              </a:fillRef>
-              <a:effectRef idx="0">
-                <a:schemeClr val="accent1"/>
-              </a:effectRef>
-              <a:fontRef idx="minor">
-                <a:schemeClr val="lt1"/>
-              </a:fontRef>
-            </p:style>
-            <p:txBody>
-              <a:bodyPr rtlCol="0" anchor="ctr"/>
-              <a:lstStyle/>
-              <a:p>
-                <a:pPr algn="ctr"/>
-                <a:endParaRPr lang="en-US"/>
-              </a:p>
-            </p:txBody>
-          </p:sp>
-          <p:sp>
-            <p:nvSpPr>
-              <p:cNvPr id="198" name="Oval 197">
-                <a:extLst>
-                  <a:ext uri="{FF2B5EF4-FFF2-40B4-BE49-F238E27FC236}">
-                    <a16:creationId xmlns:a16="http://schemas.microsoft.com/office/drawing/2014/main" id="{8FE30223-6800-FA0B-11FF-45EAD84C3D3C}"/>
-                  </a:ext>
-                </a:extLst>
-              </p:cNvPr>
-              <p:cNvSpPr/>
-              <p:nvPr/>
-            </p:nvSpPr>
-            <p:spPr>
-              <a:xfrm>
-                <a:off x="-3206995" y="681233"/>
+                <a:off x="1614504" y="653159"/>
                 <a:ext cx="267629" cy="267629"/>
               </a:xfrm>
               <a:prstGeom prst="ellipse">
@@ -20937,10 +20428,10 @@
         </p:grpSp>
         <p:grpSp>
           <p:nvGrpSpPr>
-            <p:cNvPr id="199" name="Group 198">
-              <a:extLst>
-                <a:ext uri="{FF2B5EF4-FFF2-40B4-BE49-F238E27FC236}">
-                  <a16:creationId xmlns:a16="http://schemas.microsoft.com/office/drawing/2014/main" id="{23A791D0-023D-DA79-39D8-276C86E04384}"/>
+            <p:cNvPr id="91" name="Group 90">
+              <a:extLst>
+                <a:ext uri="{FF2B5EF4-FFF2-40B4-BE49-F238E27FC236}">
+                  <a16:creationId xmlns:a16="http://schemas.microsoft.com/office/drawing/2014/main" id="{43616AF5-DD12-4BF9-68F8-1B8309DE4B4F}"/>
                 </a:ext>
               </a:extLst>
             </p:cNvPr>
@@ -20949,18 +20440,18 @@
           </p:nvGrpSpPr>
           <p:grpSpPr>
             <a:xfrm>
-              <a:off x="482980" y="9521241"/>
-              <a:ext cx="2042468" cy="473633"/>
-              <a:chOff x="-4846261" y="583986"/>
-              <a:chExt cx="2042468" cy="473633"/>
+              <a:off x="4127553" y="9503325"/>
+              <a:ext cx="1671045" cy="473633"/>
+              <a:chOff x="343224" y="555912"/>
+              <a:chExt cx="1671045" cy="473633"/>
             </a:xfrm>
           </p:grpSpPr>
           <p:sp>
             <p:nvSpPr>
-              <p:cNvPr id="200" name="Rounded Rectangle 199">
+              <p:cNvPr id="92" name="Rounded Rectangle 91">
                 <a:extLst>
                   <a:ext uri="{FF2B5EF4-FFF2-40B4-BE49-F238E27FC236}">
-                    <a16:creationId xmlns:a16="http://schemas.microsoft.com/office/drawing/2014/main" id="{6DFB6D19-466B-C081-E990-43869FC8F4C7}"/>
+                    <a16:creationId xmlns:a16="http://schemas.microsoft.com/office/drawing/2014/main" id="{E9A1A45D-7293-CCE6-62A9-E49D2EE357A5}"/>
                   </a:ext>
                 </a:extLst>
               </p:cNvPr>
@@ -20969,8 +20460,8 @@
             </p:nvSpPr>
             <p:spPr>
               <a:xfrm>
-                <a:off x="-4846261" y="583986"/>
-                <a:ext cx="2042468" cy="473633"/>
+                <a:off x="343224" y="555912"/>
+                <a:ext cx="1671045" cy="473633"/>
               </a:xfrm>
               <a:prstGeom prst="roundRect">
                 <a:avLst/>
@@ -21007,10 +20498,10 @@
           </p:sp>
           <p:sp>
             <p:nvSpPr>
-              <p:cNvPr id="201" name="Oval 200">
+              <p:cNvPr id="93" name="Oval 92">
                 <a:extLst>
                   <a:ext uri="{FF2B5EF4-FFF2-40B4-BE49-F238E27FC236}">
-                    <a16:creationId xmlns:a16="http://schemas.microsoft.com/office/drawing/2014/main" id="{9D2D3F9C-289B-3AAD-B08A-682B0604D567}"/>
+                    <a16:creationId xmlns:a16="http://schemas.microsoft.com/office/drawing/2014/main" id="{1BC01EEE-3A05-BF5B-7AA8-71B6FC6029BB}"/>
                   </a:ext>
                 </a:extLst>
               </p:cNvPr>
@@ -21019,7 +20510,7 @@
             </p:nvSpPr>
             <p:spPr>
               <a:xfrm>
-                <a:off x="-4723598" y="678771"/>
+                <a:off x="465887" y="650697"/>
                 <a:ext cx="267629" cy="267629"/>
               </a:xfrm>
               <a:prstGeom prst="ellipse">
@@ -21057,10 +20548,10 @@
           </p:sp>
           <p:sp>
             <p:nvSpPr>
-              <p:cNvPr id="202" name="Oval 201">
+              <p:cNvPr id="94" name="Oval 93">
                 <a:extLst>
                   <a:ext uri="{FF2B5EF4-FFF2-40B4-BE49-F238E27FC236}">
-                    <a16:creationId xmlns:a16="http://schemas.microsoft.com/office/drawing/2014/main" id="{D353144F-5464-991D-D996-15AB1303801E}"/>
+                    <a16:creationId xmlns:a16="http://schemas.microsoft.com/office/drawing/2014/main" id="{FB400595-5CEA-6752-4FAE-2DF7229A8568}"/>
                   </a:ext>
                 </a:extLst>
               </p:cNvPr>
@@ -21069,7 +20560,7 @@
             </p:nvSpPr>
             <p:spPr>
               <a:xfrm>
-                <a:off x="-4333307" y="678771"/>
+                <a:off x="856178" y="650697"/>
                 <a:ext cx="267629" cy="267629"/>
               </a:xfrm>
               <a:prstGeom prst="ellipse">
@@ -21107,10 +20598,10 @@
           </p:sp>
           <p:sp>
             <p:nvSpPr>
-              <p:cNvPr id="224" name="Oval 223">
+              <p:cNvPr id="95" name="Oval 94">
                 <a:extLst>
                   <a:ext uri="{FF2B5EF4-FFF2-40B4-BE49-F238E27FC236}">
-                    <a16:creationId xmlns:a16="http://schemas.microsoft.com/office/drawing/2014/main" id="{425BC304-D610-9AC8-F90F-2559558B6C75}"/>
+                    <a16:creationId xmlns:a16="http://schemas.microsoft.com/office/drawing/2014/main" id="{E1574AC4-834F-31F0-28A5-9FAD5F8C4E2A}"/>
                   </a:ext>
                 </a:extLst>
               </p:cNvPr>
@@ -21119,7 +20610,7 @@
             </p:nvSpPr>
             <p:spPr>
               <a:xfrm>
-                <a:off x="-3965321" y="678771"/>
+                <a:off x="1224164" y="650697"/>
                 <a:ext cx="267629" cy="267629"/>
               </a:xfrm>
               <a:prstGeom prst="ellipse">
@@ -21157,10 +20648,10 @@
           </p:sp>
           <p:sp>
             <p:nvSpPr>
-              <p:cNvPr id="225" name="Oval 224">
+              <p:cNvPr id="96" name="Oval 95">
                 <a:extLst>
                   <a:ext uri="{FF2B5EF4-FFF2-40B4-BE49-F238E27FC236}">
-                    <a16:creationId xmlns:a16="http://schemas.microsoft.com/office/drawing/2014/main" id="{5C793F61-E9EE-96BC-A056-7E1E488275A5}"/>
+                    <a16:creationId xmlns:a16="http://schemas.microsoft.com/office/drawing/2014/main" id="{F7DD7DE5-3316-F2AB-782C-40E0EB49AB62}"/>
                   </a:ext>
                 </a:extLst>
               </p:cNvPr>
@@ -21169,378 +20660,7 @@
             </p:nvSpPr>
             <p:spPr>
               <a:xfrm>
-                <a:off x="-3574981" y="681233"/>
-                <a:ext cx="267629" cy="267629"/>
-              </a:xfrm>
-              <a:prstGeom prst="ellipse">
-                <a:avLst/>
-              </a:prstGeom>
-              <a:solidFill>
-                <a:srgbClr val="00B050"/>
-              </a:solidFill>
-              <a:ln w="22225"/>
-            </p:spPr>
-            <p:style>
-              <a:lnRef idx="2">
-                <a:schemeClr val="accent1">
-                  <a:shade val="15000"/>
-                </a:schemeClr>
-              </a:lnRef>
-              <a:fillRef idx="1">
-                <a:schemeClr val="accent1"/>
-              </a:fillRef>
-              <a:effectRef idx="0">
-                <a:schemeClr val="accent1"/>
-              </a:effectRef>
-              <a:fontRef idx="minor">
-                <a:schemeClr val="lt1"/>
-              </a:fontRef>
-            </p:style>
-            <p:txBody>
-              <a:bodyPr rtlCol="0" anchor="ctr"/>
-              <a:lstStyle/>
-              <a:p>
-                <a:pPr algn="ctr"/>
-                <a:endParaRPr lang="en-US"/>
-              </a:p>
-            </p:txBody>
-          </p:sp>
-          <p:sp>
-            <p:nvSpPr>
-              <p:cNvPr id="226" name="Oval 225">
-                <a:extLst>
-                  <a:ext uri="{FF2B5EF4-FFF2-40B4-BE49-F238E27FC236}">
-                    <a16:creationId xmlns:a16="http://schemas.microsoft.com/office/drawing/2014/main" id="{77E4A063-101E-BFF2-80C6-4FA1D1AED630}"/>
-                  </a:ext>
-                </a:extLst>
-              </p:cNvPr>
-              <p:cNvSpPr/>
-              <p:nvPr/>
-            </p:nvSpPr>
-            <p:spPr>
-              <a:xfrm>
-                <a:off x="-3206995" y="681233"/>
-                <a:ext cx="267629" cy="267629"/>
-              </a:xfrm>
-              <a:prstGeom prst="ellipse">
-                <a:avLst/>
-              </a:prstGeom>
-              <a:solidFill>
-                <a:srgbClr val="00B050"/>
-              </a:solidFill>
-              <a:ln w="22225"/>
-            </p:spPr>
-            <p:style>
-              <a:lnRef idx="2">
-                <a:schemeClr val="accent1">
-                  <a:shade val="15000"/>
-                </a:schemeClr>
-              </a:lnRef>
-              <a:fillRef idx="1">
-                <a:schemeClr val="accent1"/>
-              </a:fillRef>
-              <a:effectRef idx="0">
-                <a:schemeClr val="accent1"/>
-              </a:effectRef>
-              <a:fontRef idx="minor">
-                <a:schemeClr val="lt1"/>
-              </a:fontRef>
-            </p:style>
-            <p:txBody>
-              <a:bodyPr rtlCol="0" anchor="ctr"/>
-              <a:lstStyle/>
-              <a:p>
-                <a:pPr algn="ctr"/>
-                <a:endParaRPr lang="en-US"/>
-              </a:p>
-            </p:txBody>
-          </p:sp>
-        </p:grpSp>
-        <p:grpSp>
-          <p:nvGrpSpPr>
-            <p:cNvPr id="227" name="Group 226">
-              <a:extLst>
-                <a:ext uri="{FF2B5EF4-FFF2-40B4-BE49-F238E27FC236}">
-                  <a16:creationId xmlns:a16="http://schemas.microsoft.com/office/drawing/2014/main" id="{E11C6681-74B4-5BFD-D6F3-5D3C44E62450}"/>
-                </a:ext>
-              </a:extLst>
-            </p:cNvPr>
-            <p:cNvGrpSpPr/>
-            <p:nvPr/>
-          </p:nvGrpSpPr>
-          <p:grpSpPr>
-            <a:xfrm>
-              <a:off x="3692653" y="9494051"/>
-              <a:ext cx="2042468" cy="473633"/>
-              <a:chOff x="-4846261" y="583986"/>
-              <a:chExt cx="2042468" cy="473633"/>
-            </a:xfrm>
-          </p:grpSpPr>
-          <p:sp>
-            <p:nvSpPr>
-              <p:cNvPr id="228" name="Rounded Rectangle 227">
-                <a:extLst>
-                  <a:ext uri="{FF2B5EF4-FFF2-40B4-BE49-F238E27FC236}">
-                    <a16:creationId xmlns:a16="http://schemas.microsoft.com/office/drawing/2014/main" id="{A74679C8-387A-08CF-E47D-4D5AA111C6A8}"/>
-                  </a:ext>
-                </a:extLst>
-              </p:cNvPr>
-              <p:cNvSpPr/>
-              <p:nvPr/>
-            </p:nvSpPr>
-            <p:spPr>
-              <a:xfrm>
-                <a:off x="-4846261" y="583986"/>
-                <a:ext cx="2042468" cy="473633"/>
-              </a:xfrm>
-              <a:prstGeom prst="roundRect">
-                <a:avLst/>
-              </a:prstGeom>
-              <a:solidFill>
-                <a:schemeClr val="bg2"/>
-              </a:solidFill>
-              <a:ln w="22225"/>
-            </p:spPr>
-            <p:style>
-              <a:lnRef idx="2">
-                <a:schemeClr val="accent1">
-                  <a:shade val="15000"/>
-                </a:schemeClr>
-              </a:lnRef>
-              <a:fillRef idx="1">
-                <a:schemeClr val="accent1"/>
-              </a:fillRef>
-              <a:effectRef idx="0">
-                <a:schemeClr val="accent1"/>
-              </a:effectRef>
-              <a:fontRef idx="minor">
-                <a:schemeClr val="lt1"/>
-              </a:fontRef>
-            </p:style>
-            <p:txBody>
-              <a:bodyPr rtlCol="0" anchor="ctr"/>
-              <a:lstStyle/>
-              <a:p>
-                <a:pPr algn="ctr"/>
-                <a:endParaRPr lang="en-US"/>
-              </a:p>
-            </p:txBody>
-          </p:sp>
-          <p:sp>
-            <p:nvSpPr>
-              <p:cNvPr id="229" name="Oval 228">
-                <a:extLst>
-                  <a:ext uri="{FF2B5EF4-FFF2-40B4-BE49-F238E27FC236}">
-                    <a16:creationId xmlns:a16="http://schemas.microsoft.com/office/drawing/2014/main" id="{F345627E-7287-DFD7-7212-E5B445731393}"/>
-                  </a:ext>
-                </a:extLst>
-              </p:cNvPr>
-              <p:cNvSpPr/>
-              <p:nvPr/>
-            </p:nvSpPr>
-            <p:spPr>
-              <a:xfrm>
-                <a:off x="-4723598" y="678771"/>
-                <a:ext cx="267629" cy="267629"/>
-              </a:xfrm>
-              <a:prstGeom prst="ellipse">
-                <a:avLst/>
-              </a:prstGeom>
-              <a:solidFill>
-                <a:srgbClr val="FF0000"/>
-              </a:solidFill>
-              <a:ln w="22225"/>
-            </p:spPr>
-            <p:style>
-              <a:lnRef idx="2">
-                <a:schemeClr val="accent1">
-                  <a:shade val="15000"/>
-                </a:schemeClr>
-              </a:lnRef>
-              <a:fillRef idx="1">
-                <a:schemeClr val="accent1"/>
-              </a:fillRef>
-              <a:effectRef idx="0">
-                <a:schemeClr val="accent1"/>
-              </a:effectRef>
-              <a:fontRef idx="minor">
-                <a:schemeClr val="lt1"/>
-              </a:fontRef>
-            </p:style>
-            <p:txBody>
-              <a:bodyPr rtlCol="0" anchor="ctr"/>
-              <a:lstStyle/>
-              <a:p>
-                <a:pPr algn="ctr"/>
-                <a:endParaRPr lang="en-US"/>
-              </a:p>
-            </p:txBody>
-          </p:sp>
-          <p:sp>
-            <p:nvSpPr>
-              <p:cNvPr id="230" name="Oval 229">
-                <a:extLst>
-                  <a:ext uri="{FF2B5EF4-FFF2-40B4-BE49-F238E27FC236}">
-                    <a16:creationId xmlns:a16="http://schemas.microsoft.com/office/drawing/2014/main" id="{90938086-6D67-6184-0802-7C394D58143F}"/>
-                  </a:ext>
-                </a:extLst>
-              </p:cNvPr>
-              <p:cNvSpPr/>
-              <p:nvPr/>
-            </p:nvSpPr>
-            <p:spPr>
-              <a:xfrm>
-                <a:off x="-4333307" y="678771"/>
-                <a:ext cx="267629" cy="267629"/>
-              </a:xfrm>
-              <a:prstGeom prst="ellipse">
-                <a:avLst/>
-              </a:prstGeom>
-              <a:solidFill>
-                <a:srgbClr val="FF0000"/>
-              </a:solidFill>
-              <a:ln w="22225"/>
-            </p:spPr>
-            <p:style>
-              <a:lnRef idx="2">
-                <a:schemeClr val="accent1">
-                  <a:shade val="15000"/>
-                </a:schemeClr>
-              </a:lnRef>
-              <a:fillRef idx="1">
-                <a:schemeClr val="accent1"/>
-              </a:fillRef>
-              <a:effectRef idx="0">
-                <a:schemeClr val="accent1"/>
-              </a:effectRef>
-              <a:fontRef idx="minor">
-                <a:schemeClr val="lt1"/>
-              </a:fontRef>
-            </p:style>
-            <p:txBody>
-              <a:bodyPr rtlCol="0" anchor="ctr"/>
-              <a:lstStyle/>
-              <a:p>
-                <a:pPr algn="ctr"/>
-                <a:endParaRPr lang="en-US"/>
-              </a:p>
-            </p:txBody>
-          </p:sp>
-          <p:sp>
-            <p:nvSpPr>
-              <p:cNvPr id="231" name="Oval 230">
-                <a:extLst>
-                  <a:ext uri="{FF2B5EF4-FFF2-40B4-BE49-F238E27FC236}">
-                    <a16:creationId xmlns:a16="http://schemas.microsoft.com/office/drawing/2014/main" id="{86812ACB-7825-8D0A-B8F2-020CE6429F04}"/>
-                  </a:ext>
-                </a:extLst>
-              </p:cNvPr>
-              <p:cNvSpPr/>
-              <p:nvPr/>
-            </p:nvSpPr>
-            <p:spPr>
-              <a:xfrm>
-                <a:off x="-3965321" y="678771"/>
-                <a:ext cx="267629" cy="267629"/>
-              </a:xfrm>
-              <a:prstGeom prst="ellipse">
-                <a:avLst/>
-              </a:prstGeom>
-              <a:solidFill>
-                <a:srgbClr val="FF0000"/>
-              </a:solidFill>
-              <a:ln w="22225"/>
-            </p:spPr>
-            <p:style>
-              <a:lnRef idx="2">
-                <a:schemeClr val="accent1">
-                  <a:shade val="15000"/>
-                </a:schemeClr>
-              </a:lnRef>
-              <a:fillRef idx="1">
-                <a:schemeClr val="accent1"/>
-              </a:fillRef>
-              <a:effectRef idx="0">
-                <a:schemeClr val="accent1"/>
-              </a:effectRef>
-              <a:fontRef idx="minor">
-                <a:schemeClr val="lt1"/>
-              </a:fontRef>
-            </p:style>
-            <p:txBody>
-              <a:bodyPr rtlCol="0" anchor="ctr"/>
-              <a:lstStyle/>
-              <a:p>
-                <a:pPr algn="ctr"/>
-                <a:endParaRPr lang="en-US"/>
-              </a:p>
-            </p:txBody>
-          </p:sp>
-          <p:sp>
-            <p:nvSpPr>
-              <p:cNvPr id="232" name="Oval 231">
-                <a:extLst>
-                  <a:ext uri="{FF2B5EF4-FFF2-40B4-BE49-F238E27FC236}">
-                    <a16:creationId xmlns:a16="http://schemas.microsoft.com/office/drawing/2014/main" id="{88999B70-CD0F-3643-F48D-800C46241A83}"/>
-                  </a:ext>
-                </a:extLst>
-              </p:cNvPr>
-              <p:cNvSpPr/>
-              <p:nvPr/>
-            </p:nvSpPr>
-            <p:spPr>
-              <a:xfrm>
-                <a:off x="-3574981" y="681233"/>
-                <a:ext cx="267629" cy="267629"/>
-              </a:xfrm>
-              <a:prstGeom prst="ellipse">
-                <a:avLst/>
-              </a:prstGeom>
-              <a:solidFill>
-                <a:srgbClr val="FF0000"/>
-              </a:solidFill>
-              <a:ln w="22225"/>
-            </p:spPr>
-            <p:style>
-              <a:lnRef idx="2">
-                <a:schemeClr val="accent1">
-                  <a:shade val="15000"/>
-                </a:schemeClr>
-              </a:lnRef>
-              <a:fillRef idx="1">
-                <a:schemeClr val="accent1"/>
-              </a:fillRef>
-              <a:effectRef idx="0">
-                <a:schemeClr val="accent1"/>
-              </a:effectRef>
-              <a:fontRef idx="minor">
-                <a:schemeClr val="lt1"/>
-              </a:fontRef>
-            </p:style>
-            <p:txBody>
-              <a:bodyPr rtlCol="0" anchor="ctr"/>
-              <a:lstStyle/>
-              <a:p>
-                <a:pPr algn="ctr"/>
-                <a:endParaRPr lang="en-US"/>
-              </a:p>
-            </p:txBody>
-          </p:sp>
-          <p:sp>
-            <p:nvSpPr>
-              <p:cNvPr id="233" name="Oval 232">
-                <a:extLst>
-                  <a:ext uri="{FF2B5EF4-FFF2-40B4-BE49-F238E27FC236}">
-                    <a16:creationId xmlns:a16="http://schemas.microsoft.com/office/drawing/2014/main" id="{93B6CBC1-2AD6-0FE4-FF5B-C6022168E1A8}"/>
-                  </a:ext>
-                </a:extLst>
-              </p:cNvPr>
-              <p:cNvSpPr/>
-              <p:nvPr/>
-            </p:nvSpPr>
-            <p:spPr>
-              <a:xfrm>
-                <a:off x="-3206995" y="681233"/>
+                <a:off x="1614504" y="653159"/>
                 <a:ext cx="267629" cy="267629"/>
               </a:xfrm>
               <a:prstGeom prst="ellipse">
@@ -21579,10 +20699,160 @@
         </p:grpSp>
         <p:sp>
           <p:nvSpPr>
-            <p:cNvPr id="235" name="TextBox 234">
-              <a:extLst>
-                <a:ext uri="{FF2B5EF4-FFF2-40B4-BE49-F238E27FC236}">
-                  <a16:creationId xmlns:a16="http://schemas.microsoft.com/office/drawing/2014/main" id="{77D7C0AB-C5FA-CF36-50C6-FFFC45935BEB}"/>
+            <p:cNvPr id="97" name="Oval 96">
+              <a:extLst>
+                <a:ext uri="{FF2B5EF4-FFF2-40B4-BE49-F238E27FC236}">
+                  <a16:creationId xmlns:a16="http://schemas.microsoft.com/office/drawing/2014/main" id="{DFC68E3C-94B6-3DFF-01D8-AECC307CDDBC}"/>
+                </a:ext>
+              </a:extLst>
+            </p:cNvPr>
+            <p:cNvSpPr/>
+            <p:nvPr/>
+          </p:nvSpPr>
+          <p:spPr>
+            <a:xfrm>
+              <a:off x="7502570" y="8733283"/>
+              <a:ext cx="894965" cy="896381"/>
+            </a:xfrm>
+            <a:prstGeom prst="ellipse">
+              <a:avLst/>
+            </a:prstGeom>
+            <a:solidFill>
+              <a:schemeClr val="bg2"/>
+            </a:solidFill>
+            <a:ln w="22225"/>
+          </p:spPr>
+          <p:style>
+            <a:lnRef idx="2">
+              <a:schemeClr val="accent1">
+                <a:shade val="15000"/>
+              </a:schemeClr>
+            </a:lnRef>
+            <a:fillRef idx="1">
+              <a:schemeClr val="accent1"/>
+            </a:fillRef>
+            <a:effectRef idx="0">
+              <a:schemeClr val="accent1"/>
+            </a:effectRef>
+            <a:fontRef idx="minor">
+              <a:schemeClr val="lt1"/>
+            </a:fontRef>
+          </p:style>
+          <p:txBody>
+            <a:bodyPr rtlCol="0" anchor="ctr"/>
+            <a:lstStyle/>
+            <a:p>
+              <a:pPr algn="ctr"/>
+              <a:endParaRPr lang="en-US" sz="1600"/>
+            </a:p>
+          </p:txBody>
+        </p:sp>
+        <p:sp>
+          <p:nvSpPr>
+            <p:cNvPr id="98" name="Oval 97">
+              <a:extLst>
+                <a:ext uri="{FF2B5EF4-FFF2-40B4-BE49-F238E27FC236}">
+                  <a16:creationId xmlns:a16="http://schemas.microsoft.com/office/drawing/2014/main" id="{824DDEB2-3A38-A4AE-4DA7-2B179A7E7DF1}"/>
+                </a:ext>
+              </a:extLst>
+            </p:cNvPr>
+            <p:cNvSpPr/>
+            <p:nvPr/>
+          </p:nvSpPr>
+          <p:spPr>
+            <a:xfrm>
+              <a:off x="8562987" y="8729497"/>
+              <a:ext cx="894965" cy="896381"/>
+            </a:xfrm>
+            <a:prstGeom prst="ellipse">
+              <a:avLst/>
+            </a:prstGeom>
+            <a:solidFill>
+              <a:schemeClr val="bg2"/>
+            </a:solidFill>
+            <a:ln w="22225"/>
+          </p:spPr>
+          <p:style>
+            <a:lnRef idx="2">
+              <a:schemeClr val="accent1">
+                <a:shade val="15000"/>
+              </a:schemeClr>
+            </a:lnRef>
+            <a:fillRef idx="1">
+              <a:schemeClr val="accent1"/>
+            </a:fillRef>
+            <a:effectRef idx="0">
+              <a:schemeClr val="accent1"/>
+            </a:effectRef>
+            <a:fontRef idx="minor">
+              <a:schemeClr val="lt1"/>
+            </a:fontRef>
+          </p:style>
+          <p:txBody>
+            <a:bodyPr rtlCol="0" anchor="ctr"/>
+            <a:lstStyle/>
+            <a:p>
+              <a:pPr algn="ctr"/>
+              <a:endParaRPr lang="en-US" sz="1600"/>
+            </a:p>
+          </p:txBody>
+        </p:sp>
+        <p:sp>
+          <p:nvSpPr>
+            <p:cNvPr id="99" name="Oval 98">
+              <a:extLst>
+                <a:ext uri="{FF2B5EF4-FFF2-40B4-BE49-F238E27FC236}">
+                  <a16:creationId xmlns:a16="http://schemas.microsoft.com/office/drawing/2014/main" id="{493C2ED9-B0C1-1507-1E2A-2FF10DEE2D2F}"/>
+                </a:ext>
+              </a:extLst>
+            </p:cNvPr>
+            <p:cNvSpPr/>
+            <p:nvPr/>
+          </p:nvSpPr>
+          <p:spPr>
+            <a:xfrm>
+              <a:off x="9623404" y="8729545"/>
+              <a:ext cx="894965" cy="896381"/>
+            </a:xfrm>
+            <a:prstGeom prst="ellipse">
+              <a:avLst/>
+            </a:prstGeom>
+            <a:solidFill>
+              <a:schemeClr val="bg2"/>
+            </a:solidFill>
+            <a:ln w="22225"/>
+          </p:spPr>
+          <p:style>
+            <a:lnRef idx="2">
+              <a:schemeClr val="accent1">
+                <a:shade val="15000"/>
+              </a:schemeClr>
+            </a:lnRef>
+            <a:fillRef idx="1">
+              <a:schemeClr val="accent1"/>
+            </a:fillRef>
+            <a:effectRef idx="0">
+              <a:schemeClr val="accent1"/>
+            </a:effectRef>
+            <a:fontRef idx="minor">
+              <a:schemeClr val="lt1"/>
+            </a:fontRef>
+          </p:style>
+          <p:txBody>
+            <a:bodyPr rtlCol="0" anchor="ctr"/>
+            <a:lstStyle/>
+            <a:p>
+              <a:pPr algn="ctr"/>
+              <a:endParaRPr lang="en-US" sz="1600"/>
+            </a:p>
+          </p:txBody>
+        </p:sp>
+        <p:sp>
+          <p:nvSpPr>
+            <p:cNvPr id="213" name="TextBox 212">
+              <a:extLst>
+                <a:ext uri="{FF2B5EF4-FFF2-40B4-BE49-F238E27FC236}">
+                  <a16:creationId xmlns:a16="http://schemas.microsoft.com/office/drawing/2014/main" id="{732C086B-4413-0501-4613-C4C93A65D112}"/>
                 </a:ext>
               </a:extLst>
             </p:cNvPr>
@@ -21591,33 +20861,130 @@
           </p:nvSpPr>
           <p:spPr>
             <a:xfrm>
-              <a:off x="7448723" y="8087622"/>
-              <a:ext cx="575607" cy="400110"/>
-            </a:xfrm>
-            <a:prstGeom prst="rect">
-              <a:avLst/>
-            </a:prstGeom>
-            <a:solidFill>
-              <a:schemeClr val="bg1"/>
-            </a:solidFill>
-            <a:ln w="19050">
-              <a:solidFill>
-                <a:schemeClr val="accent1">
-                  <a:shade val="15000"/>
-                </a:schemeClr>
-              </a:solidFill>
-              <a:prstDash val="sysDash"/>
-            </a:ln>
+              <a:off x="7545413" y="9037854"/>
+              <a:ext cx="796638" cy="307777"/>
+            </a:xfrm>
+            <a:prstGeom prst="rect">
+              <a:avLst/>
+            </a:prstGeom>
+            <a:noFill/>
           </p:spPr>
           <p:txBody>
-            <a:bodyPr wrap="none" rtlCol="0">
+            <a:bodyPr wrap="square">
               <a:spAutoFit/>
             </a:bodyPr>
             <a:lstStyle/>
             <a:p>
+              <a:pPr algn="ctr"/>
               <a:r>
-                <a:rPr lang="en-US" sz="2000" dirty="0"/>
-                <a:t>Key</a:t>
+                <a:rPr lang="en-US" sz="1400" dirty="0">
+                  <a:solidFill>
+                    <a:schemeClr val="tx1"/>
+                  </a:solidFill>
+                </a:rPr>
+                <a:t>T</a:t>
+              </a:r>
+              <a:r>
+                <a:rPr lang="en-US" sz="1400" baseline="-25000" dirty="0">
+                  <a:solidFill>
+                    <a:schemeClr val="tx1"/>
+                  </a:solidFill>
+                </a:rPr>
+                <a:t>1</a:t>
+              </a:r>
+              <a:endParaRPr lang="en-US" sz="1400" baseline="-25000" dirty="0"/>
+            </a:p>
+          </p:txBody>
+        </p:sp>
+        <p:sp>
+          <p:nvSpPr>
+            <p:cNvPr id="214" name="TextBox 213">
+              <a:extLst>
+                <a:ext uri="{FF2B5EF4-FFF2-40B4-BE49-F238E27FC236}">
+                  <a16:creationId xmlns:a16="http://schemas.microsoft.com/office/drawing/2014/main" id="{FD363BB7-0CD7-BA65-202C-1A2468D2DD94}"/>
+                </a:ext>
+              </a:extLst>
+            </p:cNvPr>
+            <p:cNvSpPr txBox="1"/>
+            <p:nvPr/>
+          </p:nvSpPr>
+          <p:spPr>
+            <a:xfrm>
+              <a:off x="8612150" y="9033147"/>
+              <a:ext cx="796638" cy="307777"/>
+            </a:xfrm>
+            <a:prstGeom prst="rect">
+              <a:avLst/>
+            </a:prstGeom>
+            <a:noFill/>
+          </p:spPr>
+          <p:txBody>
+            <a:bodyPr wrap="square">
+              <a:spAutoFit/>
+            </a:bodyPr>
+            <a:lstStyle/>
+            <a:p>
+              <a:pPr algn="ctr"/>
+              <a:r>
+                <a:rPr lang="en-US" sz="1400" dirty="0">
+                  <a:solidFill>
+                    <a:schemeClr val="tx1"/>
+                  </a:solidFill>
+                </a:rPr>
+                <a:t>T</a:t>
+              </a:r>
+              <a:r>
+                <a:rPr lang="en-US" sz="1400" baseline="-25000" dirty="0">
+                  <a:solidFill>
+                    <a:schemeClr val="tx1"/>
+                  </a:solidFill>
+                </a:rPr>
+                <a:t>3</a:t>
+              </a:r>
+              <a:endParaRPr lang="en-US" sz="1400" baseline="-25000" dirty="0"/>
+            </a:p>
+          </p:txBody>
+        </p:sp>
+        <p:sp>
+          <p:nvSpPr>
+            <p:cNvPr id="215" name="TextBox 214">
+              <a:extLst>
+                <a:ext uri="{FF2B5EF4-FFF2-40B4-BE49-F238E27FC236}">
+                  <a16:creationId xmlns:a16="http://schemas.microsoft.com/office/drawing/2014/main" id="{0549EFD8-C758-6BBE-F799-2AE2940C7A74}"/>
+                </a:ext>
+              </a:extLst>
+            </p:cNvPr>
+            <p:cNvSpPr txBox="1"/>
+            <p:nvPr/>
+          </p:nvSpPr>
+          <p:spPr>
+            <a:xfrm>
+              <a:off x="9670330" y="9030211"/>
+              <a:ext cx="796638" cy="307777"/>
+            </a:xfrm>
+            <a:prstGeom prst="rect">
+              <a:avLst/>
+            </a:prstGeom>
+            <a:noFill/>
+          </p:spPr>
+          <p:txBody>
+            <a:bodyPr wrap="square">
+              <a:spAutoFit/>
+            </a:bodyPr>
+            <a:lstStyle/>
+            <a:p>
+              <a:pPr algn="ctr"/>
+              <a:r>
+                <a:rPr lang="en-US" sz="1400" dirty="0">
+                  <a:solidFill>
+                    <a:schemeClr val="tx1"/>
+                  </a:solidFill>
+                </a:rPr>
+                <a:t>T</a:t>
+              </a:r>
+              <a:r>
+                <a:rPr lang="en-US" sz="1400" baseline="-25000" dirty="0"/>
+                <a:t>5</a:t>
               </a:r>
             </a:p>
           </p:txBody>

</xml_diff>